<commit_message>
Align presentation with ten-minute grading rubric
</commit_message>
<xml_diff>
--- a/docs/Presentacion_Robot_Framework_G4_visual.pptx
+++ b/docs/Presentacion_Robot_Framework_G4_visual.pptx
@@ -2,22 +2,22 @@
 <file path=ppt/presentation.xml><?xml version="1.0" encoding="utf-8"?>
 <p:presentation xmlns:p="http://schemas.openxmlformats.org/presentationml/2006/main">
   <p:sldMasterIdLst>
-    <p:sldMasterId xmlns:r="http://schemas.openxmlformats.org/officeDocument/2006/relationships" id="2147483648" r:id="R39182841609041da"/>
+    <p:sldMasterId xmlns:r="http://schemas.openxmlformats.org/officeDocument/2006/relationships" id="2147483648" r:id="R2ae380a6541e4f20"/>
   </p:sldMasterIdLst>
   <p:notesMasterIdLst>
-    <p:notesMasterId xmlns:r="http://schemas.openxmlformats.org/officeDocument/2006/relationships" r:id="R0f4e663057414d8f"/>
+    <p:notesMasterId xmlns:r="http://schemas.openxmlformats.org/officeDocument/2006/relationships" r:id="R5e01f9ae0f994251"/>
   </p:notesMasterIdLst>
   <p:sldIdLst>
-    <p:sldId xmlns:r="http://schemas.openxmlformats.org/officeDocument/2006/relationships" id="256" r:id="R47c371e698dc49ca"/>
-    <p:sldId xmlns:r="http://schemas.openxmlformats.org/officeDocument/2006/relationships" id="257" r:id="R9611e245be104f61"/>
-    <p:sldId xmlns:r="http://schemas.openxmlformats.org/officeDocument/2006/relationships" id="258" r:id="Rc5cd942114aa450c"/>
-    <p:sldId xmlns:r="http://schemas.openxmlformats.org/officeDocument/2006/relationships" id="259" r:id="R7523201f633d402b"/>
-    <p:sldId xmlns:r="http://schemas.openxmlformats.org/officeDocument/2006/relationships" id="260" r:id="Ra3fa68bb5d34420f"/>
-    <p:sldId xmlns:r="http://schemas.openxmlformats.org/officeDocument/2006/relationships" id="261" r:id="Rc8f5bf37505b4693"/>
-    <p:sldId xmlns:r="http://schemas.openxmlformats.org/officeDocument/2006/relationships" id="262" r:id="R51265f029d4c4834"/>
-    <p:sldId xmlns:r="http://schemas.openxmlformats.org/officeDocument/2006/relationships" id="263" r:id="R098a81e9e14c4c77"/>
-    <p:sldId xmlns:r="http://schemas.openxmlformats.org/officeDocument/2006/relationships" id="264" r:id="Rcdc43dca255d43b4"/>
-    <p:sldId xmlns:r="http://schemas.openxmlformats.org/officeDocument/2006/relationships" id="265" r:id="R63dcf72d0bfa46d5"/>
+    <p:sldId xmlns:r="http://schemas.openxmlformats.org/officeDocument/2006/relationships" id="256" r:id="R99011ee507364b06"/>
+    <p:sldId xmlns:r="http://schemas.openxmlformats.org/officeDocument/2006/relationships" id="257" r:id="R92cf04694527474b"/>
+    <p:sldId xmlns:r="http://schemas.openxmlformats.org/officeDocument/2006/relationships" id="258" r:id="Rb76e397e8499422f"/>
+    <p:sldId xmlns:r="http://schemas.openxmlformats.org/officeDocument/2006/relationships" id="259" r:id="Reb699d1ed04b4a24"/>
+    <p:sldId xmlns:r="http://schemas.openxmlformats.org/officeDocument/2006/relationships" id="260" r:id="Ra078f7db640a4b75"/>
+    <p:sldId xmlns:r="http://schemas.openxmlformats.org/officeDocument/2006/relationships" id="261" r:id="Rc1999236c5984120"/>
+    <p:sldId xmlns:r="http://schemas.openxmlformats.org/officeDocument/2006/relationships" id="262" r:id="R9c85d9eb7bf24aae"/>
+    <p:sldId xmlns:r="http://schemas.openxmlformats.org/officeDocument/2006/relationships" id="263" r:id="R74b73686d31f4ccd"/>
+    <p:sldId xmlns:r="http://schemas.openxmlformats.org/officeDocument/2006/relationships" id="264" r:id="R102ba38e8d4b49b1"/>
+    <p:sldId xmlns:r="http://schemas.openxmlformats.org/officeDocument/2006/relationships" id="265" r:id="Rb0d88f7e90c6452e"/>
   </p:sldIdLst>
   <p:sldSz cx="12192000" cy="6858000"/>
   <p:notesSz cx="6858000" cy="9144000"/>
@@ -451,7 +451,7 @@
           <a:lstStyle xmlns:a="http://schemas.openxmlformats.org/drawingml/2006/main"/>
           <a:p xmlns:a="http://schemas.openxmlformats.org/drawingml/2006/main">
             <a:r>
-              <a:t>35 s. Presentar el trabajo: recorrido de dos usuarios del módulo G4, automatizado con Robot Framework y Browser Library. La captura es del entorno local real de Qolqe. Fuente principal del encargo: Canvas, Clase 11 - Automatización.pdf, archivo 4957072, y tarea 349599.</a:t>
+              <a:t>0:00-0:20 (20 s). Presentar el objetivo y anunciar que se verá la ejecución real y una revisión con IA en vivo. El flujo involucra a Diego y Bruno en el módulo G4. La captura es de la instancia local de Qolqe. Fuente del encargo: Canvas, Clase 11 - Automatización.pdf, archivo 4957072, y tarea 349599.</a:t>
             </a:r>
           </a:p>
         </p:txBody>
@@ -521,7 +521,7 @@
           <a:lstStyle xmlns:a="http://schemas.openxmlformats.org/drawingml/2006/main"/>
           <a:p xmlns:a="http://schemas.openxmlformats.org/drawingml/2006/main">
             <a:r>
-              <a:t>75 s. Dificultad observada: tras aceptar, la pantalla aún podía mostrar Pendiente; se resolvió esperando el estado visible. Límites: instalación del navegador y dependencias, UI más lenta que API/unidad, y mantenimiento de selectores. No usar UI E2E para cada regla pequeña, pantallas inestables o servicios externos sin control. Esta prueba no valida los SMS simulados. Entregar repo, código, README y presentación. Fuente: Canvas Clase 11, secciones de riesgos/esperas/pirámide; ejecución local; README del repositorio.</a:t>
+              <a:t>9:10-10:00 (50 s). Dificultad observada: tras aceptar, la pantalla podía seguir en Pendiente; la espera por estado visible resolvió la carrera. Límites: Chromium y dependencias, mayor lentitud que API/unidad y mantenimiento de selectores. No usar UI E2E para cada regla pequeña ni contra servicios externos no controlados. Reconocer que el SMS simulado todavía no está validado. Cerrar señalando el enlace público al repositorio, con código, README ejecutable y esta presentación. Fuente: Canvas Clase 11, riesgos/esperas/pirámide; ejecución local; README del repositorio.</a:t>
             </a:r>
           </a:p>
         </p:txBody>
@@ -591,7 +591,7 @@
           <a:lstStyle xmlns:a="http://schemas.openxmlformats.org/drawingml/2006/main"/>
           <a:p xmlns:a="http://schemas.openxmlformats.org/drawingml/2006/main">
             <a:r>
-              <a:t>55 s. Robot Framework es un marco abierto de automatización basado en palabras clave. El núcleo ejecuta los casos y las bibliotecas interactúan con la aplicación. Se usa aquí porque el recorrido es visible, se repite y tiene estados observables. Fuente: https://robotframework.org/robotframework/latest/RobotFrameworkUserGuide y material de Canvas Clase 11.</a:t>
+              <a:t>0:20-1:00 (40 s). Definir Robot Framework como marco abierto de automatización basado en palabras clave. Problema: repetir y comprobar el recorrido sin depender de clics manuales, con evidencia de cada ejecución. En Qolqe hay acciones y estados visibles. Fuente: https://robotframework.org/robotframework/latest/RobotFrameworkUserGuide y Canvas Clase 11.</a:t>
             </a:r>
           </a:p>
         </p:txBody>
@@ -661,7 +661,7 @@
           <a:lstStyle xmlns:a="http://schemas.openxmlformats.org/drawingml/2006/main"/>
           <a:p xmlns:a="http://schemas.openxmlformats.org/drawingml/2006/main">
             <a:r>
-              <a:t>55 s. La línea resume hitos de capacidad, no toda la historia. Robot Framework 3.1 incorporó soporte oficial para tareas de RPA. En esta entrega se verificó Robot 7.5 y Browser Library 20.6.0; esta última usa Playwright. Fuentes: Robot Framework User Guide; https://github.com/MarketSquare/robotframework-browser ; notas de versión Robot Framework 7.5.</a:t>
+              <a:t>1:00-1:40 (40 s). Explicar la evolución por capacidades: pruebas de aceptación con keywords, tareas RPA desde Robot Framework 3.1, y automatización web moderna con Browser Library sobre Playwright. No presentar esto como cronología exhaustiva. La instalación usada se verificó con Robot 7.5 y Browser Library 20.6.0. Fuentes: Robot Framework User Guide; https://github.com/MarketSquare/robotframework-browser ; notas de versión de Robot Framework 7.5.</a:t>
             </a:r>
           </a:p>
         </p:txBody>
@@ -731,7 +731,7 @@
           <a:lstStyle xmlns:a="http://schemas.openxmlformats.org/drawingml/2006/main"/>
           <a:p xmlns:a="http://schemas.openxmlformats.org/drawingml/2006/main">
             <a:r>
-              <a:t>70 s. El archivo .robot llama keywords por pantalla. Los recursos Page Object contienen acciones y selectores. El motor Robot ejecuta el caso; Browser Library conecta con Playwright, que controla Chromium contra Qolqe. Reportes: output.xml, log.html y report.html. Fuentes: Robot Framework User Guide; https://github.com/MarketSquare/robotframework-browser ; código de tests/e2e del repositorio.</a:t>
+              <a:t>1:40-2:35 (55 s). Seguir las flechas: el caso .robot llama keywords de los recursos Page Object; el motor de Robot los ejecuta; Browser Library usa Playwright para controlar Chromium contra Qolqe. El motor genera output.xml, log.html y report.html. Diferenciar motor, biblioteca, navegador y sistema bajo prueba. Fuentes: Robot Framework User Guide; https://github.com/MarketSquare/robotframework-browser ; tests/e2e del repositorio.</a:t>
             </a:r>
           </a:p>
         </p:txBody>
@@ -801,7 +801,7 @@
           <a:lstStyle xmlns:a="http://schemas.openxmlformats.org/drawingml/2006/main"/>
           <a:p xmlns:a="http://schemas.openxmlformats.org/drawingml/2006/main">
             <a:r>
-              <a:t>75 s. El caso en g4_solicitud_happy_path.robot expresa el qué; los archivos tests/e2e/pages/*.resource contienen el cómo: localizadores y acciones. Robot implementa el patrón mediante user keywords. Fuente: Canvas Clase 11, sección de patrones; archivos tests/e2e/g4_solicitud_happy_path.robot y tests/e2e/pages/ del repositorio.</a:t>
+              <a:t>2:35-3:40 (65 s). Mostrar los dos fragmentos reales: el caso llama Enviar solicitud a contacto sin selectores; SolicitudesPage.resource usa Fill Text sobre input-solicitud-monto y Click sobre boton-solicitar. En Robot el patrón se implementa con recursos y user keywords, no requiere clases. Justificación: localizadores concentrados por pantalla, caso legible y menos cambios cuando varía un selector. Señalar tests/e2e/pages/ en el repositorio. Fuentes: Canvas Clase 11, sección de patrones; tests/e2e/g4_solicitud_happy_path.robot; tests/e2e/pages/SolicitudesPage.resource.</a:t>
             </a:r>
           </a:p>
         </p:txBody>
@@ -871,7 +871,7 @@
           <a:lstStyle xmlns:a="http://schemas.openxmlformats.org/drawingml/2006/main"/>
           <a:p xmlns:a="http://schemas.openxmlformats.org/drawingml/2006/main">
             <a:r>
-              <a:t>85 s. Ejecutar o mostrar el video/navegador: Diego entra a Qolqe, agrega a Bruno y envía solicitud por S/ 25 con el motivo Devolución demo G4. La prueba verifica que aparece Pendiente. Fuente: capturas reales 01-contacto-creado.png y 03-solicitud-pendiente.png; requisitos Qolqe HU-G4-01, HU-G4-06, HU-G4-07.</a:t>
+              <a:t>3:40-4:45 (65 s). Mostrar las capturas como mapa previo a la ejecución y nombrar las validaciones: alias Bruno Demo visible, mensaje de solicitud enviada y fila por S/ 25 con estado Pendiente. Durante la ejecución del slide 8, estas acciones ocurrirán en Chromium. Fuente: capturas reales 01-contacto-creado.png y 03-solicitud-pendiente.png; requisitos Qolqe HU-G4-01, HU-G4-06 y HU-G4-07.</a:t>
             </a:r>
           </a:p>
         </p:txBody>
@@ -941,7 +941,7 @@
           <a:lstStyle xmlns:a="http://schemas.openxmlformats.org/drawingml/2006/main"/>
           <a:p xmlns:a="http://schemas.openxmlformats.org/drawingml/2006/main">
             <a:r>
-              <a:t>85 s. Bruno abre solicitudes recibidas y acepta la solicitud. El cuadro confirma una transferencia de S/ 25. Diego y Bruno ven Aceptada; se verifica código de operación y saldos Diego S/ 2,525.00, Bruno S/ 775.00. La comisión es S/ 0.00 según RN-09. Fuente: capturas reales 04-confirmacion-bruno.png, 05-solicitud-aceptada.png, 06-saldo-bruno.png y 07-saldo-diego.png; Qolqe HU-G4-08, RN-09 y RN-10.</a:t>
+              <a:t>4:45-5:55 (70 s). Mostrar cuadro de confirmación, estado Aceptada y código de operación. Enumerar oráculos del caso: estado para Bruno y Diego, detalle con Operación, Bruno S/ 775.00 y Diego S/ 2,525.00. Los saldos se derivan de S/ 800.00 y S/ 2,500.00 iniciales con una transferencia de S/ 25.00 y comisión cero. Fuente: capturas reales 04 a 07; Qolqe HU-G4-08, RN-09 y RN-10.</a:t>
             </a:r>
           </a:p>
         </p:txBody>
@@ -1011,7 +1011,7 @@
           <a:lstStyle xmlns:a="http://schemas.openxmlformats.org/drawingml/2006/main"/>
           <a:p xmlns:a="http://schemas.openxmlformats.org/drawingml/2006/main">
             <a:r>
-              <a:t>80 s. Iniciar Qolqe en modo de pruebas según README sección 7. Ejecutar python -m robot --variable HEADLESS:False --outputdir reportes tests/e2e/g4_solicitud_happy_path.robot. Ver el navegador y luego abrir reportes/report.html y log.html. La ejecución verificada el 24 de octubre de 2026 aprobó 1 de 1 prueba. Fuente: reportes locales y captura real 08-robot-report.png.</a:t>
+              <a:t>5:55-7:30 (95 s). PREPARACIÓN: Qolqe debe estar iniciado con el comando de la sección 7 del README. EN VIVO: ejecutar python -m robot --variable HEADLESS:False --outputdir reportes tests/e2e/g4_solicitud_happy_path.robot. Dejar que la audiencia vea Chromium; abrir reportes/report.html, señalar 1 test/1 passed; abrir log.html y expandir Enviar solicitud a contacto o Aceptar solicitud recibida para mostrar validaciones. Si la ventana tarda, usar la captura real como respaldo, aclarando que es una ejecución previa. La ejecución verificada el 24 de octubre de 2026 aprobó 1 de 1 prueba. Fuente: reportes locales y captura real 08-robot-report.png.</a:t>
             </a:r>
           </a:p>
         </p:txBody>
@@ -1081,7 +1081,7 @@
           <a:lstStyle xmlns:a="http://schemas.openxmlformats.org/drawingml/2006/main"/>
           <a:p xmlns:a="http://schemas.openxmlformats.org/drawingml/2006/main">
             <a:r>
-              <a:t>80 s. En Codex, abrir docs/demo-robot-ia.md y usar su prompt, aportando output.xml y los requisitos. La respuesta esperada señala que no se verifica el SMS simulado: destinatario tras crear solicitud (HU-G4-06 CA2) y solicitante tras aceptarla (HU-G4-08 CA3). Es asistencia de IA alrededor de Robot Framework; no es una función integrada de Robot. Validar la propuesta contra el requisito y ejecutar cualquier cambio. Fuente: docs/demo-robot-ia.md y docs/requisitos.md.</a:t>
+              <a:t>7:30-9:10 (100 s). EN VIVO: abrir Codex con este repositorio y pegar el prompt completo de docs/demo-robot-ia.md. Adjuntar o referir reportes/output.xml, tests/e2e/g4_solicitud_happy_path.robot y docs/requisitos.md. Pedir tres cosas: qué validó Robot, qué requisito no validó, y un keyword mínimo propuesto. La respuesta útil debe detectar los SMS simulados de HU-G4-06 CA2 y HU-G4-08 CA3. La IA es asistencia externa aplicada al resultado de Robot; no atribuir IA integrada al motor. Mostrar la propuesta y aclarar que se debe comprobar con requisitos y ejecutar antes de incorporarla. Fuente: docs/demo-robot-ia.md y docs/requisitos.md.</a:t>
             </a:r>
           </a:p>
         </p:txBody>
@@ -1128,7 +1128,7 @@
           <p:cNvPr id="3" name="Title">
             <a:extLst xmlns:a="http://schemas.openxmlformats.org/drawingml/2006/main">
               <a:ext uri="{FF2B5EF4-FFF2-40B4-BE49-F238E27FC236}">
-                <a16:creationId xmlns:a16="http://schemas.microsoft.com/office/drawing/2014/main" id="{9A8CAA09-3A29-4858-8EBC-D8010C440E33}"/>
+                <a16:creationId xmlns:a16="http://schemas.microsoft.com/office/drawing/2014/main" id="{C28D5550-E046-42B9-9546-8D851ED4E9A0}"/>
               </a:ext>
             </a:extLst>
           </p:cNvPr>
@@ -1357,7 +1357,7 @@
           <p:cNvPr id="2" name="Subtitle">
             <a:extLst xmlns:a="http://schemas.openxmlformats.org/drawingml/2006/main">
               <a:ext uri="{FF2B5EF4-FFF2-40B4-BE49-F238E27FC236}">
-                <a16:creationId xmlns:a16="http://schemas.microsoft.com/office/drawing/2014/main" id="{FE54DD16-9634-4B03-8CEC-9D937260B8C0}"/>
+                <a16:creationId xmlns:a16="http://schemas.microsoft.com/office/drawing/2014/main" id="{336BBD53-F08F-4202-ABC7-9DE906A226D9}"/>
               </a:ext>
             </a:extLst>
           </p:cNvPr>
@@ -1603,7 +1603,7 @@
           <p:cNvPr id="2" name="Section title">
             <a:extLst xmlns:a="http://schemas.openxmlformats.org/drawingml/2006/main">
               <a:ext uri="{FF2B5EF4-FFF2-40B4-BE49-F238E27FC236}">
-                <a16:creationId xmlns:a16="http://schemas.microsoft.com/office/drawing/2014/main" id="{25E2DB98-1D9C-4CB4-A71B-469E7AA2F503}"/>
+                <a16:creationId xmlns:a16="http://schemas.microsoft.com/office/drawing/2014/main" id="{FF533745-70E0-4CFA-8424-F926CCFBA702}"/>
               </a:ext>
             </a:extLst>
           </p:cNvPr>
@@ -1849,7 +1849,7 @@
           <p:cNvPr id="3" name="Title">
             <a:extLst xmlns:a="http://schemas.openxmlformats.org/drawingml/2006/main">
               <a:ext uri="{FF2B5EF4-FFF2-40B4-BE49-F238E27FC236}">
-                <a16:creationId xmlns:a16="http://schemas.microsoft.com/office/drawing/2014/main" id="{3623CD56-0877-48F3-8CC6-05B014889B77}"/>
+                <a16:creationId xmlns:a16="http://schemas.microsoft.com/office/drawing/2014/main" id="{CEBA62EE-FAF2-4CC9-A4A0-3BAD99350B3D}"/>
               </a:ext>
             </a:extLst>
           </p:cNvPr>
@@ -2078,7 +2078,7 @@
           <p:cNvPr id="2" name="Body">
             <a:extLst xmlns:a="http://schemas.openxmlformats.org/drawingml/2006/main">
               <a:ext uri="{FF2B5EF4-FFF2-40B4-BE49-F238E27FC236}">
-                <a16:creationId xmlns:a16="http://schemas.microsoft.com/office/drawing/2014/main" id="{646CD7E6-CFDB-4D69-AC08-74C35AD9C55B}"/>
+                <a16:creationId xmlns:a16="http://schemas.microsoft.com/office/drawing/2014/main" id="{18AE414D-9C6D-4100-9791-CB6006449571}"/>
               </a:ext>
             </a:extLst>
           </p:cNvPr>
@@ -2324,7 +2324,7 @@
           <p:cNvPr id="4" name="Title">
             <a:extLst xmlns:a="http://schemas.openxmlformats.org/drawingml/2006/main">
               <a:ext uri="{FF2B5EF4-FFF2-40B4-BE49-F238E27FC236}">
-                <a16:creationId xmlns:a16="http://schemas.microsoft.com/office/drawing/2014/main" id="{2231F2A2-D6B9-478E-AFF8-5CD2DF2F3F15}"/>
+                <a16:creationId xmlns:a16="http://schemas.microsoft.com/office/drawing/2014/main" id="{FAA4182E-91A0-4EA7-B0BF-452A79C0A218}"/>
               </a:ext>
             </a:extLst>
           </p:cNvPr>
@@ -2553,7 +2553,7 @@
           <p:cNvPr id="2" name="Left column">
             <a:extLst xmlns:a="http://schemas.openxmlformats.org/drawingml/2006/main">
               <a:ext uri="{FF2B5EF4-FFF2-40B4-BE49-F238E27FC236}">
-                <a16:creationId xmlns:a16="http://schemas.microsoft.com/office/drawing/2014/main" id="{0C9AA059-E629-4EBC-8E2A-95E6003CD34C}"/>
+                <a16:creationId xmlns:a16="http://schemas.microsoft.com/office/drawing/2014/main" id="{BDB72F9C-7568-4A94-981C-A5BA2457257E}"/>
               </a:ext>
             </a:extLst>
           </p:cNvPr>
@@ -2782,7 +2782,7 @@
           <p:cNvPr id="3" name="Right column">
             <a:extLst xmlns:a="http://schemas.openxmlformats.org/drawingml/2006/main">
               <a:ext uri="{FF2B5EF4-FFF2-40B4-BE49-F238E27FC236}">
-                <a16:creationId xmlns:a16="http://schemas.microsoft.com/office/drawing/2014/main" id="{86964948-3A8A-4E33-970E-2F045D456209}"/>
+                <a16:creationId xmlns:a16="http://schemas.microsoft.com/office/drawing/2014/main" id="{BF34218B-F32B-4879-8EE7-856EB150A19A}"/>
               </a:ext>
             </a:extLst>
           </p:cNvPr>
@@ -3028,7 +3028,7 @@
           <p:cNvPr id="3" name="Title">
             <a:extLst xmlns:a="http://schemas.openxmlformats.org/drawingml/2006/main">
               <a:ext uri="{FF2B5EF4-FFF2-40B4-BE49-F238E27FC236}">
-                <a16:creationId xmlns:a16="http://schemas.microsoft.com/office/drawing/2014/main" id="{0312AE36-029B-4CCE-8877-BB256849C2E1}"/>
+                <a16:creationId xmlns:a16="http://schemas.microsoft.com/office/drawing/2014/main" id="{2010F5A3-9E22-4BBC-A94A-6C1F018FEF59}"/>
               </a:ext>
             </a:extLst>
           </p:cNvPr>
@@ -3257,7 +3257,7 @@
           <p:cNvPr id="2" name="Left column">
             <a:extLst xmlns:a="http://schemas.openxmlformats.org/drawingml/2006/main">
               <a:ext uri="{FF2B5EF4-FFF2-40B4-BE49-F238E27FC236}">
-                <a16:creationId xmlns:a16="http://schemas.microsoft.com/office/drawing/2014/main" id="{3B0B798B-E837-4E46-AAE8-5DBB28FCCD59}"/>
+                <a16:creationId xmlns:a16="http://schemas.microsoft.com/office/drawing/2014/main" id="{45F81AC0-DDD6-4664-AF8D-073570065E17}"/>
               </a:ext>
             </a:extLst>
           </p:cNvPr>
@@ -3524,12 +3524,12 @@
   </p:cSld>
   <p:clrMap bg1="lt1" tx1="dk1" bg2="lt2" tx2="dk2" accent1="accent1" accent2="accent2" accent3="accent3" accent4="accent4" accent5="accent5" accent6="accent6" hlink="hlink" folHlink="folHlink"/>
   <p:sldLayoutIdLst>
-    <p:sldLayoutId xmlns:r="http://schemas.openxmlformats.org/officeDocument/2006/relationships" id="2147483649" r:id="Rbdb7f345e6e642e7"/>
-    <p:sldLayoutId xmlns:r="http://schemas.openxmlformats.org/officeDocument/2006/relationships" id="2147483650" r:id="Rd4b3588cb2ce47ce"/>
-    <p:sldLayoutId xmlns:r="http://schemas.openxmlformats.org/officeDocument/2006/relationships" id="2147483651" r:id="R2b252f06bb944227"/>
-    <p:sldLayoutId xmlns:r="http://schemas.openxmlformats.org/officeDocument/2006/relationships" id="2147483652" r:id="Rb112c707cff3440f"/>
-    <p:sldLayoutId xmlns:r="http://schemas.openxmlformats.org/officeDocument/2006/relationships" id="2147483653" r:id="R29f1eeeb5e5e4f44"/>
-    <p:sldLayoutId xmlns:r="http://schemas.openxmlformats.org/officeDocument/2006/relationships" id="2147483654" r:id="Rd534196db49a4cf5"/>
+    <p:sldLayoutId xmlns:r="http://schemas.openxmlformats.org/officeDocument/2006/relationships" id="2147483649" r:id="R0ee563ba7619493a"/>
+    <p:sldLayoutId xmlns:r="http://schemas.openxmlformats.org/officeDocument/2006/relationships" id="2147483650" r:id="R01b5ef90e4d74bac"/>
+    <p:sldLayoutId xmlns:r="http://schemas.openxmlformats.org/officeDocument/2006/relationships" id="2147483651" r:id="R9b377f7a22134943"/>
+    <p:sldLayoutId xmlns:r="http://schemas.openxmlformats.org/officeDocument/2006/relationships" id="2147483652" r:id="R26ab98dc771f488d"/>
+    <p:sldLayoutId xmlns:r="http://schemas.openxmlformats.org/officeDocument/2006/relationships" id="2147483653" r:id="R20352c333f9143f1"/>
+    <p:sldLayoutId xmlns:r="http://schemas.openxmlformats.org/officeDocument/2006/relationships" id="2147483654" r:id="Red053e5a9d1d4388"/>
   </p:sldLayoutIdLst>
   <p:txStyles>
     <p:titleStyle>
@@ -4080,7 +4080,7 @@
           <p:cNvPr id="12" name="">
             <a:extLst xmlns:a="http://schemas.openxmlformats.org/drawingml/2006/main">
               <a:ext uri="{FF2B5EF4-FFF2-40B4-BE49-F238E27FC236}">
-                <a16:creationId xmlns:a16="http://schemas.microsoft.com/office/drawing/2014/main" id="{E20A59DF-EA45-4719-84F9-9BFF0C50AA10}"/>
+                <a16:creationId xmlns:a16="http://schemas.microsoft.com/office/drawing/2014/main" id="{56A393DA-EF0C-4A13-9964-6184A36FE8B8}"/>
               </a:ext>
             </a:extLst>
           </p:cNvPr>
@@ -4111,7 +4111,7 @@
           <p:cNvPr id="2" name="">
             <a:extLst xmlns:a="http://schemas.openxmlformats.org/drawingml/2006/main">
               <a:ext uri="{FF2B5EF4-FFF2-40B4-BE49-F238E27FC236}">
-                <a16:creationId xmlns:a16="http://schemas.microsoft.com/office/drawing/2014/main" id="{D34FAD8D-BF65-42AE-93D6-BBFB9BF2F537}"/>
+                <a16:creationId xmlns:a16="http://schemas.microsoft.com/office/drawing/2014/main" id="{6648137C-5A67-42E1-B0B2-FC0765CDCBE7}"/>
               </a:ext>
             </a:extLst>
           </p:cNvPr>
@@ -4142,7 +4142,7 @@
           <p:cNvPr id="3" name="">
             <a:extLst xmlns:a="http://schemas.openxmlformats.org/drawingml/2006/main">
               <a:ext uri="{FF2B5EF4-FFF2-40B4-BE49-F238E27FC236}">
-                <a16:creationId xmlns:a16="http://schemas.microsoft.com/office/drawing/2014/main" id="{9E2A7DC7-786E-4245-AB9C-D1F44B32005A}"/>
+                <a16:creationId xmlns:a16="http://schemas.microsoft.com/office/drawing/2014/main" id="{0372A2F5-A67E-4FCA-B8D6-652802ED50FB}"/>
               </a:ext>
             </a:extLst>
           </p:cNvPr>
@@ -4322,7 +4322,7 @@
           <p:cNvPr id="4" name="">
             <a:extLst xmlns:a="http://schemas.openxmlformats.org/drawingml/2006/main">
               <a:ext uri="{FF2B5EF4-FFF2-40B4-BE49-F238E27FC236}">
-                <a16:creationId xmlns:a16="http://schemas.microsoft.com/office/drawing/2014/main" id="{955F835F-B69D-4546-88BA-8EB12E4694A1}"/>
+                <a16:creationId xmlns:a16="http://schemas.microsoft.com/office/drawing/2014/main" id="{3BD68D6B-1E1E-46D0-85DE-3CE919080183}"/>
               </a:ext>
             </a:extLst>
           </p:cNvPr>
@@ -4479,7 +4479,7 @@
           <p:cNvPr id="5" name="">
             <a:extLst xmlns:a="http://schemas.openxmlformats.org/drawingml/2006/main">
               <a:ext uri="{FF2B5EF4-FFF2-40B4-BE49-F238E27FC236}">
-                <a16:creationId xmlns:a16="http://schemas.microsoft.com/office/drawing/2014/main" id="{D4C88B5B-13C0-4D28-A781-E6269CCA20CC}"/>
+                <a16:creationId xmlns:a16="http://schemas.microsoft.com/office/drawing/2014/main" id="{E259CA8F-DA8C-4477-B6E3-F5085775B2C9}"/>
               </a:ext>
             </a:extLst>
           </p:cNvPr>
@@ -4636,7 +4636,7 @@
           <p:cNvPr id="6" name="">
             <a:extLst xmlns:a="http://schemas.openxmlformats.org/drawingml/2006/main">
               <a:ext uri="{FF2B5EF4-FFF2-40B4-BE49-F238E27FC236}">
-                <a16:creationId xmlns:a16="http://schemas.microsoft.com/office/drawing/2014/main" id="{C76A3A4A-1609-46D5-BB69-979874014607}"/>
+                <a16:creationId xmlns:a16="http://schemas.microsoft.com/office/drawing/2014/main" id="{5B6E2D33-CCCE-49B2-8F63-886F8388691E}"/>
               </a:ext>
             </a:extLst>
           </p:cNvPr>
@@ -4669,7 +4669,7 @@
           <p:cNvPr id="7" name="">
             <a:extLst xmlns:a="http://schemas.openxmlformats.org/drawingml/2006/main">
               <a:ext uri="{FF2B5EF4-FFF2-40B4-BE49-F238E27FC236}">
-                <a16:creationId xmlns:a16="http://schemas.microsoft.com/office/drawing/2014/main" id="{92151F7E-AC62-4314-ACD3-02BA3E98D3B3}"/>
+                <a16:creationId xmlns:a16="http://schemas.microsoft.com/office/drawing/2014/main" id="{8CBEAD91-424B-43A5-A1CC-1A0DD17C8487}"/>
               </a:ext>
             </a:extLst>
           </p:cNvPr>
@@ -4826,7 +4826,7 @@
           <p:cNvPr id="8" name="">
             <a:extLst xmlns:a="http://schemas.openxmlformats.org/drawingml/2006/main">
               <a:ext uri="{FF2B5EF4-FFF2-40B4-BE49-F238E27FC236}">
-                <a16:creationId xmlns:a16="http://schemas.microsoft.com/office/drawing/2014/main" id="{B0699D76-D78A-45D0-844E-877B19B91BD6}"/>
+                <a16:creationId xmlns:a16="http://schemas.microsoft.com/office/drawing/2014/main" id="{373A2261-842E-4944-90C4-0A1FD7BC5CF5}"/>
               </a:ext>
             </a:extLst>
           </p:cNvPr>
@@ -4859,7 +4859,7 @@
           <p:cNvPr id="9" name="">
             <a:extLst xmlns:a="http://schemas.openxmlformats.org/drawingml/2006/main">
               <a:ext uri="{FF2B5EF4-FFF2-40B4-BE49-F238E27FC236}">
-                <a16:creationId xmlns:a16="http://schemas.microsoft.com/office/drawing/2014/main" id="{A355390E-FAF0-47FE-8A1A-D6D42AA0A81B}"/>
+                <a16:creationId xmlns:a16="http://schemas.microsoft.com/office/drawing/2014/main" id="{4C2F0F19-9772-4E7F-B123-5ED0936B7C49}"/>
               </a:ext>
             </a:extLst>
           </p:cNvPr>
@@ -4869,7 +4869,7 @@
           <p:nvPr/>
         </p:nvPicPr>
         <p:blipFill>
-          <a:blip xmlns:r="http://schemas.openxmlformats.org/officeDocument/2006/relationships" xmlns:a="http://schemas.openxmlformats.org/drawingml/2006/main" r:embed="R16f9957777004b95"/>
+          <a:blip xmlns:r="http://schemas.openxmlformats.org/officeDocument/2006/relationships" xmlns:a="http://schemas.openxmlformats.org/drawingml/2006/main" r:embed="Rd1a34ca7150b458d"/>
           <a:stretch xmlns:a="http://schemas.openxmlformats.org/drawingml/2006/main"/>
         </p:blipFill>
         <p:spPr>
@@ -4889,7 +4889,7 @@
           <p:cNvPr id="10" name="">
             <a:extLst xmlns:a="http://schemas.openxmlformats.org/drawingml/2006/main">
               <a:ext uri="{FF2B5EF4-FFF2-40B4-BE49-F238E27FC236}">
-                <a16:creationId xmlns:a16="http://schemas.microsoft.com/office/drawing/2014/main" id="{D18F44B7-E02E-457D-AD3F-CC3C336C88BB}"/>
+                <a16:creationId xmlns:a16="http://schemas.microsoft.com/office/drawing/2014/main" id="{2A022AD0-49B0-4B81-B3DA-1E1F2067939C}"/>
               </a:ext>
             </a:extLst>
           </p:cNvPr>
@@ -5046,7 +5046,7 @@
           <p:cNvPr id="11" name="">
             <a:extLst xmlns:a="http://schemas.openxmlformats.org/drawingml/2006/main">
               <a:ext uri="{FF2B5EF4-FFF2-40B4-BE49-F238E27FC236}">
-                <a16:creationId xmlns:a16="http://schemas.microsoft.com/office/drawing/2014/main" id="{8224D652-EC04-4903-B86B-EB520225BCE0}"/>
+                <a16:creationId xmlns:a16="http://schemas.microsoft.com/office/drawing/2014/main" id="{104782A3-C747-4DBC-96B9-AD1E79B6EDA4}"/>
               </a:ext>
             </a:extLst>
           </p:cNvPr>
@@ -5201,7 +5201,7 @@
     </p:spTree>
     <p:extLst>
       <p:ext uri="{BB962C8B-B14F-4D97-AF65-F5344CB8AC3E}">
-        <p14:creationId xmlns:p14="http://schemas.microsoft.com/office/powerpoint/2010/main" val="1357853167"/>
+        <p14:creationId xmlns:p14="http://schemas.microsoft.com/office/powerpoint/2010/main" val="982478593"/>
       </p:ext>
     </p:extLst>
   </p:cSld>
@@ -5232,7 +5232,7 @@
           <p:cNvPr id="21" name="">
             <a:extLst xmlns:a="http://schemas.openxmlformats.org/drawingml/2006/main">
               <a:ext uri="{FF2B5EF4-FFF2-40B4-BE49-F238E27FC236}">
-                <a16:creationId xmlns:a16="http://schemas.microsoft.com/office/drawing/2014/main" id="{DED79263-6AD1-4A52-89A0-02849D319C38}"/>
+                <a16:creationId xmlns:a16="http://schemas.microsoft.com/office/drawing/2014/main" id="{7D94C27A-4B06-450F-AD5C-7B5CFA3A8B09}"/>
               </a:ext>
             </a:extLst>
           </p:cNvPr>
@@ -5263,7 +5263,7 @@
           <p:cNvPr id="2" name="">
             <a:extLst xmlns:a="http://schemas.openxmlformats.org/drawingml/2006/main">
               <a:ext uri="{FF2B5EF4-FFF2-40B4-BE49-F238E27FC236}">
-                <a16:creationId xmlns:a16="http://schemas.microsoft.com/office/drawing/2014/main" id="{A4EFDC97-C28E-49B2-825D-BFDE7633F894}"/>
+                <a16:creationId xmlns:a16="http://schemas.microsoft.com/office/drawing/2014/main" id="{78450E61-79DA-4930-A706-7E4BBAE934A0}"/>
               </a:ext>
             </a:extLst>
           </p:cNvPr>
@@ -5420,7 +5420,7 @@
           <p:cNvPr id="3" name="">
             <a:extLst xmlns:a="http://schemas.openxmlformats.org/drawingml/2006/main">
               <a:ext uri="{FF2B5EF4-FFF2-40B4-BE49-F238E27FC236}">
-                <a16:creationId xmlns:a16="http://schemas.microsoft.com/office/drawing/2014/main" id="{8453240F-B7CC-4E5C-BFB6-38EF3ED352AA}"/>
+                <a16:creationId xmlns:a16="http://schemas.microsoft.com/office/drawing/2014/main" id="{37FA1C5E-52D4-40C5-96DF-C5AB60328C4B}"/>
               </a:ext>
             </a:extLst>
           </p:cNvPr>
@@ -5577,7 +5577,7 @@
           <p:cNvPr id="4" name="">
             <a:extLst xmlns:a="http://schemas.openxmlformats.org/drawingml/2006/main">
               <a:ext uri="{FF2B5EF4-FFF2-40B4-BE49-F238E27FC236}">
-                <a16:creationId xmlns:a16="http://schemas.microsoft.com/office/drawing/2014/main" id="{32D48589-95C8-4B75-8215-ECF78580A3F1}"/>
+                <a16:creationId xmlns:a16="http://schemas.microsoft.com/office/drawing/2014/main" id="{0C540B55-4642-4D56-8E75-58E9E82822A9}"/>
               </a:ext>
             </a:extLst>
           </p:cNvPr>
@@ -5734,7 +5734,7 @@
           <p:cNvPr id="5" name="">
             <a:extLst xmlns:a="http://schemas.openxmlformats.org/drawingml/2006/main">
               <a:ext uri="{FF2B5EF4-FFF2-40B4-BE49-F238E27FC236}">
-                <a16:creationId xmlns:a16="http://schemas.microsoft.com/office/drawing/2014/main" id="{506AA31E-D8AD-44FC-B3A4-035F91348417}"/>
+                <a16:creationId xmlns:a16="http://schemas.microsoft.com/office/drawing/2014/main" id="{EC7A4D5F-91A5-42F0-8991-13489393BE72}"/>
               </a:ext>
             </a:extLst>
           </p:cNvPr>
@@ -5765,7 +5765,7 @@
           <p:cNvPr id="6" name="">
             <a:extLst xmlns:a="http://schemas.openxmlformats.org/drawingml/2006/main">
               <a:ext uri="{FF2B5EF4-FFF2-40B4-BE49-F238E27FC236}">
-                <a16:creationId xmlns:a16="http://schemas.microsoft.com/office/drawing/2014/main" id="{603F3B62-1D54-4CF9-8ADD-5EC98956C6DA}"/>
+                <a16:creationId xmlns:a16="http://schemas.microsoft.com/office/drawing/2014/main" id="{9C7CD021-CC61-482D-B818-B0E44772552F}"/>
               </a:ext>
             </a:extLst>
           </p:cNvPr>
@@ -5922,7 +5922,7 @@
           <p:cNvPr id="7" name="">
             <a:extLst xmlns:a="http://schemas.openxmlformats.org/drawingml/2006/main">
               <a:ext uri="{FF2B5EF4-FFF2-40B4-BE49-F238E27FC236}">
-                <a16:creationId xmlns:a16="http://schemas.microsoft.com/office/drawing/2014/main" id="{B824B00D-2B16-4040-84FF-132FE1859D55}"/>
+                <a16:creationId xmlns:a16="http://schemas.microsoft.com/office/drawing/2014/main" id="{24E410CB-C670-4C81-B01F-86C43C82C55C}"/>
               </a:ext>
             </a:extLst>
           </p:cNvPr>
@@ -6079,7 +6079,7 @@
           <p:cNvPr id="8" name="">
             <a:extLst xmlns:a="http://schemas.openxmlformats.org/drawingml/2006/main">
               <a:ext uri="{FF2B5EF4-FFF2-40B4-BE49-F238E27FC236}">
-                <a16:creationId xmlns:a16="http://schemas.microsoft.com/office/drawing/2014/main" id="{27068C33-BFDB-47E5-A0C3-79561A7B0E01}"/>
+                <a16:creationId xmlns:a16="http://schemas.microsoft.com/office/drawing/2014/main" id="{16045E05-0061-430B-AAFA-561AD2D15F29}"/>
               </a:ext>
             </a:extLst>
           </p:cNvPr>
@@ -6112,7 +6112,7 @@
           <p:cNvPr id="9" name="">
             <a:extLst xmlns:a="http://schemas.openxmlformats.org/drawingml/2006/main">
               <a:ext uri="{FF2B5EF4-FFF2-40B4-BE49-F238E27FC236}">
-                <a16:creationId xmlns:a16="http://schemas.microsoft.com/office/drawing/2014/main" id="{B4FD1641-539A-48B9-B7F2-2FD964B3423D}"/>
+                <a16:creationId xmlns:a16="http://schemas.microsoft.com/office/drawing/2014/main" id="{CE7859A9-4C3F-4DE3-9C1E-E106A945CC7E}"/>
               </a:ext>
             </a:extLst>
           </p:cNvPr>
@@ -6269,7 +6269,7 @@
           <p:cNvPr id="10" name="">
             <a:extLst xmlns:a="http://schemas.openxmlformats.org/drawingml/2006/main">
               <a:ext uri="{FF2B5EF4-FFF2-40B4-BE49-F238E27FC236}">
-                <a16:creationId xmlns:a16="http://schemas.microsoft.com/office/drawing/2014/main" id="{590F3B20-1692-4320-A4E3-E9F0A2E924D7}"/>
+                <a16:creationId xmlns:a16="http://schemas.microsoft.com/office/drawing/2014/main" id="{97B5FBF8-7521-4A9A-B3B3-626416FA0CDF}"/>
               </a:ext>
             </a:extLst>
           </p:cNvPr>
@@ -6449,7 +6449,7 @@
           <p:cNvPr id="11" name="">
             <a:extLst xmlns:a="http://schemas.openxmlformats.org/drawingml/2006/main">
               <a:ext uri="{FF2B5EF4-FFF2-40B4-BE49-F238E27FC236}">
-                <a16:creationId xmlns:a16="http://schemas.microsoft.com/office/drawing/2014/main" id="{FD2E47F8-FB9F-4EE0-8F06-1C09ED692C79}"/>
+                <a16:creationId xmlns:a16="http://schemas.microsoft.com/office/drawing/2014/main" id="{73897800-BA70-4F51-A08C-8CDE78F1DFF7}"/>
               </a:ext>
             </a:extLst>
           </p:cNvPr>
@@ -6482,7 +6482,7 @@
           <p:cNvPr id="12" name="">
             <a:extLst xmlns:a="http://schemas.openxmlformats.org/drawingml/2006/main">
               <a:ext uri="{FF2B5EF4-FFF2-40B4-BE49-F238E27FC236}">
-                <a16:creationId xmlns:a16="http://schemas.microsoft.com/office/drawing/2014/main" id="{074EE905-EF5C-4795-B04B-21C89297D078}"/>
+                <a16:creationId xmlns:a16="http://schemas.microsoft.com/office/drawing/2014/main" id="{FF30D2E8-652F-4691-9395-F5DF16BF8581}"/>
               </a:ext>
             </a:extLst>
           </p:cNvPr>
@@ -6639,7 +6639,7 @@
           <p:cNvPr id="13" name="">
             <a:extLst xmlns:a="http://schemas.openxmlformats.org/drawingml/2006/main">
               <a:ext uri="{FF2B5EF4-FFF2-40B4-BE49-F238E27FC236}">
-                <a16:creationId xmlns:a16="http://schemas.microsoft.com/office/drawing/2014/main" id="{0C196FD3-F10B-4D9C-B205-C18777C11661}"/>
+                <a16:creationId xmlns:a16="http://schemas.microsoft.com/office/drawing/2014/main" id="{F51F5A95-5695-4149-BE6D-81353ABBAD87}"/>
               </a:ext>
             </a:extLst>
           </p:cNvPr>
@@ -6819,7 +6819,7 @@
           <p:cNvPr id="14" name="">
             <a:extLst xmlns:a="http://schemas.openxmlformats.org/drawingml/2006/main">
               <a:ext uri="{FF2B5EF4-FFF2-40B4-BE49-F238E27FC236}">
-                <a16:creationId xmlns:a16="http://schemas.microsoft.com/office/drawing/2014/main" id="{3DC04BA1-BEBE-45BE-AE06-E07A440BC33B}"/>
+                <a16:creationId xmlns:a16="http://schemas.microsoft.com/office/drawing/2014/main" id="{0A616DAB-D257-4370-88AA-1BAFA4C43969}"/>
               </a:ext>
             </a:extLst>
           </p:cNvPr>
@@ -6852,7 +6852,7 @@
           <p:cNvPr id="15" name="">
             <a:extLst xmlns:a="http://schemas.openxmlformats.org/drawingml/2006/main">
               <a:ext uri="{FF2B5EF4-FFF2-40B4-BE49-F238E27FC236}">
-                <a16:creationId xmlns:a16="http://schemas.microsoft.com/office/drawing/2014/main" id="{B495BE5C-3035-4B27-874E-4C35E297733D}"/>
+                <a16:creationId xmlns:a16="http://schemas.microsoft.com/office/drawing/2014/main" id="{0F32BBF7-CF5D-4387-B12E-5A92DD9F5CDE}"/>
               </a:ext>
             </a:extLst>
           </p:cNvPr>
@@ -7009,7 +7009,7 @@
           <p:cNvPr id="16" name="">
             <a:extLst xmlns:a="http://schemas.openxmlformats.org/drawingml/2006/main">
               <a:ext uri="{FF2B5EF4-FFF2-40B4-BE49-F238E27FC236}">
-                <a16:creationId xmlns:a16="http://schemas.microsoft.com/office/drawing/2014/main" id="{86AF1C7F-F1A6-40AD-B513-85DB92E02BCA}"/>
+                <a16:creationId xmlns:a16="http://schemas.microsoft.com/office/drawing/2014/main" id="{A58F4993-F358-41B2-A12C-54AE59DE2025}"/>
               </a:ext>
             </a:extLst>
           </p:cNvPr>
@@ -7189,7 +7189,7 @@
           <p:cNvPr id="17" name="">
             <a:extLst xmlns:a="http://schemas.openxmlformats.org/drawingml/2006/main">
               <a:ext uri="{FF2B5EF4-FFF2-40B4-BE49-F238E27FC236}">
-                <a16:creationId xmlns:a16="http://schemas.microsoft.com/office/drawing/2014/main" id="{F40CCC51-A0BB-42ED-A05D-D88D77E9774F}"/>
+                <a16:creationId xmlns:a16="http://schemas.microsoft.com/office/drawing/2014/main" id="{49C3214E-0083-430D-BA47-9A27194861EB}"/>
               </a:ext>
             </a:extLst>
           </p:cNvPr>
@@ -7222,7 +7222,7 @@
           <p:cNvPr id="18" name="">
             <a:extLst xmlns:a="http://schemas.openxmlformats.org/drawingml/2006/main">
               <a:ext uri="{FF2B5EF4-FFF2-40B4-BE49-F238E27FC236}">
-                <a16:creationId xmlns:a16="http://schemas.microsoft.com/office/drawing/2014/main" id="{032E0271-895C-4249-978B-97032BA38CFA}"/>
+                <a16:creationId xmlns:a16="http://schemas.microsoft.com/office/drawing/2014/main" id="{5281A693-5CB0-4BB6-AFE7-D4F102ACD073}"/>
               </a:ext>
             </a:extLst>
           </p:cNvPr>
@@ -7379,7 +7379,7 @@
           <p:cNvPr id="19" name="">
             <a:extLst xmlns:a="http://schemas.openxmlformats.org/drawingml/2006/main">
               <a:ext uri="{FF2B5EF4-FFF2-40B4-BE49-F238E27FC236}">
-                <a16:creationId xmlns:a16="http://schemas.microsoft.com/office/drawing/2014/main" id="{BFDCB41E-8B52-42E3-BD3E-D576FF9DE8E7}"/>
+                <a16:creationId xmlns:a16="http://schemas.microsoft.com/office/drawing/2014/main" id="{5BA027C6-C786-4B2D-A684-A7D1A117FD5C}"/>
               </a:ext>
             </a:extLst>
           </p:cNvPr>
@@ -7536,7 +7536,7 @@
           <p:cNvPr id="20" name="">
             <a:extLst xmlns:a="http://schemas.openxmlformats.org/drawingml/2006/main">
               <a:ext uri="{FF2B5EF4-FFF2-40B4-BE49-F238E27FC236}">
-                <a16:creationId xmlns:a16="http://schemas.microsoft.com/office/drawing/2014/main" id="{F5985D1F-DA5A-441E-9275-3058A92A79E9}"/>
+                <a16:creationId xmlns:a16="http://schemas.microsoft.com/office/drawing/2014/main" id="{69733634-7E3B-4235-87A0-7627436DA43D}"/>
               </a:ext>
             </a:extLst>
           </p:cNvPr>
@@ -7682,7 +7682,7 @@
                 <a:latin typeface="Avenir Next"/>
                 <a:ea typeface="Avenir Next"/>
                 <a:cs typeface="Avenir Next"/>
-                <a:hlinkClick xmlns:r="http://schemas.openxmlformats.org/officeDocument/2006/relationships" r:id="R4806752dcb584010"/>
+                <a:hlinkClick xmlns:r="http://schemas.openxmlformats.org/officeDocument/2006/relationships" r:id="R799c12652e4740ed"/>
               </a:rPr>
               <a:t>Repositorio y código</a:t>
             </a:r>
@@ -7692,7 +7692,7 @@
     </p:spTree>
     <p:extLst>
       <p:ext uri="{BB962C8B-B14F-4D97-AF65-F5344CB8AC3E}">
-        <p14:creationId xmlns:p14="http://schemas.microsoft.com/office/powerpoint/2010/main" val="266309823"/>
+        <p14:creationId xmlns:p14="http://schemas.microsoft.com/office/powerpoint/2010/main" val="1404349858"/>
       </p:ext>
     </p:extLst>
   </p:cSld>
@@ -7723,7 +7723,7 @@
           <p:cNvPr id="17" name="">
             <a:extLst xmlns:a="http://schemas.openxmlformats.org/drawingml/2006/main">
               <a:ext uri="{FF2B5EF4-FFF2-40B4-BE49-F238E27FC236}">
-                <a16:creationId xmlns:a16="http://schemas.microsoft.com/office/drawing/2014/main" id="{B45715CA-0082-4F3E-8F31-8127C135DFEC}"/>
+                <a16:creationId xmlns:a16="http://schemas.microsoft.com/office/drawing/2014/main" id="{6ABD00AB-C990-4036-BE8E-98EA3D7E74D4}"/>
               </a:ext>
             </a:extLst>
           </p:cNvPr>
@@ -7754,7 +7754,7 @@
           <p:cNvPr id="2" name="">
             <a:extLst xmlns:a="http://schemas.openxmlformats.org/drawingml/2006/main">
               <a:ext uri="{FF2B5EF4-FFF2-40B4-BE49-F238E27FC236}">
-                <a16:creationId xmlns:a16="http://schemas.microsoft.com/office/drawing/2014/main" id="{E8A35F16-79F6-4930-8CE2-493441605333}"/>
+                <a16:creationId xmlns:a16="http://schemas.microsoft.com/office/drawing/2014/main" id="{773B7EA3-D606-4D85-B20D-D79ED29FAC62}"/>
               </a:ext>
             </a:extLst>
           </p:cNvPr>
@@ -7911,7 +7911,7 @@
           <p:cNvPr id="3" name="">
             <a:extLst xmlns:a="http://schemas.openxmlformats.org/drawingml/2006/main">
               <a:ext uri="{FF2B5EF4-FFF2-40B4-BE49-F238E27FC236}">
-                <a16:creationId xmlns:a16="http://schemas.microsoft.com/office/drawing/2014/main" id="{1F80D2AF-1D6A-4367-B064-3EF212C64531}"/>
+                <a16:creationId xmlns:a16="http://schemas.microsoft.com/office/drawing/2014/main" id="{3063DD09-B653-4DC8-AF77-97AEDB6CF4E8}"/>
               </a:ext>
             </a:extLst>
           </p:cNvPr>
@@ -8068,7 +8068,7 @@
           <p:cNvPr id="4" name="">
             <a:extLst xmlns:a="http://schemas.openxmlformats.org/drawingml/2006/main">
               <a:ext uri="{FF2B5EF4-FFF2-40B4-BE49-F238E27FC236}">
-                <a16:creationId xmlns:a16="http://schemas.microsoft.com/office/drawing/2014/main" id="{FC78ADDF-109F-49DE-92EB-120B4C44F898}"/>
+                <a16:creationId xmlns:a16="http://schemas.microsoft.com/office/drawing/2014/main" id="{4EFC2CB9-4738-469A-A31F-D122AB27D559}"/>
               </a:ext>
             </a:extLst>
           </p:cNvPr>
@@ -8225,7 +8225,7 @@
           <p:cNvPr id="5" name="">
             <a:extLst xmlns:a="http://schemas.openxmlformats.org/drawingml/2006/main">
               <a:ext uri="{FF2B5EF4-FFF2-40B4-BE49-F238E27FC236}">
-                <a16:creationId xmlns:a16="http://schemas.microsoft.com/office/drawing/2014/main" id="{35CB200E-FC9B-4396-ADDE-247DD31AB330}"/>
+                <a16:creationId xmlns:a16="http://schemas.microsoft.com/office/drawing/2014/main" id="{13E28022-AE8C-4FC2-8B48-1CFEE258BC3A}"/>
               </a:ext>
             </a:extLst>
           </p:cNvPr>
@@ -8256,7 +8256,7 @@
           <p:cNvPr id="6" name="">
             <a:extLst xmlns:a="http://schemas.openxmlformats.org/drawingml/2006/main">
               <a:ext uri="{FF2B5EF4-FFF2-40B4-BE49-F238E27FC236}">
-                <a16:creationId xmlns:a16="http://schemas.microsoft.com/office/drawing/2014/main" id="{C5124682-360C-47B8-855C-0CD3F5F0F96D}"/>
+                <a16:creationId xmlns:a16="http://schemas.microsoft.com/office/drawing/2014/main" id="{86A92C07-4FDE-48EE-9FFB-E22987E69622}"/>
               </a:ext>
             </a:extLst>
           </p:cNvPr>
@@ -8413,7 +8413,7 @@
           <p:cNvPr id="7" name="">
             <a:extLst xmlns:a="http://schemas.openxmlformats.org/drawingml/2006/main">
               <a:ext uri="{FF2B5EF4-FFF2-40B4-BE49-F238E27FC236}">
-                <a16:creationId xmlns:a16="http://schemas.microsoft.com/office/drawing/2014/main" id="{5FD9ADDC-CCF6-4234-A6B7-D51F8E5ED783}"/>
+                <a16:creationId xmlns:a16="http://schemas.microsoft.com/office/drawing/2014/main" id="{FA8599F2-B53A-40A5-AB78-6AB2DA0B7324}"/>
               </a:ext>
             </a:extLst>
           </p:cNvPr>
@@ -8570,7 +8570,7 @@
           <p:cNvPr id="8" name="">
             <a:extLst xmlns:a="http://schemas.openxmlformats.org/drawingml/2006/main">
               <a:ext uri="{FF2B5EF4-FFF2-40B4-BE49-F238E27FC236}">
-                <a16:creationId xmlns:a16="http://schemas.microsoft.com/office/drawing/2014/main" id="{AC3B163F-BBCD-4527-A805-FFCC65348F4E}"/>
+                <a16:creationId xmlns:a16="http://schemas.microsoft.com/office/drawing/2014/main" id="{F04BEED5-6900-4D12-8769-D6F3C3077149}"/>
               </a:ext>
             </a:extLst>
           </p:cNvPr>
@@ -8603,7 +8603,7 @@
           <p:cNvPr id="9" name="">
             <a:extLst xmlns:a="http://schemas.openxmlformats.org/drawingml/2006/main">
               <a:ext uri="{FF2B5EF4-FFF2-40B4-BE49-F238E27FC236}">
-                <a16:creationId xmlns:a16="http://schemas.microsoft.com/office/drawing/2014/main" id="{1C36CD13-C084-4E4E-85AD-C28A97F4306E}"/>
+                <a16:creationId xmlns:a16="http://schemas.microsoft.com/office/drawing/2014/main" id="{CD5E5E9D-42BE-414F-879F-6CDB684395E7}"/>
               </a:ext>
             </a:extLst>
           </p:cNvPr>
@@ -8760,7 +8760,7 @@
           <p:cNvPr id="10" name="">
             <a:extLst xmlns:a="http://schemas.openxmlformats.org/drawingml/2006/main">
               <a:ext uri="{FF2B5EF4-FFF2-40B4-BE49-F238E27FC236}">
-                <a16:creationId xmlns:a16="http://schemas.microsoft.com/office/drawing/2014/main" id="{67C4BDBC-0FB6-430A-A131-1270DF82F6C1}"/>
+                <a16:creationId xmlns:a16="http://schemas.microsoft.com/office/drawing/2014/main" id="{8F391FCD-A1AB-4503-AF0F-CFBAA4AC818D}"/>
               </a:ext>
             </a:extLst>
           </p:cNvPr>
@@ -8940,7 +8940,7 @@
           <p:cNvPr id="11" name="">
             <a:extLst xmlns:a="http://schemas.openxmlformats.org/drawingml/2006/main">
               <a:ext uri="{FF2B5EF4-FFF2-40B4-BE49-F238E27FC236}">
-                <a16:creationId xmlns:a16="http://schemas.microsoft.com/office/drawing/2014/main" id="{112BB242-04B4-4173-950D-615506E71FED}"/>
+                <a16:creationId xmlns:a16="http://schemas.microsoft.com/office/drawing/2014/main" id="{8A8FFDFC-8BAA-4A15-8DC8-C2E460249256}"/>
               </a:ext>
             </a:extLst>
           </p:cNvPr>
@@ -8973,7 +8973,7 @@
           <p:cNvPr id="12" name="">
             <a:extLst xmlns:a="http://schemas.openxmlformats.org/drawingml/2006/main">
               <a:ext uri="{FF2B5EF4-FFF2-40B4-BE49-F238E27FC236}">
-                <a16:creationId xmlns:a16="http://schemas.microsoft.com/office/drawing/2014/main" id="{5ED615E4-3B7F-4470-AD6B-EA441F2D8113}"/>
+                <a16:creationId xmlns:a16="http://schemas.microsoft.com/office/drawing/2014/main" id="{F7B301EC-2BD2-432B-97DA-9588FEE076BB}"/>
               </a:ext>
             </a:extLst>
           </p:cNvPr>
@@ -9130,7 +9130,7 @@
           <p:cNvPr id="13" name="">
             <a:extLst xmlns:a="http://schemas.openxmlformats.org/drawingml/2006/main">
               <a:ext uri="{FF2B5EF4-FFF2-40B4-BE49-F238E27FC236}">
-                <a16:creationId xmlns:a16="http://schemas.microsoft.com/office/drawing/2014/main" id="{5BFB7C07-809D-49C6-82CF-C0AE6F3D37EE}"/>
+                <a16:creationId xmlns:a16="http://schemas.microsoft.com/office/drawing/2014/main" id="{BCCEBE40-2C49-4D5A-81C4-450CF5983EE9}"/>
               </a:ext>
             </a:extLst>
           </p:cNvPr>
@@ -9310,7 +9310,7 @@
           <p:cNvPr id="14" name="">
             <a:extLst xmlns:a="http://schemas.openxmlformats.org/drawingml/2006/main">
               <a:ext uri="{FF2B5EF4-FFF2-40B4-BE49-F238E27FC236}">
-                <a16:creationId xmlns:a16="http://schemas.microsoft.com/office/drawing/2014/main" id="{740E4489-5448-4CAC-BEA2-9AE322293655}"/>
+                <a16:creationId xmlns:a16="http://schemas.microsoft.com/office/drawing/2014/main" id="{86935C14-9885-472D-A66E-F7724F508192}"/>
               </a:ext>
             </a:extLst>
           </p:cNvPr>
@@ -9343,7 +9343,7 @@
           <p:cNvPr id="15" name="">
             <a:extLst xmlns:a="http://schemas.openxmlformats.org/drawingml/2006/main">
               <a:ext uri="{FF2B5EF4-FFF2-40B4-BE49-F238E27FC236}">
-                <a16:creationId xmlns:a16="http://schemas.microsoft.com/office/drawing/2014/main" id="{17453D5E-3EF9-4F22-9EA6-3CB313486BF2}"/>
+                <a16:creationId xmlns:a16="http://schemas.microsoft.com/office/drawing/2014/main" id="{E12216DA-CCDE-4F9C-9020-15C08D94EC80}"/>
               </a:ext>
             </a:extLst>
           </p:cNvPr>
@@ -9353,7 +9353,7 @@
           <p:nvPr/>
         </p:nvPicPr>
         <p:blipFill>
-          <a:blip xmlns:r="http://schemas.openxmlformats.org/officeDocument/2006/relationships" xmlns:a="http://schemas.openxmlformats.org/drawingml/2006/main" r:embed="R3cd2cc70dc0e4359"/>
+          <a:blip xmlns:r="http://schemas.openxmlformats.org/officeDocument/2006/relationships" xmlns:a="http://schemas.openxmlformats.org/drawingml/2006/main" r:embed="Rf1f36bfb1f0c4ef2"/>
           <a:stretch xmlns:a="http://schemas.openxmlformats.org/drawingml/2006/main"/>
         </p:blipFill>
         <p:spPr>
@@ -9373,7 +9373,7 @@
           <p:cNvPr id="16" name="">
             <a:extLst xmlns:a="http://schemas.openxmlformats.org/drawingml/2006/main">
               <a:ext uri="{FF2B5EF4-FFF2-40B4-BE49-F238E27FC236}">
-                <a16:creationId xmlns:a16="http://schemas.microsoft.com/office/drawing/2014/main" id="{6230025D-D6A4-4735-BE03-90CAF3454DA7}"/>
+                <a16:creationId xmlns:a16="http://schemas.microsoft.com/office/drawing/2014/main" id="{D1BF61CA-AB59-4D9B-B722-7D9375756666}"/>
               </a:ext>
             </a:extLst>
           </p:cNvPr>
@@ -9528,7 +9528,7 @@
     </p:spTree>
     <p:extLst>
       <p:ext uri="{BB962C8B-B14F-4D97-AF65-F5344CB8AC3E}">
-        <p14:creationId xmlns:p14="http://schemas.microsoft.com/office/powerpoint/2010/main" val="297995531"/>
+        <p14:creationId xmlns:p14="http://schemas.microsoft.com/office/powerpoint/2010/main" val="1096057734"/>
       </p:ext>
     </p:extLst>
   </p:cSld>
@@ -9559,7 +9559,7 @@
           <p:cNvPr id="25" name="">
             <a:extLst xmlns:a="http://schemas.openxmlformats.org/drawingml/2006/main">
               <a:ext uri="{FF2B5EF4-FFF2-40B4-BE49-F238E27FC236}">
-                <a16:creationId xmlns:a16="http://schemas.microsoft.com/office/drawing/2014/main" id="{BA89003B-FAC4-424A-8C2E-FD45278ECD1B}"/>
+                <a16:creationId xmlns:a16="http://schemas.microsoft.com/office/drawing/2014/main" id="{074EE560-4428-41D5-8719-9AD84B727C75}"/>
               </a:ext>
             </a:extLst>
           </p:cNvPr>
@@ -9590,7 +9590,7 @@
           <p:cNvPr id="2" name="">
             <a:extLst xmlns:a="http://schemas.openxmlformats.org/drawingml/2006/main">
               <a:ext uri="{FF2B5EF4-FFF2-40B4-BE49-F238E27FC236}">
-                <a16:creationId xmlns:a16="http://schemas.microsoft.com/office/drawing/2014/main" id="{894F8111-08E4-4FF1-B8AE-8A098F9F431B}"/>
+                <a16:creationId xmlns:a16="http://schemas.microsoft.com/office/drawing/2014/main" id="{A48C219C-31E4-4EB0-B742-3453A94083DC}"/>
               </a:ext>
             </a:extLst>
           </p:cNvPr>
@@ -9747,7 +9747,7 @@
           <p:cNvPr id="3" name="">
             <a:extLst xmlns:a="http://schemas.openxmlformats.org/drawingml/2006/main">
               <a:ext uri="{FF2B5EF4-FFF2-40B4-BE49-F238E27FC236}">
-                <a16:creationId xmlns:a16="http://schemas.microsoft.com/office/drawing/2014/main" id="{E5A3C824-0369-4BBF-A999-B0988B2D6089}"/>
+                <a16:creationId xmlns:a16="http://schemas.microsoft.com/office/drawing/2014/main" id="{8242EC58-8302-4417-B2DF-35BE254FEDB5}"/>
               </a:ext>
             </a:extLst>
           </p:cNvPr>
@@ -9904,7 +9904,7 @@
           <p:cNvPr id="4" name="">
             <a:extLst xmlns:a="http://schemas.openxmlformats.org/drawingml/2006/main">
               <a:ext uri="{FF2B5EF4-FFF2-40B4-BE49-F238E27FC236}">
-                <a16:creationId xmlns:a16="http://schemas.microsoft.com/office/drawing/2014/main" id="{0AD0977D-5916-485A-9B1F-6FF81C35EFEA}"/>
+                <a16:creationId xmlns:a16="http://schemas.microsoft.com/office/drawing/2014/main" id="{32B2ED0B-356C-4D7B-A92E-721B8D6D9CB0}"/>
               </a:ext>
             </a:extLst>
           </p:cNvPr>
@@ -10061,7 +10061,7 @@
           <p:cNvPr id="5" name="">
             <a:extLst xmlns:a="http://schemas.openxmlformats.org/drawingml/2006/main">
               <a:ext uri="{FF2B5EF4-FFF2-40B4-BE49-F238E27FC236}">
-                <a16:creationId xmlns:a16="http://schemas.microsoft.com/office/drawing/2014/main" id="{D7340A2F-62EB-4C24-B113-8836A27E1D90}"/>
+                <a16:creationId xmlns:a16="http://schemas.microsoft.com/office/drawing/2014/main" id="{AA67E6B0-D683-44E6-8318-288AFBE4D830}"/>
               </a:ext>
             </a:extLst>
           </p:cNvPr>
@@ -10092,7 +10092,7 @@
           <p:cNvPr id="6" name="">
             <a:extLst xmlns:a="http://schemas.openxmlformats.org/drawingml/2006/main">
               <a:ext uri="{FF2B5EF4-FFF2-40B4-BE49-F238E27FC236}">
-                <a16:creationId xmlns:a16="http://schemas.microsoft.com/office/drawing/2014/main" id="{9ECAFC0B-5AA0-40CB-ABEA-C6CBC3F0E989}"/>
+                <a16:creationId xmlns:a16="http://schemas.microsoft.com/office/drawing/2014/main" id="{2C070871-CD12-4A59-9D71-2B8F6DC72FC3}"/>
               </a:ext>
             </a:extLst>
           </p:cNvPr>
@@ -10249,7 +10249,7 @@
           <p:cNvPr id="7" name="">
             <a:extLst xmlns:a="http://schemas.openxmlformats.org/drawingml/2006/main">
               <a:ext uri="{FF2B5EF4-FFF2-40B4-BE49-F238E27FC236}">
-                <a16:creationId xmlns:a16="http://schemas.microsoft.com/office/drawing/2014/main" id="{7B22852B-9171-4B07-8A94-767DDA5A66F1}"/>
+                <a16:creationId xmlns:a16="http://schemas.microsoft.com/office/drawing/2014/main" id="{FAE81EF2-17C4-4B61-9E6F-98BD59E9E160}"/>
               </a:ext>
             </a:extLst>
           </p:cNvPr>
@@ -10406,7 +10406,7 @@
           <p:cNvPr id="8" name="">
             <a:extLst xmlns:a="http://schemas.openxmlformats.org/drawingml/2006/main">
               <a:ext uri="{FF2B5EF4-FFF2-40B4-BE49-F238E27FC236}">
-                <a16:creationId xmlns:a16="http://schemas.microsoft.com/office/drawing/2014/main" id="{983ECC4E-00FB-4760-A62C-0CE08B458FDD}"/>
+                <a16:creationId xmlns:a16="http://schemas.microsoft.com/office/drawing/2014/main" id="{74390A9C-890D-4BE3-B61B-7E3CB9B61AE5}"/>
               </a:ext>
             </a:extLst>
           </p:cNvPr>
@@ -10437,7 +10437,7 @@
           <p:cNvPr id="9" name="">
             <a:extLst xmlns:a="http://schemas.openxmlformats.org/drawingml/2006/main">
               <a:ext uri="{FF2B5EF4-FFF2-40B4-BE49-F238E27FC236}">
-                <a16:creationId xmlns:a16="http://schemas.microsoft.com/office/drawing/2014/main" id="{28D172FC-8135-44C2-A798-21BE5D4F4DDA}"/>
+                <a16:creationId xmlns:a16="http://schemas.microsoft.com/office/drawing/2014/main" id="{29F89054-5794-4280-9854-E5B586E9ED9A}"/>
               </a:ext>
             </a:extLst>
           </p:cNvPr>
@@ -10470,7 +10470,7 @@
           <p:cNvPr id="10" name="">
             <a:extLst xmlns:a="http://schemas.openxmlformats.org/drawingml/2006/main">
               <a:ext uri="{FF2B5EF4-FFF2-40B4-BE49-F238E27FC236}">
-                <a16:creationId xmlns:a16="http://schemas.microsoft.com/office/drawing/2014/main" id="{940EE346-09B8-468B-855A-AFCE4F44780B}"/>
+                <a16:creationId xmlns:a16="http://schemas.microsoft.com/office/drawing/2014/main" id="{B2EB733E-5C20-44BD-B134-E8E11F4417C7}"/>
               </a:ext>
             </a:extLst>
           </p:cNvPr>
@@ -10503,7 +10503,7 @@
           <p:cNvPr id="11" name="">
             <a:extLst xmlns:a="http://schemas.openxmlformats.org/drawingml/2006/main">
               <a:ext uri="{FF2B5EF4-FFF2-40B4-BE49-F238E27FC236}">
-                <a16:creationId xmlns:a16="http://schemas.microsoft.com/office/drawing/2014/main" id="{DD8C5548-E121-40D2-9F1B-4D1C87D0C8BA}"/>
+                <a16:creationId xmlns:a16="http://schemas.microsoft.com/office/drawing/2014/main" id="{F54B20AE-741D-4ED2-BB48-8F9430B4792F}"/>
               </a:ext>
             </a:extLst>
           </p:cNvPr>
@@ -10660,7 +10660,7 @@
           <p:cNvPr id="12" name="">
             <a:extLst xmlns:a="http://schemas.openxmlformats.org/drawingml/2006/main">
               <a:ext uri="{FF2B5EF4-FFF2-40B4-BE49-F238E27FC236}">
-                <a16:creationId xmlns:a16="http://schemas.microsoft.com/office/drawing/2014/main" id="{EC665DE1-90B2-496C-B01D-35856E6FBA1B}"/>
+                <a16:creationId xmlns:a16="http://schemas.microsoft.com/office/drawing/2014/main" id="{D9FB5FBB-3616-408D-8664-360A3B4AABF5}"/>
               </a:ext>
             </a:extLst>
           </p:cNvPr>
@@ -10817,7 +10817,7 @@
           <p:cNvPr id="13" name="">
             <a:extLst xmlns:a="http://schemas.openxmlformats.org/drawingml/2006/main">
               <a:ext uri="{FF2B5EF4-FFF2-40B4-BE49-F238E27FC236}">
-                <a16:creationId xmlns:a16="http://schemas.microsoft.com/office/drawing/2014/main" id="{83EFA215-7C9E-41D6-8C98-0B8E309F5C56}"/>
+                <a16:creationId xmlns:a16="http://schemas.microsoft.com/office/drawing/2014/main" id="{008C85E3-8B2D-47C4-B71B-CDF7AB68621D}"/>
               </a:ext>
             </a:extLst>
           </p:cNvPr>
@@ -10997,7 +10997,7 @@
           <p:cNvPr id="14" name="">
             <a:extLst xmlns:a="http://schemas.openxmlformats.org/drawingml/2006/main">
               <a:ext uri="{FF2B5EF4-FFF2-40B4-BE49-F238E27FC236}">
-                <a16:creationId xmlns:a16="http://schemas.microsoft.com/office/drawing/2014/main" id="{7946604A-50AF-4196-9C81-E6D480FF6C40}"/>
+                <a16:creationId xmlns:a16="http://schemas.microsoft.com/office/drawing/2014/main" id="{EADC3DF6-C6A8-474A-A693-E31C47A18527}"/>
               </a:ext>
             </a:extLst>
           </p:cNvPr>
@@ -11030,7 +11030,7 @@
           <p:cNvPr id="15" name="">
             <a:extLst xmlns:a="http://schemas.openxmlformats.org/drawingml/2006/main">
               <a:ext uri="{FF2B5EF4-FFF2-40B4-BE49-F238E27FC236}">
-                <a16:creationId xmlns:a16="http://schemas.microsoft.com/office/drawing/2014/main" id="{98B385CF-3091-497A-A23B-DD40B72A7172}"/>
+                <a16:creationId xmlns:a16="http://schemas.microsoft.com/office/drawing/2014/main" id="{258E5521-091A-4EA7-A56C-BF06A9BF3FF4}"/>
               </a:ext>
             </a:extLst>
           </p:cNvPr>
@@ -11063,7 +11063,7 @@
           <p:cNvPr id="16" name="">
             <a:extLst xmlns:a="http://schemas.openxmlformats.org/drawingml/2006/main">
               <a:ext uri="{FF2B5EF4-FFF2-40B4-BE49-F238E27FC236}">
-                <a16:creationId xmlns:a16="http://schemas.microsoft.com/office/drawing/2014/main" id="{746378D8-59DA-4F6E-8580-701E1B3A4213}"/>
+                <a16:creationId xmlns:a16="http://schemas.microsoft.com/office/drawing/2014/main" id="{D97E5A33-36F1-48E0-98E9-42EDFFA0D734}"/>
               </a:ext>
             </a:extLst>
           </p:cNvPr>
@@ -11220,7 +11220,7 @@
           <p:cNvPr id="17" name="">
             <a:extLst xmlns:a="http://schemas.openxmlformats.org/drawingml/2006/main">
               <a:ext uri="{FF2B5EF4-FFF2-40B4-BE49-F238E27FC236}">
-                <a16:creationId xmlns:a16="http://schemas.microsoft.com/office/drawing/2014/main" id="{F94806C6-7699-4541-B276-18D6E694924F}"/>
+                <a16:creationId xmlns:a16="http://schemas.microsoft.com/office/drawing/2014/main" id="{B608B87E-948D-4BB2-8FE3-47242BF1BDBC}"/>
               </a:ext>
             </a:extLst>
           </p:cNvPr>
@@ -11377,7 +11377,7 @@
           <p:cNvPr id="18" name="">
             <a:extLst xmlns:a="http://schemas.openxmlformats.org/drawingml/2006/main">
               <a:ext uri="{FF2B5EF4-FFF2-40B4-BE49-F238E27FC236}">
-                <a16:creationId xmlns:a16="http://schemas.microsoft.com/office/drawing/2014/main" id="{3DB5B63F-581E-4EF6-85CE-831A17416159}"/>
+                <a16:creationId xmlns:a16="http://schemas.microsoft.com/office/drawing/2014/main" id="{A54258FD-1AF5-42FD-AE9E-B9E28990A41A}"/>
               </a:ext>
             </a:extLst>
           </p:cNvPr>
@@ -11557,7 +11557,7 @@
           <p:cNvPr id="19" name="">
             <a:extLst xmlns:a="http://schemas.openxmlformats.org/drawingml/2006/main">
               <a:ext uri="{FF2B5EF4-FFF2-40B4-BE49-F238E27FC236}">
-                <a16:creationId xmlns:a16="http://schemas.microsoft.com/office/drawing/2014/main" id="{8CE3427E-83BE-4B10-8D55-5A8D2266A1C6}"/>
+                <a16:creationId xmlns:a16="http://schemas.microsoft.com/office/drawing/2014/main" id="{2F982C4E-BAB5-4FB1-9527-A3ABAAE0C341}"/>
               </a:ext>
             </a:extLst>
           </p:cNvPr>
@@ -11590,7 +11590,7 @@
           <p:cNvPr id="20" name="">
             <a:extLst xmlns:a="http://schemas.openxmlformats.org/drawingml/2006/main">
               <a:ext uri="{FF2B5EF4-FFF2-40B4-BE49-F238E27FC236}">
-                <a16:creationId xmlns:a16="http://schemas.microsoft.com/office/drawing/2014/main" id="{86E77652-F962-40BB-BBD8-3929A56829B7}"/>
+                <a16:creationId xmlns:a16="http://schemas.microsoft.com/office/drawing/2014/main" id="{1E62395F-9199-47D8-8F17-63AF1B0360A2}"/>
               </a:ext>
             </a:extLst>
           </p:cNvPr>
@@ -11623,7 +11623,7 @@
           <p:cNvPr id="21" name="">
             <a:extLst xmlns:a="http://schemas.openxmlformats.org/drawingml/2006/main">
               <a:ext uri="{FF2B5EF4-FFF2-40B4-BE49-F238E27FC236}">
-                <a16:creationId xmlns:a16="http://schemas.microsoft.com/office/drawing/2014/main" id="{AA601801-3FE3-497C-9419-A12A25FE5731}"/>
+                <a16:creationId xmlns:a16="http://schemas.microsoft.com/office/drawing/2014/main" id="{45716F94-EC6F-4C2F-97C3-A907174DE3E1}"/>
               </a:ext>
             </a:extLst>
           </p:cNvPr>
@@ -11780,7 +11780,7 @@
           <p:cNvPr id="22" name="">
             <a:extLst xmlns:a="http://schemas.openxmlformats.org/drawingml/2006/main">
               <a:ext uri="{FF2B5EF4-FFF2-40B4-BE49-F238E27FC236}">
-                <a16:creationId xmlns:a16="http://schemas.microsoft.com/office/drawing/2014/main" id="{CB30D92C-5266-433D-A181-C56F1FFF6D86}"/>
+                <a16:creationId xmlns:a16="http://schemas.microsoft.com/office/drawing/2014/main" id="{55444597-B890-49D3-AEBE-FC295AE1A83E}"/>
               </a:ext>
             </a:extLst>
           </p:cNvPr>
@@ -11937,7 +11937,7 @@
           <p:cNvPr id="23" name="">
             <a:extLst xmlns:a="http://schemas.openxmlformats.org/drawingml/2006/main">
               <a:ext uri="{FF2B5EF4-FFF2-40B4-BE49-F238E27FC236}">
-                <a16:creationId xmlns:a16="http://schemas.microsoft.com/office/drawing/2014/main" id="{54AD67B2-10EE-4F6D-AAE9-8FE40E3AEF29}"/>
+                <a16:creationId xmlns:a16="http://schemas.microsoft.com/office/drawing/2014/main" id="{B404D969-1A5B-4C6E-BF8C-14270B925437}"/>
               </a:ext>
             </a:extLst>
           </p:cNvPr>
@@ -12117,7 +12117,7 @@
           <p:cNvPr id="24" name="">
             <a:extLst xmlns:a="http://schemas.openxmlformats.org/drawingml/2006/main">
               <a:ext uri="{FF2B5EF4-FFF2-40B4-BE49-F238E27FC236}">
-                <a16:creationId xmlns:a16="http://schemas.microsoft.com/office/drawing/2014/main" id="{8BAE538D-09C2-40BE-9D1B-3A7D825F4882}"/>
+                <a16:creationId xmlns:a16="http://schemas.microsoft.com/office/drawing/2014/main" id="{FEA9B161-2863-4B3B-98DE-F792CCF1CCE4}"/>
               </a:ext>
             </a:extLst>
           </p:cNvPr>
@@ -12272,7 +12272,7 @@
     </p:spTree>
     <p:extLst>
       <p:ext uri="{BB962C8B-B14F-4D97-AF65-F5344CB8AC3E}">
-        <p14:creationId xmlns:p14="http://schemas.microsoft.com/office/powerpoint/2010/main" val="2133140859"/>
+        <p14:creationId xmlns:p14="http://schemas.microsoft.com/office/powerpoint/2010/main" val="287843285"/>
       </p:ext>
     </p:extLst>
   </p:cSld>
@@ -12303,7 +12303,7 @@
           <p:cNvPr id="34" name="">
             <a:extLst xmlns:a="http://schemas.openxmlformats.org/drawingml/2006/main">
               <a:ext uri="{FF2B5EF4-FFF2-40B4-BE49-F238E27FC236}">
-                <a16:creationId xmlns:a16="http://schemas.microsoft.com/office/drawing/2014/main" id="{57DAC29D-7EAC-4D42-A77F-866EF82EA39F}"/>
+                <a16:creationId xmlns:a16="http://schemas.microsoft.com/office/drawing/2014/main" id="{5A87909D-64C2-4D25-8F82-D2A360DDAE47}"/>
               </a:ext>
             </a:extLst>
           </p:cNvPr>
@@ -12334,7 +12334,7 @@
           <p:cNvPr id="2" name="">
             <a:extLst xmlns:a="http://schemas.openxmlformats.org/drawingml/2006/main">
               <a:ext uri="{FF2B5EF4-FFF2-40B4-BE49-F238E27FC236}">
-                <a16:creationId xmlns:a16="http://schemas.microsoft.com/office/drawing/2014/main" id="{BE2BFD6B-B0ED-4747-9826-7FEAFC8FC433}"/>
+                <a16:creationId xmlns:a16="http://schemas.microsoft.com/office/drawing/2014/main" id="{E4027B97-CD73-43DD-B9CC-FA6D286989E4}"/>
               </a:ext>
             </a:extLst>
           </p:cNvPr>
@@ -12491,7 +12491,7 @@
           <p:cNvPr id="3" name="">
             <a:extLst xmlns:a="http://schemas.openxmlformats.org/drawingml/2006/main">
               <a:ext uri="{FF2B5EF4-FFF2-40B4-BE49-F238E27FC236}">
-                <a16:creationId xmlns:a16="http://schemas.microsoft.com/office/drawing/2014/main" id="{66ED20ED-EF08-4A7E-8D0B-161567D93EFC}"/>
+                <a16:creationId xmlns:a16="http://schemas.microsoft.com/office/drawing/2014/main" id="{FBC7C483-8142-4E4E-94AA-574810E99615}"/>
               </a:ext>
             </a:extLst>
           </p:cNvPr>
@@ -12648,7 +12648,7 @@
           <p:cNvPr id="4" name="">
             <a:extLst xmlns:a="http://schemas.openxmlformats.org/drawingml/2006/main">
               <a:ext uri="{FF2B5EF4-FFF2-40B4-BE49-F238E27FC236}">
-                <a16:creationId xmlns:a16="http://schemas.microsoft.com/office/drawing/2014/main" id="{4CF1DB58-B97C-492E-A1FE-662565D4A9BD}"/>
+                <a16:creationId xmlns:a16="http://schemas.microsoft.com/office/drawing/2014/main" id="{B6C0C35C-DACC-4FE5-8988-DC91E4E0229E}"/>
               </a:ext>
             </a:extLst>
           </p:cNvPr>
@@ -12805,7 +12805,7 @@
           <p:cNvPr id="5" name="">
             <a:extLst xmlns:a="http://schemas.openxmlformats.org/drawingml/2006/main">
               <a:ext uri="{FF2B5EF4-FFF2-40B4-BE49-F238E27FC236}">
-                <a16:creationId xmlns:a16="http://schemas.microsoft.com/office/drawing/2014/main" id="{1EA1C605-D0A2-4A32-B413-57407F6599D8}"/>
+                <a16:creationId xmlns:a16="http://schemas.microsoft.com/office/drawing/2014/main" id="{A2B85224-DFDC-43BF-8D34-34BB47ACD1A5}"/>
               </a:ext>
             </a:extLst>
           </p:cNvPr>
@@ -12836,7 +12836,7 @@
           <p:cNvPr id="6" name="">
             <a:extLst xmlns:a="http://schemas.openxmlformats.org/drawingml/2006/main">
               <a:ext uri="{FF2B5EF4-FFF2-40B4-BE49-F238E27FC236}">
-                <a16:creationId xmlns:a16="http://schemas.microsoft.com/office/drawing/2014/main" id="{FE210207-C79F-4FE0-AD48-3E6D60BB59A5}"/>
+                <a16:creationId xmlns:a16="http://schemas.microsoft.com/office/drawing/2014/main" id="{551C1EA2-2AC3-442D-8688-1E70A4F882DE}"/>
               </a:ext>
             </a:extLst>
           </p:cNvPr>
@@ -12993,7 +12993,7 @@
           <p:cNvPr id="7" name="">
             <a:extLst xmlns:a="http://schemas.openxmlformats.org/drawingml/2006/main">
               <a:ext uri="{FF2B5EF4-FFF2-40B4-BE49-F238E27FC236}">
-                <a16:creationId xmlns:a16="http://schemas.microsoft.com/office/drawing/2014/main" id="{94FF45AC-6852-41FB-AEBC-04C919F5D913}"/>
+                <a16:creationId xmlns:a16="http://schemas.microsoft.com/office/drawing/2014/main" id="{B16B0AB2-E862-47E7-B4C2-B9E8910A0BD3}"/>
               </a:ext>
             </a:extLst>
           </p:cNvPr>
@@ -13150,7 +13150,7 @@
           <p:cNvPr id="8" name="">
             <a:extLst xmlns:a="http://schemas.openxmlformats.org/drawingml/2006/main">
               <a:ext uri="{FF2B5EF4-FFF2-40B4-BE49-F238E27FC236}">
-                <a16:creationId xmlns:a16="http://schemas.microsoft.com/office/drawing/2014/main" id="{2EF2725B-7317-46AB-915C-3C194032DA86}"/>
+                <a16:creationId xmlns:a16="http://schemas.microsoft.com/office/drawing/2014/main" id="{99D425FA-D4BA-4F05-B595-4F24BCB1D2A2}"/>
               </a:ext>
             </a:extLst>
           </p:cNvPr>
@@ -13183,7 +13183,7 @@
           <p:cNvPr id="9" name="">
             <a:extLst xmlns:a="http://schemas.openxmlformats.org/drawingml/2006/main">
               <a:ext uri="{FF2B5EF4-FFF2-40B4-BE49-F238E27FC236}">
-                <a16:creationId xmlns:a16="http://schemas.microsoft.com/office/drawing/2014/main" id="{40D61B9A-760F-4E7A-9B7A-7AC28C303FE0}"/>
+                <a16:creationId xmlns:a16="http://schemas.microsoft.com/office/drawing/2014/main" id="{F7C86884-4DB3-4B57-9912-FDB09D8E2D31}"/>
               </a:ext>
             </a:extLst>
           </p:cNvPr>
@@ -13363,7 +13363,7 @@
           <p:cNvPr id="10" name="">
             <a:extLst xmlns:a="http://schemas.openxmlformats.org/drawingml/2006/main">
               <a:ext uri="{FF2B5EF4-FFF2-40B4-BE49-F238E27FC236}">
-                <a16:creationId xmlns:a16="http://schemas.microsoft.com/office/drawing/2014/main" id="{26340B85-2FB6-4AFE-9F91-73B34094F5D1}"/>
+                <a16:creationId xmlns:a16="http://schemas.microsoft.com/office/drawing/2014/main" id="{B4D72AAA-9B20-4C1E-BA9C-7BB315780922}"/>
               </a:ext>
             </a:extLst>
           </p:cNvPr>
@@ -13520,7 +13520,7 @@
           <p:cNvPr id="11" name="">
             <a:extLst xmlns:a="http://schemas.openxmlformats.org/drawingml/2006/main">
               <a:ext uri="{FF2B5EF4-FFF2-40B4-BE49-F238E27FC236}">
-                <a16:creationId xmlns:a16="http://schemas.microsoft.com/office/drawing/2014/main" id="{36549E45-7E9E-464D-811D-49CA81587482}"/>
+                <a16:creationId xmlns:a16="http://schemas.microsoft.com/office/drawing/2014/main" id="{0234379C-0DA7-4F11-9057-9C7F9F6F0730}"/>
               </a:ext>
             </a:extLst>
           </p:cNvPr>
@@ -13553,7 +13553,7 @@
           <p:cNvPr id="12" name="">
             <a:extLst xmlns:a="http://schemas.openxmlformats.org/drawingml/2006/main">
               <a:ext uri="{FF2B5EF4-FFF2-40B4-BE49-F238E27FC236}">
-                <a16:creationId xmlns:a16="http://schemas.microsoft.com/office/drawing/2014/main" id="{B4554903-A7C6-4638-8B8F-4DB58D933349}"/>
+                <a16:creationId xmlns:a16="http://schemas.microsoft.com/office/drawing/2014/main" id="{69C4A74D-7631-4A50-B632-F37074A61A0A}"/>
               </a:ext>
             </a:extLst>
           </p:cNvPr>
@@ -13733,7 +13733,7 @@
           <p:cNvPr id="13" name="">
             <a:extLst xmlns:a="http://schemas.openxmlformats.org/drawingml/2006/main">
               <a:ext uri="{FF2B5EF4-FFF2-40B4-BE49-F238E27FC236}">
-                <a16:creationId xmlns:a16="http://schemas.microsoft.com/office/drawing/2014/main" id="{952DE5D5-0850-4327-BFDA-C5827B19421A}"/>
+                <a16:creationId xmlns:a16="http://schemas.microsoft.com/office/drawing/2014/main" id="{7C04C8B2-9107-4E5D-A756-3F8EABAC53C8}"/>
               </a:ext>
             </a:extLst>
           </p:cNvPr>
@@ -13890,7 +13890,7 @@
           <p:cNvPr id="14" name="">
             <a:extLst xmlns:a="http://schemas.openxmlformats.org/drawingml/2006/main">
               <a:ext uri="{FF2B5EF4-FFF2-40B4-BE49-F238E27FC236}">
-                <a16:creationId xmlns:a16="http://schemas.microsoft.com/office/drawing/2014/main" id="{273AF873-0B11-4DCC-ACA7-669D0DE4CF91}"/>
+                <a16:creationId xmlns:a16="http://schemas.microsoft.com/office/drawing/2014/main" id="{D059DFB3-E205-4FBE-91CD-7A1844358B42}"/>
               </a:ext>
             </a:extLst>
           </p:cNvPr>
@@ -13923,7 +13923,7 @@
           <p:cNvPr id="15" name="">
             <a:extLst xmlns:a="http://schemas.openxmlformats.org/drawingml/2006/main">
               <a:ext uri="{FF2B5EF4-FFF2-40B4-BE49-F238E27FC236}">
-                <a16:creationId xmlns:a16="http://schemas.microsoft.com/office/drawing/2014/main" id="{D6BCAD0A-C219-4A4E-B048-52593A26497C}"/>
+                <a16:creationId xmlns:a16="http://schemas.microsoft.com/office/drawing/2014/main" id="{0258F0A5-982B-4B83-9DB2-D62982FA3417}"/>
               </a:ext>
             </a:extLst>
           </p:cNvPr>
@@ -14103,7 +14103,7 @@
           <p:cNvPr id="16" name="">
             <a:extLst xmlns:a="http://schemas.openxmlformats.org/drawingml/2006/main">
               <a:ext uri="{FF2B5EF4-FFF2-40B4-BE49-F238E27FC236}">
-                <a16:creationId xmlns:a16="http://schemas.microsoft.com/office/drawing/2014/main" id="{DFB76831-3E11-44B2-A181-31C90EA6BD40}"/>
+                <a16:creationId xmlns:a16="http://schemas.microsoft.com/office/drawing/2014/main" id="{838D7EE6-3762-4BD5-A2D7-C96D3B4DFE8C}"/>
               </a:ext>
             </a:extLst>
           </p:cNvPr>
@@ -14260,7 +14260,7 @@
           <p:cNvPr id="17" name="">
             <a:extLst xmlns:a="http://schemas.openxmlformats.org/drawingml/2006/main">
               <a:ext uri="{FF2B5EF4-FFF2-40B4-BE49-F238E27FC236}">
-                <a16:creationId xmlns:a16="http://schemas.microsoft.com/office/drawing/2014/main" id="{A9E53E54-DE2F-47B2-A3D7-8D2BB4FAE3F9}"/>
+                <a16:creationId xmlns:a16="http://schemas.microsoft.com/office/drawing/2014/main" id="{9135B641-6012-42DF-9242-27C591C66FB1}"/>
               </a:ext>
             </a:extLst>
           </p:cNvPr>
@@ -14293,7 +14293,7 @@
           <p:cNvPr id="18" name="">
             <a:extLst xmlns:a="http://schemas.openxmlformats.org/drawingml/2006/main">
               <a:ext uri="{FF2B5EF4-FFF2-40B4-BE49-F238E27FC236}">
-                <a16:creationId xmlns:a16="http://schemas.microsoft.com/office/drawing/2014/main" id="{DC9EC9A7-8DBC-4852-BF5F-40DD7E5331D7}"/>
+                <a16:creationId xmlns:a16="http://schemas.microsoft.com/office/drawing/2014/main" id="{7EE4EA20-EF93-4D89-ACBB-9988D72E7339}"/>
               </a:ext>
             </a:extLst>
           </p:cNvPr>
@@ -14473,7 +14473,7 @@
           <p:cNvPr id="19" name="">
             <a:extLst xmlns:a="http://schemas.openxmlformats.org/drawingml/2006/main">
               <a:ext uri="{FF2B5EF4-FFF2-40B4-BE49-F238E27FC236}">
-                <a16:creationId xmlns:a16="http://schemas.microsoft.com/office/drawing/2014/main" id="{82D0F496-42BF-4894-8C07-02B3A0CA2B3C}"/>
+                <a16:creationId xmlns:a16="http://schemas.microsoft.com/office/drawing/2014/main" id="{B64ED10C-81FB-4CF4-8034-8065267A7070}"/>
               </a:ext>
             </a:extLst>
           </p:cNvPr>
@@ -14630,7 +14630,7 @@
           <p:cNvPr id="20" name="">
             <a:extLst xmlns:a="http://schemas.openxmlformats.org/drawingml/2006/main">
               <a:ext uri="{FF2B5EF4-FFF2-40B4-BE49-F238E27FC236}">
-                <a16:creationId xmlns:a16="http://schemas.microsoft.com/office/drawing/2014/main" id="{7AD8B9F2-14B9-48C8-A7B6-F5CE473DBCFD}"/>
+                <a16:creationId xmlns:a16="http://schemas.microsoft.com/office/drawing/2014/main" id="{7B801FF2-8E7C-4891-B3B7-2EDA76D8E5BC}"/>
               </a:ext>
             </a:extLst>
           </p:cNvPr>
@@ -14663,7 +14663,7 @@
           <p:cNvPr id="21" name="">
             <a:extLst xmlns:a="http://schemas.openxmlformats.org/drawingml/2006/main">
               <a:ext uri="{FF2B5EF4-FFF2-40B4-BE49-F238E27FC236}">
-                <a16:creationId xmlns:a16="http://schemas.microsoft.com/office/drawing/2014/main" id="{EE949F94-3C28-4D45-B4F2-70298435303C}"/>
+                <a16:creationId xmlns:a16="http://schemas.microsoft.com/office/drawing/2014/main" id="{9D9649C1-9BD8-4CD7-AA2F-B18294FEA9AD}"/>
               </a:ext>
             </a:extLst>
           </p:cNvPr>
@@ -14820,7 +14820,7 @@
           <p:cNvPr id="22" name="">
             <a:extLst xmlns:a="http://schemas.openxmlformats.org/drawingml/2006/main">
               <a:ext uri="{FF2B5EF4-FFF2-40B4-BE49-F238E27FC236}">
-                <a16:creationId xmlns:a16="http://schemas.microsoft.com/office/drawing/2014/main" id="{9EAE3316-44B4-41EF-8422-1124BFE038BF}"/>
+                <a16:creationId xmlns:a16="http://schemas.microsoft.com/office/drawing/2014/main" id="{65098E63-6F51-49DC-AC75-185A0E493449}"/>
               </a:ext>
             </a:extLst>
           </p:cNvPr>
@@ -14977,7 +14977,7 @@
           <p:cNvPr id="23" name="">
             <a:extLst xmlns:a="http://schemas.openxmlformats.org/drawingml/2006/main">
               <a:ext uri="{FF2B5EF4-FFF2-40B4-BE49-F238E27FC236}">
-                <a16:creationId xmlns:a16="http://schemas.microsoft.com/office/drawing/2014/main" id="{6C16830A-2A4B-4B01-858C-5762AB30F61F}"/>
+                <a16:creationId xmlns:a16="http://schemas.microsoft.com/office/drawing/2014/main" id="{7883AA84-37F7-4886-8DAD-D4C30499DC46}"/>
               </a:ext>
             </a:extLst>
           </p:cNvPr>
@@ -15010,7 +15010,7 @@
           <p:cNvPr id="24" name="">
             <a:extLst xmlns:a="http://schemas.openxmlformats.org/drawingml/2006/main">
               <a:ext uri="{FF2B5EF4-FFF2-40B4-BE49-F238E27FC236}">
-                <a16:creationId xmlns:a16="http://schemas.microsoft.com/office/drawing/2014/main" id="{161A2DBA-CB60-40F8-A2AC-75EE47D7AE70}"/>
+                <a16:creationId xmlns:a16="http://schemas.microsoft.com/office/drawing/2014/main" id="{99AA7137-9001-476F-897A-3C3D87C2D3D4}"/>
               </a:ext>
             </a:extLst>
           </p:cNvPr>
@@ -15167,7 +15167,7 @@
           <p:cNvPr id="25" name="">
             <a:extLst xmlns:a="http://schemas.openxmlformats.org/drawingml/2006/main">
               <a:ext uri="{FF2B5EF4-FFF2-40B4-BE49-F238E27FC236}">
-                <a16:creationId xmlns:a16="http://schemas.microsoft.com/office/drawing/2014/main" id="{0E70D69F-94F6-43DA-87BD-6F1817AEB2C9}"/>
+                <a16:creationId xmlns:a16="http://schemas.microsoft.com/office/drawing/2014/main" id="{8480AD5B-E4DF-452D-A639-1080E71FC2C7}"/>
               </a:ext>
             </a:extLst>
           </p:cNvPr>
@@ -15324,7 +15324,7 @@
           <p:cNvPr id="26" name="">
             <a:extLst xmlns:a="http://schemas.openxmlformats.org/drawingml/2006/main">
               <a:ext uri="{FF2B5EF4-FFF2-40B4-BE49-F238E27FC236}">
-                <a16:creationId xmlns:a16="http://schemas.microsoft.com/office/drawing/2014/main" id="{102E3856-7212-4F1B-BED6-48F8DE5FBA75}"/>
+                <a16:creationId xmlns:a16="http://schemas.microsoft.com/office/drawing/2014/main" id="{3E9ECF40-B23B-438D-9337-69F10EB75CB3}"/>
               </a:ext>
             </a:extLst>
           </p:cNvPr>
@@ -15357,7 +15357,7 @@
           <p:cNvPr id="27" name="">
             <a:extLst xmlns:a="http://schemas.openxmlformats.org/drawingml/2006/main">
               <a:ext uri="{FF2B5EF4-FFF2-40B4-BE49-F238E27FC236}">
-                <a16:creationId xmlns:a16="http://schemas.microsoft.com/office/drawing/2014/main" id="{6378A44B-5167-4353-ACFF-4AF1BC6FE2F9}"/>
+                <a16:creationId xmlns:a16="http://schemas.microsoft.com/office/drawing/2014/main" id="{C5CF18E7-73A5-4EF6-9F88-BFE2D1964468}"/>
               </a:ext>
             </a:extLst>
           </p:cNvPr>
@@ -15514,7 +15514,7 @@
           <p:cNvPr id="28" name="">
             <a:extLst xmlns:a="http://schemas.openxmlformats.org/drawingml/2006/main">
               <a:ext uri="{FF2B5EF4-FFF2-40B4-BE49-F238E27FC236}">
-                <a16:creationId xmlns:a16="http://schemas.microsoft.com/office/drawing/2014/main" id="{57BCEED6-1531-4992-A1F9-964C21699FBB}"/>
+                <a16:creationId xmlns:a16="http://schemas.microsoft.com/office/drawing/2014/main" id="{9B24D30B-557B-42D4-92B3-23D83312E38B}"/>
               </a:ext>
             </a:extLst>
           </p:cNvPr>
@@ -15671,7 +15671,7 @@
           <p:cNvPr id="29" name="">
             <a:extLst xmlns:a="http://schemas.openxmlformats.org/drawingml/2006/main">
               <a:ext uri="{FF2B5EF4-FFF2-40B4-BE49-F238E27FC236}">
-                <a16:creationId xmlns:a16="http://schemas.microsoft.com/office/drawing/2014/main" id="{9AD64955-3559-4FDD-ACC0-0418AE5E0724}"/>
+                <a16:creationId xmlns:a16="http://schemas.microsoft.com/office/drawing/2014/main" id="{43F53440-A55F-4CD9-88D2-2BD125B8ECA2}"/>
               </a:ext>
             </a:extLst>
           </p:cNvPr>
@@ -15828,7 +15828,7 @@
           <p:cNvPr id="30" name="">
             <a:extLst xmlns:a="http://schemas.openxmlformats.org/drawingml/2006/main">
               <a:ext uri="{FF2B5EF4-FFF2-40B4-BE49-F238E27FC236}">
-                <a16:creationId xmlns:a16="http://schemas.microsoft.com/office/drawing/2014/main" id="{FF512BBA-ABBF-4EB3-82A4-585883213749}"/>
+                <a16:creationId xmlns:a16="http://schemas.microsoft.com/office/drawing/2014/main" id="{BEB60B28-AA48-4E1E-AD30-423A1ED8FE6B}"/>
               </a:ext>
             </a:extLst>
           </p:cNvPr>
@@ -15985,7 +15985,7 @@
           <p:cNvPr id="31" name="">
             <a:extLst xmlns:a="http://schemas.openxmlformats.org/drawingml/2006/main">
               <a:ext uri="{FF2B5EF4-FFF2-40B4-BE49-F238E27FC236}">
-                <a16:creationId xmlns:a16="http://schemas.microsoft.com/office/drawing/2014/main" id="{8165E380-F3B8-4474-BCEC-87E84329FA62}"/>
+                <a16:creationId xmlns:a16="http://schemas.microsoft.com/office/drawing/2014/main" id="{954DFB46-E4E5-4E44-B7F5-01EBDCF573EE}"/>
               </a:ext>
             </a:extLst>
           </p:cNvPr>
@@ -16018,7 +16018,7 @@
           <p:cNvPr id="32" name="">
             <a:extLst xmlns:a="http://schemas.openxmlformats.org/drawingml/2006/main">
               <a:ext uri="{FF2B5EF4-FFF2-40B4-BE49-F238E27FC236}">
-                <a16:creationId xmlns:a16="http://schemas.microsoft.com/office/drawing/2014/main" id="{AA3E2736-9F23-4A6F-B34F-2476276760CD}"/>
+                <a16:creationId xmlns:a16="http://schemas.microsoft.com/office/drawing/2014/main" id="{73814AAA-E8B9-4795-B35A-EB43DD921166}"/>
               </a:ext>
             </a:extLst>
           </p:cNvPr>
@@ -16175,7 +16175,7 @@
           <p:cNvPr id="33" name="">
             <a:extLst xmlns:a="http://schemas.openxmlformats.org/drawingml/2006/main">
               <a:ext uri="{FF2B5EF4-FFF2-40B4-BE49-F238E27FC236}">
-                <a16:creationId xmlns:a16="http://schemas.microsoft.com/office/drawing/2014/main" id="{D40E8C50-A166-4511-8F74-19ED8EF2186F}"/>
+                <a16:creationId xmlns:a16="http://schemas.microsoft.com/office/drawing/2014/main" id="{5689F893-938C-4C59-8924-AF9B548B9AE4}"/>
               </a:ext>
             </a:extLst>
           </p:cNvPr>
@@ -16330,7 +16330,7 @@
     </p:spTree>
     <p:extLst>
       <p:ext uri="{BB962C8B-B14F-4D97-AF65-F5344CB8AC3E}">
-        <p14:creationId xmlns:p14="http://schemas.microsoft.com/office/powerpoint/2010/main" val="1491721067"/>
+        <p14:creationId xmlns:p14="http://schemas.microsoft.com/office/powerpoint/2010/main" val="1177133100"/>
       </p:ext>
     </p:extLst>
   </p:cSld>
@@ -16358,10 +16358,10 @@
       </p:grpSpPr>
       <p:sp>
         <p:nvSpPr>
-          <p:cNvPr id="17" name="">
+          <p:cNvPr id="18" name="">
             <a:extLst xmlns:a="http://schemas.openxmlformats.org/drawingml/2006/main">
               <a:ext uri="{FF2B5EF4-FFF2-40B4-BE49-F238E27FC236}">
-                <a16:creationId xmlns:a16="http://schemas.microsoft.com/office/drawing/2014/main" id="{783CDEEF-3E14-43C9-8B36-2E01CFEA1E54}"/>
+                <a16:creationId xmlns:a16="http://schemas.microsoft.com/office/drawing/2014/main" id="{C2617706-C116-44A0-8C6D-B0FC1F0743F1}"/>
               </a:ext>
             </a:extLst>
           </p:cNvPr>
@@ -16392,7 +16392,7 @@
           <p:cNvPr id="2" name="">
             <a:extLst xmlns:a="http://schemas.openxmlformats.org/drawingml/2006/main">
               <a:ext uri="{FF2B5EF4-FFF2-40B4-BE49-F238E27FC236}">
-                <a16:creationId xmlns:a16="http://schemas.microsoft.com/office/drawing/2014/main" id="{D14725A9-D998-4BA7-B062-EB5CC2B961E6}"/>
+                <a16:creationId xmlns:a16="http://schemas.microsoft.com/office/drawing/2014/main" id="{851D5298-9977-4C17-B046-28847E5ED68A}"/>
               </a:ext>
             </a:extLst>
           </p:cNvPr>
@@ -16549,7 +16549,7 @@
           <p:cNvPr id="3" name="">
             <a:extLst xmlns:a="http://schemas.openxmlformats.org/drawingml/2006/main">
               <a:ext uri="{FF2B5EF4-FFF2-40B4-BE49-F238E27FC236}">
-                <a16:creationId xmlns:a16="http://schemas.microsoft.com/office/drawing/2014/main" id="{06CAFC5F-215A-4A18-A514-30B0E5B76DD6}"/>
+                <a16:creationId xmlns:a16="http://schemas.microsoft.com/office/drawing/2014/main" id="{11047C05-F338-4179-8D4B-78899A470EF1}"/>
               </a:ext>
             </a:extLst>
           </p:cNvPr>
@@ -16706,7 +16706,7 @@
           <p:cNvPr id="4" name="">
             <a:extLst xmlns:a="http://schemas.openxmlformats.org/drawingml/2006/main">
               <a:ext uri="{FF2B5EF4-FFF2-40B4-BE49-F238E27FC236}">
-                <a16:creationId xmlns:a16="http://schemas.microsoft.com/office/drawing/2014/main" id="{F962443E-B483-4067-A79D-4DB229438728}"/>
+                <a16:creationId xmlns:a16="http://schemas.microsoft.com/office/drawing/2014/main" id="{59F0B6DC-7D5B-4037-83A9-DCCA8ADEBF6F}"/>
               </a:ext>
             </a:extLst>
           </p:cNvPr>
@@ -16853,7 +16853,7 @@
                 <a:ea typeface="Avenir Next"/>
                 <a:cs typeface="Avenir Next"/>
               </a:rPr>
-              <a:t>Un cambio en la interfaz se corrige en el recurso de esa pantalla.</a:t>
+              <a:t>El caso expresa el negocio; cada recurso encapsula las acciones de una pantalla.</a:t>
             </a:r>
           </a:p>
         </p:txBody>
@@ -16863,7 +16863,7 @@
           <p:cNvPr id="5" name="">
             <a:extLst xmlns:a="http://schemas.openxmlformats.org/drawingml/2006/main">
               <a:ext uri="{FF2B5EF4-FFF2-40B4-BE49-F238E27FC236}">
-                <a16:creationId xmlns:a16="http://schemas.microsoft.com/office/drawing/2014/main" id="{7EFB6CD4-50F8-4266-B9D0-39A58FE96209}"/>
+                <a16:creationId xmlns:a16="http://schemas.microsoft.com/office/drawing/2014/main" id="{B4395EC4-0A71-4623-9CD7-086CCE784406}"/>
               </a:ext>
             </a:extLst>
           </p:cNvPr>
@@ -16894,7 +16894,7 @@
           <p:cNvPr id="6" name="">
             <a:extLst xmlns:a="http://schemas.openxmlformats.org/drawingml/2006/main">
               <a:ext uri="{FF2B5EF4-FFF2-40B4-BE49-F238E27FC236}">
-                <a16:creationId xmlns:a16="http://schemas.microsoft.com/office/drawing/2014/main" id="{1BBCC16F-0166-47FE-89F6-975EEA46D0BE}"/>
+                <a16:creationId xmlns:a16="http://schemas.microsoft.com/office/drawing/2014/main" id="{BACDDF43-FF51-4689-99D8-311D7FE0976F}"/>
               </a:ext>
             </a:extLst>
           </p:cNvPr>
@@ -17051,7 +17051,7 @@
           <p:cNvPr id="7" name="">
             <a:extLst xmlns:a="http://schemas.openxmlformats.org/drawingml/2006/main">
               <a:ext uri="{FF2B5EF4-FFF2-40B4-BE49-F238E27FC236}">
-                <a16:creationId xmlns:a16="http://schemas.microsoft.com/office/drawing/2014/main" id="{6D53286A-7D55-4599-93DA-A398204E630E}"/>
+                <a16:creationId xmlns:a16="http://schemas.microsoft.com/office/drawing/2014/main" id="{F0F3E601-1133-4B63-A288-3323B98D115A}"/>
               </a:ext>
             </a:extLst>
           </p:cNvPr>
@@ -17208,7 +17208,7 @@
           <p:cNvPr id="8" name="">
             <a:extLst xmlns:a="http://schemas.openxmlformats.org/drawingml/2006/main">
               <a:ext uri="{FF2B5EF4-FFF2-40B4-BE49-F238E27FC236}">
-                <a16:creationId xmlns:a16="http://schemas.microsoft.com/office/drawing/2014/main" id="{6F8BCF56-C03D-407C-A14C-458F9C35B647}"/>
+                <a16:creationId xmlns:a16="http://schemas.microsoft.com/office/drawing/2014/main" id="{18C42C6C-D247-44E4-8D03-877C8A7CE742}"/>
               </a:ext>
             </a:extLst>
           </p:cNvPr>
@@ -17241,7 +17241,7 @@
           <p:cNvPr id="9" name="">
             <a:extLst xmlns:a="http://schemas.openxmlformats.org/drawingml/2006/main">
               <a:ext uri="{FF2B5EF4-FFF2-40B4-BE49-F238E27FC236}">
-                <a16:creationId xmlns:a16="http://schemas.microsoft.com/office/drawing/2014/main" id="{BFBFD02C-24E2-4C2B-BEEB-A3BC38FD0931}"/>
+                <a16:creationId xmlns:a16="http://schemas.microsoft.com/office/drawing/2014/main" id="{02770072-8A54-4C63-9D45-58CDB5A82129}"/>
               </a:ext>
             </a:extLst>
           </p:cNvPr>
@@ -17253,7 +17253,7 @@
         <p:spPr>
           <a:xfrm xmlns:a="http://schemas.openxmlformats.org/drawingml/2006/main">
             <a:off x="723900" y="1866900"/>
-            <a:ext cx="1466850" cy="333375"/>
+            <a:ext cx="1990725" cy="333375"/>
           </a:xfrm>
           <a:prstGeom xmlns:a="http://schemas.openxmlformats.org/drawingml/2006/main" prst="roundRect">
             <a:avLst>
@@ -17274,7 +17274,7 @@
           <p:cNvPr id="10" name="">
             <a:extLst xmlns:a="http://schemas.openxmlformats.org/drawingml/2006/main">
               <a:ext uri="{FF2B5EF4-FFF2-40B4-BE49-F238E27FC236}">
-                <a16:creationId xmlns:a16="http://schemas.microsoft.com/office/drawing/2014/main" id="{595D931C-6E84-44FC-9651-EECBD02CA056}"/>
+                <a16:creationId xmlns:a16="http://schemas.microsoft.com/office/drawing/2014/main" id="{44C9CE04-C580-4D18-9182-1E833534E13A}"/>
               </a:ext>
             </a:extLst>
           </p:cNvPr>
@@ -17286,7 +17286,7 @@
         <p:spPr>
           <a:xfrm xmlns:a="http://schemas.openxmlformats.org/drawingml/2006/main">
             <a:off x="838200" y="1905000"/>
-            <a:ext cx="1238250" cy="266700"/>
+            <a:ext cx="1762125" cy="266700"/>
           </a:xfrm>
           <a:prstGeom xmlns:a="http://schemas.openxmlformats.org/drawingml/2006/main" prst="rect">
             <a:avLst/>
@@ -17421,7 +17421,7 @@
                 <a:ea typeface="Avenir Next"/>
                 <a:cs typeface="Avenir Next"/>
               </a:rPr>
-              <a:t>CASO · QUÉ</a:t>
+              <a:t>CASO .robot · QUÉ</a:t>
             </a:r>
           </a:p>
         </p:txBody>
@@ -17431,7 +17431,7 @@
           <p:cNvPr id="11" name="">
             <a:extLst xmlns:a="http://schemas.openxmlformats.org/drawingml/2006/main">
               <a:ext uri="{FF2B5EF4-FFF2-40B4-BE49-F238E27FC236}">
-                <a16:creationId xmlns:a16="http://schemas.microsoft.com/office/drawing/2014/main" id="{6F21CE43-CCB2-4024-ADEC-D6B4EFABD554}"/>
+                <a16:creationId xmlns:a16="http://schemas.microsoft.com/office/drawing/2014/main" id="{6026E4E9-F107-46F7-A839-663D8FC97D03}"/>
               </a:ext>
             </a:extLst>
           </p:cNvPr>
@@ -17442,8 +17442,8 @@
         </p:nvSpPr>
         <p:spPr>
           <a:xfrm xmlns:a="http://schemas.openxmlformats.org/drawingml/2006/main">
-            <a:off x="790575" y="2457450"/>
-            <a:ext cx="4772025" cy="2266950"/>
+            <a:off x="790575" y="2419350"/>
+            <a:ext cx="4772025" cy="2162175"/>
           </a:xfrm>
           <a:prstGeom xmlns:a="http://schemas.openxmlformats.org/drawingml/2006/main" prst="rect">
             <a:avLst/>
@@ -17578,52 +17578,6 @@
                 <a:ea typeface="Avenir Next"/>
                 <a:cs typeface="Avenir Next"/>
               </a:rPr>
-              <a:t>Ingresar como usuario</a:t>
-            </a:r>
-          </a:p>
-          <a:p xmlns:a="http://schemas.openxmlformats.org/drawingml/2006/main">
-            <a:pPr algn="l">
-              <a:defRPr sz="1875" b="0">
-                <a:solidFill>
-                  <a:srgbClr val="FFFFFF"/>
-                </a:solidFill>
-                <a:latin typeface="Avenir Next"/>
-                <a:ea typeface="Avenir Next"/>
-                <a:cs typeface="Avenir Next"/>
-              </a:defRPr>
-            </a:pPr>
-            <a:r>
-              <a:rPr sz="1875" b="0">
-                <a:solidFill>
-                  <a:srgbClr val="FFFFFF"/>
-                </a:solidFill>
-                <a:latin typeface="Avenir Next"/>
-                <a:ea typeface="Avenir Next"/>
-                <a:cs typeface="Avenir Next"/>
-              </a:rPr>
-              <a:t>Agregar contacto y comprobarlo</a:t>
-            </a:r>
-          </a:p>
-          <a:p xmlns:a="http://schemas.openxmlformats.org/drawingml/2006/main">
-            <a:pPr algn="l">
-              <a:defRPr sz="1875" b="0">
-                <a:solidFill>
-                  <a:srgbClr val="FFFFFF"/>
-                </a:solidFill>
-                <a:latin typeface="Avenir Next"/>
-                <a:ea typeface="Avenir Next"/>
-                <a:cs typeface="Avenir Next"/>
-              </a:defRPr>
-            </a:pPr>
-            <a:r>
-              <a:rPr sz="1875" b="0">
-                <a:solidFill>
-                  <a:srgbClr val="FFFFFF"/>
-                </a:solidFill>
-                <a:latin typeface="Avenir Next"/>
-                <a:ea typeface="Avenir Next"/>
-                <a:cs typeface="Avenir Next"/>
-              </a:rPr>
               <a:t>Enviar solicitud a contacto</a:t>
             </a:r>
           </a:p>
@@ -17648,6 +17602,52 @@
                 <a:cs typeface="Avenir Next"/>
               </a:rPr>
               <a:t>Aceptar solicitud recibida</a:t>
+            </a:r>
+          </a:p>
+          <a:p xmlns:a="http://schemas.openxmlformats.org/drawingml/2006/main">
+            <a:pPr algn="l">
+              <a:defRPr sz="1875" b="0">
+                <a:solidFill>
+                  <a:srgbClr val="FFFFFF"/>
+                </a:solidFill>
+                <a:latin typeface="Avenir Next"/>
+                <a:ea typeface="Avenir Next"/>
+                <a:cs typeface="Avenir Next"/>
+              </a:defRPr>
+            </a:pPr>
+            <a:r>
+              <a:rPr sz="1875" b="0">
+                <a:solidFill>
+                  <a:srgbClr val="FFFFFF"/>
+                </a:solidFill>
+                <a:latin typeface="Avenir Next"/>
+                <a:ea typeface="Avenir Next"/>
+                <a:cs typeface="Avenir Next"/>
+              </a:rPr>
+              <a:t>Comprobar estado de solicitud</a:t>
+            </a:r>
+          </a:p>
+          <a:p xmlns:a="http://schemas.openxmlformats.org/drawingml/2006/main">
+            <a:pPr algn="l">
+              <a:defRPr sz="1875" b="0">
+                <a:solidFill>
+                  <a:srgbClr val="FFFFFF"/>
+                </a:solidFill>
+                <a:latin typeface="Avenir Next"/>
+                <a:ea typeface="Avenir Next"/>
+                <a:cs typeface="Avenir Next"/>
+              </a:defRPr>
+            </a:pPr>
+            <a:r>
+              <a:rPr sz="1875" b="0">
+                <a:solidFill>
+                  <a:srgbClr val="FFFFFF"/>
+                </a:solidFill>
+                <a:latin typeface="Avenir Next"/>
+                <a:ea typeface="Avenir Next"/>
+                <a:cs typeface="Avenir Next"/>
+              </a:rPr>
+              <a:t>Comprobar saldo en inicio</a:t>
             </a:r>
           </a:p>
         </p:txBody>
@@ -17657,7 +17657,7 @@
           <p:cNvPr id="12" name="">
             <a:extLst xmlns:a="http://schemas.openxmlformats.org/drawingml/2006/main">
               <a:ext uri="{FF2B5EF4-FFF2-40B4-BE49-F238E27FC236}">
-                <a16:creationId xmlns:a16="http://schemas.microsoft.com/office/drawing/2014/main" id="{5667199D-0258-4E19-9F06-848138675A4F}"/>
+                <a16:creationId xmlns:a16="http://schemas.microsoft.com/office/drawing/2014/main" id="{752D4472-6B14-419B-AF08-7D750D757EAD}"/>
               </a:ext>
             </a:extLst>
           </p:cNvPr>
@@ -17690,7 +17690,7 @@
           <p:cNvPr id="13" name="">
             <a:extLst xmlns:a="http://schemas.openxmlformats.org/drawingml/2006/main">
               <a:ext uri="{FF2B5EF4-FFF2-40B4-BE49-F238E27FC236}">
-                <a16:creationId xmlns:a16="http://schemas.microsoft.com/office/drawing/2014/main" id="{FCB9E2DB-CFB2-494F-AD62-03BB1158DBCE}"/>
+                <a16:creationId xmlns:a16="http://schemas.microsoft.com/office/drawing/2014/main" id="{469A0AC9-E294-4A2D-836C-838DB83FF783}"/>
               </a:ext>
             </a:extLst>
           </p:cNvPr>
@@ -17702,7 +17702,7 @@
         <p:spPr>
           <a:xfrm xmlns:a="http://schemas.openxmlformats.org/drawingml/2006/main">
             <a:off x="6515100" y="1866900"/>
-            <a:ext cx="2143125" cy="333375"/>
+            <a:ext cx="2190750" cy="333375"/>
           </a:xfrm>
           <a:prstGeom xmlns:a="http://schemas.openxmlformats.org/drawingml/2006/main" prst="roundRect">
             <a:avLst>
@@ -17723,7 +17723,7 @@
           <p:cNvPr id="14" name="">
             <a:extLst xmlns:a="http://schemas.openxmlformats.org/drawingml/2006/main">
               <a:ext uri="{FF2B5EF4-FFF2-40B4-BE49-F238E27FC236}">
-                <a16:creationId xmlns:a16="http://schemas.microsoft.com/office/drawing/2014/main" id="{9EC7FD4B-FDD9-4018-A157-C9F012F5C523}"/>
+                <a16:creationId xmlns:a16="http://schemas.microsoft.com/office/drawing/2014/main" id="{2A7E689B-4F09-4EDD-8B3F-B36F284479F9}"/>
               </a:ext>
             </a:extLst>
           </p:cNvPr>
@@ -17735,7 +17735,7 @@
         <p:spPr>
           <a:xfrm xmlns:a="http://schemas.openxmlformats.org/drawingml/2006/main">
             <a:off x="6629400" y="1905000"/>
-            <a:ext cx="1914525" cy="266700"/>
+            <a:ext cx="1962150" cy="266700"/>
           </a:xfrm>
           <a:prstGeom xmlns:a="http://schemas.openxmlformats.org/drawingml/2006/main" prst="rect">
             <a:avLst/>
@@ -17870,7 +17870,7 @@
                 <a:ea typeface="Avenir Next"/>
                 <a:cs typeface="Avenir Next"/>
               </a:rPr>
-              <a:t>RECURSOS · CÓMO</a:t>
+              <a:t>RECURSO · CÓMO</a:t>
             </a:r>
           </a:p>
         </p:txBody>
@@ -17880,7 +17880,7 @@
           <p:cNvPr id="15" name="">
             <a:extLst xmlns:a="http://schemas.openxmlformats.org/drawingml/2006/main">
               <a:ext uri="{FF2B5EF4-FFF2-40B4-BE49-F238E27FC236}">
-                <a16:creationId xmlns:a16="http://schemas.microsoft.com/office/drawing/2014/main" id="{9C2491C8-B42E-473D-AF19-93F88DAD6B4F}"/>
+                <a16:creationId xmlns:a16="http://schemas.microsoft.com/office/drawing/2014/main" id="{797983DE-03A3-4CF8-899C-871DF41CCD28}"/>
               </a:ext>
             </a:extLst>
           </p:cNvPr>
@@ -17891,8 +17891,8 @@
         </p:nvSpPr>
         <p:spPr>
           <a:xfrm xmlns:a="http://schemas.openxmlformats.org/drawingml/2006/main">
-            <a:off x="6581775" y="2457450"/>
-            <a:ext cx="4772025" cy="2266950"/>
+            <a:off x="6581775" y="2409825"/>
+            <a:ext cx="4772025" cy="2476500"/>
           </a:xfrm>
           <a:prstGeom xmlns:a="http://schemas.openxmlformats.org/drawingml/2006/main" prst="rect">
             <a:avLst/>
@@ -17907,7 +17907,7 @@
           <a:bodyPr xmlns:a="http://schemas.openxmlformats.org/drawingml/2006/main" anchor="ctr"/>
           <a:lstStyle xmlns:a="http://schemas.openxmlformats.org/drawingml/2006/main">
             <a:defPPr algn="l">
-              <a:defRPr sz="1950" b="0">
+              <a:defRPr sz="1575" b="0">
                 <a:solidFill>
                   <a:srgbClr val="122D32"/>
                 </a:solidFill>
@@ -17917,7 +17917,7 @@
               </a:defRPr>
             </a:defPPr>
             <a:lvl1pPr algn="l">
-              <a:defRPr sz="1950" b="0">
+              <a:defRPr sz="1575" b="0">
                 <a:solidFill>
                   <a:srgbClr val="122D32"/>
                 </a:solidFill>
@@ -17927,7 +17927,7 @@
               </a:defRPr>
             </a:lvl1pPr>
             <a:lvl2pPr algn="l">
-              <a:defRPr sz="1950" b="0">
+              <a:defRPr sz="1575" b="0">
                 <a:solidFill>
                   <a:srgbClr val="122D32"/>
                 </a:solidFill>
@@ -17937,7 +17937,7 @@
               </a:defRPr>
             </a:lvl2pPr>
             <a:lvl3pPr algn="l">
-              <a:defRPr sz="1950" b="0">
+              <a:defRPr sz="1575" b="0">
                 <a:solidFill>
                   <a:srgbClr val="122D32"/>
                 </a:solidFill>
@@ -17947,7 +17947,7 @@
               </a:defRPr>
             </a:lvl3pPr>
             <a:lvl4pPr algn="l">
-              <a:defRPr sz="1950" b="0">
+              <a:defRPr sz="1575" b="0">
                 <a:solidFill>
                   <a:srgbClr val="122D32"/>
                 </a:solidFill>
@@ -17957,7 +17957,7 @@
               </a:defRPr>
             </a:lvl4pPr>
             <a:lvl5pPr algn="l">
-              <a:defRPr sz="1950" b="0">
+              <a:defRPr sz="1575" b="0">
                 <a:solidFill>
                   <a:srgbClr val="122D32"/>
                 </a:solidFill>
@@ -17967,7 +17967,7 @@
               </a:defRPr>
             </a:lvl5pPr>
             <a:lvl6pPr algn="l">
-              <a:defRPr sz="1950" b="0">
+              <a:defRPr sz="1575" b="0">
                 <a:solidFill>
                   <a:srgbClr val="122D32"/>
                 </a:solidFill>
@@ -17977,7 +17977,7 @@
               </a:defRPr>
             </a:lvl6pPr>
             <a:lvl7pPr algn="l">
-              <a:defRPr sz="1950" b="0">
+              <a:defRPr sz="1575" b="0">
                 <a:solidFill>
                   <a:srgbClr val="122D32"/>
                 </a:solidFill>
@@ -17987,7 +17987,7 @@
               </a:defRPr>
             </a:lvl7pPr>
             <a:lvl8pPr algn="l">
-              <a:defRPr sz="1950" b="0">
+              <a:defRPr sz="1575" b="0">
                 <a:solidFill>
                   <a:srgbClr val="122D32"/>
                 </a:solidFill>
@@ -17997,7 +17997,7 @@
               </a:defRPr>
             </a:lvl8pPr>
             <a:lvl9pPr algn="l">
-              <a:defRPr sz="1950" b="0">
+              <a:defRPr sz="1575" b="0">
                 <a:solidFill>
                   <a:srgbClr val="122D32"/>
                 </a:solidFill>
@@ -18009,7 +18009,7 @@
           </a:lstStyle>
           <a:p xmlns:a="http://schemas.openxmlformats.org/drawingml/2006/main">
             <a:pPr algn="l">
-              <a:defRPr sz="1950" b="0">
+              <a:defRPr sz="1575" b="0">
                 <a:solidFill>
                   <a:srgbClr val="122D32"/>
                 </a:solidFill>
@@ -18019,7 +18019,7 @@
               </a:defRPr>
             </a:pPr>
             <a:r>
-              <a:rPr sz="1950" b="0">
+              <a:rPr sz="1575" b="0">
                 <a:solidFill>
                   <a:srgbClr val="122D32"/>
                 </a:solidFill>
@@ -18027,12 +18027,12 @@
                 <a:ea typeface="Avenir Next"/>
                 <a:cs typeface="Avenir Next"/>
               </a:rPr>
-              <a:t>LoginPage.resource</a:t>
+              <a:t>Fill Text</a:t>
             </a:r>
           </a:p>
           <a:p xmlns:a="http://schemas.openxmlformats.org/drawingml/2006/main">
             <a:pPr algn="l">
-              <a:defRPr sz="1950" b="0">
+              <a:defRPr sz="1575" b="0">
                 <a:solidFill>
                   <a:srgbClr val="122D32"/>
                 </a:solidFill>
@@ -18042,7 +18042,7 @@
               </a:defRPr>
             </a:pPr>
             <a:r>
-              <a:rPr sz="1950" b="0">
+              <a:rPr sz="1575" b="0">
                 <a:solidFill>
                   <a:srgbClr val="122D32"/>
                 </a:solidFill>
@@ -18050,12 +18050,17 @@
                 <a:ea typeface="Avenir Next"/>
                 <a:cs typeface="Avenir Next"/>
               </a:rPr>
-              <a:t>ContactosPage.resource</a:t>
+              <a:t>css=[data-testid="input-solicitud-monto"]</a:t>
+            </a:r>
+          </a:p>
+          <a:p xmlns:a="http://schemas.openxmlformats.org/drawingml/2006/main">
+            <a:r>
+              <a:t/>
             </a:r>
           </a:p>
           <a:p xmlns:a="http://schemas.openxmlformats.org/drawingml/2006/main">
             <a:pPr algn="l">
-              <a:defRPr sz="1950" b="0">
+              <a:defRPr sz="1575" b="0">
                 <a:solidFill>
                   <a:srgbClr val="122D32"/>
                 </a:solidFill>
@@ -18065,7 +18070,7 @@
               </a:defRPr>
             </a:pPr>
             <a:r>
-              <a:rPr sz="1950" b="0">
+              <a:rPr sz="1575" b="0">
                 <a:solidFill>
                   <a:srgbClr val="122D32"/>
                 </a:solidFill>
@@ -18073,12 +18078,12 @@
                 <a:ea typeface="Avenir Next"/>
                 <a:cs typeface="Avenir Next"/>
               </a:rPr>
-              <a:t>SolicitudesPage.resource</a:t>
+              <a:t>Click</a:t>
             </a:r>
           </a:p>
           <a:p xmlns:a="http://schemas.openxmlformats.org/drawingml/2006/main">
             <a:pPr algn="l">
-              <a:defRPr sz="1950" b="0">
+              <a:defRPr sz="1575" b="0">
                 <a:solidFill>
                   <a:srgbClr val="122D32"/>
                 </a:solidFill>
@@ -18088,7 +18093,7 @@
               </a:defRPr>
             </a:pPr>
             <a:r>
-              <a:rPr sz="1950" b="0">
+              <a:rPr sz="1575" b="0">
                 <a:solidFill>
                   <a:srgbClr val="122D32"/>
                 </a:solidFill>
@@ -18096,7 +18101,7 @@
                 <a:ea typeface="Avenir Next"/>
                 <a:cs typeface="Avenir Next"/>
               </a:rPr>
-              <a:t>InicioPage.resource</a:t>
+              <a:t>css=[data-testid="boton-solicitar"]</a:t>
             </a:r>
           </a:p>
         </p:txBody>
@@ -18106,7 +18111,164 @@
           <p:cNvPr id="16" name="">
             <a:extLst xmlns:a="http://schemas.openxmlformats.org/drawingml/2006/main">
               <a:ext uri="{FF2B5EF4-FFF2-40B4-BE49-F238E27FC236}">
-                <a16:creationId xmlns:a16="http://schemas.microsoft.com/office/drawing/2014/main" id="{F394E40B-F095-4962-B971-734BB9F90077}"/>
+                <a16:creationId xmlns:a16="http://schemas.microsoft.com/office/drawing/2014/main" id="{2FE15401-AC87-43EB-B7C0-DA20CC733A88}"/>
+              </a:ext>
+            </a:extLst>
+          </p:cNvPr>
+          <p:cNvSpPr>
+            <a:spLocks xmlns:a="http://schemas.openxmlformats.org/drawingml/2006/main" noGrp="1"/>
+          </p:cNvSpPr>
+          <p:nvPr/>
+        </p:nvSpPr>
+        <p:spPr>
+          <a:xfrm xmlns:a="http://schemas.openxmlformats.org/drawingml/2006/main">
+            <a:off x="6581775" y="4848225"/>
+            <a:ext cx="4772025" cy="247650"/>
+          </a:xfrm>
+          <a:prstGeom xmlns:a="http://schemas.openxmlformats.org/drawingml/2006/main" prst="rect">
+            <a:avLst/>
+          </a:prstGeom>
+          <a:noFill xmlns:a="http://schemas.openxmlformats.org/drawingml/2006/main"/>
+          <a:ln xmlns:a="http://schemas.openxmlformats.org/drawingml/2006/main" w="0">
+            <a:noFill/>
+            <a:prstDash val="solid"/>
+          </a:ln>
+        </p:spPr>
+        <p:txBody>
+          <a:bodyPr xmlns:a="http://schemas.openxmlformats.org/drawingml/2006/main" anchor="ctr"/>
+          <a:lstStyle xmlns:a="http://schemas.openxmlformats.org/drawingml/2006/main">
+            <a:defPPr algn="l">
+              <a:defRPr sz="1275" b="1">
+                <a:solidFill>
+                  <a:srgbClr val="11766E"/>
+                </a:solidFill>
+                <a:latin typeface="Avenir Next"/>
+                <a:ea typeface="Avenir Next"/>
+                <a:cs typeface="Avenir Next"/>
+              </a:defRPr>
+            </a:defPPr>
+            <a:lvl1pPr algn="l">
+              <a:defRPr sz="1275" b="1">
+                <a:solidFill>
+                  <a:srgbClr val="11766E"/>
+                </a:solidFill>
+                <a:latin typeface="Avenir Next"/>
+                <a:ea typeface="Avenir Next"/>
+                <a:cs typeface="Avenir Next"/>
+              </a:defRPr>
+            </a:lvl1pPr>
+            <a:lvl2pPr algn="l">
+              <a:defRPr sz="1275" b="1">
+                <a:solidFill>
+                  <a:srgbClr val="11766E"/>
+                </a:solidFill>
+                <a:latin typeface="Avenir Next"/>
+                <a:ea typeface="Avenir Next"/>
+                <a:cs typeface="Avenir Next"/>
+              </a:defRPr>
+            </a:lvl2pPr>
+            <a:lvl3pPr algn="l">
+              <a:defRPr sz="1275" b="1">
+                <a:solidFill>
+                  <a:srgbClr val="11766E"/>
+                </a:solidFill>
+                <a:latin typeface="Avenir Next"/>
+                <a:ea typeface="Avenir Next"/>
+                <a:cs typeface="Avenir Next"/>
+              </a:defRPr>
+            </a:lvl3pPr>
+            <a:lvl4pPr algn="l">
+              <a:defRPr sz="1275" b="1">
+                <a:solidFill>
+                  <a:srgbClr val="11766E"/>
+                </a:solidFill>
+                <a:latin typeface="Avenir Next"/>
+                <a:ea typeface="Avenir Next"/>
+                <a:cs typeface="Avenir Next"/>
+              </a:defRPr>
+            </a:lvl4pPr>
+            <a:lvl5pPr algn="l">
+              <a:defRPr sz="1275" b="1">
+                <a:solidFill>
+                  <a:srgbClr val="11766E"/>
+                </a:solidFill>
+                <a:latin typeface="Avenir Next"/>
+                <a:ea typeface="Avenir Next"/>
+                <a:cs typeface="Avenir Next"/>
+              </a:defRPr>
+            </a:lvl5pPr>
+            <a:lvl6pPr algn="l">
+              <a:defRPr sz="1275" b="1">
+                <a:solidFill>
+                  <a:srgbClr val="11766E"/>
+                </a:solidFill>
+                <a:latin typeface="Avenir Next"/>
+                <a:ea typeface="Avenir Next"/>
+                <a:cs typeface="Avenir Next"/>
+              </a:defRPr>
+            </a:lvl6pPr>
+            <a:lvl7pPr algn="l">
+              <a:defRPr sz="1275" b="1">
+                <a:solidFill>
+                  <a:srgbClr val="11766E"/>
+                </a:solidFill>
+                <a:latin typeface="Avenir Next"/>
+                <a:ea typeface="Avenir Next"/>
+                <a:cs typeface="Avenir Next"/>
+              </a:defRPr>
+            </a:lvl7pPr>
+            <a:lvl8pPr algn="l">
+              <a:defRPr sz="1275" b="1">
+                <a:solidFill>
+                  <a:srgbClr val="11766E"/>
+                </a:solidFill>
+                <a:latin typeface="Avenir Next"/>
+                <a:ea typeface="Avenir Next"/>
+                <a:cs typeface="Avenir Next"/>
+              </a:defRPr>
+            </a:lvl8pPr>
+            <a:lvl9pPr algn="l">
+              <a:defRPr sz="1275" b="1">
+                <a:solidFill>
+                  <a:srgbClr val="11766E"/>
+                </a:solidFill>
+                <a:latin typeface="Avenir Next"/>
+                <a:ea typeface="Avenir Next"/>
+                <a:cs typeface="Avenir Next"/>
+              </a:defRPr>
+            </a:lvl9pPr>
+          </a:lstStyle>
+          <a:p xmlns:a="http://schemas.openxmlformats.org/drawingml/2006/main">
+            <a:pPr algn="l">
+              <a:defRPr sz="1275" b="1">
+                <a:solidFill>
+                  <a:srgbClr val="11766E"/>
+                </a:solidFill>
+                <a:latin typeface="Avenir Next"/>
+                <a:ea typeface="Avenir Next"/>
+                <a:cs typeface="Avenir Next"/>
+              </a:defRPr>
+            </a:pPr>
+            <a:r>
+              <a:rPr sz="1275" b="1">
+                <a:solidFill>
+                  <a:srgbClr val="11766E"/>
+                </a:solidFill>
+                <a:latin typeface="Avenir Next"/>
+                <a:ea typeface="Avenir Next"/>
+                <a:cs typeface="Avenir Next"/>
+              </a:rPr>
+              <a:t>SolicitudesPage.resource</a:t>
+            </a:r>
+          </a:p>
+        </p:txBody>
+      </p:sp>
+      <p:sp>
+        <p:nvSpPr>
+          <p:cNvPr id="17" name="">
+            <a:extLst xmlns:a="http://schemas.openxmlformats.org/drawingml/2006/main">
+              <a:ext uri="{FF2B5EF4-FFF2-40B4-BE49-F238E27FC236}">
+                <a16:creationId xmlns:a16="http://schemas.microsoft.com/office/drawing/2014/main" id="{F4B722AB-6B03-47B4-BFA5-A42819FD5000}"/>
               </a:ext>
             </a:extLst>
           </p:cNvPr>
@@ -18133,7 +18295,7 @@
           <a:bodyPr xmlns:a="http://schemas.openxmlformats.org/drawingml/2006/main" anchor="ctr"/>
           <a:lstStyle xmlns:a="http://schemas.openxmlformats.org/drawingml/2006/main">
             <a:defPPr algn="ctr">
-              <a:defRPr sz="2100" b="1">
+              <a:defRPr sz="1950" b="1">
                 <a:solidFill>
                   <a:srgbClr val="11766E"/>
                 </a:solidFill>
@@ -18143,7 +18305,7 @@
               </a:defRPr>
             </a:defPPr>
             <a:lvl1pPr algn="ctr">
-              <a:defRPr sz="2100" b="1">
+              <a:defRPr sz="1950" b="1">
                 <a:solidFill>
                   <a:srgbClr val="11766E"/>
                 </a:solidFill>
@@ -18153,7 +18315,7 @@
               </a:defRPr>
             </a:lvl1pPr>
             <a:lvl2pPr algn="ctr">
-              <a:defRPr sz="2100" b="1">
+              <a:defRPr sz="1950" b="1">
                 <a:solidFill>
                   <a:srgbClr val="11766E"/>
                 </a:solidFill>
@@ -18163,7 +18325,7 @@
               </a:defRPr>
             </a:lvl2pPr>
             <a:lvl3pPr algn="ctr">
-              <a:defRPr sz="2100" b="1">
+              <a:defRPr sz="1950" b="1">
                 <a:solidFill>
                   <a:srgbClr val="11766E"/>
                 </a:solidFill>
@@ -18173,7 +18335,7 @@
               </a:defRPr>
             </a:lvl3pPr>
             <a:lvl4pPr algn="ctr">
-              <a:defRPr sz="2100" b="1">
+              <a:defRPr sz="1950" b="1">
                 <a:solidFill>
                   <a:srgbClr val="11766E"/>
                 </a:solidFill>
@@ -18183,7 +18345,7 @@
               </a:defRPr>
             </a:lvl4pPr>
             <a:lvl5pPr algn="ctr">
-              <a:defRPr sz="2100" b="1">
+              <a:defRPr sz="1950" b="1">
                 <a:solidFill>
                   <a:srgbClr val="11766E"/>
                 </a:solidFill>
@@ -18193,7 +18355,7 @@
               </a:defRPr>
             </a:lvl5pPr>
             <a:lvl6pPr algn="ctr">
-              <a:defRPr sz="2100" b="1">
+              <a:defRPr sz="1950" b="1">
                 <a:solidFill>
                   <a:srgbClr val="11766E"/>
                 </a:solidFill>
@@ -18203,7 +18365,7 @@
               </a:defRPr>
             </a:lvl6pPr>
             <a:lvl7pPr algn="ctr">
-              <a:defRPr sz="2100" b="1">
+              <a:defRPr sz="1950" b="1">
                 <a:solidFill>
                   <a:srgbClr val="11766E"/>
                 </a:solidFill>
@@ -18213,7 +18375,7 @@
               </a:defRPr>
             </a:lvl7pPr>
             <a:lvl8pPr algn="ctr">
-              <a:defRPr sz="2100" b="1">
+              <a:defRPr sz="1950" b="1">
                 <a:solidFill>
                   <a:srgbClr val="11766E"/>
                 </a:solidFill>
@@ -18223,7 +18385,7 @@
               </a:defRPr>
             </a:lvl8pPr>
             <a:lvl9pPr algn="ctr">
-              <a:defRPr sz="2100" b="1">
+              <a:defRPr sz="1950" b="1">
                 <a:solidFill>
                   <a:srgbClr val="11766E"/>
                 </a:solidFill>
@@ -18235,7 +18397,7 @@
           </a:lstStyle>
           <a:p xmlns:a="http://schemas.openxmlformats.org/drawingml/2006/main">
             <a:pPr algn="ctr">
-              <a:defRPr sz="2100" b="1">
+              <a:defRPr sz="1950" b="1">
                 <a:solidFill>
                   <a:srgbClr val="11766E"/>
                 </a:solidFill>
@@ -18245,7 +18407,7 @@
               </a:defRPr>
             </a:pPr>
             <a:r>
-              <a:rPr sz="2100" b="1">
+              <a:rPr sz="1950" b="1">
                 <a:solidFill>
                   <a:srgbClr val="11766E"/>
                 </a:solidFill>
@@ -18253,7 +18415,7 @@
                 <a:ea typeface="Avenir Next"/>
                 <a:cs typeface="Avenir Next"/>
               </a:rPr>
-              <a:t>El caso se lee como un flujo de negocio.</a:t>
+              <a:t>Un selector cambia en un recurso; el caso sigue legible.</a:t>
             </a:r>
           </a:p>
         </p:txBody>
@@ -18261,7 +18423,7 @@
     </p:spTree>
     <p:extLst>
       <p:ext uri="{BB962C8B-B14F-4D97-AF65-F5344CB8AC3E}">
-        <p14:creationId xmlns:p14="http://schemas.microsoft.com/office/powerpoint/2010/main" val="1482535934"/>
+        <p14:creationId xmlns:p14="http://schemas.microsoft.com/office/powerpoint/2010/main" val="384629891"/>
       </p:ext>
     </p:extLst>
   </p:cSld>
@@ -18292,7 +18454,7 @@
           <p:cNvPr id="16" name="">
             <a:extLst xmlns:a="http://schemas.openxmlformats.org/drawingml/2006/main">
               <a:ext uri="{FF2B5EF4-FFF2-40B4-BE49-F238E27FC236}">
-                <a16:creationId xmlns:a16="http://schemas.microsoft.com/office/drawing/2014/main" id="{FC9FAFC5-38A2-4C04-8502-5C0FC5DEF17C}"/>
+                <a16:creationId xmlns:a16="http://schemas.microsoft.com/office/drawing/2014/main" id="{CDFCA038-5561-4017-8813-17EC7DC2B954}"/>
               </a:ext>
             </a:extLst>
           </p:cNvPr>
@@ -18323,7 +18485,7 @@
           <p:cNvPr id="2" name="">
             <a:extLst xmlns:a="http://schemas.openxmlformats.org/drawingml/2006/main">
               <a:ext uri="{FF2B5EF4-FFF2-40B4-BE49-F238E27FC236}">
-                <a16:creationId xmlns:a16="http://schemas.microsoft.com/office/drawing/2014/main" id="{32018FCB-841A-4C1D-B043-0A2AB6CA8F02}"/>
+                <a16:creationId xmlns:a16="http://schemas.microsoft.com/office/drawing/2014/main" id="{802A275E-F71B-4F92-B8C6-BE9C6C69E492}"/>
               </a:ext>
             </a:extLst>
           </p:cNvPr>
@@ -18480,7 +18642,7 @@
           <p:cNvPr id="3" name="">
             <a:extLst xmlns:a="http://schemas.openxmlformats.org/drawingml/2006/main">
               <a:ext uri="{FF2B5EF4-FFF2-40B4-BE49-F238E27FC236}">
-                <a16:creationId xmlns:a16="http://schemas.microsoft.com/office/drawing/2014/main" id="{AB083550-7BE2-4301-9A68-E3C79C656A11}"/>
+                <a16:creationId xmlns:a16="http://schemas.microsoft.com/office/drawing/2014/main" id="{8E313DF9-E0E4-479F-9366-D2574AF903AA}"/>
               </a:ext>
             </a:extLst>
           </p:cNvPr>
@@ -18637,7 +18799,7 @@
           <p:cNvPr id="4" name="">
             <a:extLst xmlns:a="http://schemas.openxmlformats.org/drawingml/2006/main">
               <a:ext uri="{FF2B5EF4-FFF2-40B4-BE49-F238E27FC236}">
-                <a16:creationId xmlns:a16="http://schemas.microsoft.com/office/drawing/2014/main" id="{AD3EACC2-2750-4830-AED3-96BB8EA8ECA5}"/>
+                <a16:creationId xmlns:a16="http://schemas.microsoft.com/office/drawing/2014/main" id="{75C1D0A8-EC01-4F2D-A740-D3741C920E65}"/>
               </a:ext>
             </a:extLst>
           </p:cNvPr>
@@ -18794,7 +18956,7 @@
           <p:cNvPr id="5" name="">
             <a:extLst xmlns:a="http://schemas.openxmlformats.org/drawingml/2006/main">
               <a:ext uri="{FF2B5EF4-FFF2-40B4-BE49-F238E27FC236}">
-                <a16:creationId xmlns:a16="http://schemas.microsoft.com/office/drawing/2014/main" id="{634C245B-ABE2-41A8-8185-DE42E17E4693}"/>
+                <a16:creationId xmlns:a16="http://schemas.microsoft.com/office/drawing/2014/main" id="{5A8D1D6A-146F-4F50-83B9-4D42272FBDAB}"/>
               </a:ext>
             </a:extLst>
           </p:cNvPr>
@@ -18825,7 +18987,7 @@
           <p:cNvPr id="6" name="">
             <a:extLst xmlns:a="http://schemas.openxmlformats.org/drawingml/2006/main">
               <a:ext uri="{FF2B5EF4-FFF2-40B4-BE49-F238E27FC236}">
-                <a16:creationId xmlns:a16="http://schemas.microsoft.com/office/drawing/2014/main" id="{88CEA145-4764-458B-80E1-82B97E044DB6}"/>
+                <a16:creationId xmlns:a16="http://schemas.microsoft.com/office/drawing/2014/main" id="{5262FEB4-7C9B-46FD-A178-ABB15A328787}"/>
               </a:ext>
             </a:extLst>
           </p:cNvPr>
@@ -18982,7 +19144,7 @@
           <p:cNvPr id="7" name="">
             <a:extLst xmlns:a="http://schemas.openxmlformats.org/drawingml/2006/main">
               <a:ext uri="{FF2B5EF4-FFF2-40B4-BE49-F238E27FC236}">
-                <a16:creationId xmlns:a16="http://schemas.microsoft.com/office/drawing/2014/main" id="{3E488C80-229C-4E1D-AFBA-66F4C48EB423}"/>
+                <a16:creationId xmlns:a16="http://schemas.microsoft.com/office/drawing/2014/main" id="{7A7281A6-62E6-4DF8-B076-61E810D3DB76}"/>
               </a:ext>
             </a:extLst>
           </p:cNvPr>
@@ -19139,7 +19301,7 @@
           <p:cNvPr id="8" name="">
             <a:extLst xmlns:a="http://schemas.openxmlformats.org/drawingml/2006/main">
               <a:ext uri="{FF2B5EF4-FFF2-40B4-BE49-F238E27FC236}">
-                <a16:creationId xmlns:a16="http://schemas.microsoft.com/office/drawing/2014/main" id="{FC1CE3F1-63A9-4CA7-9935-E007E569674B}"/>
+                <a16:creationId xmlns:a16="http://schemas.microsoft.com/office/drawing/2014/main" id="{7002CC67-3D93-4D8F-9B4F-0D0EA5A020B0}"/>
               </a:ext>
             </a:extLst>
           </p:cNvPr>
@@ -19172,7 +19334,7 @@
           <p:cNvPr id="9" name="">
             <a:extLst xmlns:a="http://schemas.openxmlformats.org/drawingml/2006/main">
               <a:ext uri="{FF2B5EF4-FFF2-40B4-BE49-F238E27FC236}">
-                <a16:creationId xmlns:a16="http://schemas.microsoft.com/office/drawing/2014/main" id="{4360144D-DEEF-4B01-A97E-B3EC6A25988A}"/>
+                <a16:creationId xmlns:a16="http://schemas.microsoft.com/office/drawing/2014/main" id="{3A171BE3-E124-4C1D-A3DE-2CF2AFCA893E}"/>
               </a:ext>
             </a:extLst>
           </p:cNvPr>
@@ -19329,7 +19491,7 @@
           <p:cNvPr id="10" name="">
             <a:extLst xmlns:a="http://schemas.openxmlformats.org/drawingml/2006/main">
               <a:ext uri="{FF2B5EF4-FFF2-40B4-BE49-F238E27FC236}">
-                <a16:creationId xmlns:a16="http://schemas.microsoft.com/office/drawing/2014/main" id="{EC241478-8D1B-4A37-A5F4-4200D37647A7}"/>
+                <a16:creationId xmlns:a16="http://schemas.microsoft.com/office/drawing/2014/main" id="{BEC365DD-DD6F-4508-9E2D-87DE6DEA88F7}"/>
               </a:ext>
             </a:extLst>
           </p:cNvPr>
@@ -19362,7 +19524,7 @@
           <p:cNvPr id="11" name="">
             <a:extLst xmlns:a="http://schemas.openxmlformats.org/drawingml/2006/main">
               <a:ext uri="{FF2B5EF4-FFF2-40B4-BE49-F238E27FC236}">
-                <a16:creationId xmlns:a16="http://schemas.microsoft.com/office/drawing/2014/main" id="{94F21689-9869-4E70-96E8-42C4E73AFF3E}"/>
+                <a16:creationId xmlns:a16="http://schemas.microsoft.com/office/drawing/2014/main" id="{6C9E14C6-FE8B-4D93-9AD0-5CD1C7964A72}"/>
               </a:ext>
             </a:extLst>
           </p:cNvPr>
@@ -19372,7 +19534,7 @@
           <p:nvPr/>
         </p:nvPicPr>
         <p:blipFill>
-          <a:blip xmlns:r="http://schemas.openxmlformats.org/officeDocument/2006/relationships" xmlns:a="http://schemas.openxmlformats.org/drawingml/2006/main" r:embed="Ra70be270424b47e6"/>
+          <a:blip xmlns:r="http://schemas.openxmlformats.org/officeDocument/2006/relationships" xmlns:a="http://schemas.openxmlformats.org/drawingml/2006/main" r:embed="R9688b299f1984ee2"/>
           <a:srcRect xmlns:a="http://schemas.openxmlformats.org/drawingml/2006/main" l="0" t="581" r="0" b="581"/>
           <a:stretch xmlns:a="http://schemas.openxmlformats.org/drawingml/2006/main">
             <a:fillRect l="0" t="0" r="0" b="0"/>
@@ -19395,7 +19557,7 @@
           <p:cNvPr id="12" name="">
             <a:extLst xmlns:a="http://schemas.openxmlformats.org/drawingml/2006/main">
               <a:ext uri="{FF2B5EF4-FFF2-40B4-BE49-F238E27FC236}">
-                <a16:creationId xmlns:a16="http://schemas.microsoft.com/office/drawing/2014/main" id="{A63F2D33-5890-41BA-B539-86445CF3D701}"/>
+                <a16:creationId xmlns:a16="http://schemas.microsoft.com/office/drawing/2014/main" id="{E922B619-DC6B-464B-ADEB-B34DF5C4E347}"/>
               </a:ext>
             </a:extLst>
           </p:cNvPr>
@@ -19428,7 +19590,7 @@
           <p:cNvPr id="13" name="">
             <a:extLst xmlns:a="http://schemas.openxmlformats.org/drawingml/2006/main">
               <a:ext uri="{FF2B5EF4-FFF2-40B4-BE49-F238E27FC236}">
-                <a16:creationId xmlns:a16="http://schemas.microsoft.com/office/drawing/2014/main" id="{6153EFD8-5CA3-4273-A9C1-ED90FA1C58E2}"/>
+                <a16:creationId xmlns:a16="http://schemas.microsoft.com/office/drawing/2014/main" id="{573B3F20-818B-4E17-9106-0DB00BFE5F94}"/>
               </a:ext>
             </a:extLst>
           </p:cNvPr>
@@ -19585,7 +19747,7 @@
           <p:cNvPr id="14" name="">
             <a:extLst xmlns:a="http://schemas.openxmlformats.org/drawingml/2006/main">
               <a:ext uri="{FF2B5EF4-FFF2-40B4-BE49-F238E27FC236}">
-                <a16:creationId xmlns:a16="http://schemas.microsoft.com/office/drawing/2014/main" id="{A50BC852-6E75-4C8C-B800-28B447C03C5A}"/>
+                <a16:creationId xmlns:a16="http://schemas.microsoft.com/office/drawing/2014/main" id="{A07F2F8D-7223-4440-95F2-9DBC29A0C9E4}"/>
               </a:ext>
             </a:extLst>
           </p:cNvPr>
@@ -19618,7 +19780,7 @@
           <p:cNvPr id="15" name="">
             <a:extLst xmlns:a="http://schemas.openxmlformats.org/drawingml/2006/main">
               <a:ext uri="{FF2B5EF4-FFF2-40B4-BE49-F238E27FC236}">
-                <a16:creationId xmlns:a16="http://schemas.microsoft.com/office/drawing/2014/main" id="{7A72880F-6D65-4501-88E6-B746E750FCB6}"/>
+                <a16:creationId xmlns:a16="http://schemas.microsoft.com/office/drawing/2014/main" id="{2C73BB68-5F7D-4435-A355-18F630010358}"/>
               </a:ext>
             </a:extLst>
           </p:cNvPr>
@@ -19628,7 +19790,7 @@
           <p:nvPr/>
         </p:nvPicPr>
         <p:blipFill>
-          <a:blip xmlns:r="http://schemas.openxmlformats.org/officeDocument/2006/relationships" xmlns:a="http://schemas.openxmlformats.org/drawingml/2006/main" r:embed="R94aa56aa1db74d64"/>
+          <a:blip xmlns:r="http://schemas.openxmlformats.org/officeDocument/2006/relationships" xmlns:a="http://schemas.openxmlformats.org/drawingml/2006/main" r:embed="R3c4532d52b21434e"/>
           <a:srcRect xmlns:a="http://schemas.openxmlformats.org/drawingml/2006/main" l="0" t="884" r="0" b="884"/>
           <a:stretch xmlns:a="http://schemas.openxmlformats.org/drawingml/2006/main">
             <a:fillRect l="0" t="0" r="0" b="0"/>
@@ -19649,7 +19811,7 @@
     </p:spTree>
     <p:extLst>
       <p:ext uri="{BB962C8B-B14F-4D97-AF65-F5344CB8AC3E}">
-        <p14:creationId xmlns:p14="http://schemas.microsoft.com/office/powerpoint/2010/main" val="119862031"/>
+        <p14:creationId xmlns:p14="http://schemas.microsoft.com/office/powerpoint/2010/main" val="635569642"/>
       </p:ext>
     </p:extLst>
   </p:cSld>
@@ -19680,7 +19842,7 @@
           <p:cNvPr id="18" name="">
             <a:extLst xmlns:a="http://schemas.openxmlformats.org/drawingml/2006/main">
               <a:ext uri="{FF2B5EF4-FFF2-40B4-BE49-F238E27FC236}">
-                <a16:creationId xmlns:a16="http://schemas.microsoft.com/office/drawing/2014/main" id="{8359DF81-9C58-471E-B321-89F9AA998A78}"/>
+                <a16:creationId xmlns:a16="http://schemas.microsoft.com/office/drawing/2014/main" id="{D3EFDAD8-D604-4ED7-9D1C-16A1D3DC1ACF}"/>
               </a:ext>
             </a:extLst>
           </p:cNvPr>
@@ -19711,7 +19873,7 @@
           <p:cNvPr id="2" name="">
             <a:extLst xmlns:a="http://schemas.openxmlformats.org/drawingml/2006/main">
               <a:ext uri="{FF2B5EF4-FFF2-40B4-BE49-F238E27FC236}">
-                <a16:creationId xmlns:a16="http://schemas.microsoft.com/office/drawing/2014/main" id="{0D72BF23-FE7C-4528-AE5F-6B0864147271}"/>
+                <a16:creationId xmlns:a16="http://schemas.microsoft.com/office/drawing/2014/main" id="{0AB68627-CBAE-43C9-BC8E-1D1774741229}"/>
               </a:ext>
             </a:extLst>
           </p:cNvPr>
@@ -19868,7 +20030,7 @@
           <p:cNvPr id="3" name="">
             <a:extLst xmlns:a="http://schemas.openxmlformats.org/drawingml/2006/main">
               <a:ext uri="{FF2B5EF4-FFF2-40B4-BE49-F238E27FC236}">
-                <a16:creationId xmlns:a16="http://schemas.microsoft.com/office/drawing/2014/main" id="{E08A8999-3878-4D4E-9D81-A49766266F9E}"/>
+                <a16:creationId xmlns:a16="http://schemas.microsoft.com/office/drawing/2014/main" id="{129AC497-C42E-4E7F-9825-AA55FF215C95}"/>
               </a:ext>
             </a:extLst>
           </p:cNvPr>
@@ -20025,7 +20187,7 @@
           <p:cNvPr id="4" name="">
             <a:extLst xmlns:a="http://schemas.openxmlformats.org/drawingml/2006/main">
               <a:ext uri="{FF2B5EF4-FFF2-40B4-BE49-F238E27FC236}">
-                <a16:creationId xmlns:a16="http://schemas.microsoft.com/office/drawing/2014/main" id="{6F6D2DE9-E89A-4886-8B21-3507E5178643}"/>
+                <a16:creationId xmlns:a16="http://schemas.microsoft.com/office/drawing/2014/main" id="{D7408DAF-9B7B-46D4-97A4-7478536FD739}"/>
               </a:ext>
             </a:extLst>
           </p:cNvPr>
@@ -20182,7 +20344,7 @@
           <p:cNvPr id="5" name="">
             <a:extLst xmlns:a="http://schemas.openxmlformats.org/drawingml/2006/main">
               <a:ext uri="{FF2B5EF4-FFF2-40B4-BE49-F238E27FC236}">
-                <a16:creationId xmlns:a16="http://schemas.microsoft.com/office/drawing/2014/main" id="{673F2929-53A8-4D3E-9827-1EE9878B3191}"/>
+                <a16:creationId xmlns:a16="http://schemas.microsoft.com/office/drawing/2014/main" id="{213620ED-7B1C-45F4-B88A-AD63CED89240}"/>
               </a:ext>
             </a:extLst>
           </p:cNvPr>
@@ -20213,7 +20375,7 @@
           <p:cNvPr id="6" name="">
             <a:extLst xmlns:a="http://schemas.openxmlformats.org/drawingml/2006/main">
               <a:ext uri="{FF2B5EF4-FFF2-40B4-BE49-F238E27FC236}">
-                <a16:creationId xmlns:a16="http://schemas.microsoft.com/office/drawing/2014/main" id="{B5439DA3-83D7-487E-8379-804B95CEF416}"/>
+                <a16:creationId xmlns:a16="http://schemas.microsoft.com/office/drawing/2014/main" id="{619730F5-35B1-434B-8E16-DE143AD8BA6A}"/>
               </a:ext>
             </a:extLst>
           </p:cNvPr>
@@ -20370,7 +20532,7 @@
           <p:cNvPr id="7" name="">
             <a:extLst xmlns:a="http://schemas.openxmlformats.org/drawingml/2006/main">
               <a:ext uri="{FF2B5EF4-FFF2-40B4-BE49-F238E27FC236}">
-                <a16:creationId xmlns:a16="http://schemas.microsoft.com/office/drawing/2014/main" id="{4AE1A9E3-1DF6-4C59-B9D7-BC741887664E}"/>
+                <a16:creationId xmlns:a16="http://schemas.microsoft.com/office/drawing/2014/main" id="{65DB1732-D5D4-4E26-8FF8-A02692007574}"/>
               </a:ext>
             </a:extLst>
           </p:cNvPr>
@@ -20527,7 +20689,7 @@
           <p:cNvPr id="8" name="">
             <a:extLst xmlns:a="http://schemas.openxmlformats.org/drawingml/2006/main">
               <a:ext uri="{FF2B5EF4-FFF2-40B4-BE49-F238E27FC236}">
-                <a16:creationId xmlns:a16="http://schemas.microsoft.com/office/drawing/2014/main" id="{30836F02-EEE3-4E00-91BA-43CB3229CEBE}"/>
+                <a16:creationId xmlns:a16="http://schemas.microsoft.com/office/drawing/2014/main" id="{3353EB6E-4EE9-48BF-AF74-F783F45404BC}"/>
               </a:ext>
             </a:extLst>
           </p:cNvPr>
@@ -20560,7 +20722,7 @@
           <p:cNvPr id="9" name="">
             <a:extLst xmlns:a="http://schemas.openxmlformats.org/drawingml/2006/main">
               <a:ext uri="{FF2B5EF4-FFF2-40B4-BE49-F238E27FC236}">
-                <a16:creationId xmlns:a16="http://schemas.microsoft.com/office/drawing/2014/main" id="{0AFEED28-8F9C-4002-8564-512126527142}"/>
+                <a16:creationId xmlns:a16="http://schemas.microsoft.com/office/drawing/2014/main" id="{C33617FC-75DA-4EA5-B16E-5D89F77B0ECA}"/>
               </a:ext>
             </a:extLst>
           </p:cNvPr>
@@ -20570,7 +20732,7 @@
           <p:nvPr/>
         </p:nvPicPr>
         <p:blipFill>
-          <a:blip xmlns:r="http://schemas.openxmlformats.org/officeDocument/2006/relationships" xmlns:a="http://schemas.openxmlformats.org/drawingml/2006/main" r:embed="Rad6c617b8b3c4cb7"/>
+          <a:blip xmlns:r="http://schemas.openxmlformats.org/officeDocument/2006/relationships" xmlns:a="http://schemas.openxmlformats.org/drawingml/2006/main" r:embed="Rf5ad5267d3714ad6"/>
           <a:srcRect xmlns:a="http://schemas.openxmlformats.org/drawingml/2006/main" l="0" t="1104" r="0" b="1104"/>
           <a:stretch xmlns:a="http://schemas.openxmlformats.org/drawingml/2006/main">
             <a:fillRect l="0" t="0" r="0" b="0"/>
@@ -20593,7 +20755,7 @@
           <p:cNvPr id="10" name="">
             <a:extLst xmlns:a="http://schemas.openxmlformats.org/drawingml/2006/main">
               <a:ext uri="{FF2B5EF4-FFF2-40B4-BE49-F238E27FC236}">
-                <a16:creationId xmlns:a16="http://schemas.microsoft.com/office/drawing/2014/main" id="{69B83AA9-C089-49BE-B46D-AE1A61439626}"/>
+                <a16:creationId xmlns:a16="http://schemas.microsoft.com/office/drawing/2014/main" id="{02A770B0-A726-4714-819C-A1D7D3E80130}"/>
               </a:ext>
             </a:extLst>
           </p:cNvPr>
@@ -20626,7 +20788,7 @@
           <p:cNvPr id="11" name="">
             <a:extLst xmlns:a="http://schemas.openxmlformats.org/drawingml/2006/main">
               <a:ext uri="{FF2B5EF4-FFF2-40B4-BE49-F238E27FC236}">
-                <a16:creationId xmlns:a16="http://schemas.microsoft.com/office/drawing/2014/main" id="{6C143597-151D-4B4D-A770-80DB151F97B7}"/>
+                <a16:creationId xmlns:a16="http://schemas.microsoft.com/office/drawing/2014/main" id="{05E4632C-E8E6-4EE6-8A86-7397406E955B}"/>
               </a:ext>
             </a:extLst>
           </p:cNvPr>
@@ -20636,7 +20798,7 @@
           <p:nvPr/>
         </p:nvPicPr>
         <p:blipFill>
-          <a:blip xmlns:r="http://schemas.openxmlformats.org/officeDocument/2006/relationships" xmlns:a="http://schemas.openxmlformats.org/drawingml/2006/main" r:embed="R81a1a84f55384ab3"/>
+          <a:blip xmlns:r="http://schemas.openxmlformats.org/officeDocument/2006/relationships" xmlns:a="http://schemas.openxmlformats.org/drawingml/2006/main" r:embed="R736a5946ad254ae2"/>
           <a:srcRect xmlns:a="http://schemas.openxmlformats.org/drawingml/2006/main" l="94" t="0" r="94" b="0"/>
           <a:stretch xmlns:a="http://schemas.openxmlformats.org/drawingml/2006/main">
             <a:fillRect l="0" t="0" r="0" b="0"/>
@@ -20659,7 +20821,7 @@
           <p:cNvPr id="12" name="">
             <a:extLst xmlns:a="http://schemas.openxmlformats.org/drawingml/2006/main">
               <a:ext uri="{FF2B5EF4-FFF2-40B4-BE49-F238E27FC236}">
-                <a16:creationId xmlns:a16="http://schemas.microsoft.com/office/drawing/2014/main" id="{9E5FE6B6-E860-4E75-90B1-CB1C8F09FE11}"/>
+                <a16:creationId xmlns:a16="http://schemas.microsoft.com/office/drawing/2014/main" id="{01468021-BF74-422D-90FE-D38B068EA2FC}"/>
               </a:ext>
             </a:extLst>
           </p:cNvPr>
@@ -20692,7 +20854,7 @@
           <p:cNvPr id="13" name="">
             <a:extLst xmlns:a="http://schemas.openxmlformats.org/drawingml/2006/main">
               <a:ext uri="{FF2B5EF4-FFF2-40B4-BE49-F238E27FC236}">
-                <a16:creationId xmlns:a16="http://schemas.microsoft.com/office/drawing/2014/main" id="{8659C23E-5F41-446D-A29D-A23F31F03E31}"/>
+                <a16:creationId xmlns:a16="http://schemas.microsoft.com/office/drawing/2014/main" id="{59B392B9-CED8-4581-8A40-6545EC87EF99}"/>
               </a:ext>
             </a:extLst>
           </p:cNvPr>
@@ -20849,7 +21011,7 @@
           <p:cNvPr id="14" name="">
             <a:extLst xmlns:a="http://schemas.openxmlformats.org/drawingml/2006/main">
               <a:ext uri="{FF2B5EF4-FFF2-40B4-BE49-F238E27FC236}">
-                <a16:creationId xmlns:a16="http://schemas.microsoft.com/office/drawing/2014/main" id="{F65F2277-FAC9-42D0-B3B7-DC5F6C1AA726}"/>
+                <a16:creationId xmlns:a16="http://schemas.microsoft.com/office/drawing/2014/main" id="{A4F8038F-04C7-4BC1-9D04-A7DDD6244DE8}"/>
               </a:ext>
             </a:extLst>
           </p:cNvPr>
@@ -21006,7 +21168,7 @@
           <p:cNvPr id="15" name="">
             <a:extLst xmlns:a="http://schemas.openxmlformats.org/drawingml/2006/main">
               <a:ext uri="{FF2B5EF4-FFF2-40B4-BE49-F238E27FC236}">
-                <a16:creationId xmlns:a16="http://schemas.microsoft.com/office/drawing/2014/main" id="{A8968AA2-8780-4033-A81A-963549405525}"/>
+                <a16:creationId xmlns:a16="http://schemas.microsoft.com/office/drawing/2014/main" id="{5F34D7E9-4CC9-4FCB-9DCD-48E8558D8FA3}"/>
               </a:ext>
             </a:extLst>
           </p:cNvPr>
@@ -21039,7 +21201,7 @@
           <p:cNvPr id="16" name="">
             <a:extLst xmlns:a="http://schemas.openxmlformats.org/drawingml/2006/main">
               <a:ext uri="{FF2B5EF4-FFF2-40B4-BE49-F238E27FC236}">
-                <a16:creationId xmlns:a16="http://schemas.microsoft.com/office/drawing/2014/main" id="{56B19628-4593-427A-AEBA-267D1680A4D1}"/>
+                <a16:creationId xmlns:a16="http://schemas.microsoft.com/office/drawing/2014/main" id="{8BF8BFC3-B1F7-4423-9DE5-49EC26988967}"/>
               </a:ext>
             </a:extLst>
           </p:cNvPr>
@@ -21196,7 +21358,7 @@
           <p:cNvPr id="17" name="">
             <a:extLst xmlns:a="http://schemas.openxmlformats.org/drawingml/2006/main">
               <a:ext uri="{FF2B5EF4-FFF2-40B4-BE49-F238E27FC236}">
-                <a16:creationId xmlns:a16="http://schemas.microsoft.com/office/drawing/2014/main" id="{7C8C1BAC-C998-4853-AC9F-7BD19ABB5355}"/>
+                <a16:creationId xmlns:a16="http://schemas.microsoft.com/office/drawing/2014/main" id="{E61E83AC-D5CF-4D3A-AC6D-777BF89FE9AA}"/>
               </a:ext>
             </a:extLst>
           </p:cNvPr>
@@ -21351,7 +21513,7 @@
     </p:spTree>
     <p:extLst>
       <p:ext uri="{BB962C8B-B14F-4D97-AF65-F5344CB8AC3E}">
-        <p14:creationId xmlns:p14="http://schemas.microsoft.com/office/powerpoint/2010/main" val="20555708"/>
+        <p14:creationId xmlns:p14="http://schemas.microsoft.com/office/powerpoint/2010/main" val="151551091"/>
       </p:ext>
     </p:extLst>
   </p:cSld>
@@ -21382,7 +21544,7 @@
           <p:cNvPr id="15" name="">
             <a:extLst xmlns:a="http://schemas.openxmlformats.org/drawingml/2006/main">
               <a:ext uri="{FF2B5EF4-FFF2-40B4-BE49-F238E27FC236}">
-                <a16:creationId xmlns:a16="http://schemas.microsoft.com/office/drawing/2014/main" id="{9A4B4D5C-2D4E-479C-B9B0-D4B995E1E514}"/>
+                <a16:creationId xmlns:a16="http://schemas.microsoft.com/office/drawing/2014/main" id="{66449AEA-370B-4FB8-9A04-A54D46AD2168}"/>
               </a:ext>
             </a:extLst>
           </p:cNvPr>
@@ -21413,7 +21575,7 @@
           <p:cNvPr id="2" name="">
             <a:extLst xmlns:a="http://schemas.openxmlformats.org/drawingml/2006/main">
               <a:ext uri="{FF2B5EF4-FFF2-40B4-BE49-F238E27FC236}">
-                <a16:creationId xmlns:a16="http://schemas.microsoft.com/office/drawing/2014/main" id="{66AE6998-7A41-4224-9BCF-DA050EE63555}"/>
+                <a16:creationId xmlns:a16="http://schemas.microsoft.com/office/drawing/2014/main" id="{EDB172E7-EAB4-4FE4-A9F4-11FA30A0DD6F}"/>
               </a:ext>
             </a:extLst>
           </p:cNvPr>
@@ -21570,7 +21732,7 @@
           <p:cNvPr id="3" name="">
             <a:extLst xmlns:a="http://schemas.openxmlformats.org/drawingml/2006/main">
               <a:ext uri="{FF2B5EF4-FFF2-40B4-BE49-F238E27FC236}">
-                <a16:creationId xmlns:a16="http://schemas.microsoft.com/office/drawing/2014/main" id="{B82EC2D9-9A10-44F2-8576-F153F2FD54AF}"/>
+                <a16:creationId xmlns:a16="http://schemas.microsoft.com/office/drawing/2014/main" id="{E5E50FAC-BFF2-4ADD-BB82-6928EBE41020}"/>
               </a:ext>
             </a:extLst>
           </p:cNvPr>
@@ -21727,7 +21889,7 @@
           <p:cNvPr id="4" name="">
             <a:extLst xmlns:a="http://schemas.openxmlformats.org/drawingml/2006/main">
               <a:ext uri="{FF2B5EF4-FFF2-40B4-BE49-F238E27FC236}">
-                <a16:creationId xmlns:a16="http://schemas.microsoft.com/office/drawing/2014/main" id="{2A14B3A2-CCD1-44DD-803B-BC3EC4A18DFD}"/>
+                <a16:creationId xmlns:a16="http://schemas.microsoft.com/office/drawing/2014/main" id="{CF0CDBB8-F932-4CAC-B69C-64C23284B15A}"/>
               </a:ext>
             </a:extLst>
           </p:cNvPr>
@@ -21884,7 +22046,7 @@
           <p:cNvPr id="5" name="">
             <a:extLst xmlns:a="http://schemas.openxmlformats.org/drawingml/2006/main">
               <a:ext uri="{FF2B5EF4-FFF2-40B4-BE49-F238E27FC236}">
-                <a16:creationId xmlns:a16="http://schemas.microsoft.com/office/drawing/2014/main" id="{56B83838-3953-44E8-8726-6591FD64CD00}"/>
+                <a16:creationId xmlns:a16="http://schemas.microsoft.com/office/drawing/2014/main" id="{7E23E2C2-B11B-49BE-AE21-D3193FB78F1A}"/>
               </a:ext>
             </a:extLst>
           </p:cNvPr>
@@ -21915,7 +22077,7 @@
           <p:cNvPr id="6" name="">
             <a:extLst xmlns:a="http://schemas.openxmlformats.org/drawingml/2006/main">
               <a:ext uri="{FF2B5EF4-FFF2-40B4-BE49-F238E27FC236}">
-                <a16:creationId xmlns:a16="http://schemas.microsoft.com/office/drawing/2014/main" id="{9056C20D-0FD1-47E7-B337-767BBE16C38F}"/>
+                <a16:creationId xmlns:a16="http://schemas.microsoft.com/office/drawing/2014/main" id="{AC302A6E-295C-4BD0-BC88-EBDA29CBEA5F}"/>
               </a:ext>
             </a:extLst>
           </p:cNvPr>
@@ -22072,7 +22234,7 @@
           <p:cNvPr id="7" name="">
             <a:extLst xmlns:a="http://schemas.openxmlformats.org/drawingml/2006/main">
               <a:ext uri="{FF2B5EF4-FFF2-40B4-BE49-F238E27FC236}">
-                <a16:creationId xmlns:a16="http://schemas.microsoft.com/office/drawing/2014/main" id="{F9E7CE7D-2496-42B6-A45E-A599DDE59362}"/>
+                <a16:creationId xmlns:a16="http://schemas.microsoft.com/office/drawing/2014/main" id="{082E4491-6B93-41D7-86C7-314FF609D3FB}"/>
               </a:ext>
             </a:extLst>
           </p:cNvPr>
@@ -22229,7 +22391,7 @@
           <p:cNvPr id="8" name="">
             <a:extLst xmlns:a="http://schemas.openxmlformats.org/drawingml/2006/main">
               <a:ext uri="{FF2B5EF4-FFF2-40B4-BE49-F238E27FC236}">
-                <a16:creationId xmlns:a16="http://schemas.microsoft.com/office/drawing/2014/main" id="{7F1ED812-0D11-48F6-8A86-6CEEF511C43B}"/>
+                <a16:creationId xmlns:a16="http://schemas.microsoft.com/office/drawing/2014/main" id="{B8B6CF64-4183-413F-A911-C6FE6D40EA79}"/>
               </a:ext>
             </a:extLst>
           </p:cNvPr>
@@ -22262,7 +22424,7 @@
           <p:cNvPr id="9" name="">
             <a:extLst xmlns:a="http://schemas.openxmlformats.org/drawingml/2006/main">
               <a:ext uri="{FF2B5EF4-FFF2-40B4-BE49-F238E27FC236}">
-                <a16:creationId xmlns:a16="http://schemas.microsoft.com/office/drawing/2014/main" id="{F0A8A685-2ADD-4213-AF37-645ADAEEAE92}"/>
+                <a16:creationId xmlns:a16="http://schemas.microsoft.com/office/drawing/2014/main" id="{2FB8F2D0-B29A-4BC3-80B5-14205B0DAA0F}"/>
               </a:ext>
             </a:extLst>
           </p:cNvPr>
@@ -22272,7 +22434,7 @@
           <p:nvPr/>
         </p:nvPicPr>
         <p:blipFill>
-          <a:blip xmlns:r="http://schemas.openxmlformats.org/officeDocument/2006/relationships" xmlns:a="http://schemas.openxmlformats.org/drawingml/2006/main" r:embed="R60b89a5dee1848ab"/>
+          <a:blip xmlns:r="http://schemas.openxmlformats.org/officeDocument/2006/relationships" xmlns:a="http://schemas.openxmlformats.org/drawingml/2006/main" r:embed="R90b9793debc346e8"/>
           <a:srcRect xmlns:a="http://schemas.openxmlformats.org/drawingml/2006/main" l="0" t="417" r="0" b="417"/>
           <a:stretch xmlns:a="http://schemas.openxmlformats.org/drawingml/2006/main">
             <a:fillRect l="0" t="0" r="0" b="0"/>
@@ -22295,7 +22457,7 @@
           <p:cNvPr id="10" name="">
             <a:extLst xmlns:a="http://schemas.openxmlformats.org/drawingml/2006/main">
               <a:ext uri="{FF2B5EF4-FFF2-40B4-BE49-F238E27FC236}">
-                <a16:creationId xmlns:a16="http://schemas.microsoft.com/office/drawing/2014/main" id="{41ECA631-BC3C-422A-80C0-A58E29D8C971}"/>
+                <a16:creationId xmlns:a16="http://schemas.microsoft.com/office/drawing/2014/main" id="{0E6B7241-1558-4D0F-8AEB-C99CAFAAB5E9}"/>
               </a:ext>
             </a:extLst>
           </p:cNvPr>
@@ -22328,7 +22490,7 @@
           <p:cNvPr id="11" name="">
             <a:extLst xmlns:a="http://schemas.openxmlformats.org/drawingml/2006/main">
               <a:ext uri="{FF2B5EF4-FFF2-40B4-BE49-F238E27FC236}">
-                <a16:creationId xmlns:a16="http://schemas.microsoft.com/office/drawing/2014/main" id="{DD65CD25-D252-4C3D-AB82-37F041E78F61}"/>
+                <a16:creationId xmlns:a16="http://schemas.microsoft.com/office/drawing/2014/main" id="{3EA911F2-6D9C-4300-8AFA-68B6A440B564}"/>
               </a:ext>
             </a:extLst>
           </p:cNvPr>
@@ -22485,7 +22647,7 @@
           <p:cNvPr id="12" name="">
             <a:extLst xmlns:a="http://schemas.openxmlformats.org/drawingml/2006/main">
               <a:ext uri="{FF2B5EF4-FFF2-40B4-BE49-F238E27FC236}">
-                <a16:creationId xmlns:a16="http://schemas.microsoft.com/office/drawing/2014/main" id="{E1AAE156-A82A-415F-BADF-FC57BE93C62A}"/>
+                <a16:creationId xmlns:a16="http://schemas.microsoft.com/office/drawing/2014/main" id="{EC919BA5-0AA7-45B3-85B3-4D1EBE5BD4EB}"/>
               </a:ext>
             </a:extLst>
           </p:cNvPr>
@@ -22642,7 +22804,7 @@
           <p:cNvPr id="13" name="">
             <a:extLst xmlns:a="http://schemas.openxmlformats.org/drawingml/2006/main">
               <a:ext uri="{FF2B5EF4-FFF2-40B4-BE49-F238E27FC236}">
-                <a16:creationId xmlns:a16="http://schemas.microsoft.com/office/drawing/2014/main" id="{261338D7-781E-4AD8-BA11-33A54C23B758}"/>
+                <a16:creationId xmlns:a16="http://schemas.microsoft.com/office/drawing/2014/main" id="{084410EE-2E34-4CF6-A9B1-AACD1B3A6789}"/>
               </a:ext>
             </a:extLst>
           </p:cNvPr>
@@ -22653,8 +22815,8 @@
         </p:nvSpPr>
         <p:spPr>
           <a:xfrm xmlns:a="http://schemas.openxmlformats.org/drawingml/2006/main">
-            <a:off x="8258175" y="3524250"/>
-            <a:ext cx="3086100" cy="1524000"/>
+            <a:off x="8258175" y="3448050"/>
+            <a:ext cx="3086100" cy="1676400"/>
           </a:xfrm>
           <a:prstGeom xmlns:a="http://schemas.openxmlformats.org/drawingml/2006/main" prst="rect">
             <a:avLst/>
@@ -22789,7 +22951,7 @@
                 <a:ea typeface="Avenir Next"/>
                 <a:cs typeface="Avenir Next"/>
               </a:rPr>
-              <a:t>1. Iniciar Qolqe</a:t>
+              <a:t>EN VIVO</a:t>
             </a:r>
           </a:p>
           <a:p xmlns:a="http://schemas.openxmlformats.org/drawingml/2006/main">
@@ -22812,7 +22974,7 @@
                 <a:ea typeface="Avenir Next"/>
                 <a:cs typeface="Avenir Next"/>
               </a:rPr>
-              <a:t>2. Ejecutar Robot</a:t>
+              <a:t>Ejecutar Robot</a:t>
             </a:r>
           </a:p>
           <a:p xmlns:a="http://schemas.openxmlformats.org/drawingml/2006/main">
@@ -22835,7 +22997,30 @@
                 <a:ea typeface="Avenir Next"/>
                 <a:cs typeface="Avenir Next"/>
               </a:rPr>
-              <a:t>3. Abrir report.html</a:t>
+              <a:t>Abrir report.html</a:t>
+            </a:r>
+          </a:p>
+          <a:p xmlns:a="http://schemas.openxmlformats.org/drawingml/2006/main">
+            <a:pPr algn="l">
+              <a:defRPr sz="1800" b="0">
+                <a:solidFill>
+                  <a:srgbClr val="FFFFFF"/>
+                </a:solidFill>
+                <a:latin typeface="Avenir Next"/>
+                <a:ea typeface="Avenir Next"/>
+                <a:cs typeface="Avenir Next"/>
+              </a:defRPr>
+            </a:pPr>
+            <a:r>
+              <a:rPr sz="1800" b="0">
+                <a:solidFill>
+                  <a:srgbClr val="FFFFFF"/>
+                </a:solidFill>
+                <a:latin typeface="Avenir Next"/>
+                <a:ea typeface="Avenir Next"/>
+                <a:cs typeface="Avenir Next"/>
+              </a:rPr>
+              <a:t>Expandir log.html</a:t>
             </a:r>
           </a:p>
         </p:txBody>
@@ -22845,7 +23030,7 @@
           <p:cNvPr id="14" name="">
             <a:extLst xmlns:a="http://schemas.openxmlformats.org/drawingml/2006/main">
               <a:ext uri="{FF2B5EF4-FFF2-40B4-BE49-F238E27FC236}">
-                <a16:creationId xmlns:a16="http://schemas.microsoft.com/office/drawing/2014/main" id="{E0643247-7531-49B9-8FCB-62E594734AC3}"/>
+                <a16:creationId xmlns:a16="http://schemas.microsoft.com/office/drawing/2014/main" id="{D6DEDB5E-75F1-486A-BF96-F2308EC96C88}"/>
               </a:ext>
             </a:extLst>
           </p:cNvPr>
@@ -22991,7 +23176,7 @@
                 <a:latin typeface="Avenir Next"/>
                 <a:ea typeface="Avenir Next"/>
                 <a:cs typeface="Avenir Next"/>
-                <a:hlinkClick xmlns:r="http://schemas.openxmlformats.org/officeDocument/2006/relationships" r:id="R7d5dba2d43394d11"/>
+                <a:hlinkClick xmlns:r="http://schemas.openxmlformats.org/officeDocument/2006/relationships" r:id="R7cd36be46e304e3d"/>
               </a:rPr>
               <a:t>Abrir README de ejecución</a:t>
             </a:r>
@@ -23001,7 +23186,7 @@
     </p:spTree>
     <p:extLst>
       <p:ext uri="{BB962C8B-B14F-4D97-AF65-F5344CB8AC3E}">
-        <p14:creationId xmlns:p14="http://schemas.microsoft.com/office/powerpoint/2010/main" val="456408890"/>
+        <p14:creationId xmlns:p14="http://schemas.microsoft.com/office/powerpoint/2010/main" val="1629542298"/>
       </p:ext>
     </p:extLst>
   </p:cSld>
@@ -23032,7 +23217,7 @@
           <p:cNvPr id="19" name="">
             <a:extLst xmlns:a="http://schemas.openxmlformats.org/drawingml/2006/main">
               <a:ext uri="{FF2B5EF4-FFF2-40B4-BE49-F238E27FC236}">
-                <a16:creationId xmlns:a16="http://schemas.microsoft.com/office/drawing/2014/main" id="{A69CB88F-426D-4E64-A383-20877E6108AA}"/>
+                <a16:creationId xmlns:a16="http://schemas.microsoft.com/office/drawing/2014/main" id="{8120710B-7029-4994-83F2-FF59B2B3D96E}"/>
               </a:ext>
             </a:extLst>
           </p:cNvPr>
@@ -23063,7 +23248,7 @@
           <p:cNvPr id="2" name="">
             <a:extLst xmlns:a="http://schemas.openxmlformats.org/drawingml/2006/main">
               <a:ext uri="{FF2B5EF4-FFF2-40B4-BE49-F238E27FC236}">
-                <a16:creationId xmlns:a16="http://schemas.microsoft.com/office/drawing/2014/main" id="{F85B46AB-514A-44B4-9128-06F085994047}"/>
+                <a16:creationId xmlns:a16="http://schemas.microsoft.com/office/drawing/2014/main" id="{923888A0-F100-434D-A618-CF885558781C}"/>
               </a:ext>
             </a:extLst>
           </p:cNvPr>
@@ -23220,7 +23405,7 @@
           <p:cNvPr id="3" name="">
             <a:extLst xmlns:a="http://schemas.openxmlformats.org/drawingml/2006/main">
               <a:ext uri="{FF2B5EF4-FFF2-40B4-BE49-F238E27FC236}">
-                <a16:creationId xmlns:a16="http://schemas.microsoft.com/office/drawing/2014/main" id="{14DC0450-6ECD-4BC5-AA6B-58444692DF8F}"/>
+                <a16:creationId xmlns:a16="http://schemas.microsoft.com/office/drawing/2014/main" id="{F7F1D703-C935-4E2E-BF73-E02406692919}"/>
               </a:ext>
             </a:extLst>
           </p:cNvPr>
@@ -23367,7 +23552,7 @@
                 <a:ea typeface="Avenir Next"/>
                 <a:cs typeface="Avenir Next"/>
               </a:rPr>
-              <a:t>IA aplicada: revisión del caso</a:t>
+              <a:t>IA en vivo: detectar una brecha</a:t>
             </a:r>
           </a:p>
         </p:txBody>
@@ -23377,7 +23562,7 @@
           <p:cNvPr id="4" name="">
             <a:extLst xmlns:a="http://schemas.openxmlformats.org/drawingml/2006/main">
               <a:ext uri="{FF2B5EF4-FFF2-40B4-BE49-F238E27FC236}">
-                <a16:creationId xmlns:a16="http://schemas.microsoft.com/office/drawing/2014/main" id="{414C9FC5-64D0-4108-938B-4180AE1DE5DE}"/>
+                <a16:creationId xmlns:a16="http://schemas.microsoft.com/office/drawing/2014/main" id="{7D1B584F-29DA-4A92-96DE-D7E31085C151}"/>
               </a:ext>
             </a:extLst>
           </p:cNvPr>
@@ -23524,7 +23709,7 @@
                 <a:ea typeface="Avenir Next"/>
                 <a:cs typeface="Avenir Next"/>
               </a:rPr>
-              <a:t>Codex inspecciona la evidencia y señala una validación faltante.</a:t>
+              <a:t>Codex contrasta la ejecución de Robot con los criterios de aceptación.</a:t>
             </a:r>
           </a:p>
         </p:txBody>
@@ -23534,7 +23719,7 @@
           <p:cNvPr id="5" name="">
             <a:extLst xmlns:a="http://schemas.openxmlformats.org/drawingml/2006/main">
               <a:ext uri="{FF2B5EF4-FFF2-40B4-BE49-F238E27FC236}">
-                <a16:creationId xmlns:a16="http://schemas.microsoft.com/office/drawing/2014/main" id="{B1A66FBC-FBD9-4532-A55B-2B69AD1E918C}"/>
+                <a16:creationId xmlns:a16="http://schemas.microsoft.com/office/drawing/2014/main" id="{FA2DC893-697F-4AE6-B542-881954C7FA77}"/>
               </a:ext>
             </a:extLst>
           </p:cNvPr>
@@ -23565,7 +23750,7 @@
           <p:cNvPr id="6" name="">
             <a:extLst xmlns:a="http://schemas.openxmlformats.org/drawingml/2006/main">
               <a:ext uri="{FF2B5EF4-FFF2-40B4-BE49-F238E27FC236}">
-                <a16:creationId xmlns:a16="http://schemas.microsoft.com/office/drawing/2014/main" id="{F9EBCF51-D382-47AF-BF64-F585939FA90D}"/>
+                <a16:creationId xmlns:a16="http://schemas.microsoft.com/office/drawing/2014/main" id="{675A4E74-024C-40CD-A1CA-828A36234EDF}"/>
               </a:ext>
             </a:extLst>
           </p:cNvPr>
@@ -23722,7 +23907,7 @@
           <p:cNvPr id="7" name="">
             <a:extLst xmlns:a="http://schemas.openxmlformats.org/drawingml/2006/main">
               <a:ext uri="{FF2B5EF4-FFF2-40B4-BE49-F238E27FC236}">
-                <a16:creationId xmlns:a16="http://schemas.microsoft.com/office/drawing/2014/main" id="{FF70F313-96DB-489E-A5AE-4B6540AB969B}"/>
+                <a16:creationId xmlns:a16="http://schemas.microsoft.com/office/drawing/2014/main" id="{F905A7D7-23BC-433B-8394-BD5D130BEC01}"/>
               </a:ext>
             </a:extLst>
           </p:cNvPr>
@@ -23879,7 +24064,7 @@
           <p:cNvPr id="8" name="">
             <a:extLst xmlns:a="http://schemas.openxmlformats.org/drawingml/2006/main">
               <a:ext uri="{FF2B5EF4-FFF2-40B4-BE49-F238E27FC236}">
-                <a16:creationId xmlns:a16="http://schemas.microsoft.com/office/drawing/2014/main" id="{1E9E6C2D-5B18-4D49-B3B3-27B88B618F02}"/>
+                <a16:creationId xmlns:a16="http://schemas.microsoft.com/office/drawing/2014/main" id="{F383F324-1AAE-4745-857D-B45A3478EBC3}"/>
               </a:ext>
             </a:extLst>
           </p:cNvPr>
@@ -23912,7 +24097,7 @@
           <p:cNvPr id="9" name="">
             <a:extLst xmlns:a="http://schemas.openxmlformats.org/drawingml/2006/main">
               <a:ext uri="{FF2B5EF4-FFF2-40B4-BE49-F238E27FC236}">
-                <a16:creationId xmlns:a16="http://schemas.microsoft.com/office/drawing/2014/main" id="{85A75C4A-8EC0-43BD-8C95-8384CCF4B3E4}"/>
+                <a16:creationId xmlns:a16="http://schemas.microsoft.com/office/drawing/2014/main" id="{E8BD1A57-9257-4FED-B8C7-5937EB8364FA}"/>
               </a:ext>
             </a:extLst>
           </p:cNvPr>
@@ -23945,7 +24130,7 @@
           <p:cNvPr id="10" name="">
             <a:extLst xmlns:a="http://schemas.openxmlformats.org/drawingml/2006/main">
               <a:ext uri="{FF2B5EF4-FFF2-40B4-BE49-F238E27FC236}">
-                <a16:creationId xmlns:a16="http://schemas.microsoft.com/office/drawing/2014/main" id="{919A4225-F493-4ADA-B8D5-0BB51EFE3330}"/>
+                <a16:creationId xmlns:a16="http://schemas.microsoft.com/office/drawing/2014/main" id="{6D61C56E-090A-46E4-97C0-C2300F2177BD}"/>
               </a:ext>
             </a:extLst>
           </p:cNvPr>
@@ -24102,7 +24287,7 @@
           <p:cNvPr id="11" name="">
             <a:extLst xmlns:a="http://schemas.openxmlformats.org/drawingml/2006/main">
               <a:ext uri="{FF2B5EF4-FFF2-40B4-BE49-F238E27FC236}">
-                <a16:creationId xmlns:a16="http://schemas.microsoft.com/office/drawing/2014/main" id="{08DFC5FA-9438-4BA4-A411-8B353BD3FE48}"/>
+                <a16:creationId xmlns:a16="http://schemas.microsoft.com/office/drawing/2014/main" id="{CE610B44-828A-4C69-90AE-7B2842C44798}"/>
               </a:ext>
             </a:extLst>
           </p:cNvPr>
@@ -24129,7 +24314,7 @@
           <a:bodyPr xmlns:a="http://schemas.openxmlformats.org/drawingml/2006/main" anchor="ctr"/>
           <a:lstStyle xmlns:a="http://schemas.openxmlformats.org/drawingml/2006/main">
             <a:defPPr algn="l">
-              <a:defRPr sz="2325" b="1">
+              <a:defRPr sz="2100" b="1">
                 <a:solidFill>
                   <a:srgbClr val="FFFFFF"/>
                 </a:solidFill>
@@ -24139,7 +24324,7 @@
               </a:defRPr>
             </a:defPPr>
             <a:lvl1pPr algn="l">
-              <a:defRPr sz="2325" b="1">
+              <a:defRPr sz="2100" b="1">
                 <a:solidFill>
                   <a:srgbClr val="FFFFFF"/>
                 </a:solidFill>
@@ -24149,7 +24334,7 @@
               </a:defRPr>
             </a:lvl1pPr>
             <a:lvl2pPr algn="l">
-              <a:defRPr sz="2325" b="1">
+              <a:defRPr sz="2100" b="1">
                 <a:solidFill>
                   <a:srgbClr val="FFFFFF"/>
                 </a:solidFill>
@@ -24159,7 +24344,7 @@
               </a:defRPr>
             </a:lvl2pPr>
             <a:lvl3pPr algn="l">
-              <a:defRPr sz="2325" b="1">
+              <a:defRPr sz="2100" b="1">
                 <a:solidFill>
                   <a:srgbClr val="FFFFFF"/>
                 </a:solidFill>
@@ -24169,7 +24354,7 @@
               </a:defRPr>
             </a:lvl3pPr>
             <a:lvl4pPr algn="l">
-              <a:defRPr sz="2325" b="1">
+              <a:defRPr sz="2100" b="1">
                 <a:solidFill>
                   <a:srgbClr val="FFFFFF"/>
                 </a:solidFill>
@@ -24179,7 +24364,7 @@
               </a:defRPr>
             </a:lvl4pPr>
             <a:lvl5pPr algn="l">
-              <a:defRPr sz="2325" b="1">
+              <a:defRPr sz="2100" b="1">
                 <a:solidFill>
                   <a:srgbClr val="FFFFFF"/>
                 </a:solidFill>
@@ -24189,7 +24374,7 @@
               </a:defRPr>
             </a:lvl5pPr>
             <a:lvl6pPr algn="l">
-              <a:defRPr sz="2325" b="1">
+              <a:defRPr sz="2100" b="1">
                 <a:solidFill>
                   <a:srgbClr val="FFFFFF"/>
                 </a:solidFill>
@@ -24199,7 +24384,7 @@
               </a:defRPr>
             </a:lvl6pPr>
             <a:lvl7pPr algn="l">
-              <a:defRPr sz="2325" b="1">
+              <a:defRPr sz="2100" b="1">
                 <a:solidFill>
                   <a:srgbClr val="FFFFFF"/>
                 </a:solidFill>
@@ -24209,7 +24394,7 @@
               </a:defRPr>
             </a:lvl7pPr>
             <a:lvl8pPr algn="l">
-              <a:defRPr sz="2325" b="1">
+              <a:defRPr sz="2100" b="1">
                 <a:solidFill>
                   <a:srgbClr val="FFFFFF"/>
                 </a:solidFill>
@@ -24219,7 +24404,7 @@
               </a:defRPr>
             </a:lvl8pPr>
             <a:lvl9pPr algn="l">
-              <a:defRPr sz="2325" b="1">
+              <a:defRPr sz="2100" b="1">
                 <a:solidFill>
                   <a:srgbClr val="FFFFFF"/>
                 </a:solidFill>
@@ -24231,7 +24416,7 @@
           </a:lstStyle>
           <a:p xmlns:a="http://schemas.openxmlformats.org/drawingml/2006/main">
             <a:pPr algn="l">
-              <a:defRPr sz="2325" b="1">
+              <a:defRPr sz="2100" b="1">
                 <a:solidFill>
                   <a:srgbClr val="FFFFFF"/>
                 </a:solidFill>
@@ -24241,7 +24426,7 @@
               </a:defRPr>
             </a:pPr>
             <a:r>
-              <a:rPr sz="2325" b="1">
+              <a:rPr sz="2100" b="1">
                 <a:solidFill>
                   <a:srgbClr val="FFFFFF"/>
                 </a:solidFill>
@@ -24249,12 +24434,12 @@
                 <a:ea typeface="Avenir Next"/>
                 <a:cs typeface="Avenir Next"/>
               </a:rPr>
-              <a:t>“Compara output.xml con HU-G4-06 y HU-G4-08.</a:t>
+              <a:t>“Compara output.xml + el caso .robot con HU-G4-06 y HU-G4-08.</a:t>
             </a:r>
           </a:p>
           <a:p xmlns:a="http://schemas.openxmlformats.org/drawingml/2006/main">
             <a:pPr algn="l">
-              <a:defRPr sz="2325" b="1">
+              <a:defRPr sz="2100" b="1">
                 <a:solidFill>
                   <a:srgbClr val="FFFFFF"/>
                 </a:solidFill>
@@ -24264,7 +24449,7 @@
               </a:defRPr>
             </a:pPr>
             <a:r>
-              <a:rPr sz="2325" b="1">
+              <a:rPr sz="2100" b="1">
                 <a:solidFill>
                   <a:srgbClr val="FFFFFF"/>
                 </a:solidFill>
@@ -24272,7 +24457,7 @@
                 <a:ea typeface="Avenir Next"/>
                 <a:cs typeface="Avenir Next"/>
               </a:rPr>
-              <a:t>¿Qué validación importante falta?”</a:t>
+              <a:t>¿Qué falta validar? Propón un keyword mínimo.”</a:t>
             </a:r>
           </a:p>
         </p:txBody>
@@ -24282,7 +24467,7 @@
           <p:cNvPr id="12" name="">
             <a:extLst xmlns:a="http://schemas.openxmlformats.org/drawingml/2006/main">
               <a:ext uri="{FF2B5EF4-FFF2-40B4-BE49-F238E27FC236}">
-                <a16:creationId xmlns:a16="http://schemas.microsoft.com/office/drawing/2014/main" id="{13D83747-1ECF-4E9C-93E7-CDCA39BA0ECC}"/>
+                <a16:creationId xmlns:a16="http://schemas.microsoft.com/office/drawing/2014/main" id="{88071D09-59CB-44B3-B895-2FC45063ECF7}"/>
               </a:ext>
             </a:extLst>
           </p:cNvPr>
@@ -24315,7 +24500,7 @@
           <p:cNvPr id="13" name="">
             <a:extLst xmlns:a="http://schemas.openxmlformats.org/drawingml/2006/main">
               <a:ext uri="{FF2B5EF4-FFF2-40B4-BE49-F238E27FC236}">
-                <a16:creationId xmlns:a16="http://schemas.microsoft.com/office/drawing/2014/main" id="{CFD288BA-42D5-4C67-9DF7-329753C9220D}"/>
+                <a16:creationId xmlns:a16="http://schemas.microsoft.com/office/drawing/2014/main" id="{4BB3F7E8-3FF0-4CF8-A0D8-A776E18C36EF}"/>
               </a:ext>
             </a:extLst>
           </p:cNvPr>
@@ -24462,7 +24647,7 @@
                 <a:ea typeface="Avenir Next"/>
                 <a:cs typeface="Avenir Next"/>
               </a:rPr>
-              <a:t>HALLAZGO</a:t>
+              <a:t>SALIDA ESPERADA</a:t>
             </a:r>
           </a:p>
         </p:txBody>
@@ -24472,7 +24657,7 @@
           <p:cNvPr id="14" name="">
             <a:extLst xmlns:a="http://schemas.openxmlformats.org/drawingml/2006/main">
               <a:ext uri="{FF2B5EF4-FFF2-40B4-BE49-F238E27FC236}">
-                <a16:creationId xmlns:a16="http://schemas.microsoft.com/office/drawing/2014/main" id="{F8AFC800-6BB4-4F20-9DC3-4E2008EAA409}"/>
+                <a16:creationId xmlns:a16="http://schemas.microsoft.com/office/drawing/2014/main" id="{150419C7-1E8F-46B0-8738-524134BBD6D5}"/>
               </a:ext>
             </a:extLst>
           </p:cNvPr>
@@ -24619,7 +24804,7 @@
                 <a:ea typeface="Avenir Next"/>
                 <a:cs typeface="Avenir Next"/>
               </a:rPr>
-              <a:t>Falta verificar el SMS simulado</a:t>
+              <a:t>Brecha: SMS simulado</a:t>
             </a:r>
           </a:p>
           <a:p xmlns:a="http://schemas.openxmlformats.org/drawingml/2006/main">
@@ -24652,7 +24837,7 @@
           <p:cNvPr id="15" name="">
             <a:extLst xmlns:a="http://schemas.openxmlformats.org/drawingml/2006/main">
               <a:ext uri="{FF2B5EF4-FFF2-40B4-BE49-F238E27FC236}">
-                <a16:creationId xmlns:a16="http://schemas.microsoft.com/office/drawing/2014/main" id="{6F689109-8662-4835-81D7-83847696ACB7}"/>
+                <a16:creationId xmlns:a16="http://schemas.microsoft.com/office/drawing/2014/main" id="{B9FA757A-859B-4C3A-9CEE-07EEFF47ABFF}"/>
               </a:ext>
             </a:extLst>
           </p:cNvPr>
@@ -24685,7 +24870,7 @@
           <p:cNvPr id="16" name="">
             <a:extLst xmlns:a="http://schemas.openxmlformats.org/drawingml/2006/main">
               <a:ext uri="{FF2B5EF4-FFF2-40B4-BE49-F238E27FC236}">
-                <a16:creationId xmlns:a16="http://schemas.microsoft.com/office/drawing/2014/main" id="{DD8CE56F-6E5A-4289-BB4C-618DD889F30D}"/>
+                <a16:creationId xmlns:a16="http://schemas.microsoft.com/office/drawing/2014/main" id="{D562F405-1A9A-4D4C-AAEB-80C80D558C71}"/>
               </a:ext>
             </a:extLst>
           </p:cNvPr>
@@ -24832,7 +25017,7 @@
                 <a:ea typeface="Avenir Next"/>
                 <a:cs typeface="Avenir Next"/>
               </a:rPr>
-              <a:t>CRITERIO</a:t>
+              <a:t>PROPUESTA DE IA</a:t>
             </a:r>
           </a:p>
         </p:txBody>
@@ -24842,7 +25027,7 @@
           <p:cNvPr id="17" name="">
             <a:extLst xmlns:a="http://schemas.openxmlformats.org/drawingml/2006/main">
               <a:ext uri="{FF2B5EF4-FFF2-40B4-BE49-F238E27FC236}">
-                <a16:creationId xmlns:a16="http://schemas.microsoft.com/office/drawing/2014/main" id="{9A9AA587-612E-4705-AD92-ECD2332F33B5}"/>
+                <a16:creationId xmlns:a16="http://schemas.microsoft.com/office/drawing/2014/main" id="{A5C05754-2FB4-4B70-B40A-A3DE018A1AA7}"/>
               </a:ext>
             </a:extLst>
           </p:cNvPr>
@@ -24989,7 +25174,7 @@
                 <a:ea typeface="Avenir Next"/>
                 <a:cs typeface="Avenir Next"/>
               </a:rPr>
-              <a:t>Contrastar con requisitos y</a:t>
+              <a:t>Keyword para notificaciones;</a:t>
             </a:r>
           </a:p>
           <a:p xmlns:a="http://schemas.openxmlformats.org/drawingml/2006/main">
@@ -25012,7 +25197,7 @@
                 <a:ea typeface="Avenir Next"/>
                 <a:cs typeface="Avenir Next"/>
               </a:rPr>
-              <a:t>ejecutar el cambio propuesto.</a:t>
+              <a:t>validarlo y ejecutarlo.</a:t>
             </a:r>
           </a:p>
         </p:txBody>
@@ -25022,7 +25207,7 @@
           <p:cNvPr id="18" name="">
             <a:extLst xmlns:a="http://schemas.openxmlformats.org/drawingml/2006/main">
               <a:ext uri="{FF2B5EF4-FFF2-40B4-BE49-F238E27FC236}">
-                <a16:creationId xmlns:a16="http://schemas.microsoft.com/office/drawing/2014/main" id="{9A5C260A-B026-44D3-8783-770DD49F7BDC}"/>
+                <a16:creationId xmlns:a16="http://schemas.microsoft.com/office/drawing/2014/main" id="{79AE9826-282A-4C4D-8FE1-4204E6A64459}"/>
               </a:ext>
             </a:extLst>
           </p:cNvPr>
@@ -25168,7 +25353,7 @@
                 <a:latin typeface="Avenir Next"/>
                 <a:ea typeface="Avenir Next"/>
                 <a:cs typeface="Avenir Next"/>
-                <a:hlinkClick xmlns:r="http://schemas.openxmlformats.org/officeDocument/2006/relationships" r:id="R7037d8fb938d4ce5"/>
+                <a:hlinkClick xmlns:r="http://schemas.openxmlformats.org/officeDocument/2006/relationships" r:id="R9c2f3d13c6a34446"/>
               </a:rPr>
               <a:t>Abrir guía de la demo IA</a:t>
             </a:r>
@@ -25178,7 +25363,7 @@
     </p:spTree>
     <p:extLst>
       <p:ext uri="{BB962C8B-B14F-4D97-AF65-F5344CB8AC3E}">
-        <p14:creationId xmlns:p14="http://schemas.microsoft.com/office/powerpoint/2010/main" val="1260835745"/>
+        <p14:creationId xmlns:p14="http://schemas.microsoft.com/office/powerpoint/2010/main" val="1664538901"/>
       </p:ext>
     </p:extLst>
   </p:cSld>

</xml_diff>

<commit_message>
Align visible slide text with presentation script
</commit_message>
<xml_diff>
--- a/docs/Presentacion_Robot_Framework_G4_visual.pptx
+++ b/docs/Presentacion_Robot_Framework_G4_visual.pptx
@@ -2,22 +2,22 @@
 <file path=ppt/presentation.xml><?xml version="1.0" encoding="utf-8"?>
 <p:presentation xmlns:p="http://schemas.openxmlformats.org/presentationml/2006/main">
   <p:sldMasterIdLst>
-    <p:sldMasterId xmlns:r="http://schemas.openxmlformats.org/officeDocument/2006/relationships" id="2147483648" r:id="R2ae380a6541e4f20"/>
+    <p:sldMasterId xmlns:r="http://schemas.openxmlformats.org/officeDocument/2006/relationships" id="2147483648" r:id="R4466f21476964483"/>
   </p:sldMasterIdLst>
   <p:notesMasterIdLst>
-    <p:notesMasterId xmlns:r="http://schemas.openxmlformats.org/officeDocument/2006/relationships" r:id="R5e01f9ae0f994251"/>
+    <p:notesMasterId xmlns:r="http://schemas.openxmlformats.org/officeDocument/2006/relationships" r:id="R8ddd3a5d857c4668"/>
   </p:notesMasterIdLst>
   <p:sldIdLst>
-    <p:sldId xmlns:r="http://schemas.openxmlformats.org/officeDocument/2006/relationships" id="256" r:id="R99011ee507364b06"/>
-    <p:sldId xmlns:r="http://schemas.openxmlformats.org/officeDocument/2006/relationships" id="257" r:id="R92cf04694527474b"/>
-    <p:sldId xmlns:r="http://schemas.openxmlformats.org/officeDocument/2006/relationships" id="258" r:id="Rb76e397e8499422f"/>
-    <p:sldId xmlns:r="http://schemas.openxmlformats.org/officeDocument/2006/relationships" id="259" r:id="Reb699d1ed04b4a24"/>
-    <p:sldId xmlns:r="http://schemas.openxmlformats.org/officeDocument/2006/relationships" id="260" r:id="Ra078f7db640a4b75"/>
-    <p:sldId xmlns:r="http://schemas.openxmlformats.org/officeDocument/2006/relationships" id="261" r:id="Rc1999236c5984120"/>
-    <p:sldId xmlns:r="http://schemas.openxmlformats.org/officeDocument/2006/relationships" id="262" r:id="R9c85d9eb7bf24aae"/>
-    <p:sldId xmlns:r="http://schemas.openxmlformats.org/officeDocument/2006/relationships" id="263" r:id="R74b73686d31f4ccd"/>
-    <p:sldId xmlns:r="http://schemas.openxmlformats.org/officeDocument/2006/relationships" id="264" r:id="R102ba38e8d4b49b1"/>
-    <p:sldId xmlns:r="http://schemas.openxmlformats.org/officeDocument/2006/relationships" id="265" r:id="Rb0d88f7e90c6452e"/>
+    <p:sldId xmlns:r="http://schemas.openxmlformats.org/officeDocument/2006/relationships" id="256" r:id="R7443b7981e154fb9"/>
+    <p:sldId xmlns:r="http://schemas.openxmlformats.org/officeDocument/2006/relationships" id="257" r:id="Rfd14674a671e47f6"/>
+    <p:sldId xmlns:r="http://schemas.openxmlformats.org/officeDocument/2006/relationships" id="258" r:id="R71e11bfdec694053"/>
+    <p:sldId xmlns:r="http://schemas.openxmlformats.org/officeDocument/2006/relationships" id="259" r:id="R782c8ef467fc49d0"/>
+    <p:sldId xmlns:r="http://schemas.openxmlformats.org/officeDocument/2006/relationships" id="260" r:id="R588a943505524f1e"/>
+    <p:sldId xmlns:r="http://schemas.openxmlformats.org/officeDocument/2006/relationships" id="261" r:id="R8f1c0e6fe96a4228"/>
+    <p:sldId xmlns:r="http://schemas.openxmlformats.org/officeDocument/2006/relationships" id="262" r:id="R616efd341dc44ba0"/>
+    <p:sldId xmlns:r="http://schemas.openxmlformats.org/officeDocument/2006/relationships" id="263" r:id="R6aa6a7f57288474f"/>
+    <p:sldId xmlns:r="http://schemas.openxmlformats.org/officeDocument/2006/relationships" id="264" r:id="Rc31e49eb5d884363"/>
+    <p:sldId xmlns:r="http://schemas.openxmlformats.org/officeDocument/2006/relationships" id="265" r:id="R793c3a4f35894720"/>
   </p:sldIdLst>
   <p:sldSz cx="12192000" cy="6858000"/>
   <p:notesSz cx="6858000" cy="9144000"/>
@@ -451,6 +451,26 @@
           <a:lstStyle xmlns:a="http://schemas.openxmlformats.org/drawingml/2006/main"/>
           <a:p xmlns:a="http://schemas.openxmlformats.org/drawingml/2006/main">
             <a:r>
+              <a:t>GUION 0:00-0:20</a:t>
+            </a:r>
+          </a:p>
+          <a:p xmlns:a="http://schemas.openxmlformats.org/drawingml/2006/main">
+            <a:r>
+              <a:t>Hola. En este trabajo automatizamos un recorrido completo del módulo de solicitudes de dinero de Qolqe. Diego agrega a Bruno como contacto, le pide 25 soles y Bruno acepta. Lo hicimos con Robot Framework y el patrón Page Object. Al final veremos la prueba ejecutándose y una revisión con inteligencia artificial.</a:t>
+            </a:r>
+          </a:p>
+          <a:p xmlns:a="http://schemas.openxmlformats.org/drawingml/2006/main">
+            <a:r>
+              <a:t/>
+            </a:r>
+          </a:p>
+          <a:p xmlns:a="http://schemas.openxmlformats.org/drawingml/2006/main">
+            <a:r>
+              <a:t>REFERENCIAS Y GUÍA</a:t>
+            </a:r>
+          </a:p>
+          <a:p xmlns:a="http://schemas.openxmlformats.org/drawingml/2006/main">
+            <a:r>
               <a:t>0:00-0:20 (20 s). Presentar el objetivo y anunciar que se verá la ejecución real y una revisión con IA en vivo. El flujo involucra a Diego y Bruno en el módulo G4. La captura es de la instancia local de Qolqe. Fuente del encargo: Canvas, Clase 11 - Automatización.pdf, archivo 4957072, y tarea 349599.</a:t>
             </a:r>
           </a:p>
@@ -519,6 +539,26 @@
         <p:txBody>
           <a:bodyPr xmlns:a="http://schemas.openxmlformats.org/drawingml/2006/main"/>
           <a:lstStyle xmlns:a="http://schemas.openxmlformats.org/drawingml/2006/main"/>
+          <a:p xmlns:a="http://schemas.openxmlformats.org/drawingml/2006/main">
+            <a:r>
+              <a:t>GUION 9:10-10:00</a:t>
+            </a:r>
+          </a:p>
+          <a:p xmlns:a="http://schemas.openxmlformats.org/drawingml/2006/main">
+            <a:r>
+              <a:t>Para cerrar, encontramos una dificultad real: justo después de aceptar, la pantalla todavía podía mostrar Pendiente durante un instante. Lo resolvimos esperando a que el estado Aceptada fuera visible antes de comprobarlo. También hay límites: instalar el navegador y sus dependencias toma tiempo, las pruebas por interfaz son más lentas que las de API y los selectores requieren mantenimiento. Por eso no usaríamos este enfoque para cada regla pequeña ni para servicios externos que no controlamos. El repositorio incluye el código, el README para ejecutar la demo y esta presentación. Gracias.</a:t>
+            </a:r>
+          </a:p>
+          <a:p xmlns:a="http://schemas.openxmlformats.org/drawingml/2006/main">
+            <a:r>
+              <a:t/>
+            </a:r>
+          </a:p>
+          <a:p xmlns:a="http://schemas.openxmlformats.org/drawingml/2006/main">
+            <a:r>
+              <a:t>REFERENCIAS Y GUÍA</a:t>
+            </a:r>
+          </a:p>
           <a:p xmlns:a="http://schemas.openxmlformats.org/drawingml/2006/main">
             <a:r>
               <a:t>9:10-10:00 (50 s). Dificultad observada: tras aceptar, la pantalla podía seguir en Pendiente; la espera por estado visible resolvió la carrera. Límites: Chromium y dependencias, mayor lentitud que API/unidad y mantenimiento de selectores. No usar UI E2E para cada regla pequeña ni contra servicios externos no controlados. Reconocer que el SMS simulado todavía no está validado. Cerrar señalando el enlace público al repositorio, con código, README ejecutable y esta presentación. Fuente: Canvas Clase 11, riesgos/esperas/pirámide; ejecución local; README del repositorio.</a:t>
@@ -591,6 +631,26 @@
           <a:lstStyle xmlns:a="http://schemas.openxmlformats.org/drawingml/2006/main"/>
           <a:p xmlns:a="http://schemas.openxmlformats.org/drawingml/2006/main">
             <a:r>
+              <a:t>GUION 0:20-1:00</a:t>
+            </a:r>
+          </a:p>
+          <a:p xmlns:a="http://schemas.openxmlformats.org/drawingml/2006/main">
+            <a:r>
+              <a:t>Robot Framework es una herramienta para automatizar pruebas usando palabras clave fáciles de leer. En lugar de repetir manualmente todos los clics, describimos el recorrido una vez y dejamos que la prueba lo ejecute y compruebe el resultado. En Qolqe no basta con pulsar “Enviar solicitud”: también queremos saber si quedó Pendiente, si después fue Aceptada y si el dinero realmente cambió de cuenta. Ese es el problema que buscamos resolver.</a:t>
+            </a:r>
+          </a:p>
+          <a:p xmlns:a="http://schemas.openxmlformats.org/drawingml/2006/main">
+            <a:r>
+              <a:t/>
+            </a:r>
+          </a:p>
+          <a:p xmlns:a="http://schemas.openxmlformats.org/drawingml/2006/main">
+            <a:r>
+              <a:t>REFERENCIAS Y GUÍA</a:t>
+            </a:r>
+          </a:p>
+          <a:p xmlns:a="http://schemas.openxmlformats.org/drawingml/2006/main">
+            <a:r>
               <a:t>0:20-1:00 (40 s). Definir Robot Framework como marco abierto de automatización basado en palabras clave. Problema: repetir y comprobar el recorrido sin depender de clics manuales, con evidencia de cada ejecución. En Qolqe hay acciones y estados visibles. Fuente: https://robotframework.org/robotframework/latest/RobotFrameworkUserGuide y Canvas Clase 11.</a:t>
             </a:r>
           </a:p>
@@ -659,6 +719,26 @@
         <p:txBody>
           <a:bodyPr xmlns:a="http://schemas.openxmlformats.org/drawingml/2006/main"/>
           <a:lstStyle xmlns:a="http://schemas.openxmlformats.org/drawingml/2006/main"/>
+          <a:p xmlns:a="http://schemas.openxmlformats.org/drawingml/2006/main">
+            <a:r>
+              <a:t>GUION 1:00-1:40</a:t>
+            </a:r>
+          </a:p>
+          <a:p xmlns:a="http://schemas.openxmlformats.org/drawingml/2006/main">
+            <a:r>
+              <a:t>Robot Framework comenzó muy ligado a las pruebas de aceptación: casos expresados con palabras clave, bibliotecas para interactuar con sistemas y reportes claros. Luego amplió su uso a la automatización de tareas repetitivas, lo que se conoce como RPA. Para aplicaciones web actuales podemos usar Browser Library, que se apoya en Playwright. En este proyecto esa combinación controla un navegador Chromium real, igual que el que usaría una persona.</a:t>
+            </a:r>
+          </a:p>
+          <a:p xmlns:a="http://schemas.openxmlformats.org/drawingml/2006/main">
+            <a:r>
+              <a:t/>
+            </a:r>
+          </a:p>
+          <a:p xmlns:a="http://schemas.openxmlformats.org/drawingml/2006/main">
+            <a:r>
+              <a:t>REFERENCIAS Y GUÍA</a:t>
+            </a:r>
+          </a:p>
           <a:p xmlns:a="http://schemas.openxmlformats.org/drawingml/2006/main">
             <a:r>
               <a:t>1:00-1:40 (40 s). Explicar la evolución por capacidades: pruebas de aceptación con keywords, tareas RPA desde Robot Framework 3.1, y automatización web moderna con Browser Library sobre Playwright. No presentar esto como cronología exhaustiva. La instalación usada se verificó con Robot 7.5 y Browser Library 20.6.0. Fuentes: Robot Framework User Guide; https://github.com/MarketSquare/robotframework-browser ; notas de versión de Robot Framework 7.5.</a:t>
@@ -731,6 +811,26 @@
           <a:lstStyle xmlns:a="http://schemas.openxmlformats.org/drawingml/2006/main"/>
           <a:p xmlns:a="http://schemas.openxmlformats.org/drawingml/2006/main">
             <a:r>
+              <a:t>GUION 1:40-2:35</a:t>
+            </a:r>
+          </a:p>
+          <a:p xmlns:a="http://schemas.openxmlformats.org/drawingml/2006/main">
+            <a:r>
+              <a:t>La arquitectura se puede leer de izquierda a derecha. Primero está nuestro archivo de prueba, terminado en .robot, donde escribimos las acciones de negocio. Luego están los recursos Page Object: ahí viven los clics, los campos, las esperas y las comprobaciones de cada pantalla. El motor de Robot ejecuta esas palabras clave. Browser Library se comunica con Playwright, Playwright controla Chromium y el navegador interactúa con Qolqe. Esta separación ayuda porque el caso no necesita saber dónde está cada botón: solo expresa qué resultado esperamos. Al terminar, Robot produce output.xml, log.html y report.html. Así tenemos tanto el resultado resumido como el detalle de cada paso.</a:t>
+            </a:r>
+          </a:p>
+          <a:p xmlns:a="http://schemas.openxmlformats.org/drawingml/2006/main">
+            <a:r>
+              <a:t/>
+            </a:r>
+          </a:p>
+          <a:p xmlns:a="http://schemas.openxmlformats.org/drawingml/2006/main">
+            <a:r>
+              <a:t>REFERENCIAS Y GUÍA</a:t>
+            </a:r>
+          </a:p>
+          <a:p xmlns:a="http://schemas.openxmlformats.org/drawingml/2006/main">
+            <a:r>
               <a:t>1:40-2:35 (55 s). Seguir las flechas: el caso .robot llama keywords de los recursos Page Object; el motor de Robot los ejecuta; Browser Library usa Playwright para controlar Chromium contra Qolqe. El motor genera output.xml, log.html y report.html. Diferenciar motor, biblioteca, navegador y sistema bajo prueba. Fuentes: Robot Framework User Guide; https://github.com/MarketSquare/robotframework-browser ; tests/e2e del repositorio.</a:t>
             </a:r>
           </a:p>
@@ -799,6 +899,26 @@
         <p:txBody>
           <a:bodyPr xmlns:a="http://schemas.openxmlformats.org/drawingml/2006/main"/>
           <a:lstStyle xmlns:a="http://schemas.openxmlformats.org/drawingml/2006/main"/>
+          <a:p xmlns:a="http://schemas.openxmlformats.org/drawingml/2006/main">
+            <a:r>
+              <a:t>GUION 2:35-3:40</a:t>
+            </a:r>
+          </a:p>
+          <a:p xmlns:a="http://schemas.openxmlformats.org/drawingml/2006/main">
+            <a:r>
+              <a:t>El patrón que aplicamos es Page Object. En la izquierda vemos que el caso dice qué debe ocurrir: enviar la solicitud, aceptarla y comprobar estado y saldos. A la derecha vemos cómo se hace una de esas acciones: el recurso SolicitudesPage usa un selector para escribir el monto y otro para pulsar el botón. Cuando Bruno acepta, otra palabra clave reúne el clic de aceptación, el cuadro de confirmación y la espera por el nuevo estado. Elegimos este patrón porque el recorrido pasa por varias pantallas y por dos usuarios. Si Qolqe cambia un selector, lo corregimos en el recurso de esa pantalla; el caso principal sigue siendo legible y no tenemos que reescribir toda la historia.</a:t>
+            </a:r>
+          </a:p>
+          <a:p xmlns:a="http://schemas.openxmlformats.org/drawingml/2006/main">
+            <a:r>
+              <a:t/>
+            </a:r>
+          </a:p>
+          <a:p xmlns:a="http://schemas.openxmlformats.org/drawingml/2006/main">
+            <a:r>
+              <a:t>REFERENCIAS Y GUÍA</a:t>
+            </a:r>
+          </a:p>
           <a:p xmlns:a="http://schemas.openxmlformats.org/drawingml/2006/main">
             <a:r>
               <a:t>2:35-3:40 (65 s). Mostrar los dos fragmentos reales: el caso llama Enviar solicitud a contacto sin selectores; SolicitudesPage.resource usa Fill Text sobre input-solicitud-monto y Click sobre boton-solicitar. En Robot el patrón se implementa con recursos y user keywords, no requiere clases. Justificación: localizadores concentrados por pantalla, caso legible y menos cambios cuando varía un selector. Señalar tests/e2e/pages/ en el repositorio. Fuentes: Canvas Clase 11, sección de patrones; tests/e2e/g4_solicitud_happy_path.robot; tests/e2e/pages/SolicitudesPage.resource.</a:t>
@@ -871,6 +991,26 @@
           <a:lstStyle xmlns:a="http://schemas.openxmlformats.org/drawingml/2006/main"/>
           <a:p xmlns:a="http://schemas.openxmlformats.org/drawingml/2006/main">
             <a:r>
+              <a:t>GUION 3:40-4:45</a:t>
+            </a:r>
+          </a:p>
+          <a:p xmlns:a="http://schemas.openxmlformats.org/drawingml/2006/main">
+            <a:r>
+              <a:t>El happy path empieza con Diego. Entra a Qolqe y agrega a Bruno como contacto. La prueba no se queda solo con el clic en “Agregar”: busca el alias Bruno Demo y comprueba que aparece en la lista. Después Diego le solicita 25 soles con el motivo “Devolución demo G4”. El monto y el motivo están definidos en la suite, de modo que la prueba identifica esta solicitud concreta y no cualquier fila que esté en la pantalla. La segunda captura muestra el resultado que esperamos en ese momento: una solicitud enviada por 25 soles y en estado Pendiente. Estas son las primeras validaciones del flujo.</a:t>
+            </a:r>
+          </a:p>
+          <a:p xmlns:a="http://schemas.openxmlformats.org/drawingml/2006/main">
+            <a:r>
+              <a:t/>
+            </a:r>
+          </a:p>
+          <a:p xmlns:a="http://schemas.openxmlformats.org/drawingml/2006/main">
+            <a:r>
+              <a:t>REFERENCIAS Y GUÍA</a:t>
+            </a:r>
+          </a:p>
+          <a:p xmlns:a="http://schemas.openxmlformats.org/drawingml/2006/main">
+            <a:r>
               <a:t>3:40-4:45 (65 s). Mostrar las capturas como mapa previo a la ejecución y nombrar las validaciones: alias Bruno Demo visible, mensaje de solicitud enviada y fila por S/ 25 con estado Pendiente. Durante la ejecución del slide 8, estas acciones ocurrirán en Chromium. Fuente: capturas reales 01-contacto-creado.png y 03-solicitud-pendiente.png; requisitos Qolqe HU-G4-01, HU-G4-06 y HU-G4-07.</a:t>
             </a:r>
           </a:p>
@@ -939,6 +1079,26 @@
         <p:txBody>
           <a:bodyPr xmlns:a="http://schemas.openxmlformats.org/drawingml/2006/main"/>
           <a:lstStyle xmlns:a="http://schemas.openxmlformats.org/drawingml/2006/main"/>
+          <a:p xmlns:a="http://schemas.openxmlformats.org/drawingml/2006/main">
+            <a:r>
+              <a:t>GUION 4:45-5:55</a:t>
+            </a:r>
+          </a:p>
+          <a:p xmlns:a="http://schemas.openxmlformats.org/drawingml/2006/main">
+            <a:r>
+              <a:t>Ahora cambiamos de usuario. Bruno entra, encuentra la solicitud recibida y confirma que quiere transferir los 25 soles a Diego. Después de aceptar, la prueba verifica que el estado diga Aceptada y que aparezca un código de operación. También comprueba el efecto en los saldos: Bruno empieza con 800 soles y termina con 775; Diego empieza con 2,500 y termina con 2,525. En este caso la comisión es cero. La etiqueta Aceptada por sí sola no sería suficiente: por eso comprobamos también la operación y el cambio observable de dinero. Finalmente, volvemos a la cuenta de Diego y comprobamos que él también ve la solicitud como Aceptada.</a:t>
+            </a:r>
+          </a:p>
+          <a:p xmlns:a="http://schemas.openxmlformats.org/drawingml/2006/main">
+            <a:r>
+              <a:t/>
+            </a:r>
+          </a:p>
+          <a:p xmlns:a="http://schemas.openxmlformats.org/drawingml/2006/main">
+            <a:r>
+              <a:t>REFERENCIAS Y GUÍA</a:t>
+            </a:r>
+          </a:p>
           <a:p xmlns:a="http://schemas.openxmlformats.org/drawingml/2006/main">
             <a:r>
               <a:t>4:45-5:55 (70 s). Mostrar cuadro de confirmación, estado Aceptada y código de operación. Enumerar oráculos del caso: estado para Bruno y Diego, detalle con Operación, Bruno S/ 775.00 y Diego S/ 2,525.00. Los saldos se derivan de S/ 800.00 y S/ 2,500.00 iniciales con una transferencia de S/ 25.00 y comisión cero. Fuente: capturas reales 04 a 07; Qolqe HU-G4-08, RN-09 y RN-10.</a:t>
@@ -1011,6 +1171,46 @@
           <a:lstStyle xmlns:a="http://schemas.openxmlformats.org/drawingml/2006/main"/>
           <a:p xmlns:a="http://schemas.openxmlformats.org/drawingml/2006/main">
             <a:r>
+              <a:t>GUION 5:55-7:30</a:t>
+            </a:r>
+          </a:p>
+          <a:p xmlns:a="http://schemas.openxmlformats.org/drawingml/2006/main">
+            <a:r>
+              <a:t>Pasemos a la ejecución. Voy a lanzar Robot con el navegador visible. El caso prepara los datos de una instancia local de pruebas, entra primero como Diego y después como Bruno, y hace las comprobaciones que acabamos de revisar.</a:t>
+            </a:r>
+          </a:p>
+          <a:p xmlns:a="http://schemas.openxmlformats.org/drawingml/2006/main">
+            <a:r>
+              <a:t/>
+            </a:r>
+          </a:p>
+          <a:p xmlns:a="http://schemas.openxmlformats.org/drawingml/2006/main">
+            <a:r>
+              <a:t>[ACCIÓN EN VIVO, NO LEER] No leer: con Qolqe ya iniciado, ejecutar en otra terminal: python -m robot --variable HEADLESS:False --outputdir reportes tests/e2e/g4_solicitud_happy_path.robot. Luego abrir reportes/report.html y expandir un paso en reportes/log.html.</a:t>
+            </a:r>
+          </a:p>
+          <a:p xmlns:a="http://schemas.openxmlformats.org/drawingml/2006/main">
+            <a:r>
+              <a:t/>
+            </a:r>
+          </a:p>
+          <a:p xmlns:a="http://schemas.openxmlformats.org/drawingml/2006/main">
+            <a:r>
+              <a:t>Aquí vemos el resultado: una prueba ejecutada y aprobada. En el log podemos abrir los pasos y ver que Robot comparó los estados, el código de operación y los saldos. El reporte queda guardado, de modo que la ejecución se puede revisar y repetir; no dependemos solo de una captura de pantalla.</a:t>
+            </a:r>
+          </a:p>
+          <a:p xmlns:a="http://schemas.openxmlformats.org/drawingml/2006/main">
+            <a:r>
+              <a:t/>
+            </a:r>
+          </a:p>
+          <a:p xmlns:a="http://schemas.openxmlformats.org/drawingml/2006/main">
+            <a:r>
+              <a:t>REFERENCIAS Y GUÍA</a:t>
+            </a:r>
+          </a:p>
+          <a:p xmlns:a="http://schemas.openxmlformats.org/drawingml/2006/main">
+            <a:r>
               <a:t>5:55-7:30 (95 s). PREPARACIÓN: Qolqe debe estar iniciado con el comando de la sección 7 del README. EN VIVO: ejecutar python -m robot --variable HEADLESS:False --outputdir reportes tests/e2e/g4_solicitud_happy_path.robot. Dejar que la audiencia vea Chromium; abrir reportes/report.html, señalar 1 test/1 passed; abrir log.html y expandir Enviar solicitud a contacto o Aceptar solicitud recibida para mostrar validaciones. Si la ventana tarda, usar la captura real como respaldo, aclarando que es una ejecución previa. La ejecución verificada el 24 de octubre de 2026 aprobó 1 de 1 prueba. Fuente: reportes locales y captura real 08-robot-report.png.</a:t>
             </a:r>
           </a:p>
@@ -1081,6 +1281,46 @@
           <a:lstStyle xmlns:a="http://schemas.openxmlformats.org/drawingml/2006/main"/>
           <a:p xmlns:a="http://schemas.openxmlformats.org/drawingml/2006/main">
             <a:r>
+              <a:t>GUION 7:30-9:10</a:t>
+            </a:r>
+          </a:p>
+          <a:p xmlns:a="http://schemas.openxmlformats.org/drawingml/2006/main">
+            <a:r>
+              <a:t>Ahora voy a usar IA como apoyo para revisar nuestra prueba de Robot Framework. Le daré a Codex el resultado real, el archivo de la prueba y los criterios de aceptación. Le pediré que diga qué se comprobó, qué falta y qué palabra clave pequeña propondría para cubrirlo. La IA no ejecuta ni valida por sí sola esta prueba: nos ayuda a detectar una posible brecha.</a:t>
+            </a:r>
+          </a:p>
+          <a:p xmlns:a="http://schemas.openxmlformats.org/drawingml/2006/main">
+            <a:r>
+              <a:t/>
+            </a:r>
+          </a:p>
+          <a:p xmlns:a="http://schemas.openxmlformats.org/drawingml/2006/main">
+            <a:r>
+              <a:t>[ACCIÓN EN VIVO, NO LEER] No leer: abrir docs/demo-robot-ia.md, copiar el prompt completo en Codex y mostrar la respuesta. Usar reportes/output.xml, tests/e2e/g4_solicitud_happy_path.robot y docs/requisitos.md como contexto.</a:t>
+            </a:r>
+          </a:p>
+          <a:p xmlns:a="http://schemas.openxmlformats.org/drawingml/2006/main">
+            <a:r>
+              <a:t/>
+            </a:r>
+          </a:p>
+          <a:p xmlns:a="http://schemas.openxmlformats.org/drawingml/2006/main">
+            <a:r>
+              <a:t>Comparemos la respuesta con los requisitos. La brecha que esperamos detectar es el SMS simulado: el caso actual verifica estado, operación y saldos, pero todavía no comprueba la notificación a Bruno ni la que recibe Diego después de la aceptación. Si la IA propone un keyword para consultar notificaciones, eso sigue siendo una propuesta. Para decir que está cubierto, tendríamos que incorporarlo y ejecutar la prueba otra vez. Si Codex pasa por alto el requisito, se lo señalamos: la IA tampoco reemplaza nuestro criterio.</a:t>
+            </a:r>
+          </a:p>
+          <a:p xmlns:a="http://schemas.openxmlformats.org/drawingml/2006/main">
+            <a:r>
+              <a:t/>
+            </a:r>
+          </a:p>
+          <a:p xmlns:a="http://schemas.openxmlformats.org/drawingml/2006/main">
+            <a:r>
+              <a:t>REFERENCIAS Y GUÍA</a:t>
+            </a:r>
+          </a:p>
+          <a:p xmlns:a="http://schemas.openxmlformats.org/drawingml/2006/main">
+            <a:r>
               <a:t>7:30-9:10 (100 s). EN VIVO: abrir Codex con este repositorio y pegar el prompt completo de docs/demo-robot-ia.md. Adjuntar o referir reportes/output.xml, tests/e2e/g4_solicitud_happy_path.robot y docs/requisitos.md. Pedir tres cosas: qué validó Robot, qué requisito no validó, y un keyword mínimo propuesto. La respuesta útil debe detectar los SMS simulados de HU-G4-06 CA2 y HU-G4-08 CA3. La IA es asistencia externa aplicada al resultado de Robot; no atribuir IA integrada al motor. Mostrar la propuesta y aclarar que se debe comprobar con requisitos y ejecutar antes de incorporarla. Fuente: docs/demo-robot-ia.md y docs/requisitos.md.</a:t>
             </a:r>
           </a:p>
@@ -1128,7 +1368,7 @@
           <p:cNvPr id="3" name="Title">
             <a:extLst xmlns:a="http://schemas.openxmlformats.org/drawingml/2006/main">
               <a:ext uri="{FF2B5EF4-FFF2-40B4-BE49-F238E27FC236}">
-                <a16:creationId xmlns:a16="http://schemas.microsoft.com/office/drawing/2014/main" id="{C28D5550-E046-42B9-9546-8D851ED4E9A0}"/>
+                <a16:creationId xmlns:a16="http://schemas.microsoft.com/office/drawing/2014/main" id="{361D7898-4D4C-4FF4-B381-1FD797C2A816}"/>
               </a:ext>
             </a:extLst>
           </p:cNvPr>
@@ -1357,7 +1597,7 @@
           <p:cNvPr id="2" name="Subtitle">
             <a:extLst xmlns:a="http://schemas.openxmlformats.org/drawingml/2006/main">
               <a:ext uri="{FF2B5EF4-FFF2-40B4-BE49-F238E27FC236}">
-                <a16:creationId xmlns:a16="http://schemas.microsoft.com/office/drawing/2014/main" id="{336BBD53-F08F-4202-ABC7-9DE906A226D9}"/>
+                <a16:creationId xmlns:a16="http://schemas.microsoft.com/office/drawing/2014/main" id="{7D1072C6-E049-4BB4-9BA4-789EDC4F50FC}"/>
               </a:ext>
             </a:extLst>
           </p:cNvPr>
@@ -1603,7 +1843,7 @@
           <p:cNvPr id="2" name="Section title">
             <a:extLst xmlns:a="http://schemas.openxmlformats.org/drawingml/2006/main">
               <a:ext uri="{FF2B5EF4-FFF2-40B4-BE49-F238E27FC236}">
-                <a16:creationId xmlns:a16="http://schemas.microsoft.com/office/drawing/2014/main" id="{FF533745-70E0-4CFA-8424-F926CCFBA702}"/>
+                <a16:creationId xmlns:a16="http://schemas.microsoft.com/office/drawing/2014/main" id="{FD873AB6-C80A-475B-9476-A20E9FF0E4DE}"/>
               </a:ext>
             </a:extLst>
           </p:cNvPr>
@@ -1849,7 +2089,7 @@
           <p:cNvPr id="3" name="Title">
             <a:extLst xmlns:a="http://schemas.openxmlformats.org/drawingml/2006/main">
               <a:ext uri="{FF2B5EF4-FFF2-40B4-BE49-F238E27FC236}">
-                <a16:creationId xmlns:a16="http://schemas.microsoft.com/office/drawing/2014/main" id="{CEBA62EE-FAF2-4CC9-A4A0-3BAD99350B3D}"/>
+                <a16:creationId xmlns:a16="http://schemas.microsoft.com/office/drawing/2014/main" id="{45080D34-7ABB-4F1A-B058-6344D98EB512}"/>
               </a:ext>
             </a:extLst>
           </p:cNvPr>
@@ -2078,7 +2318,7 @@
           <p:cNvPr id="2" name="Body">
             <a:extLst xmlns:a="http://schemas.openxmlformats.org/drawingml/2006/main">
               <a:ext uri="{FF2B5EF4-FFF2-40B4-BE49-F238E27FC236}">
-                <a16:creationId xmlns:a16="http://schemas.microsoft.com/office/drawing/2014/main" id="{18AE414D-9C6D-4100-9791-CB6006449571}"/>
+                <a16:creationId xmlns:a16="http://schemas.microsoft.com/office/drawing/2014/main" id="{51FECD3F-EE88-46B7-9472-D3555496FA8B}"/>
               </a:ext>
             </a:extLst>
           </p:cNvPr>
@@ -2324,7 +2564,7 @@
           <p:cNvPr id="4" name="Title">
             <a:extLst xmlns:a="http://schemas.openxmlformats.org/drawingml/2006/main">
               <a:ext uri="{FF2B5EF4-FFF2-40B4-BE49-F238E27FC236}">
-                <a16:creationId xmlns:a16="http://schemas.microsoft.com/office/drawing/2014/main" id="{FAA4182E-91A0-4EA7-B0BF-452A79C0A218}"/>
+                <a16:creationId xmlns:a16="http://schemas.microsoft.com/office/drawing/2014/main" id="{1B6358FC-5EDD-482F-A27C-FE9B52D92036}"/>
               </a:ext>
             </a:extLst>
           </p:cNvPr>
@@ -2553,7 +2793,7 @@
           <p:cNvPr id="2" name="Left column">
             <a:extLst xmlns:a="http://schemas.openxmlformats.org/drawingml/2006/main">
               <a:ext uri="{FF2B5EF4-FFF2-40B4-BE49-F238E27FC236}">
-                <a16:creationId xmlns:a16="http://schemas.microsoft.com/office/drawing/2014/main" id="{BDB72F9C-7568-4A94-981C-A5BA2457257E}"/>
+                <a16:creationId xmlns:a16="http://schemas.microsoft.com/office/drawing/2014/main" id="{0D7DCEB9-D316-42FA-8A53-36EC1480D4C2}"/>
               </a:ext>
             </a:extLst>
           </p:cNvPr>
@@ -2782,7 +3022,7 @@
           <p:cNvPr id="3" name="Right column">
             <a:extLst xmlns:a="http://schemas.openxmlformats.org/drawingml/2006/main">
               <a:ext uri="{FF2B5EF4-FFF2-40B4-BE49-F238E27FC236}">
-                <a16:creationId xmlns:a16="http://schemas.microsoft.com/office/drawing/2014/main" id="{BF34218B-F32B-4879-8EE7-856EB150A19A}"/>
+                <a16:creationId xmlns:a16="http://schemas.microsoft.com/office/drawing/2014/main" id="{2F0B760B-573A-4DEA-A0AA-3AA9079B3BED}"/>
               </a:ext>
             </a:extLst>
           </p:cNvPr>
@@ -3028,7 +3268,7 @@
           <p:cNvPr id="3" name="Title">
             <a:extLst xmlns:a="http://schemas.openxmlformats.org/drawingml/2006/main">
               <a:ext uri="{FF2B5EF4-FFF2-40B4-BE49-F238E27FC236}">
-                <a16:creationId xmlns:a16="http://schemas.microsoft.com/office/drawing/2014/main" id="{2010F5A3-9E22-4BBC-A94A-6C1F018FEF59}"/>
+                <a16:creationId xmlns:a16="http://schemas.microsoft.com/office/drawing/2014/main" id="{7F02192F-A2F8-43FF-8DCA-58BFECEA5C80}"/>
               </a:ext>
             </a:extLst>
           </p:cNvPr>
@@ -3257,7 +3497,7 @@
           <p:cNvPr id="2" name="Left column">
             <a:extLst xmlns:a="http://schemas.openxmlformats.org/drawingml/2006/main">
               <a:ext uri="{FF2B5EF4-FFF2-40B4-BE49-F238E27FC236}">
-                <a16:creationId xmlns:a16="http://schemas.microsoft.com/office/drawing/2014/main" id="{45F81AC0-DDD6-4664-AF8D-073570065E17}"/>
+                <a16:creationId xmlns:a16="http://schemas.microsoft.com/office/drawing/2014/main" id="{1ECE5D41-0BBA-4E27-9409-603012C455AF}"/>
               </a:ext>
             </a:extLst>
           </p:cNvPr>
@@ -3524,12 +3764,12 @@
   </p:cSld>
   <p:clrMap bg1="lt1" tx1="dk1" bg2="lt2" tx2="dk2" accent1="accent1" accent2="accent2" accent3="accent3" accent4="accent4" accent5="accent5" accent6="accent6" hlink="hlink" folHlink="folHlink"/>
   <p:sldLayoutIdLst>
-    <p:sldLayoutId xmlns:r="http://schemas.openxmlformats.org/officeDocument/2006/relationships" id="2147483649" r:id="R0ee563ba7619493a"/>
-    <p:sldLayoutId xmlns:r="http://schemas.openxmlformats.org/officeDocument/2006/relationships" id="2147483650" r:id="R01b5ef90e4d74bac"/>
-    <p:sldLayoutId xmlns:r="http://schemas.openxmlformats.org/officeDocument/2006/relationships" id="2147483651" r:id="R9b377f7a22134943"/>
-    <p:sldLayoutId xmlns:r="http://schemas.openxmlformats.org/officeDocument/2006/relationships" id="2147483652" r:id="R26ab98dc771f488d"/>
-    <p:sldLayoutId xmlns:r="http://schemas.openxmlformats.org/officeDocument/2006/relationships" id="2147483653" r:id="R20352c333f9143f1"/>
-    <p:sldLayoutId xmlns:r="http://schemas.openxmlformats.org/officeDocument/2006/relationships" id="2147483654" r:id="Red053e5a9d1d4388"/>
+    <p:sldLayoutId xmlns:r="http://schemas.openxmlformats.org/officeDocument/2006/relationships" id="2147483649" r:id="R32f179d829fe4123"/>
+    <p:sldLayoutId xmlns:r="http://schemas.openxmlformats.org/officeDocument/2006/relationships" id="2147483650" r:id="Rdf713b9150e04859"/>
+    <p:sldLayoutId xmlns:r="http://schemas.openxmlformats.org/officeDocument/2006/relationships" id="2147483651" r:id="Rede5c8891ec6433e"/>
+    <p:sldLayoutId xmlns:r="http://schemas.openxmlformats.org/officeDocument/2006/relationships" id="2147483652" r:id="R67dbd31b2ba84a97"/>
+    <p:sldLayoutId xmlns:r="http://schemas.openxmlformats.org/officeDocument/2006/relationships" id="2147483653" r:id="R102e41e1af954845"/>
+    <p:sldLayoutId xmlns:r="http://schemas.openxmlformats.org/officeDocument/2006/relationships" id="2147483654" r:id="R31d7b5d9aa0a45c7"/>
   </p:sldLayoutIdLst>
   <p:txStyles>
     <p:titleStyle>
@@ -4077,10 +4317,10 @@
       </p:grpSpPr>
       <p:sp>
         <p:nvSpPr>
-          <p:cNvPr id="12" name="">
+          <p:cNvPr id="13" name="">
             <a:extLst xmlns:a="http://schemas.openxmlformats.org/drawingml/2006/main">
               <a:ext uri="{FF2B5EF4-FFF2-40B4-BE49-F238E27FC236}">
-                <a16:creationId xmlns:a16="http://schemas.microsoft.com/office/drawing/2014/main" id="{56A393DA-EF0C-4A13-9964-6184A36FE8B8}"/>
+                <a16:creationId xmlns:a16="http://schemas.microsoft.com/office/drawing/2014/main" id="{BCC613AC-2E4B-4D25-B898-52C9D86B7DA6}"/>
               </a:ext>
             </a:extLst>
           </p:cNvPr>
@@ -4111,7 +4351,7 @@
           <p:cNvPr id="2" name="">
             <a:extLst xmlns:a="http://schemas.openxmlformats.org/drawingml/2006/main">
               <a:ext uri="{FF2B5EF4-FFF2-40B4-BE49-F238E27FC236}">
-                <a16:creationId xmlns:a16="http://schemas.microsoft.com/office/drawing/2014/main" id="{6648137C-5A67-42E1-B0B2-FC0765CDCBE7}"/>
+                <a16:creationId xmlns:a16="http://schemas.microsoft.com/office/drawing/2014/main" id="{57A510FC-4444-4845-B4C6-D8AEDEB40494}"/>
               </a:ext>
             </a:extLst>
           </p:cNvPr>
@@ -4142,7 +4382,7 @@
           <p:cNvPr id="3" name="">
             <a:extLst xmlns:a="http://schemas.openxmlformats.org/drawingml/2006/main">
               <a:ext uri="{FF2B5EF4-FFF2-40B4-BE49-F238E27FC236}">
-                <a16:creationId xmlns:a16="http://schemas.microsoft.com/office/drawing/2014/main" id="{0372A2F5-A67E-4FCA-B8D6-652802ED50FB}"/>
+                <a16:creationId xmlns:a16="http://schemas.microsoft.com/office/drawing/2014/main" id="{9C259622-3764-4F24-A007-AF926D386B6E}"/>
               </a:ext>
             </a:extLst>
           </p:cNvPr>
@@ -4322,7 +4562,7 @@
           <p:cNvPr id="4" name="">
             <a:extLst xmlns:a="http://schemas.openxmlformats.org/drawingml/2006/main">
               <a:ext uri="{FF2B5EF4-FFF2-40B4-BE49-F238E27FC236}">
-                <a16:creationId xmlns:a16="http://schemas.microsoft.com/office/drawing/2014/main" id="{3BD68D6B-1E1E-46D0-85DE-3CE919080183}"/>
+                <a16:creationId xmlns:a16="http://schemas.microsoft.com/office/drawing/2014/main" id="{648D470C-5C00-40B9-833A-613E30D65A73}"/>
               </a:ext>
             </a:extLst>
           </p:cNvPr>
@@ -4479,7 +4719,7 @@
           <p:cNvPr id="5" name="">
             <a:extLst xmlns:a="http://schemas.openxmlformats.org/drawingml/2006/main">
               <a:ext uri="{FF2B5EF4-FFF2-40B4-BE49-F238E27FC236}">
-                <a16:creationId xmlns:a16="http://schemas.microsoft.com/office/drawing/2014/main" id="{E259CA8F-DA8C-4477-B6E3-F5085775B2C9}"/>
+                <a16:creationId xmlns:a16="http://schemas.microsoft.com/office/drawing/2014/main" id="{354FFA4B-F6D3-4AE2-AF7D-6082CDD3A3C2}"/>
               </a:ext>
             </a:extLst>
           </p:cNvPr>
@@ -4490,8 +4730,8 @@
         </p:nvSpPr>
         <p:spPr>
           <a:xfrm xmlns:a="http://schemas.openxmlformats.org/drawingml/2006/main">
-            <a:off x="600075" y="4343400"/>
-            <a:ext cx="4705350" cy="552450"/>
+            <a:off x="600075" y="4143375"/>
+            <a:ext cx="4857750" cy="885825"/>
           </a:xfrm>
           <a:prstGeom xmlns:a="http://schemas.openxmlformats.org/drawingml/2006/main" prst="rect">
             <a:avLst/>
@@ -4626,7 +4866,30 @@
                 <a:ea typeface="Avenir Next"/>
                 <a:cs typeface="Avenir Next"/>
               </a:rPr>
-              <a:t>Contacto  →  solicitud  →  aceptación</a:t>
+              <a:t>Diego agrega a Bruno</a:t>
+            </a:r>
+          </a:p>
+          <a:p xmlns:a="http://schemas.openxmlformats.org/drawingml/2006/main">
+            <a:pPr algn="l">
+              <a:defRPr sz="1875" b="1">
+                <a:solidFill>
+                  <a:srgbClr val="FFFFFF"/>
+                </a:solidFill>
+                <a:latin typeface="Avenir Next"/>
+                <a:ea typeface="Avenir Next"/>
+                <a:cs typeface="Avenir Next"/>
+              </a:defRPr>
+            </a:pPr>
+            <a:r>
+              <a:rPr sz="1875" b="1">
+                <a:solidFill>
+                  <a:srgbClr val="FFFFFF"/>
+                </a:solidFill>
+                <a:latin typeface="Avenir Next"/>
+                <a:ea typeface="Avenir Next"/>
+                <a:cs typeface="Avenir Next"/>
+              </a:rPr>
+              <a:t>y solicita S/ 25; Bruno acepta</a:t>
             </a:r>
           </a:p>
         </p:txBody>
@@ -4636,7 +4899,7 @@
           <p:cNvPr id="6" name="">
             <a:extLst xmlns:a="http://schemas.openxmlformats.org/drawingml/2006/main">
               <a:ext uri="{FF2B5EF4-FFF2-40B4-BE49-F238E27FC236}">
-                <a16:creationId xmlns:a16="http://schemas.microsoft.com/office/drawing/2014/main" id="{5B6E2D33-CCCE-49B2-8F63-886F8388691E}"/>
+                <a16:creationId xmlns:a16="http://schemas.microsoft.com/office/drawing/2014/main" id="{271B8233-1CB3-4ADD-94A8-BC81401E2ACD}"/>
               </a:ext>
             </a:extLst>
           </p:cNvPr>
@@ -4669,7 +4932,7 @@
           <p:cNvPr id="7" name="">
             <a:extLst xmlns:a="http://schemas.openxmlformats.org/drawingml/2006/main">
               <a:ext uri="{FF2B5EF4-FFF2-40B4-BE49-F238E27FC236}">
-                <a16:creationId xmlns:a16="http://schemas.microsoft.com/office/drawing/2014/main" id="{8CBEAD91-424B-43A5-A1CC-1A0DD17C8487}"/>
+                <a16:creationId xmlns:a16="http://schemas.microsoft.com/office/drawing/2014/main" id="{A0599D76-0706-4AE1-A31F-D331710CF8D7}"/>
               </a:ext>
             </a:extLst>
           </p:cNvPr>
@@ -4826,7 +5089,164 @@
           <p:cNvPr id="8" name="">
             <a:extLst xmlns:a="http://schemas.openxmlformats.org/drawingml/2006/main">
               <a:ext uri="{FF2B5EF4-FFF2-40B4-BE49-F238E27FC236}">
-                <a16:creationId xmlns:a16="http://schemas.microsoft.com/office/drawing/2014/main" id="{373A2261-842E-4944-90C4-0A1FD7BC5CF5}"/>
+                <a16:creationId xmlns:a16="http://schemas.microsoft.com/office/drawing/2014/main" id="{462DAAE2-436A-495D-995B-5E3E7E2E6574}"/>
+              </a:ext>
+            </a:extLst>
+          </p:cNvPr>
+          <p:cNvSpPr>
+            <a:spLocks xmlns:a="http://schemas.openxmlformats.org/drawingml/2006/main" noGrp="1"/>
+          </p:cNvSpPr>
+          <p:nvPr/>
+        </p:nvSpPr>
+        <p:spPr>
+          <a:xfrm xmlns:a="http://schemas.openxmlformats.org/drawingml/2006/main">
+            <a:off x="600075" y="5705475"/>
+            <a:ext cx="4895850" cy="342900"/>
+          </a:xfrm>
+          <a:prstGeom xmlns:a="http://schemas.openxmlformats.org/drawingml/2006/main" prst="rect">
+            <a:avLst/>
+          </a:prstGeom>
+          <a:noFill xmlns:a="http://schemas.openxmlformats.org/drawingml/2006/main"/>
+          <a:ln xmlns:a="http://schemas.openxmlformats.org/drawingml/2006/main" w="0">
+            <a:noFill/>
+            <a:prstDash val="solid"/>
+          </a:ln>
+        </p:spPr>
+        <p:txBody>
+          <a:bodyPr xmlns:a="http://schemas.openxmlformats.org/drawingml/2006/main" anchor="ctr"/>
+          <a:lstStyle xmlns:a="http://schemas.openxmlformats.org/drawingml/2006/main">
+            <a:defPPr algn="l">
+              <a:defRPr sz="1575" b="0">
+                <a:solidFill>
+                  <a:srgbClr val="BDE3D7"/>
+                </a:solidFill>
+                <a:latin typeface="Avenir Next"/>
+                <a:ea typeface="Avenir Next"/>
+                <a:cs typeface="Avenir Next"/>
+              </a:defRPr>
+            </a:defPPr>
+            <a:lvl1pPr algn="l">
+              <a:defRPr sz="1575" b="0">
+                <a:solidFill>
+                  <a:srgbClr val="BDE3D7"/>
+                </a:solidFill>
+                <a:latin typeface="Avenir Next"/>
+                <a:ea typeface="Avenir Next"/>
+                <a:cs typeface="Avenir Next"/>
+              </a:defRPr>
+            </a:lvl1pPr>
+            <a:lvl2pPr algn="l">
+              <a:defRPr sz="1575" b="0">
+                <a:solidFill>
+                  <a:srgbClr val="BDE3D7"/>
+                </a:solidFill>
+                <a:latin typeface="Avenir Next"/>
+                <a:ea typeface="Avenir Next"/>
+                <a:cs typeface="Avenir Next"/>
+              </a:defRPr>
+            </a:lvl2pPr>
+            <a:lvl3pPr algn="l">
+              <a:defRPr sz="1575" b="0">
+                <a:solidFill>
+                  <a:srgbClr val="BDE3D7"/>
+                </a:solidFill>
+                <a:latin typeface="Avenir Next"/>
+                <a:ea typeface="Avenir Next"/>
+                <a:cs typeface="Avenir Next"/>
+              </a:defRPr>
+            </a:lvl3pPr>
+            <a:lvl4pPr algn="l">
+              <a:defRPr sz="1575" b="0">
+                <a:solidFill>
+                  <a:srgbClr val="BDE3D7"/>
+                </a:solidFill>
+                <a:latin typeface="Avenir Next"/>
+                <a:ea typeface="Avenir Next"/>
+                <a:cs typeface="Avenir Next"/>
+              </a:defRPr>
+            </a:lvl4pPr>
+            <a:lvl5pPr algn="l">
+              <a:defRPr sz="1575" b="0">
+                <a:solidFill>
+                  <a:srgbClr val="BDE3D7"/>
+                </a:solidFill>
+                <a:latin typeface="Avenir Next"/>
+                <a:ea typeface="Avenir Next"/>
+                <a:cs typeface="Avenir Next"/>
+              </a:defRPr>
+            </a:lvl5pPr>
+            <a:lvl6pPr algn="l">
+              <a:defRPr sz="1575" b="0">
+                <a:solidFill>
+                  <a:srgbClr val="BDE3D7"/>
+                </a:solidFill>
+                <a:latin typeface="Avenir Next"/>
+                <a:ea typeface="Avenir Next"/>
+                <a:cs typeface="Avenir Next"/>
+              </a:defRPr>
+            </a:lvl6pPr>
+            <a:lvl7pPr algn="l">
+              <a:defRPr sz="1575" b="0">
+                <a:solidFill>
+                  <a:srgbClr val="BDE3D7"/>
+                </a:solidFill>
+                <a:latin typeface="Avenir Next"/>
+                <a:ea typeface="Avenir Next"/>
+                <a:cs typeface="Avenir Next"/>
+              </a:defRPr>
+            </a:lvl7pPr>
+            <a:lvl8pPr algn="l">
+              <a:defRPr sz="1575" b="0">
+                <a:solidFill>
+                  <a:srgbClr val="BDE3D7"/>
+                </a:solidFill>
+                <a:latin typeface="Avenir Next"/>
+                <a:ea typeface="Avenir Next"/>
+                <a:cs typeface="Avenir Next"/>
+              </a:defRPr>
+            </a:lvl8pPr>
+            <a:lvl9pPr algn="l">
+              <a:defRPr sz="1575" b="0">
+                <a:solidFill>
+                  <a:srgbClr val="BDE3D7"/>
+                </a:solidFill>
+                <a:latin typeface="Avenir Next"/>
+                <a:ea typeface="Avenir Next"/>
+                <a:cs typeface="Avenir Next"/>
+              </a:defRPr>
+            </a:lvl9pPr>
+          </a:lstStyle>
+          <a:p xmlns:a="http://schemas.openxmlformats.org/drawingml/2006/main">
+            <a:pPr algn="l">
+              <a:defRPr sz="1575" b="0">
+                <a:solidFill>
+                  <a:srgbClr val="BDE3D7"/>
+                </a:solidFill>
+                <a:latin typeface="Avenir Next"/>
+                <a:ea typeface="Avenir Next"/>
+                <a:cs typeface="Avenir Next"/>
+              </a:defRPr>
+            </a:pPr>
+            <a:r>
+              <a:rPr sz="1575" b="0">
+                <a:solidFill>
+                  <a:srgbClr val="BDE3D7"/>
+                </a:solidFill>
+                <a:latin typeface="Avenir Next"/>
+                <a:ea typeface="Avenir Next"/>
+                <a:cs typeface="Avenir Next"/>
+              </a:rPr>
+              <a:t>Demo Robot + revisión con IA</a:t>
+            </a:r>
+          </a:p>
+        </p:txBody>
+      </p:sp>
+      <p:sp>
+        <p:nvSpPr>
+          <p:cNvPr id="9" name="">
+            <a:extLst xmlns:a="http://schemas.openxmlformats.org/drawingml/2006/main">
+              <a:ext uri="{FF2B5EF4-FFF2-40B4-BE49-F238E27FC236}">
+                <a16:creationId xmlns:a16="http://schemas.microsoft.com/office/drawing/2014/main" id="{E4CD5E8B-0825-417C-A4BA-154C35EC7C63}"/>
               </a:ext>
             </a:extLst>
           </p:cNvPr>
@@ -4856,10 +5276,10 @@
       </p:sp>
       <p:pic>
         <p:nvPicPr>
-          <p:cNvPr id="9" name="">
+          <p:cNvPr id="10" name="">
             <a:extLst xmlns:a="http://schemas.openxmlformats.org/drawingml/2006/main">
               <a:ext uri="{FF2B5EF4-FFF2-40B4-BE49-F238E27FC236}">
-                <a16:creationId xmlns:a16="http://schemas.microsoft.com/office/drawing/2014/main" id="{4C2F0F19-9772-4E7F-B123-5ED0936B7C49}"/>
+                <a16:creationId xmlns:a16="http://schemas.microsoft.com/office/drawing/2014/main" id="{3F9C0E4D-1CF0-4BD5-870C-E95CF91365E2}"/>
               </a:ext>
             </a:extLst>
           </p:cNvPr>
@@ -4869,7 +5289,7 @@
           <p:nvPr/>
         </p:nvPicPr>
         <p:blipFill>
-          <a:blip xmlns:r="http://schemas.openxmlformats.org/officeDocument/2006/relationships" xmlns:a="http://schemas.openxmlformats.org/drawingml/2006/main" r:embed="Rd1a34ca7150b458d"/>
+          <a:blip xmlns:r="http://schemas.openxmlformats.org/officeDocument/2006/relationships" xmlns:a="http://schemas.openxmlformats.org/drawingml/2006/main" r:embed="R1e97c9911dcb4758"/>
           <a:stretch xmlns:a="http://schemas.openxmlformats.org/drawingml/2006/main"/>
         </p:blipFill>
         <p:spPr>
@@ -4886,10 +5306,10 @@
       </p:pic>
       <p:sp>
         <p:nvSpPr>
-          <p:cNvPr id="10" name="">
+          <p:cNvPr id="11" name="">
             <a:extLst xmlns:a="http://schemas.openxmlformats.org/drawingml/2006/main">
               <a:ext uri="{FF2B5EF4-FFF2-40B4-BE49-F238E27FC236}">
-                <a16:creationId xmlns:a16="http://schemas.microsoft.com/office/drawing/2014/main" id="{2A022AD0-49B0-4B81-B3DA-1E1F2067939C}"/>
+                <a16:creationId xmlns:a16="http://schemas.microsoft.com/office/drawing/2014/main" id="{A12ACC0E-6D72-4531-A279-60FD7649F5FF}"/>
               </a:ext>
             </a:extLst>
           </p:cNvPr>
@@ -5043,10 +5463,10 @@
       </p:sp>
       <p:sp>
         <p:nvSpPr>
-          <p:cNvPr id="11" name="">
+          <p:cNvPr id="12" name="">
             <a:extLst xmlns:a="http://schemas.openxmlformats.org/drawingml/2006/main">
               <a:ext uri="{FF2B5EF4-FFF2-40B4-BE49-F238E27FC236}">
-                <a16:creationId xmlns:a16="http://schemas.microsoft.com/office/drawing/2014/main" id="{104782A3-C747-4DBC-96B9-AD1E79B6EDA4}"/>
+                <a16:creationId xmlns:a16="http://schemas.microsoft.com/office/drawing/2014/main" id="{66EBD298-2FD3-401E-8C73-65FE365D8E76}"/>
               </a:ext>
             </a:extLst>
           </p:cNvPr>
@@ -5201,7 +5621,7 @@
     </p:spTree>
     <p:extLst>
       <p:ext uri="{BB962C8B-B14F-4D97-AF65-F5344CB8AC3E}">
-        <p14:creationId xmlns:p14="http://schemas.microsoft.com/office/powerpoint/2010/main" val="982478593"/>
+        <p14:creationId xmlns:p14="http://schemas.microsoft.com/office/powerpoint/2010/main" val="195414263"/>
       </p:ext>
     </p:extLst>
   </p:cSld>
@@ -5229,10 +5649,10 @@
       </p:grpSpPr>
       <p:sp>
         <p:nvSpPr>
-          <p:cNvPr id="21" name="">
+          <p:cNvPr id="22" name="">
             <a:extLst xmlns:a="http://schemas.openxmlformats.org/drawingml/2006/main">
               <a:ext uri="{FF2B5EF4-FFF2-40B4-BE49-F238E27FC236}">
-                <a16:creationId xmlns:a16="http://schemas.microsoft.com/office/drawing/2014/main" id="{7D94C27A-4B06-450F-AD5C-7B5CFA3A8B09}"/>
+                <a16:creationId xmlns:a16="http://schemas.microsoft.com/office/drawing/2014/main" id="{E2B38562-5FB0-4FED-9B8E-8017E6861F0C}"/>
               </a:ext>
             </a:extLst>
           </p:cNvPr>
@@ -5263,7 +5683,7 @@
           <p:cNvPr id="2" name="">
             <a:extLst xmlns:a="http://schemas.openxmlformats.org/drawingml/2006/main">
               <a:ext uri="{FF2B5EF4-FFF2-40B4-BE49-F238E27FC236}">
-                <a16:creationId xmlns:a16="http://schemas.microsoft.com/office/drawing/2014/main" id="{78450E61-79DA-4930-A706-7E4BBAE934A0}"/>
+                <a16:creationId xmlns:a16="http://schemas.microsoft.com/office/drawing/2014/main" id="{DFB72549-DC95-416E-AA34-6CCCE2471243}"/>
               </a:ext>
             </a:extLst>
           </p:cNvPr>
@@ -5420,7 +5840,7 @@
           <p:cNvPr id="3" name="">
             <a:extLst xmlns:a="http://schemas.openxmlformats.org/drawingml/2006/main">
               <a:ext uri="{FF2B5EF4-FFF2-40B4-BE49-F238E27FC236}">
-                <a16:creationId xmlns:a16="http://schemas.microsoft.com/office/drawing/2014/main" id="{37FA1C5E-52D4-40C5-96DF-C5AB60328C4B}"/>
+                <a16:creationId xmlns:a16="http://schemas.microsoft.com/office/drawing/2014/main" id="{12D9CFC0-1D0F-4AE3-9952-99C35F0A7721}"/>
               </a:ext>
             </a:extLst>
           </p:cNvPr>
@@ -5577,7 +5997,7 @@
           <p:cNvPr id="4" name="">
             <a:extLst xmlns:a="http://schemas.openxmlformats.org/drawingml/2006/main">
               <a:ext uri="{FF2B5EF4-FFF2-40B4-BE49-F238E27FC236}">
-                <a16:creationId xmlns:a16="http://schemas.microsoft.com/office/drawing/2014/main" id="{0C540B55-4642-4D56-8E75-58E9E82822A9}"/>
+                <a16:creationId xmlns:a16="http://schemas.microsoft.com/office/drawing/2014/main" id="{51A23FFC-0926-4DA5-8227-5552D590B0FC}"/>
               </a:ext>
             </a:extLst>
           </p:cNvPr>
@@ -5734,7 +6154,7 @@
           <p:cNvPr id="5" name="">
             <a:extLst xmlns:a="http://schemas.openxmlformats.org/drawingml/2006/main">
               <a:ext uri="{FF2B5EF4-FFF2-40B4-BE49-F238E27FC236}">
-                <a16:creationId xmlns:a16="http://schemas.microsoft.com/office/drawing/2014/main" id="{EC7A4D5F-91A5-42F0-8991-13489393BE72}"/>
+                <a16:creationId xmlns:a16="http://schemas.microsoft.com/office/drawing/2014/main" id="{265EF831-778A-4FF5-8615-64744626D924}"/>
               </a:ext>
             </a:extLst>
           </p:cNvPr>
@@ -5765,7 +6185,7 @@
           <p:cNvPr id="6" name="">
             <a:extLst xmlns:a="http://schemas.openxmlformats.org/drawingml/2006/main">
               <a:ext uri="{FF2B5EF4-FFF2-40B4-BE49-F238E27FC236}">
-                <a16:creationId xmlns:a16="http://schemas.microsoft.com/office/drawing/2014/main" id="{9C7CD021-CC61-482D-B818-B0E44772552F}"/>
+                <a16:creationId xmlns:a16="http://schemas.microsoft.com/office/drawing/2014/main" id="{423708ED-02A7-424F-8543-99FDA2EAFC75}"/>
               </a:ext>
             </a:extLst>
           </p:cNvPr>
@@ -5922,7 +6342,7 @@
           <p:cNvPr id="7" name="">
             <a:extLst xmlns:a="http://schemas.openxmlformats.org/drawingml/2006/main">
               <a:ext uri="{FF2B5EF4-FFF2-40B4-BE49-F238E27FC236}">
-                <a16:creationId xmlns:a16="http://schemas.microsoft.com/office/drawing/2014/main" id="{24E410CB-C670-4C81-B01F-86C43C82C55C}"/>
+                <a16:creationId xmlns:a16="http://schemas.microsoft.com/office/drawing/2014/main" id="{C8AA5724-052C-48C9-B653-EB8C817A0EED}"/>
               </a:ext>
             </a:extLst>
           </p:cNvPr>
@@ -6079,7 +6499,7 @@
           <p:cNvPr id="8" name="">
             <a:extLst xmlns:a="http://schemas.openxmlformats.org/drawingml/2006/main">
               <a:ext uri="{FF2B5EF4-FFF2-40B4-BE49-F238E27FC236}">
-                <a16:creationId xmlns:a16="http://schemas.microsoft.com/office/drawing/2014/main" id="{16045E05-0061-430B-AAFA-561AD2D15F29}"/>
+                <a16:creationId xmlns:a16="http://schemas.microsoft.com/office/drawing/2014/main" id="{0B0A5BB5-E207-4D90-BCB5-02005D2F6F4E}"/>
               </a:ext>
             </a:extLst>
           </p:cNvPr>
@@ -6112,7 +6532,7 @@
           <p:cNvPr id="9" name="">
             <a:extLst xmlns:a="http://schemas.openxmlformats.org/drawingml/2006/main">
               <a:ext uri="{FF2B5EF4-FFF2-40B4-BE49-F238E27FC236}">
-                <a16:creationId xmlns:a16="http://schemas.microsoft.com/office/drawing/2014/main" id="{CE7859A9-4C3F-4DE3-9C1E-E106A945CC7E}"/>
+                <a16:creationId xmlns:a16="http://schemas.microsoft.com/office/drawing/2014/main" id="{B6EA264B-DDE9-41C9-928D-29074A77EA6B}"/>
               </a:ext>
             </a:extLst>
           </p:cNvPr>
@@ -6269,7 +6689,7 @@
           <p:cNvPr id="10" name="">
             <a:extLst xmlns:a="http://schemas.openxmlformats.org/drawingml/2006/main">
               <a:ext uri="{FF2B5EF4-FFF2-40B4-BE49-F238E27FC236}">
-                <a16:creationId xmlns:a16="http://schemas.microsoft.com/office/drawing/2014/main" id="{97B5FBF8-7521-4A9A-B3B3-626416FA0CDF}"/>
+                <a16:creationId xmlns:a16="http://schemas.microsoft.com/office/drawing/2014/main" id="{502B09CB-768F-47FE-9D94-E7165ED32F17}"/>
               </a:ext>
             </a:extLst>
           </p:cNvPr>
@@ -6449,7 +6869,7 @@
           <p:cNvPr id="11" name="">
             <a:extLst xmlns:a="http://schemas.openxmlformats.org/drawingml/2006/main">
               <a:ext uri="{FF2B5EF4-FFF2-40B4-BE49-F238E27FC236}">
-                <a16:creationId xmlns:a16="http://schemas.microsoft.com/office/drawing/2014/main" id="{73897800-BA70-4F51-A08C-8CDE78F1DFF7}"/>
+                <a16:creationId xmlns:a16="http://schemas.microsoft.com/office/drawing/2014/main" id="{55D882BA-7A12-4D4F-A2A6-8D5D9F843C0E}"/>
               </a:ext>
             </a:extLst>
           </p:cNvPr>
@@ -6482,7 +6902,7 @@
           <p:cNvPr id="12" name="">
             <a:extLst xmlns:a="http://schemas.openxmlformats.org/drawingml/2006/main">
               <a:ext uri="{FF2B5EF4-FFF2-40B4-BE49-F238E27FC236}">
-                <a16:creationId xmlns:a16="http://schemas.microsoft.com/office/drawing/2014/main" id="{FF30D2E8-652F-4691-9395-F5DF16BF8581}"/>
+                <a16:creationId xmlns:a16="http://schemas.microsoft.com/office/drawing/2014/main" id="{E2A682EE-E9F1-479B-839F-2AD773E63407}"/>
               </a:ext>
             </a:extLst>
           </p:cNvPr>
@@ -6639,7 +7059,7 @@
           <p:cNvPr id="13" name="">
             <a:extLst xmlns:a="http://schemas.openxmlformats.org/drawingml/2006/main">
               <a:ext uri="{FF2B5EF4-FFF2-40B4-BE49-F238E27FC236}">
-                <a16:creationId xmlns:a16="http://schemas.microsoft.com/office/drawing/2014/main" id="{F51F5A95-5695-4149-BE6D-81353ABBAD87}"/>
+                <a16:creationId xmlns:a16="http://schemas.microsoft.com/office/drawing/2014/main" id="{8E07B4E4-338A-44EE-9057-13F60783CB25}"/>
               </a:ext>
             </a:extLst>
           </p:cNvPr>
@@ -6819,7 +7239,7 @@
           <p:cNvPr id="14" name="">
             <a:extLst xmlns:a="http://schemas.openxmlformats.org/drawingml/2006/main">
               <a:ext uri="{FF2B5EF4-FFF2-40B4-BE49-F238E27FC236}">
-                <a16:creationId xmlns:a16="http://schemas.microsoft.com/office/drawing/2014/main" id="{0A616DAB-D257-4370-88AA-1BAFA4C43969}"/>
+                <a16:creationId xmlns:a16="http://schemas.microsoft.com/office/drawing/2014/main" id="{32CE00A5-1CF9-4669-8778-0BE12F49C2A0}"/>
               </a:ext>
             </a:extLst>
           </p:cNvPr>
@@ -6852,7 +7272,7 @@
           <p:cNvPr id="15" name="">
             <a:extLst xmlns:a="http://schemas.openxmlformats.org/drawingml/2006/main">
               <a:ext uri="{FF2B5EF4-FFF2-40B4-BE49-F238E27FC236}">
-                <a16:creationId xmlns:a16="http://schemas.microsoft.com/office/drawing/2014/main" id="{0F32BBF7-CF5D-4387-B12E-5A92DD9F5CDE}"/>
+                <a16:creationId xmlns:a16="http://schemas.microsoft.com/office/drawing/2014/main" id="{1A5F9DCC-70E6-4892-8374-F2DE92E1724F}"/>
               </a:ext>
             </a:extLst>
           </p:cNvPr>
@@ -7009,7 +7429,7 @@
           <p:cNvPr id="16" name="">
             <a:extLst xmlns:a="http://schemas.openxmlformats.org/drawingml/2006/main">
               <a:ext uri="{FF2B5EF4-FFF2-40B4-BE49-F238E27FC236}">
-                <a16:creationId xmlns:a16="http://schemas.microsoft.com/office/drawing/2014/main" id="{A58F4993-F358-41B2-A12C-54AE59DE2025}"/>
+                <a16:creationId xmlns:a16="http://schemas.microsoft.com/office/drawing/2014/main" id="{7B46CCA9-0398-42D4-813A-3647F378AB3F}"/>
               </a:ext>
             </a:extLst>
           </p:cNvPr>
@@ -7189,7 +7609,164 @@
           <p:cNvPr id="17" name="">
             <a:extLst xmlns:a="http://schemas.openxmlformats.org/drawingml/2006/main">
               <a:ext uri="{FF2B5EF4-FFF2-40B4-BE49-F238E27FC236}">
-                <a16:creationId xmlns:a16="http://schemas.microsoft.com/office/drawing/2014/main" id="{49C3214E-0083-430D-BA47-9A27194861EB}"/>
+                <a16:creationId xmlns:a16="http://schemas.microsoft.com/office/drawing/2014/main" id="{72243941-52BB-44BE-8B30-ACAB4C78DAD8}"/>
+              </a:ext>
+            </a:extLst>
+          </p:cNvPr>
+          <p:cNvSpPr>
+            <a:spLocks xmlns:a="http://schemas.openxmlformats.org/drawingml/2006/main" noGrp="1"/>
+          </p:cNvSpPr>
+          <p:nvPr/>
+        </p:nvSpPr>
+        <p:spPr>
+          <a:xfrm xmlns:a="http://schemas.openxmlformats.org/drawingml/2006/main">
+            <a:off x="561975" y="4095750"/>
+            <a:ext cx="11058525" cy="352425"/>
+          </a:xfrm>
+          <a:prstGeom xmlns:a="http://schemas.openxmlformats.org/drawingml/2006/main" prst="rect">
+            <a:avLst/>
+          </a:prstGeom>
+          <a:noFill xmlns:a="http://schemas.openxmlformats.org/drawingml/2006/main"/>
+          <a:ln xmlns:a="http://schemas.openxmlformats.org/drawingml/2006/main" w="0">
+            <a:noFill/>
+            <a:prstDash val="solid"/>
+          </a:ln>
+        </p:spPr>
+        <p:txBody>
+          <a:bodyPr xmlns:a="http://schemas.openxmlformats.org/drawingml/2006/main" anchor="ctr"/>
+          <a:lstStyle xmlns:a="http://schemas.openxmlformats.org/drawingml/2006/main">
+            <a:defPPr algn="l">
+              <a:defRPr sz="1650" b="1">
+                <a:solidFill>
+                  <a:srgbClr val="11766E"/>
+                </a:solidFill>
+                <a:latin typeface="Avenir Next"/>
+                <a:ea typeface="Avenir Next"/>
+                <a:cs typeface="Avenir Next"/>
+              </a:defRPr>
+            </a:defPPr>
+            <a:lvl1pPr algn="l">
+              <a:defRPr sz="1650" b="1">
+                <a:solidFill>
+                  <a:srgbClr val="11766E"/>
+                </a:solidFill>
+                <a:latin typeface="Avenir Next"/>
+                <a:ea typeface="Avenir Next"/>
+                <a:cs typeface="Avenir Next"/>
+              </a:defRPr>
+            </a:lvl1pPr>
+            <a:lvl2pPr algn="l">
+              <a:defRPr sz="1650" b="1">
+                <a:solidFill>
+                  <a:srgbClr val="11766E"/>
+                </a:solidFill>
+                <a:latin typeface="Avenir Next"/>
+                <a:ea typeface="Avenir Next"/>
+                <a:cs typeface="Avenir Next"/>
+              </a:defRPr>
+            </a:lvl2pPr>
+            <a:lvl3pPr algn="l">
+              <a:defRPr sz="1650" b="1">
+                <a:solidFill>
+                  <a:srgbClr val="11766E"/>
+                </a:solidFill>
+                <a:latin typeface="Avenir Next"/>
+                <a:ea typeface="Avenir Next"/>
+                <a:cs typeface="Avenir Next"/>
+              </a:defRPr>
+            </a:lvl3pPr>
+            <a:lvl4pPr algn="l">
+              <a:defRPr sz="1650" b="1">
+                <a:solidFill>
+                  <a:srgbClr val="11766E"/>
+                </a:solidFill>
+                <a:latin typeface="Avenir Next"/>
+                <a:ea typeface="Avenir Next"/>
+                <a:cs typeface="Avenir Next"/>
+              </a:defRPr>
+            </a:lvl4pPr>
+            <a:lvl5pPr algn="l">
+              <a:defRPr sz="1650" b="1">
+                <a:solidFill>
+                  <a:srgbClr val="11766E"/>
+                </a:solidFill>
+                <a:latin typeface="Avenir Next"/>
+                <a:ea typeface="Avenir Next"/>
+                <a:cs typeface="Avenir Next"/>
+              </a:defRPr>
+            </a:lvl5pPr>
+            <a:lvl6pPr algn="l">
+              <a:defRPr sz="1650" b="1">
+                <a:solidFill>
+                  <a:srgbClr val="11766E"/>
+                </a:solidFill>
+                <a:latin typeface="Avenir Next"/>
+                <a:ea typeface="Avenir Next"/>
+                <a:cs typeface="Avenir Next"/>
+              </a:defRPr>
+            </a:lvl6pPr>
+            <a:lvl7pPr algn="l">
+              <a:defRPr sz="1650" b="1">
+                <a:solidFill>
+                  <a:srgbClr val="11766E"/>
+                </a:solidFill>
+                <a:latin typeface="Avenir Next"/>
+                <a:ea typeface="Avenir Next"/>
+                <a:cs typeface="Avenir Next"/>
+              </a:defRPr>
+            </a:lvl7pPr>
+            <a:lvl8pPr algn="l">
+              <a:defRPr sz="1650" b="1">
+                <a:solidFill>
+                  <a:srgbClr val="11766E"/>
+                </a:solidFill>
+                <a:latin typeface="Avenir Next"/>
+                <a:ea typeface="Avenir Next"/>
+                <a:cs typeface="Avenir Next"/>
+              </a:defRPr>
+            </a:lvl8pPr>
+            <a:lvl9pPr algn="l">
+              <a:defRPr sz="1650" b="1">
+                <a:solidFill>
+                  <a:srgbClr val="11766E"/>
+                </a:solidFill>
+                <a:latin typeface="Avenir Next"/>
+                <a:ea typeface="Avenir Next"/>
+                <a:cs typeface="Avenir Next"/>
+              </a:defRPr>
+            </a:lvl9pPr>
+          </a:lstStyle>
+          <a:p xmlns:a="http://schemas.openxmlformats.org/drawingml/2006/main">
+            <a:pPr algn="l">
+              <a:defRPr sz="1650" b="1">
+                <a:solidFill>
+                  <a:srgbClr val="11766E"/>
+                </a:solidFill>
+                <a:latin typeface="Avenir Next"/>
+                <a:ea typeface="Avenir Next"/>
+                <a:cs typeface="Avenir Next"/>
+              </a:defRPr>
+            </a:pPr>
+            <a:r>
+              <a:rPr sz="1650" b="1">
+                <a:solidFill>
+                  <a:srgbClr val="11766E"/>
+                </a:solidFill>
+                <a:latin typeface="Avenir Next"/>
+                <a:ea typeface="Avenir Next"/>
+                <a:cs typeface="Avenir Next"/>
+              </a:rPr>
+              <a:t>Pendiente técnico: la prueba aún no valida los SMS simulados.</a:t>
+            </a:r>
+          </a:p>
+        </p:txBody>
+      </p:sp>
+      <p:sp>
+        <p:nvSpPr>
+          <p:cNvPr id="18" name="">
+            <a:extLst xmlns:a="http://schemas.openxmlformats.org/drawingml/2006/main">
+              <a:ext uri="{FF2B5EF4-FFF2-40B4-BE49-F238E27FC236}">
+                <a16:creationId xmlns:a16="http://schemas.microsoft.com/office/drawing/2014/main" id="{D62911CE-9CE7-45B2-B02E-41F7FF83E254}"/>
               </a:ext>
             </a:extLst>
           </p:cNvPr>
@@ -7219,10 +7796,10 @@
       </p:sp>
       <p:sp>
         <p:nvSpPr>
-          <p:cNvPr id="18" name="">
+          <p:cNvPr id="19" name="">
             <a:extLst xmlns:a="http://schemas.openxmlformats.org/drawingml/2006/main">
               <a:ext uri="{FF2B5EF4-FFF2-40B4-BE49-F238E27FC236}">
-                <a16:creationId xmlns:a16="http://schemas.microsoft.com/office/drawing/2014/main" id="{5281A693-5CB0-4BB6-AFE7-D4F102ACD073}"/>
+                <a16:creationId xmlns:a16="http://schemas.microsoft.com/office/drawing/2014/main" id="{0219DDBF-A64A-4ABC-A54D-8542731C37F9}"/>
               </a:ext>
             </a:extLst>
           </p:cNvPr>
@@ -7376,10 +7953,10 @@
       </p:sp>
       <p:sp>
         <p:nvSpPr>
-          <p:cNvPr id="19" name="">
+          <p:cNvPr id="20" name="">
             <a:extLst xmlns:a="http://schemas.openxmlformats.org/drawingml/2006/main">
               <a:ext uri="{FF2B5EF4-FFF2-40B4-BE49-F238E27FC236}">
-                <a16:creationId xmlns:a16="http://schemas.microsoft.com/office/drawing/2014/main" id="{5BA027C6-C786-4B2D-A684-A7D1A117FD5C}"/>
+                <a16:creationId xmlns:a16="http://schemas.microsoft.com/office/drawing/2014/main" id="{6EFD2ECC-E71E-46A2-A7D2-61FF427EDE74}"/>
               </a:ext>
             </a:extLst>
           </p:cNvPr>
@@ -7533,10 +8110,10 @@
       </p:sp>
       <p:sp>
         <p:nvSpPr>
-          <p:cNvPr id="20" name="">
+          <p:cNvPr id="21" name="">
             <a:extLst xmlns:a="http://schemas.openxmlformats.org/drawingml/2006/main">
               <a:ext uri="{FF2B5EF4-FFF2-40B4-BE49-F238E27FC236}">
-                <a16:creationId xmlns:a16="http://schemas.microsoft.com/office/drawing/2014/main" id="{69733634-7E3B-4235-87A0-7627436DA43D}"/>
+                <a16:creationId xmlns:a16="http://schemas.microsoft.com/office/drawing/2014/main" id="{05A36839-9290-47C1-908E-40F00393C8E9}"/>
               </a:ext>
             </a:extLst>
           </p:cNvPr>
@@ -7682,7 +8259,7 @@
                 <a:latin typeface="Avenir Next"/>
                 <a:ea typeface="Avenir Next"/>
                 <a:cs typeface="Avenir Next"/>
-                <a:hlinkClick xmlns:r="http://schemas.openxmlformats.org/officeDocument/2006/relationships" r:id="R799c12652e4740ed"/>
+                <a:hlinkClick xmlns:r="http://schemas.openxmlformats.org/officeDocument/2006/relationships" r:id="R039a068bff7b41ee"/>
               </a:rPr>
               <a:t>Repositorio y código</a:t>
             </a:r>
@@ -7692,7 +8269,7 @@
     </p:spTree>
     <p:extLst>
       <p:ext uri="{BB962C8B-B14F-4D97-AF65-F5344CB8AC3E}">
-        <p14:creationId xmlns:p14="http://schemas.microsoft.com/office/powerpoint/2010/main" val="1404349858"/>
+        <p14:creationId xmlns:p14="http://schemas.microsoft.com/office/powerpoint/2010/main" val="975580904"/>
       </p:ext>
     </p:extLst>
   </p:cSld>
@@ -7720,10 +8297,10 @@
       </p:grpSpPr>
       <p:sp>
         <p:nvSpPr>
-          <p:cNvPr id="17" name="">
+          <p:cNvPr id="18" name="">
             <a:extLst xmlns:a="http://schemas.openxmlformats.org/drawingml/2006/main">
               <a:ext uri="{FF2B5EF4-FFF2-40B4-BE49-F238E27FC236}">
-                <a16:creationId xmlns:a16="http://schemas.microsoft.com/office/drawing/2014/main" id="{6ABD00AB-C990-4036-BE8E-98EA3D7E74D4}"/>
+                <a16:creationId xmlns:a16="http://schemas.microsoft.com/office/drawing/2014/main" id="{76072913-89E8-4940-95A5-1E69176B4C06}"/>
               </a:ext>
             </a:extLst>
           </p:cNvPr>
@@ -7754,7 +8331,7 @@
           <p:cNvPr id="2" name="">
             <a:extLst xmlns:a="http://schemas.openxmlformats.org/drawingml/2006/main">
               <a:ext uri="{FF2B5EF4-FFF2-40B4-BE49-F238E27FC236}">
-                <a16:creationId xmlns:a16="http://schemas.microsoft.com/office/drawing/2014/main" id="{773B7EA3-D606-4D85-B20D-D79ED29FAC62}"/>
+                <a16:creationId xmlns:a16="http://schemas.microsoft.com/office/drawing/2014/main" id="{AC817C9D-178A-47B3-8053-C9C9C755D103}"/>
               </a:ext>
             </a:extLst>
           </p:cNvPr>
@@ -7911,7 +8488,7 @@
           <p:cNvPr id="3" name="">
             <a:extLst xmlns:a="http://schemas.openxmlformats.org/drawingml/2006/main">
               <a:ext uri="{FF2B5EF4-FFF2-40B4-BE49-F238E27FC236}">
-                <a16:creationId xmlns:a16="http://schemas.microsoft.com/office/drawing/2014/main" id="{3063DD09-B653-4DC8-AF77-97AEDB6CF4E8}"/>
+                <a16:creationId xmlns:a16="http://schemas.microsoft.com/office/drawing/2014/main" id="{DD79612F-D2EA-45E0-AE8D-CEE3336BE449}"/>
               </a:ext>
             </a:extLst>
           </p:cNvPr>
@@ -8068,7 +8645,7 @@
           <p:cNvPr id="4" name="">
             <a:extLst xmlns:a="http://schemas.openxmlformats.org/drawingml/2006/main">
               <a:ext uri="{FF2B5EF4-FFF2-40B4-BE49-F238E27FC236}">
-                <a16:creationId xmlns:a16="http://schemas.microsoft.com/office/drawing/2014/main" id="{4EFC2CB9-4738-469A-A31F-D122AB27D559}"/>
+                <a16:creationId xmlns:a16="http://schemas.microsoft.com/office/drawing/2014/main" id="{F85F1216-3E4F-4721-ABB9-BCCD50799A1E}"/>
               </a:ext>
             </a:extLst>
           </p:cNvPr>
@@ -8225,7 +8802,7 @@
           <p:cNvPr id="5" name="">
             <a:extLst xmlns:a="http://schemas.openxmlformats.org/drawingml/2006/main">
               <a:ext uri="{FF2B5EF4-FFF2-40B4-BE49-F238E27FC236}">
-                <a16:creationId xmlns:a16="http://schemas.microsoft.com/office/drawing/2014/main" id="{13E28022-AE8C-4FC2-8B48-1CFEE258BC3A}"/>
+                <a16:creationId xmlns:a16="http://schemas.microsoft.com/office/drawing/2014/main" id="{69CF3472-48F6-4F67-B039-062FBA5AE0EB}"/>
               </a:ext>
             </a:extLst>
           </p:cNvPr>
@@ -8256,7 +8833,7 @@
           <p:cNvPr id="6" name="">
             <a:extLst xmlns:a="http://schemas.openxmlformats.org/drawingml/2006/main">
               <a:ext uri="{FF2B5EF4-FFF2-40B4-BE49-F238E27FC236}">
-                <a16:creationId xmlns:a16="http://schemas.microsoft.com/office/drawing/2014/main" id="{86A92C07-4FDE-48EE-9FFB-E22987E69622}"/>
+                <a16:creationId xmlns:a16="http://schemas.microsoft.com/office/drawing/2014/main" id="{5F231816-3B96-4B5B-9AD7-4F5CFA0E5DE3}"/>
               </a:ext>
             </a:extLst>
           </p:cNvPr>
@@ -8413,7 +8990,7 @@
           <p:cNvPr id="7" name="">
             <a:extLst xmlns:a="http://schemas.openxmlformats.org/drawingml/2006/main">
               <a:ext uri="{FF2B5EF4-FFF2-40B4-BE49-F238E27FC236}">
-                <a16:creationId xmlns:a16="http://schemas.microsoft.com/office/drawing/2014/main" id="{FA8599F2-B53A-40A5-AB78-6AB2DA0B7324}"/>
+                <a16:creationId xmlns:a16="http://schemas.microsoft.com/office/drawing/2014/main" id="{E92CB9D5-05C6-49CB-BDA9-0D4AB84E7531}"/>
               </a:ext>
             </a:extLst>
           </p:cNvPr>
@@ -8570,7 +9147,7 @@
           <p:cNvPr id="8" name="">
             <a:extLst xmlns:a="http://schemas.openxmlformats.org/drawingml/2006/main">
               <a:ext uri="{FF2B5EF4-FFF2-40B4-BE49-F238E27FC236}">
-                <a16:creationId xmlns:a16="http://schemas.microsoft.com/office/drawing/2014/main" id="{F04BEED5-6900-4D12-8769-D6F3C3077149}"/>
+                <a16:creationId xmlns:a16="http://schemas.microsoft.com/office/drawing/2014/main" id="{7368E9FD-D563-4F64-AF90-84C10CCDD5A7}"/>
               </a:ext>
             </a:extLst>
           </p:cNvPr>
@@ -8603,7 +9180,7 @@
           <p:cNvPr id="9" name="">
             <a:extLst xmlns:a="http://schemas.openxmlformats.org/drawingml/2006/main">
               <a:ext uri="{FF2B5EF4-FFF2-40B4-BE49-F238E27FC236}">
-                <a16:creationId xmlns:a16="http://schemas.microsoft.com/office/drawing/2014/main" id="{CD5E5E9D-42BE-414F-879F-6CDB684395E7}"/>
+                <a16:creationId xmlns:a16="http://schemas.microsoft.com/office/drawing/2014/main" id="{B137009A-9BB3-4002-AA13-7E2B99E3D883}"/>
               </a:ext>
             </a:extLst>
           </p:cNvPr>
@@ -8760,7 +9337,7 @@
           <p:cNvPr id="10" name="">
             <a:extLst xmlns:a="http://schemas.openxmlformats.org/drawingml/2006/main">
               <a:ext uri="{FF2B5EF4-FFF2-40B4-BE49-F238E27FC236}">
-                <a16:creationId xmlns:a16="http://schemas.microsoft.com/office/drawing/2014/main" id="{8F391FCD-A1AB-4503-AF0F-CFBAA4AC818D}"/>
+                <a16:creationId xmlns:a16="http://schemas.microsoft.com/office/drawing/2014/main" id="{C8109CEF-F352-4A6C-835A-BEFCFF72D616}"/>
               </a:ext>
             </a:extLst>
           </p:cNvPr>
@@ -8940,7 +9517,7 @@
           <p:cNvPr id="11" name="">
             <a:extLst xmlns:a="http://schemas.openxmlformats.org/drawingml/2006/main">
               <a:ext uri="{FF2B5EF4-FFF2-40B4-BE49-F238E27FC236}">
-                <a16:creationId xmlns:a16="http://schemas.microsoft.com/office/drawing/2014/main" id="{8A8FFDFC-8BAA-4A15-8DC8-C2E460249256}"/>
+                <a16:creationId xmlns:a16="http://schemas.microsoft.com/office/drawing/2014/main" id="{E3C29E2B-5E86-45E5-A7F4-12B3771CFA6B}"/>
               </a:ext>
             </a:extLst>
           </p:cNvPr>
@@ -8973,7 +9550,7 @@
           <p:cNvPr id="12" name="">
             <a:extLst xmlns:a="http://schemas.openxmlformats.org/drawingml/2006/main">
               <a:ext uri="{FF2B5EF4-FFF2-40B4-BE49-F238E27FC236}">
-                <a16:creationId xmlns:a16="http://schemas.microsoft.com/office/drawing/2014/main" id="{F7B301EC-2BD2-432B-97DA-9588FEE076BB}"/>
+                <a16:creationId xmlns:a16="http://schemas.microsoft.com/office/drawing/2014/main" id="{614A73AA-4201-4AA6-BA84-390F600959FE}"/>
               </a:ext>
             </a:extLst>
           </p:cNvPr>
@@ -9130,7 +9707,7 @@
           <p:cNvPr id="13" name="">
             <a:extLst xmlns:a="http://schemas.openxmlformats.org/drawingml/2006/main">
               <a:ext uri="{FF2B5EF4-FFF2-40B4-BE49-F238E27FC236}">
-                <a16:creationId xmlns:a16="http://schemas.microsoft.com/office/drawing/2014/main" id="{BCCEBE40-2C49-4D5A-81C4-450CF5983EE9}"/>
+                <a16:creationId xmlns:a16="http://schemas.microsoft.com/office/drawing/2014/main" id="{627A011F-08FC-4409-B047-6975F055F364}"/>
               </a:ext>
             </a:extLst>
           </p:cNvPr>
@@ -9310,7 +9887,7 @@
           <p:cNvPr id="14" name="">
             <a:extLst xmlns:a="http://schemas.openxmlformats.org/drawingml/2006/main">
               <a:ext uri="{FF2B5EF4-FFF2-40B4-BE49-F238E27FC236}">
-                <a16:creationId xmlns:a16="http://schemas.microsoft.com/office/drawing/2014/main" id="{86935C14-9885-472D-A66E-F7724F508192}"/>
+                <a16:creationId xmlns:a16="http://schemas.microsoft.com/office/drawing/2014/main" id="{0F25C73C-AD3D-4139-8E44-EE6E955A97C4}"/>
               </a:ext>
             </a:extLst>
           </p:cNvPr>
@@ -9343,7 +9920,7 @@
           <p:cNvPr id="15" name="">
             <a:extLst xmlns:a="http://schemas.openxmlformats.org/drawingml/2006/main">
               <a:ext uri="{FF2B5EF4-FFF2-40B4-BE49-F238E27FC236}">
-                <a16:creationId xmlns:a16="http://schemas.microsoft.com/office/drawing/2014/main" id="{E12216DA-CCDE-4F9C-9020-15C08D94EC80}"/>
+                <a16:creationId xmlns:a16="http://schemas.microsoft.com/office/drawing/2014/main" id="{388602A3-EA8A-4549-92DE-21256CE32DE1}"/>
               </a:ext>
             </a:extLst>
           </p:cNvPr>
@@ -9353,7 +9930,7 @@
           <p:nvPr/>
         </p:nvPicPr>
         <p:blipFill>
-          <a:blip xmlns:r="http://schemas.openxmlformats.org/officeDocument/2006/relationships" xmlns:a="http://schemas.openxmlformats.org/drawingml/2006/main" r:embed="Rf1f36bfb1f0c4ef2"/>
+          <a:blip xmlns:r="http://schemas.openxmlformats.org/officeDocument/2006/relationships" xmlns:a="http://schemas.openxmlformats.org/drawingml/2006/main" r:embed="Ra3e49aff25d34f0a"/>
           <a:stretch xmlns:a="http://schemas.openxmlformats.org/drawingml/2006/main"/>
         </p:blipFill>
         <p:spPr>
@@ -9373,7 +9950,7 @@
           <p:cNvPr id="16" name="">
             <a:extLst xmlns:a="http://schemas.openxmlformats.org/drawingml/2006/main">
               <a:ext uri="{FF2B5EF4-FFF2-40B4-BE49-F238E27FC236}">
-                <a16:creationId xmlns:a16="http://schemas.microsoft.com/office/drawing/2014/main" id="{D1BF61CA-AB59-4D9B-B722-7D9375756666}"/>
+                <a16:creationId xmlns:a16="http://schemas.microsoft.com/office/drawing/2014/main" id="{B5E232D7-66E7-4F32-B437-72C329AB4697}"/>
               </a:ext>
             </a:extLst>
           </p:cNvPr>
@@ -9525,10 +10102,167 @@
           </a:p>
         </p:txBody>
       </p:sp>
+      <p:sp>
+        <p:nvSpPr>
+          <p:cNvPr id="17" name="">
+            <a:extLst xmlns:a="http://schemas.openxmlformats.org/drawingml/2006/main">
+              <a:ext uri="{FF2B5EF4-FFF2-40B4-BE49-F238E27FC236}">
+                <a16:creationId xmlns:a16="http://schemas.microsoft.com/office/drawing/2014/main" id="{E9E57225-4FCE-48F0-8415-F8D589D59650}"/>
+              </a:ext>
+            </a:extLst>
+          </p:cNvPr>
+          <p:cNvSpPr>
+            <a:spLocks xmlns:a="http://schemas.openxmlformats.org/drawingml/2006/main" noGrp="1"/>
+          </p:cNvSpPr>
+          <p:nvPr/>
+        </p:nvSpPr>
+        <p:spPr>
+          <a:xfrm xmlns:a="http://schemas.openxmlformats.org/drawingml/2006/main">
+            <a:off x="561975" y="5762625"/>
+            <a:ext cx="11058525" cy="381000"/>
+          </a:xfrm>
+          <a:prstGeom xmlns:a="http://schemas.openxmlformats.org/drawingml/2006/main" prst="rect">
+            <a:avLst/>
+          </a:prstGeom>
+          <a:noFill xmlns:a="http://schemas.openxmlformats.org/drawingml/2006/main"/>
+          <a:ln xmlns:a="http://schemas.openxmlformats.org/drawingml/2006/main" w="0">
+            <a:noFill/>
+            <a:prstDash val="solid"/>
+          </a:ln>
+        </p:spPr>
+        <p:txBody>
+          <a:bodyPr xmlns:a="http://schemas.openxmlformats.org/drawingml/2006/main" anchor="ctr"/>
+          <a:lstStyle xmlns:a="http://schemas.openxmlformats.org/drawingml/2006/main">
+            <a:defPPr algn="l">
+              <a:defRPr sz="1800" b="1">
+                <a:solidFill>
+                  <a:srgbClr val="11766E"/>
+                </a:solidFill>
+                <a:latin typeface="Avenir Next"/>
+                <a:ea typeface="Avenir Next"/>
+                <a:cs typeface="Avenir Next"/>
+              </a:defRPr>
+            </a:defPPr>
+            <a:lvl1pPr algn="l">
+              <a:defRPr sz="1800" b="1">
+                <a:solidFill>
+                  <a:srgbClr val="11766E"/>
+                </a:solidFill>
+                <a:latin typeface="Avenir Next"/>
+                <a:ea typeface="Avenir Next"/>
+                <a:cs typeface="Avenir Next"/>
+              </a:defRPr>
+            </a:lvl1pPr>
+            <a:lvl2pPr algn="l">
+              <a:defRPr sz="1800" b="1">
+                <a:solidFill>
+                  <a:srgbClr val="11766E"/>
+                </a:solidFill>
+                <a:latin typeface="Avenir Next"/>
+                <a:ea typeface="Avenir Next"/>
+                <a:cs typeface="Avenir Next"/>
+              </a:defRPr>
+            </a:lvl2pPr>
+            <a:lvl3pPr algn="l">
+              <a:defRPr sz="1800" b="1">
+                <a:solidFill>
+                  <a:srgbClr val="11766E"/>
+                </a:solidFill>
+                <a:latin typeface="Avenir Next"/>
+                <a:ea typeface="Avenir Next"/>
+                <a:cs typeface="Avenir Next"/>
+              </a:defRPr>
+            </a:lvl3pPr>
+            <a:lvl4pPr algn="l">
+              <a:defRPr sz="1800" b="1">
+                <a:solidFill>
+                  <a:srgbClr val="11766E"/>
+                </a:solidFill>
+                <a:latin typeface="Avenir Next"/>
+                <a:ea typeface="Avenir Next"/>
+                <a:cs typeface="Avenir Next"/>
+              </a:defRPr>
+            </a:lvl4pPr>
+            <a:lvl5pPr algn="l">
+              <a:defRPr sz="1800" b="1">
+                <a:solidFill>
+                  <a:srgbClr val="11766E"/>
+                </a:solidFill>
+                <a:latin typeface="Avenir Next"/>
+                <a:ea typeface="Avenir Next"/>
+                <a:cs typeface="Avenir Next"/>
+              </a:defRPr>
+            </a:lvl5pPr>
+            <a:lvl6pPr algn="l">
+              <a:defRPr sz="1800" b="1">
+                <a:solidFill>
+                  <a:srgbClr val="11766E"/>
+                </a:solidFill>
+                <a:latin typeface="Avenir Next"/>
+                <a:ea typeface="Avenir Next"/>
+                <a:cs typeface="Avenir Next"/>
+              </a:defRPr>
+            </a:lvl6pPr>
+            <a:lvl7pPr algn="l">
+              <a:defRPr sz="1800" b="1">
+                <a:solidFill>
+                  <a:srgbClr val="11766E"/>
+                </a:solidFill>
+                <a:latin typeface="Avenir Next"/>
+                <a:ea typeface="Avenir Next"/>
+                <a:cs typeface="Avenir Next"/>
+              </a:defRPr>
+            </a:lvl7pPr>
+            <a:lvl8pPr algn="l">
+              <a:defRPr sz="1800" b="1">
+                <a:solidFill>
+                  <a:srgbClr val="11766E"/>
+                </a:solidFill>
+                <a:latin typeface="Avenir Next"/>
+                <a:ea typeface="Avenir Next"/>
+                <a:cs typeface="Avenir Next"/>
+              </a:defRPr>
+            </a:lvl8pPr>
+            <a:lvl9pPr algn="l">
+              <a:defRPr sz="1800" b="1">
+                <a:solidFill>
+                  <a:srgbClr val="11766E"/>
+                </a:solidFill>
+                <a:latin typeface="Avenir Next"/>
+                <a:ea typeface="Avenir Next"/>
+                <a:cs typeface="Avenir Next"/>
+              </a:defRPr>
+            </a:lvl9pPr>
+          </a:lstStyle>
+          <a:p xmlns:a="http://schemas.openxmlformats.org/drawingml/2006/main">
+            <a:pPr algn="l">
+              <a:defRPr sz="1800" b="1">
+                <a:solidFill>
+                  <a:srgbClr val="11766E"/>
+                </a:solidFill>
+                <a:latin typeface="Avenir Next"/>
+                <a:ea typeface="Avenir Next"/>
+                <a:cs typeface="Avenir Next"/>
+              </a:defRPr>
+            </a:pPr>
+            <a:r>
+              <a:rPr sz="1800" b="1">
+                <a:solidFill>
+                  <a:srgbClr val="11766E"/>
+                </a:solidFill>
+                <a:latin typeface="Avenir Next"/>
+                <a:ea typeface="Avenir Next"/>
+                <a:cs typeface="Avenir Next"/>
+              </a:rPr>
+              <a:t>Pendiente  →  Aceptada  →  saldos comprobados</a:t>
+            </a:r>
+          </a:p>
+        </p:txBody>
+      </p:sp>
     </p:spTree>
     <p:extLst>
       <p:ext uri="{BB962C8B-B14F-4D97-AF65-F5344CB8AC3E}">
-        <p14:creationId xmlns:p14="http://schemas.microsoft.com/office/powerpoint/2010/main" val="1096057734"/>
+        <p14:creationId xmlns:p14="http://schemas.microsoft.com/office/powerpoint/2010/main" val="1540248039"/>
       </p:ext>
     </p:extLst>
   </p:cSld>
@@ -9559,7 +10293,7 @@
           <p:cNvPr id="25" name="">
             <a:extLst xmlns:a="http://schemas.openxmlformats.org/drawingml/2006/main">
               <a:ext uri="{FF2B5EF4-FFF2-40B4-BE49-F238E27FC236}">
-                <a16:creationId xmlns:a16="http://schemas.microsoft.com/office/drawing/2014/main" id="{074EE560-4428-41D5-8719-9AD84B727C75}"/>
+                <a16:creationId xmlns:a16="http://schemas.microsoft.com/office/drawing/2014/main" id="{ADD37B3B-D093-480C-8F00-ED6BB4DA97FE}"/>
               </a:ext>
             </a:extLst>
           </p:cNvPr>
@@ -9590,7 +10324,7 @@
           <p:cNvPr id="2" name="">
             <a:extLst xmlns:a="http://schemas.openxmlformats.org/drawingml/2006/main">
               <a:ext uri="{FF2B5EF4-FFF2-40B4-BE49-F238E27FC236}">
-                <a16:creationId xmlns:a16="http://schemas.microsoft.com/office/drawing/2014/main" id="{A48C219C-31E4-4EB0-B742-3453A94083DC}"/>
+                <a16:creationId xmlns:a16="http://schemas.microsoft.com/office/drawing/2014/main" id="{12F0F5AE-5361-4886-B48C-679BEC63B9EE}"/>
               </a:ext>
             </a:extLst>
           </p:cNvPr>
@@ -9747,7 +10481,7 @@
           <p:cNvPr id="3" name="">
             <a:extLst xmlns:a="http://schemas.openxmlformats.org/drawingml/2006/main">
               <a:ext uri="{FF2B5EF4-FFF2-40B4-BE49-F238E27FC236}">
-                <a16:creationId xmlns:a16="http://schemas.microsoft.com/office/drawing/2014/main" id="{8242EC58-8302-4417-B2DF-35BE254FEDB5}"/>
+                <a16:creationId xmlns:a16="http://schemas.microsoft.com/office/drawing/2014/main" id="{F5A734EC-393D-4510-8EAB-E79669751F0A}"/>
               </a:ext>
             </a:extLst>
           </p:cNvPr>
@@ -9904,7 +10638,7 @@
           <p:cNvPr id="4" name="">
             <a:extLst xmlns:a="http://schemas.openxmlformats.org/drawingml/2006/main">
               <a:ext uri="{FF2B5EF4-FFF2-40B4-BE49-F238E27FC236}">
-                <a16:creationId xmlns:a16="http://schemas.microsoft.com/office/drawing/2014/main" id="{32B2ED0B-356C-4D7B-A92E-721B8D6D9CB0}"/>
+                <a16:creationId xmlns:a16="http://schemas.microsoft.com/office/drawing/2014/main" id="{5665E02E-6199-4267-A4D3-875F5AD61036}"/>
               </a:ext>
             </a:extLst>
           </p:cNvPr>
@@ -10061,7 +10795,7 @@
           <p:cNvPr id="5" name="">
             <a:extLst xmlns:a="http://schemas.openxmlformats.org/drawingml/2006/main">
               <a:ext uri="{FF2B5EF4-FFF2-40B4-BE49-F238E27FC236}">
-                <a16:creationId xmlns:a16="http://schemas.microsoft.com/office/drawing/2014/main" id="{AA67E6B0-D683-44E6-8318-288AFBE4D830}"/>
+                <a16:creationId xmlns:a16="http://schemas.microsoft.com/office/drawing/2014/main" id="{FE68EE16-8266-4C8C-926D-CA137843BD5B}"/>
               </a:ext>
             </a:extLst>
           </p:cNvPr>
@@ -10092,7 +10826,7 @@
           <p:cNvPr id="6" name="">
             <a:extLst xmlns:a="http://schemas.openxmlformats.org/drawingml/2006/main">
               <a:ext uri="{FF2B5EF4-FFF2-40B4-BE49-F238E27FC236}">
-                <a16:creationId xmlns:a16="http://schemas.microsoft.com/office/drawing/2014/main" id="{2C070871-CD12-4A59-9D71-2B8F6DC72FC3}"/>
+                <a16:creationId xmlns:a16="http://schemas.microsoft.com/office/drawing/2014/main" id="{7871C315-A730-4492-82B2-228C1C58F841}"/>
               </a:ext>
             </a:extLst>
           </p:cNvPr>
@@ -10249,7 +10983,7 @@
           <p:cNvPr id="7" name="">
             <a:extLst xmlns:a="http://schemas.openxmlformats.org/drawingml/2006/main">
               <a:ext uri="{FF2B5EF4-FFF2-40B4-BE49-F238E27FC236}">
-                <a16:creationId xmlns:a16="http://schemas.microsoft.com/office/drawing/2014/main" id="{FAE81EF2-17C4-4B61-9E6F-98BD59E9E160}"/>
+                <a16:creationId xmlns:a16="http://schemas.microsoft.com/office/drawing/2014/main" id="{82430060-61FF-45D4-896F-D22DA9EB5FB2}"/>
               </a:ext>
             </a:extLst>
           </p:cNvPr>
@@ -10406,7 +11140,7 @@
           <p:cNvPr id="8" name="">
             <a:extLst xmlns:a="http://schemas.openxmlformats.org/drawingml/2006/main">
               <a:ext uri="{FF2B5EF4-FFF2-40B4-BE49-F238E27FC236}">
-                <a16:creationId xmlns:a16="http://schemas.microsoft.com/office/drawing/2014/main" id="{74390A9C-890D-4BE3-B61B-7E3CB9B61AE5}"/>
+                <a16:creationId xmlns:a16="http://schemas.microsoft.com/office/drawing/2014/main" id="{10CE322C-7F88-4097-BC2C-92883E9B9AD0}"/>
               </a:ext>
             </a:extLst>
           </p:cNvPr>
@@ -10437,7 +11171,7 @@
           <p:cNvPr id="9" name="">
             <a:extLst xmlns:a="http://schemas.openxmlformats.org/drawingml/2006/main">
               <a:ext uri="{FF2B5EF4-FFF2-40B4-BE49-F238E27FC236}">
-                <a16:creationId xmlns:a16="http://schemas.microsoft.com/office/drawing/2014/main" id="{29F89054-5794-4280-9854-E5B586E9ED9A}"/>
+                <a16:creationId xmlns:a16="http://schemas.microsoft.com/office/drawing/2014/main" id="{A71E52F4-9F93-426A-8142-4389EA1B6FF4}"/>
               </a:ext>
             </a:extLst>
           </p:cNvPr>
@@ -10470,7 +11204,7 @@
           <p:cNvPr id="10" name="">
             <a:extLst xmlns:a="http://schemas.openxmlformats.org/drawingml/2006/main">
               <a:ext uri="{FF2B5EF4-FFF2-40B4-BE49-F238E27FC236}">
-                <a16:creationId xmlns:a16="http://schemas.microsoft.com/office/drawing/2014/main" id="{B2EB733E-5C20-44BD-B134-E8E11F4417C7}"/>
+                <a16:creationId xmlns:a16="http://schemas.microsoft.com/office/drawing/2014/main" id="{1EACA5B4-F9FF-41DF-995B-9511851A8B95}"/>
               </a:ext>
             </a:extLst>
           </p:cNvPr>
@@ -10503,7 +11237,7 @@
           <p:cNvPr id="11" name="">
             <a:extLst xmlns:a="http://schemas.openxmlformats.org/drawingml/2006/main">
               <a:ext uri="{FF2B5EF4-FFF2-40B4-BE49-F238E27FC236}">
-                <a16:creationId xmlns:a16="http://schemas.microsoft.com/office/drawing/2014/main" id="{F54B20AE-741D-4ED2-BB48-8F9430B4792F}"/>
+                <a16:creationId xmlns:a16="http://schemas.microsoft.com/office/drawing/2014/main" id="{2A9F25C2-7030-4582-8638-CFA5327622EE}"/>
               </a:ext>
             </a:extLst>
           </p:cNvPr>
@@ -10660,7 +11394,7 @@
           <p:cNvPr id="12" name="">
             <a:extLst xmlns:a="http://schemas.openxmlformats.org/drawingml/2006/main">
               <a:ext uri="{FF2B5EF4-FFF2-40B4-BE49-F238E27FC236}">
-                <a16:creationId xmlns:a16="http://schemas.microsoft.com/office/drawing/2014/main" id="{D9FB5FBB-3616-408D-8664-360A3B4AABF5}"/>
+                <a16:creationId xmlns:a16="http://schemas.microsoft.com/office/drawing/2014/main" id="{72333E1C-C80B-4FBC-8F52-7AD560D8428C}"/>
               </a:ext>
             </a:extLst>
           </p:cNvPr>
@@ -10817,7 +11551,7 @@
           <p:cNvPr id="13" name="">
             <a:extLst xmlns:a="http://schemas.openxmlformats.org/drawingml/2006/main">
               <a:ext uri="{FF2B5EF4-FFF2-40B4-BE49-F238E27FC236}">
-                <a16:creationId xmlns:a16="http://schemas.microsoft.com/office/drawing/2014/main" id="{008C85E3-8B2D-47C4-B71B-CDF7AB68621D}"/>
+                <a16:creationId xmlns:a16="http://schemas.microsoft.com/office/drawing/2014/main" id="{43CD61AA-6EC1-42DF-877D-BF4D0EBE9865}"/>
               </a:ext>
             </a:extLst>
           </p:cNvPr>
@@ -10964,7 +11698,7 @@
                 <a:ea typeface="Avenir Next"/>
                 <a:cs typeface="Avenir Next"/>
               </a:rPr>
-              <a:t>Keywords, bibliotecas</a:t>
+              <a:t>Casos con keywords,</a:t>
             </a:r>
           </a:p>
           <a:p xmlns:a="http://schemas.openxmlformats.org/drawingml/2006/main">
@@ -10987,7 +11721,7 @@
                 <a:ea typeface="Avenir Next"/>
                 <a:cs typeface="Avenir Next"/>
               </a:rPr>
-              <a:t>y reportes</a:t>
+              <a:t>bibliotecas y reportes</a:t>
             </a:r>
           </a:p>
         </p:txBody>
@@ -10997,7 +11731,7 @@
           <p:cNvPr id="14" name="">
             <a:extLst xmlns:a="http://schemas.openxmlformats.org/drawingml/2006/main">
               <a:ext uri="{FF2B5EF4-FFF2-40B4-BE49-F238E27FC236}">
-                <a16:creationId xmlns:a16="http://schemas.microsoft.com/office/drawing/2014/main" id="{EADC3DF6-C6A8-474A-A693-E31C47A18527}"/>
+                <a16:creationId xmlns:a16="http://schemas.microsoft.com/office/drawing/2014/main" id="{1E299ADB-97F3-4F84-9728-716FB44B8588}"/>
               </a:ext>
             </a:extLst>
           </p:cNvPr>
@@ -11030,7 +11764,7 @@
           <p:cNvPr id="15" name="">
             <a:extLst xmlns:a="http://schemas.openxmlformats.org/drawingml/2006/main">
               <a:ext uri="{FF2B5EF4-FFF2-40B4-BE49-F238E27FC236}">
-                <a16:creationId xmlns:a16="http://schemas.microsoft.com/office/drawing/2014/main" id="{258E5521-091A-4EA7-A56C-BF06A9BF3FF4}"/>
+                <a16:creationId xmlns:a16="http://schemas.microsoft.com/office/drawing/2014/main" id="{00052CF7-502F-4EC8-BCEA-B81D34967C9C}"/>
               </a:ext>
             </a:extLst>
           </p:cNvPr>
@@ -11063,7 +11797,7 @@
           <p:cNvPr id="16" name="">
             <a:extLst xmlns:a="http://schemas.openxmlformats.org/drawingml/2006/main">
               <a:ext uri="{FF2B5EF4-FFF2-40B4-BE49-F238E27FC236}">
-                <a16:creationId xmlns:a16="http://schemas.microsoft.com/office/drawing/2014/main" id="{D97E5A33-36F1-48E0-98E9-42EDFFA0D734}"/>
+                <a16:creationId xmlns:a16="http://schemas.microsoft.com/office/drawing/2014/main" id="{1C714DFD-E071-4FF0-B2FC-BB220089821A}"/>
               </a:ext>
             </a:extLst>
           </p:cNvPr>
@@ -11220,7 +11954,7 @@
           <p:cNvPr id="17" name="">
             <a:extLst xmlns:a="http://schemas.openxmlformats.org/drawingml/2006/main">
               <a:ext uri="{FF2B5EF4-FFF2-40B4-BE49-F238E27FC236}">
-                <a16:creationId xmlns:a16="http://schemas.microsoft.com/office/drawing/2014/main" id="{B608B87E-948D-4BB2-8FE3-47242BF1BDBC}"/>
+                <a16:creationId xmlns:a16="http://schemas.microsoft.com/office/drawing/2014/main" id="{E7372A63-A00A-4869-827C-753F440B7075}"/>
               </a:ext>
             </a:extLst>
           </p:cNvPr>
@@ -11377,7 +12111,7 @@
           <p:cNvPr id="18" name="">
             <a:extLst xmlns:a="http://schemas.openxmlformats.org/drawingml/2006/main">
               <a:ext uri="{FF2B5EF4-FFF2-40B4-BE49-F238E27FC236}">
-                <a16:creationId xmlns:a16="http://schemas.microsoft.com/office/drawing/2014/main" id="{A54258FD-1AF5-42FD-AE9E-B9E28990A41A}"/>
+                <a16:creationId xmlns:a16="http://schemas.microsoft.com/office/drawing/2014/main" id="{3A0A8EA4-F290-4A97-8A3A-621648E99037}"/>
               </a:ext>
             </a:extLst>
           </p:cNvPr>
@@ -11524,7 +12258,7 @@
                 <a:ea typeface="Avenir Next"/>
                 <a:cs typeface="Avenir Next"/>
               </a:rPr>
-              <a:t>Tareas automatizadas</a:t>
+              <a:t>Automatización de tareas</a:t>
             </a:r>
           </a:p>
           <a:p xmlns:a="http://schemas.openxmlformats.org/drawingml/2006/main">
@@ -11547,7 +12281,7 @@
                 <a:ea typeface="Avenir Next"/>
                 <a:cs typeface="Avenir Next"/>
               </a:rPr>
-              <a:t>desde RF 3.1</a:t>
+              <a:t>repetitivas desde RF 3.1</a:t>
             </a:r>
           </a:p>
         </p:txBody>
@@ -11557,7 +12291,7 @@
           <p:cNvPr id="19" name="">
             <a:extLst xmlns:a="http://schemas.openxmlformats.org/drawingml/2006/main">
               <a:ext uri="{FF2B5EF4-FFF2-40B4-BE49-F238E27FC236}">
-                <a16:creationId xmlns:a16="http://schemas.microsoft.com/office/drawing/2014/main" id="{2F982C4E-BAB5-4FB1-9527-A3ABAAE0C341}"/>
+                <a16:creationId xmlns:a16="http://schemas.microsoft.com/office/drawing/2014/main" id="{5FAAA6F5-26A0-43FB-AAE9-6B7DE4F61A4F}"/>
               </a:ext>
             </a:extLst>
           </p:cNvPr>
@@ -11590,7 +12324,7 @@
           <p:cNvPr id="20" name="">
             <a:extLst xmlns:a="http://schemas.openxmlformats.org/drawingml/2006/main">
               <a:ext uri="{FF2B5EF4-FFF2-40B4-BE49-F238E27FC236}">
-                <a16:creationId xmlns:a16="http://schemas.microsoft.com/office/drawing/2014/main" id="{1E62395F-9199-47D8-8F17-63AF1B0360A2}"/>
+                <a16:creationId xmlns:a16="http://schemas.microsoft.com/office/drawing/2014/main" id="{CD6F9481-8F8C-4E98-B129-60E0FD302CA2}"/>
               </a:ext>
             </a:extLst>
           </p:cNvPr>
@@ -11623,7 +12357,7 @@
           <p:cNvPr id="21" name="">
             <a:extLst xmlns:a="http://schemas.openxmlformats.org/drawingml/2006/main">
               <a:ext uri="{FF2B5EF4-FFF2-40B4-BE49-F238E27FC236}">
-                <a16:creationId xmlns:a16="http://schemas.microsoft.com/office/drawing/2014/main" id="{45716F94-EC6F-4C2F-97C3-A907174DE3E1}"/>
+                <a16:creationId xmlns:a16="http://schemas.microsoft.com/office/drawing/2014/main" id="{9001AF3C-A7F8-4F83-8D95-EED342BBDA74}"/>
               </a:ext>
             </a:extLst>
           </p:cNvPr>
@@ -11780,7 +12514,7 @@
           <p:cNvPr id="22" name="">
             <a:extLst xmlns:a="http://schemas.openxmlformats.org/drawingml/2006/main">
               <a:ext uri="{FF2B5EF4-FFF2-40B4-BE49-F238E27FC236}">
-                <a16:creationId xmlns:a16="http://schemas.microsoft.com/office/drawing/2014/main" id="{55444597-B890-49D3-AEBE-FC295AE1A83E}"/>
+                <a16:creationId xmlns:a16="http://schemas.microsoft.com/office/drawing/2014/main" id="{12615FCD-D5E6-4F79-BBF6-26538E63250B}"/>
               </a:ext>
             </a:extLst>
           </p:cNvPr>
@@ -11937,7 +12671,7 @@
           <p:cNvPr id="23" name="">
             <a:extLst xmlns:a="http://schemas.openxmlformats.org/drawingml/2006/main">
               <a:ext uri="{FF2B5EF4-FFF2-40B4-BE49-F238E27FC236}">
-                <a16:creationId xmlns:a16="http://schemas.microsoft.com/office/drawing/2014/main" id="{B404D969-1A5B-4C6E-BF8C-14270B925437}"/>
+                <a16:creationId xmlns:a16="http://schemas.microsoft.com/office/drawing/2014/main" id="{78E758A1-7FED-4C3D-B619-07BC6FBD0784}"/>
               </a:ext>
             </a:extLst>
           </p:cNvPr>
@@ -12084,7 +12818,7 @@
                 <a:ea typeface="Avenir Next"/>
                 <a:cs typeface="Avenir Next"/>
               </a:rPr>
-              <a:t>Browser Library</a:t>
+              <a:t>Browser Library + Playwright</a:t>
             </a:r>
           </a:p>
           <a:p xmlns:a="http://schemas.openxmlformats.org/drawingml/2006/main">
@@ -12107,7 +12841,7 @@
                 <a:ea typeface="Avenir Next"/>
                 <a:cs typeface="Avenir Next"/>
               </a:rPr>
-              <a:t>+ Playwright</a:t>
+              <a:t>controlan Chromium</a:t>
             </a:r>
           </a:p>
         </p:txBody>
@@ -12117,7 +12851,7 @@
           <p:cNvPr id="24" name="">
             <a:extLst xmlns:a="http://schemas.openxmlformats.org/drawingml/2006/main">
               <a:ext uri="{FF2B5EF4-FFF2-40B4-BE49-F238E27FC236}">
-                <a16:creationId xmlns:a16="http://schemas.microsoft.com/office/drawing/2014/main" id="{FEA9B161-2863-4B3B-98DE-F792CCF1CCE4}"/>
+                <a16:creationId xmlns:a16="http://schemas.microsoft.com/office/drawing/2014/main" id="{5EF78D8F-442E-4B80-884A-F36CDD1D3613}"/>
               </a:ext>
             </a:extLst>
           </p:cNvPr>
@@ -12272,7 +13006,7 @@
     </p:spTree>
     <p:extLst>
       <p:ext uri="{BB962C8B-B14F-4D97-AF65-F5344CB8AC3E}">
-        <p14:creationId xmlns:p14="http://schemas.microsoft.com/office/powerpoint/2010/main" val="287843285"/>
+        <p14:creationId xmlns:p14="http://schemas.microsoft.com/office/powerpoint/2010/main" val="1040367580"/>
       </p:ext>
     </p:extLst>
   </p:cSld>
@@ -12300,10 +13034,10 @@
       </p:grpSpPr>
       <p:sp>
         <p:nvSpPr>
-          <p:cNvPr id="34" name="">
+          <p:cNvPr id="35" name="">
             <a:extLst xmlns:a="http://schemas.openxmlformats.org/drawingml/2006/main">
               <a:ext uri="{FF2B5EF4-FFF2-40B4-BE49-F238E27FC236}">
-                <a16:creationId xmlns:a16="http://schemas.microsoft.com/office/drawing/2014/main" id="{5A87909D-64C2-4D25-8F82-D2A360DDAE47}"/>
+                <a16:creationId xmlns:a16="http://schemas.microsoft.com/office/drawing/2014/main" id="{8E2E7907-42D3-4B56-8625-9A97B1197CBD}"/>
               </a:ext>
             </a:extLst>
           </p:cNvPr>
@@ -12334,7 +13068,7 @@
           <p:cNvPr id="2" name="">
             <a:extLst xmlns:a="http://schemas.openxmlformats.org/drawingml/2006/main">
               <a:ext uri="{FF2B5EF4-FFF2-40B4-BE49-F238E27FC236}">
-                <a16:creationId xmlns:a16="http://schemas.microsoft.com/office/drawing/2014/main" id="{E4027B97-CD73-43DD-B9CC-FA6D286989E4}"/>
+                <a16:creationId xmlns:a16="http://schemas.microsoft.com/office/drawing/2014/main" id="{03BE8C03-2805-437C-B940-AA2E9FE8351A}"/>
               </a:ext>
             </a:extLst>
           </p:cNvPr>
@@ -12491,7 +13225,7 @@
           <p:cNvPr id="3" name="">
             <a:extLst xmlns:a="http://schemas.openxmlformats.org/drawingml/2006/main">
               <a:ext uri="{FF2B5EF4-FFF2-40B4-BE49-F238E27FC236}">
-                <a16:creationId xmlns:a16="http://schemas.microsoft.com/office/drawing/2014/main" id="{FBC7C483-8142-4E4E-94AA-574810E99615}"/>
+                <a16:creationId xmlns:a16="http://schemas.microsoft.com/office/drawing/2014/main" id="{A0499CBC-482F-4258-98CA-11E6339F6FDF}"/>
               </a:ext>
             </a:extLst>
           </p:cNvPr>
@@ -12648,7 +13382,7 @@
           <p:cNvPr id="4" name="">
             <a:extLst xmlns:a="http://schemas.openxmlformats.org/drawingml/2006/main">
               <a:ext uri="{FF2B5EF4-FFF2-40B4-BE49-F238E27FC236}">
-                <a16:creationId xmlns:a16="http://schemas.microsoft.com/office/drawing/2014/main" id="{B6C0C35C-DACC-4FE5-8988-DC91E4E0229E}"/>
+                <a16:creationId xmlns:a16="http://schemas.microsoft.com/office/drawing/2014/main" id="{24A7612D-DD2C-4FC6-9172-967FAB5D9B29}"/>
               </a:ext>
             </a:extLst>
           </p:cNvPr>
@@ -12805,7 +13539,7 @@
           <p:cNvPr id="5" name="">
             <a:extLst xmlns:a="http://schemas.openxmlformats.org/drawingml/2006/main">
               <a:ext uri="{FF2B5EF4-FFF2-40B4-BE49-F238E27FC236}">
-                <a16:creationId xmlns:a16="http://schemas.microsoft.com/office/drawing/2014/main" id="{A2B85224-DFDC-43BF-8D34-34BB47ACD1A5}"/>
+                <a16:creationId xmlns:a16="http://schemas.microsoft.com/office/drawing/2014/main" id="{750F4074-D055-4DA2-9E66-B002E4A0C6F1}"/>
               </a:ext>
             </a:extLst>
           </p:cNvPr>
@@ -12836,7 +13570,7 @@
           <p:cNvPr id="6" name="">
             <a:extLst xmlns:a="http://schemas.openxmlformats.org/drawingml/2006/main">
               <a:ext uri="{FF2B5EF4-FFF2-40B4-BE49-F238E27FC236}">
-                <a16:creationId xmlns:a16="http://schemas.microsoft.com/office/drawing/2014/main" id="{551C1EA2-2AC3-442D-8688-1E70A4F882DE}"/>
+                <a16:creationId xmlns:a16="http://schemas.microsoft.com/office/drawing/2014/main" id="{4F26F557-110E-4179-8505-9329DABAA0DF}"/>
               </a:ext>
             </a:extLst>
           </p:cNvPr>
@@ -12993,7 +13727,7 @@
           <p:cNvPr id="7" name="">
             <a:extLst xmlns:a="http://schemas.openxmlformats.org/drawingml/2006/main">
               <a:ext uri="{FF2B5EF4-FFF2-40B4-BE49-F238E27FC236}">
-                <a16:creationId xmlns:a16="http://schemas.microsoft.com/office/drawing/2014/main" id="{B16B0AB2-E862-47E7-B4C2-B9E8910A0BD3}"/>
+                <a16:creationId xmlns:a16="http://schemas.microsoft.com/office/drawing/2014/main" id="{21E94B63-E20C-45E4-9431-FDA5AF10986B}"/>
               </a:ext>
             </a:extLst>
           </p:cNvPr>
@@ -13150,7 +13884,164 @@
           <p:cNvPr id="8" name="">
             <a:extLst xmlns:a="http://schemas.openxmlformats.org/drawingml/2006/main">
               <a:ext uri="{FF2B5EF4-FFF2-40B4-BE49-F238E27FC236}">
-                <a16:creationId xmlns:a16="http://schemas.microsoft.com/office/drawing/2014/main" id="{99D425FA-D4BA-4F05-B595-4F24BCB1D2A2}"/>
+                <a16:creationId xmlns:a16="http://schemas.microsoft.com/office/drawing/2014/main" id="{83AC038D-2CB8-4EB8-A4B6-000E1BD71D64}"/>
+              </a:ext>
+            </a:extLst>
+          </p:cNvPr>
+          <p:cNvSpPr>
+            <a:spLocks xmlns:a="http://schemas.openxmlformats.org/drawingml/2006/main" noGrp="1"/>
+          </p:cNvSpPr>
+          <p:nvPr/>
+        </p:nvSpPr>
+        <p:spPr>
+          <a:xfrm xmlns:a="http://schemas.openxmlformats.org/drawingml/2006/main">
+            <a:off x="552450" y="1752600"/>
+            <a:ext cx="11049000" cy="590550"/>
+          </a:xfrm>
+          <a:prstGeom xmlns:a="http://schemas.openxmlformats.org/drawingml/2006/main" prst="rect">
+            <a:avLst/>
+          </a:prstGeom>
+          <a:noFill xmlns:a="http://schemas.openxmlformats.org/drawingml/2006/main"/>
+          <a:ln xmlns:a="http://schemas.openxmlformats.org/drawingml/2006/main" w="0">
+            <a:noFill/>
+            <a:prstDash val="solid"/>
+          </a:ln>
+        </p:spPr>
+        <p:txBody>
+          <a:bodyPr xmlns:a="http://schemas.openxmlformats.org/drawingml/2006/main" anchor="ctr"/>
+          <a:lstStyle xmlns:a="http://schemas.openxmlformats.org/drawingml/2006/main">
+            <a:defPPr algn="l">
+              <a:defRPr sz="1725" b="0">
+                <a:solidFill>
+                  <a:srgbClr val="122D32"/>
+                </a:solidFill>
+                <a:latin typeface="Avenir Next"/>
+                <a:ea typeface="Avenir Next"/>
+                <a:cs typeface="Avenir Next"/>
+              </a:defRPr>
+            </a:defPPr>
+            <a:lvl1pPr algn="l">
+              <a:defRPr sz="1725" b="0">
+                <a:solidFill>
+                  <a:srgbClr val="122D32"/>
+                </a:solidFill>
+                <a:latin typeface="Avenir Next"/>
+                <a:ea typeface="Avenir Next"/>
+                <a:cs typeface="Avenir Next"/>
+              </a:defRPr>
+            </a:lvl1pPr>
+            <a:lvl2pPr algn="l">
+              <a:defRPr sz="1725" b="0">
+                <a:solidFill>
+                  <a:srgbClr val="122D32"/>
+                </a:solidFill>
+                <a:latin typeface="Avenir Next"/>
+                <a:ea typeface="Avenir Next"/>
+                <a:cs typeface="Avenir Next"/>
+              </a:defRPr>
+            </a:lvl2pPr>
+            <a:lvl3pPr algn="l">
+              <a:defRPr sz="1725" b="0">
+                <a:solidFill>
+                  <a:srgbClr val="122D32"/>
+                </a:solidFill>
+                <a:latin typeface="Avenir Next"/>
+                <a:ea typeface="Avenir Next"/>
+                <a:cs typeface="Avenir Next"/>
+              </a:defRPr>
+            </a:lvl3pPr>
+            <a:lvl4pPr algn="l">
+              <a:defRPr sz="1725" b="0">
+                <a:solidFill>
+                  <a:srgbClr val="122D32"/>
+                </a:solidFill>
+                <a:latin typeface="Avenir Next"/>
+                <a:ea typeface="Avenir Next"/>
+                <a:cs typeface="Avenir Next"/>
+              </a:defRPr>
+            </a:lvl4pPr>
+            <a:lvl5pPr algn="l">
+              <a:defRPr sz="1725" b="0">
+                <a:solidFill>
+                  <a:srgbClr val="122D32"/>
+                </a:solidFill>
+                <a:latin typeface="Avenir Next"/>
+                <a:ea typeface="Avenir Next"/>
+                <a:cs typeface="Avenir Next"/>
+              </a:defRPr>
+            </a:lvl5pPr>
+            <a:lvl6pPr algn="l">
+              <a:defRPr sz="1725" b="0">
+                <a:solidFill>
+                  <a:srgbClr val="122D32"/>
+                </a:solidFill>
+                <a:latin typeface="Avenir Next"/>
+                <a:ea typeface="Avenir Next"/>
+                <a:cs typeface="Avenir Next"/>
+              </a:defRPr>
+            </a:lvl6pPr>
+            <a:lvl7pPr algn="l">
+              <a:defRPr sz="1725" b="0">
+                <a:solidFill>
+                  <a:srgbClr val="122D32"/>
+                </a:solidFill>
+                <a:latin typeface="Avenir Next"/>
+                <a:ea typeface="Avenir Next"/>
+                <a:cs typeface="Avenir Next"/>
+              </a:defRPr>
+            </a:lvl7pPr>
+            <a:lvl8pPr algn="l">
+              <a:defRPr sz="1725" b="0">
+                <a:solidFill>
+                  <a:srgbClr val="122D32"/>
+                </a:solidFill>
+                <a:latin typeface="Avenir Next"/>
+                <a:ea typeface="Avenir Next"/>
+                <a:cs typeface="Avenir Next"/>
+              </a:defRPr>
+            </a:lvl8pPr>
+            <a:lvl9pPr algn="l">
+              <a:defRPr sz="1725" b="0">
+                <a:solidFill>
+                  <a:srgbClr val="122D32"/>
+                </a:solidFill>
+                <a:latin typeface="Avenir Next"/>
+                <a:ea typeface="Avenir Next"/>
+                <a:cs typeface="Avenir Next"/>
+              </a:defRPr>
+            </a:lvl9pPr>
+          </a:lstStyle>
+          <a:p xmlns:a="http://schemas.openxmlformats.org/drawingml/2006/main">
+            <a:pPr algn="l">
+              <a:defRPr sz="1725" b="0">
+                <a:solidFill>
+                  <a:srgbClr val="122D32"/>
+                </a:solidFill>
+                <a:latin typeface="Avenir Next"/>
+                <a:ea typeface="Avenir Next"/>
+                <a:cs typeface="Avenir Next"/>
+              </a:defRPr>
+            </a:pPr>
+            <a:r>
+              <a:rPr sz="1725" b="0">
+                <a:solidFill>
+                  <a:srgbClr val="122D32"/>
+                </a:solidFill>
+                <a:latin typeface="Avenir Next"/>
+                <a:ea typeface="Avenir Next"/>
+                <a:cs typeface="Avenir Next"/>
+              </a:rPr>
+              <a:t>El caso define qué esperamos; los recursos reúnen clics, campos, esperas y comprobaciones.</a:t>
+            </a:r>
+          </a:p>
+        </p:txBody>
+      </p:sp>
+      <p:sp>
+        <p:nvSpPr>
+          <p:cNvPr id="9" name="">
+            <a:extLst xmlns:a="http://schemas.openxmlformats.org/drawingml/2006/main">
+              <a:ext uri="{FF2B5EF4-FFF2-40B4-BE49-F238E27FC236}">
+                <a16:creationId xmlns:a16="http://schemas.microsoft.com/office/drawing/2014/main" id="{D880DED6-0503-4969-A01A-6BA037940613}"/>
               </a:ext>
             </a:extLst>
           </p:cNvPr>
@@ -13180,10 +14071,10 @@
       </p:sp>
       <p:sp>
         <p:nvSpPr>
-          <p:cNvPr id="9" name="">
+          <p:cNvPr id="10" name="">
             <a:extLst xmlns:a="http://schemas.openxmlformats.org/drawingml/2006/main">
               <a:ext uri="{FF2B5EF4-FFF2-40B4-BE49-F238E27FC236}">
-                <a16:creationId xmlns:a16="http://schemas.microsoft.com/office/drawing/2014/main" id="{F7C86884-4DB3-4B57-9912-FDB09D8E2D31}"/>
+                <a16:creationId xmlns:a16="http://schemas.microsoft.com/office/drawing/2014/main" id="{4F78F561-72EF-44EC-8C89-14CDF6531761}"/>
               </a:ext>
             </a:extLst>
           </p:cNvPr>
@@ -13360,10 +14251,10 @@
       </p:sp>
       <p:sp>
         <p:nvSpPr>
-          <p:cNvPr id="10" name="">
+          <p:cNvPr id="11" name="">
             <a:extLst xmlns:a="http://schemas.openxmlformats.org/drawingml/2006/main">
               <a:ext uri="{FF2B5EF4-FFF2-40B4-BE49-F238E27FC236}">
-                <a16:creationId xmlns:a16="http://schemas.microsoft.com/office/drawing/2014/main" id="{B4D72AAA-9B20-4C1E-BA9C-7BB315780922}"/>
+                <a16:creationId xmlns:a16="http://schemas.microsoft.com/office/drawing/2014/main" id="{FDAF46B6-3411-4337-8541-EB3DEC691F4E}"/>
               </a:ext>
             </a:extLst>
           </p:cNvPr>
@@ -13517,10 +14408,10 @@
       </p:sp>
       <p:sp>
         <p:nvSpPr>
-          <p:cNvPr id="11" name="">
+          <p:cNvPr id="12" name="">
             <a:extLst xmlns:a="http://schemas.openxmlformats.org/drawingml/2006/main">
               <a:ext uri="{FF2B5EF4-FFF2-40B4-BE49-F238E27FC236}">
-                <a16:creationId xmlns:a16="http://schemas.microsoft.com/office/drawing/2014/main" id="{0234379C-0DA7-4F11-9057-9C7F9F6F0730}"/>
+                <a16:creationId xmlns:a16="http://schemas.microsoft.com/office/drawing/2014/main" id="{B12F242E-225E-4760-891D-F576E898F1A6}"/>
               </a:ext>
             </a:extLst>
           </p:cNvPr>
@@ -13550,10 +14441,10 @@
       </p:sp>
       <p:sp>
         <p:nvSpPr>
-          <p:cNvPr id="12" name="">
+          <p:cNvPr id="13" name="">
             <a:extLst xmlns:a="http://schemas.openxmlformats.org/drawingml/2006/main">
               <a:ext uri="{FF2B5EF4-FFF2-40B4-BE49-F238E27FC236}">
-                <a16:creationId xmlns:a16="http://schemas.microsoft.com/office/drawing/2014/main" id="{69C4A74D-7631-4A50-B632-F37074A61A0A}"/>
+                <a16:creationId xmlns:a16="http://schemas.microsoft.com/office/drawing/2014/main" id="{E56C922C-8EF2-441F-A028-784996F13E30}"/>
               </a:ext>
             </a:extLst>
           </p:cNvPr>
@@ -13730,10 +14621,10 @@
       </p:sp>
       <p:sp>
         <p:nvSpPr>
-          <p:cNvPr id="13" name="">
+          <p:cNvPr id="14" name="">
             <a:extLst xmlns:a="http://schemas.openxmlformats.org/drawingml/2006/main">
               <a:ext uri="{FF2B5EF4-FFF2-40B4-BE49-F238E27FC236}">
-                <a16:creationId xmlns:a16="http://schemas.microsoft.com/office/drawing/2014/main" id="{7C04C8B2-9107-4E5D-A756-3F8EABAC53C8}"/>
+                <a16:creationId xmlns:a16="http://schemas.microsoft.com/office/drawing/2014/main" id="{69FF3AFA-96F5-454A-8959-D1D342C43B86}"/>
               </a:ext>
             </a:extLst>
           </p:cNvPr>
@@ -13887,10 +14778,10 @@
       </p:sp>
       <p:sp>
         <p:nvSpPr>
-          <p:cNvPr id="14" name="">
+          <p:cNvPr id="15" name="">
             <a:extLst xmlns:a="http://schemas.openxmlformats.org/drawingml/2006/main">
               <a:ext uri="{FF2B5EF4-FFF2-40B4-BE49-F238E27FC236}">
-                <a16:creationId xmlns:a16="http://schemas.microsoft.com/office/drawing/2014/main" id="{D059DFB3-E205-4FBE-91CD-7A1844358B42}"/>
+                <a16:creationId xmlns:a16="http://schemas.microsoft.com/office/drawing/2014/main" id="{76D23866-F8EE-47AE-A7CE-722A164729AB}"/>
               </a:ext>
             </a:extLst>
           </p:cNvPr>
@@ -13920,10 +14811,10 @@
       </p:sp>
       <p:sp>
         <p:nvSpPr>
-          <p:cNvPr id="15" name="">
+          <p:cNvPr id="16" name="">
             <a:extLst xmlns:a="http://schemas.openxmlformats.org/drawingml/2006/main">
               <a:ext uri="{FF2B5EF4-FFF2-40B4-BE49-F238E27FC236}">
-                <a16:creationId xmlns:a16="http://schemas.microsoft.com/office/drawing/2014/main" id="{0258F0A5-982B-4B83-9DB2-D62982FA3417}"/>
+                <a16:creationId xmlns:a16="http://schemas.microsoft.com/office/drawing/2014/main" id="{04691FB2-41FD-4DB0-8AC5-A9C51C560CE9}"/>
               </a:ext>
             </a:extLst>
           </p:cNvPr>
@@ -14100,10 +14991,10 @@
       </p:sp>
       <p:sp>
         <p:nvSpPr>
-          <p:cNvPr id="16" name="">
+          <p:cNvPr id="17" name="">
             <a:extLst xmlns:a="http://schemas.openxmlformats.org/drawingml/2006/main">
               <a:ext uri="{FF2B5EF4-FFF2-40B4-BE49-F238E27FC236}">
-                <a16:creationId xmlns:a16="http://schemas.microsoft.com/office/drawing/2014/main" id="{838D7EE6-3762-4BD5-A2D7-C96D3B4DFE8C}"/>
+                <a16:creationId xmlns:a16="http://schemas.microsoft.com/office/drawing/2014/main" id="{ED03D2D7-E226-4C1C-BAD6-7E7E64512344}"/>
               </a:ext>
             </a:extLst>
           </p:cNvPr>
@@ -14257,10 +15148,10 @@
       </p:sp>
       <p:sp>
         <p:nvSpPr>
-          <p:cNvPr id="17" name="">
+          <p:cNvPr id="18" name="">
             <a:extLst xmlns:a="http://schemas.openxmlformats.org/drawingml/2006/main">
               <a:ext uri="{FF2B5EF4-FFF2-40B4-BE49-F238E27FC236}">
-                <a16:creationId xmlns:a16="http://schemas.microsoft.com/office/drawing/2014/main" id="{9135B641-6012-42DF-9242-27C591C66FB1}"/>
+                <a16:creationId xmlns:a16="http://schemas.microsoft.com/office/drawing/2014/main" id="{7A9FE8B1-00C8-4201-B66A-921851D3745F}"/>
               </a:ext>
             </a:extLst>
           </p:cNvPr>
@@ -14290,10 +15181,10 @@
       </p:sp>
       <p:sp>
         <p:nvSpPr>
-          <p:cNvPr id="18" name="">
+          <p:cNvPr id="19" name="">
             <a:extLst xmlns:a="http://schemas.openxmlformats.org/drawingml/2006/main">
               <a:ext uri="{FF2B5EF4-FFF2-40B4-BE49-F238E27FC236}">
-                <a16:creationId xmlns:a16="http://schemas.microsoft.com/office/drawing/2014/main" id="{7EE4EA20-EF93-4D89-ACBB-9988D72E7339}"/>
+                <a16:creationId xmlns:a16="http://schemas.microsoft.com/office/drawing/2014/main" id="{5AB4AFD2-1580-41EB-873A-D43E9AC4638C}"/>
               </a:ext>
             </a:extLst>
           </p:cNvPr>
@@ -14470,10 +15361,10 @@
       </p:sp>
       <p:sp>
         <p:nvSpPr>
-          <p:cNvPr id="19" name="">
+          <p:cNvPr id="20" name="">
             <a:extLst xmlns:a="http://schemas.openxmlformats.org/drawingml/2006/main">
               <a:ext uri="{FF2B5EF4-FFF2-40B4-BE49-F238E27FC236}">
-                <a16:creationId xmlns:a16="http://schemas.microsoft.com/office/drawing/2014/main" id="{B64ED10C-81FB-4CF4-8034-8065267A7070}"/>
+                <a16:creationId xmlns:a16="http://schemas.microsoft.com/office/drawing/2014/main" id="{B7D2AAD0-1452-4744-A68C-FA213439FA82}"/>
               </a:ext>
             </a:extLst>
           </p:cNvPr>
@@ -14627,10 +15518,10 @@
       </p:sp>
       <p:sp>
         <p:nvSpPr>
-          <p:cNvPr id="20" name="">
+          <p:cNvPr id="21" name="">
             <a:extLst xmlns:a="http://schemas.openxmlformats.org/drawingml/2006/main">
               <a:ext uri="{FF2B5EF4-FFF2-40B4-BE49-F238E27FC236}">
-                <a16:creationId xmlns:a16="http://schemas.microsoft.com/office/drawing/2014/main" id="{7B801FF2-8E7C-4891-B3B7-2EDA76D8E5BC}"/>
+                <a16:creationId xmlns:a16="http://schemas.microsoft.com/office/drawing/2014/main" id="{D50D4B3F-564B-4B2B-A9CE-F54FB34907AD}"/>
               </a:ext>
             </a:extLst>
           </p:cNvPr>
@@ -14660,10 +15551,10 @@
       </p:sp>
       <p:sp>
         <p:nvSpPr>
-          <p:cNvPr id="21" name="">
+          <p:cNvPr id="22" name="">
             <a:extLst xmlns:a="http://schemas.openxmlformats.org/drawingml/2006/main">
               <a:ext uri="{FF2B5EF4-FFF2-40B4-BE49-F238E27FC236}">
-                <a16:creationId xmlns:a16="http://schemas.microsoft.com/office/drawing/2014/main" id="{9D9649C1-9BD8-4CD7-AA2F-B18294FEA9AD}"/>
+                <a16:creationId xmlns:a16="http://schemas.microsoft.com/office/drawing/2014/main" id="{9F79FD16-FFD0-4BDB-B8B5-05FEABB99234}"/>
               </a:ext>
             </a:extLst>
           </p:cNvPr>
@@ -14817,10 +15708,10 @@
       </p:sp>
       <p:sp>
         <p:nvSpPr>
-          <p:cNvPr id="22" name="">
+          <p:cNvPr id="23" name="">
             <a:extLst xmlns:a="http://schemas.openxmlformats.org/drawingml/2006/main">
               <a:ext uri="{FF2B5EF4-FFF2-40B4-BE49-F238E27FC236}">
-                <a16:creationId xmlns:a16="http://schemas.microsoft.com/office/drawing/2014/main" id="{65098E63-6F51-49DC-AC75-185A0E493449}"/>
+                <a16:creationId xmlns:a16="http://schemas.microsoft.com/office/drawing/2014/main" id="{8E33E5AF-7503-47D0-BE7E-DDACE9E84099}"/>
               </a:ext>
             </a:extLst>
           </p:cNvPr>
@@ -14974,10 +15865,10 @@
       </p:sp>
       <p:sp>
         <p:nvSpPr>
-          <p:cNvPr id="23" name="">
+          <p:cNvPr id="24" name="">
             <a:extLst xmlns:a="http://schemas.openxmlformats.org/drawingml/2006/main">
               <a:ext uri="{FF2B5EF4-FFF2-40B4-BE49-F238E27FC236}">
-                <a16:creationId xmlns:a16="http://schemas.microsoft.com/office/drawing/2014/main" id="{7883AA84-37F7-4886-8DAD-D4C30499DC46}"/>
+                <a16:creationId xmlns:a16="http://schemas.microsoft.com/office/drawing/2014/main" id="{886002BD-3337-4D64-9F3D-59AF234B7F31}"/>
               </a:ext>
             </a:extLst>
           </p:cNvPr>
@@ -15007,10 +15898,10 @@
       </p:sp>
       <p:sp>
         <p:nvSpPr>
-          <p:cNvPr id="24" name="">
+          <p:cNvPr id="25" name="">
             <a:extLst xmlns:a="http://schemas.openxmlformats.org/drawingml/2006/main">
               <a:ext uri="{FF2B5EF4-FFF2-40B4-BE49-F238E27FC236}">
-                <a16:creationId xmlns:a16="http://schemas.microsoft.com/office/drawing/2014/main" id="{99AA7137-9001-476F-897A-3C3D87C2D3D4}"/>
+                <a16:creationId xmlns:a16="http://schemas.microsoft.com/office/drawing/2014/main" id="{749063E3-1B2D-4E7E-8618-5A1AB837287C}"/>
               </a:ext>
             </a:extLst>
           </p:cNvPr>
@@ -15164,10 +16055,10 @@
       </p:sp>
       <p:sp>
         <p:nvSpPr>
-          <p:cNvPr id="25" name="">
+          <p:cNvPr id="26" name="">
             <a:extLst xmlns:a="http://schemas.openxmlformats.org/drawingml/2006/main">
               <a:ext uri="{FF2B5EF4-FFF2-40B4-BE49-F238E27FC236}">
-                <a16:creationId xmlns:a16="http://schemas.microsoft.com/office/drawing/2014/main" id="{8480AD5B-E4DF-452D-A639-1080E71FC2C7}"/>
+                <a16:creationId xmlns:a16="http://schemas.microsoft.com/office/drawing/2014/main" id="{6E2D1F23-8F46-44DD-AA12-917F7A0F7973}"/>
               </a:ext>
             </a:extLst>
           </p:cNvPr>
@@ -15321,10 +16212,10 @@
       </p:sp>
       <p:sp>
         <p:nvSpPr>
-          <p:cNvPr id="26" name="">
+          <p:cNvPr id="27" name="">
             <a:extLst xmlns:a="http://schemas.openxmlformats.org/drawingml/2006/main">
               <a:ext uri="{FF2B5EF4-FFF2-40B4-BE49-F238E27FC236}">
-                <a16:creationId xmlns:a16="http://schemas.microsoft.com/office/drawing/2014/main" id="{3E9ECF40-B23B-438D-9337-69F10EB75CB3}"/>
+                <a16:creationId xmlns:a16="http://schemas.microsoft.com/office/drawing/2014/main" id="{F9D93AC7-B8A2-4B43-8499-EB26B124DBD0}"/>
               </a:ext>
             </a:extLst>
           </p:cNvPr>
@@ -15354,10 +16245,10 @@
       </p:sp>
       <p:sp>
         <p:nvSpPr>
-          <p:cNvPr id="27" name="">
+          <p:cNvPr id="28" name="">
             <a:extLst xmlns:a="http://schemas.openxmlformats.org/drawingml/2006/main">
               <a:ext uri="{FF2B5EF4-FFF2-40B4-BE49-F238E27FC236}">
-                <a16:creationId xmlns:a16="http://schemas.microsoft.com/office/drawing/2014/main" id="{C5CF18E7-73A5-4EF6-9F88-BFE2D1964468}"/>
+                <a16:creationId xmlns:a16="http://schemas.microsoft.com/office/drawing/2014/main" id="{54EE15DF-EF63-4549-B9C1-030FA4550B32}"/>
               </a:ext>
             </a:extLst>
           </p:cNvPr>
@@ -15511,10 +16402,10 @@
       </p:sp>
       <p:sp>
         <p:nvSpPr>
-          <p:cNvPr id="28" name="">
+          <p:cNvPr id="29" name="">
             <a:extLst xmlns:a="http://schemas.openxmlformats.org/drawingml/2006/main">
               <a:ext uri="{FF2B5EF4-FFF2-40B4-BE49-F238E27FC236}">
-                <a16:creationId xmlns:a16="http://schemas.microsoft.com/office/drawing/2014/main" id="{9B24D30B-557B-42D4-92B3-23D83312E38B}"/>
+                <a16:creationId xmlns:a16="http://schemas.microsoft.com/office/drawing/2014/main" id="{ED40DD0F-56F0-4F86-BFE2-09731680D7AE}"/>
               </a:ext>
             </a:extLst>
           </p:cNvPr>
@@ -15668,10 +16559,10 @@
       </p:sp>
       <p:sp>
         <p:nvSpPr>
-          <p:cNvPr id="29" name="">
+          <p:cNvPr id="30" name="">
             <a:extLst xmlns:a="http://schemas.openxmlformats.org/drawingml/2006/main">
               <a:ext uri="{FF2B5EF4-FFF2-40B4-BE49-F238E27FC236}">
-                <a16:creationId xmlns:a16="http://schemas.microsoft.com/office/drawing/2014/main" id="{43F53440-A55F-4CD9-88D2-2BD125B8ECA2}"/>
+                <a16:creationId xmlns:a16="http://schemas.microsoft.com/office/drawing/2014/main" id="{88B8F0C0-92D4-4452-B441-C34B2B6DFD91}"/>
               </a:ext>
             </a:extLst>
           </p:cNvPr>
@@ -15825,10 +16716,10 @@
       </p:sp>
       <p:sp>
         <p:nvSpPr>
-          <p:cNvPr id="30" name="">
+          <p:cNvPr id="31" name="">
             <a:extLst xmlns:a="http://schemas.openxmlformats.org/drawingml/2006/main">
               <a:ext uri="{FF2B5EF4-FFF2-40B4-BE49-F238E27FC236}">
-                <a16:creationId xmlns:a16="http://schemas.microsoft.com/office/drawing/2014/main" id="{BEB60B28-AA48-4E1E-AD30-423A1ED8FE6B}"/>
+                <a16:creationId xmlns:a16="http://schemas.microsoft.com/office/drawing/2014/main" id="{8F2A09A5-ED63-4BBD-A892-4CD6287DE93F}"/>
               </a:ext>
             </a:extLst>
           </p:cNvPr>
@@ -15982,10 +16873,10 @@
       </p:sp>
       <p:sp>
         <p:nvSpPr>
-          <p:cNvPr id="31" name="">
+          <p:cNvPr id="32" name="">
             <a:extLst xmlns:a="http://schemas.openxmlformats.org/drawingml/2006/main">
               <a:ext uri="{FF2B5EF4-FFF2-40B4-BE49-F238E27FC236}">
-                <a16:creationId xmlns:a16="http://schemas.microsoft.com/office/drawing/2014/main" id="{954DFB46-E4E5-4E44-B7F5-01EBDCF573EE}"/>
+                <a16:creationId xmlns:a16="http://schemas.microsoft.com/office/drawing/2014/main" id="{5E140609-6E12-47B1-AF2B-2CA1F19EFA4F}"/>
               </a:ext>
             </a:extLst>
           </p:cNvPr>
@@ -16015,10 +16906,10 @@
       </p:sp>
       <p:sp>
         <p:nvSpPr>
-          <p:cNvPr id="32" name="">
+          <p:cNvPr id="33" name="">
             <a:extLst xmlns:a="http://schemas.openxmlformats.org/drawingml/2006/main">
               <a:ext uri="{FF2B5EF4-FFF2-40B4-BE49-F238E27FC236}">
-                <a16:creationId xmlns:a16="http://schemas.microsoft.com/office/drawing/2014/main" id="{73814AAA-E8B9-4795-B35A-EB43DD921166}"/>
+                <a16:creationId xmlns:a16="http://schemas.microsoft.com/office/drawing/2014/main" id="{0FD66315-C21A-405D-A5B3-6D94829C26A0}"/>
               </a:ext>
             </a:extLst>
           </p:cNvPr>
@@ -16172,10 +17063,10 @@
       </p:sp>
       <p:sp>
         <p:nvSpPr>
-          <p:cNvPr id="33" name="">
+          <p:cNvPr id="34" name="">
             <a:extLst xmlns:a="http://schemas.openxmlformats.org/drawingml/2006/main">
               <a:ext uri="{FF2B5EF4-FFF2-40B4-BE49-F238E27FC236}">
-                <a16:creationId xmlns:a16="http://schemas.microsoft.com/office/drawing/2014/main" id="{5689F893-938C-4C59-8924-AF9B548B9AE4}"/>
+                <a16:creationId xmlns:a16="http://schemas.microsoft.com/office/drawing/2014/main" id="{993C75CC-7FD7-479C-A6CC-10CE019E9A5B}"/>
               </a:ext>
             </a:extLst>
           </p:cNvPr>
@@ -16330,7 +17221,7 @@
     </p:spTree>
     <p:extLst>
       <p:ext uri="{BB962C8B-B14F-4D97-AF65-F5344CB8AC3E}">
-        <p14:creationId xmlns:p14="http://schemas.microsoft.com/office/powerpoint/2010/main" val="1177133100"/>
+        <p14:creationId xmlns:p14="http://schemas.microsoft.com/office/powerpoint/2010/main" val="1859350037"/>
       </p:ext>
     </p:extLst>
   </p:cSld>
@@ -16358,10 +17249,10 @@
       </p:grpSpPr>
       <p:sp>
         <p:nvSpPr>
-          <p:cNvPr id="18" name="">
+          <p:cNvPr id="20" name="">
             <a:extLst xmlns:a="http://schemas.openxmlformats.org/drawingml/2006/main">
               <a:ext uri="{FF2B5EF4-FFF2-40B4-BE49-F238E27FC236}">
-                <a16:creationId xmlns:a16="http://schemas.microsoft.com/office/drawing/2014/main" id="{C2617706-C116-44A0-8C6D-B0FC1F0743F1}"/>
+                <a16:creationId xmlns:a16="http://schemas.microsoft.com/office/drawing/2014/main" id="{80B48DC0-56B5-4944-ACDB-48B8594E10EF}"/>
               </a:ext>
             </a:extLst>
           </p:cNvPr>
@@ -16392,7 +17283,7 @@
           <p:cNvPr id="2" name="">
             <a:extLst xmlns:a="http://schemas.openxmlformats.org/drawingml/2006/main">
               <a:ext uri="{FF2B5EF4-FFF2-40B4-BE49-F238E27FC236}">
-                <a16:creationId xmlns:a16="http://schemas.microsoft.com/office/drawing/2014/main" id="{851D5298-9977-4C17-B046-28847E5ED68A}"/>
+                <a16:creationId xmlns:a16="http://schemas.microsoft.com/office/drawing/2014/main" id="{7975F511-F180-46FB-960C-6E714B8438EC}"/>
               </a:ext>
             </a:extLst>
           </p:cNvPr>
@@ -16549,7 +17440,7 @@
           <p:cNvPr id="3" name="">
             <a:extLst xmlns:a="http://schemas.openxmlformats.org/drawingml/2006/main">
               <a:ext uri="{FF2B5EF4-FFF2-40B4-BE49-F238E27FC236}">
-                <a16:creationId xmlns:a16="http://schemas.microsoft.com/office/drawing/2014/main" id="{11047C05-F338-4179-8D4B-78899A470EF1}"/>
+                <a16:creationId xmlns:a16="http://schemas.microsoft.com/office/drawing/2014/main" id="{D2A8B5DA-C256-4821-967E-6221779E7A96}"/>
               </a:ext>
             </a:extLst>
           </p:cNvPr>
@@ -16706,7 +17597,7 @@
           <p:cNvPr id="4" name="">
             <a:extLst xmlns:a="http://schemas.openxmlformats.org/drawingml/2006/main">
               <a:ext uri="{FF2B5EF4-FFF2-40B4-BE49-F238E27FC236}">
-                <a16:creationId xmlns:a16="http://schemas.microsoft.com/office/drawing/2014/main" id="{59F0B6DC-7D5B-4037-83A9-DCCA8ADEBF6F}"/>
+                <a16:creationId xmlns:a16="http://schemas.microsoft.com/office/drawing/2014/main" id="{F4405FBF-A354-4CC2-8705-D76119873EF0}"/>
               </a:ext>
             </a:extLst>
           </p:cNvPr>
@@ -16863,7 +17754,7 @@
           <p:cNvPr id="5" name="">
             <a:extLst xmlns:a="http://schemas.openxmlformats.org/drawingml/2006/main">
               <a:ext uri="{FF2B5EF4-FFF2-40B4-BE49-F238E27FC236}">
-                <a16:creationId xmlns:a16="http://schemas.microsoft.com/office/drawing/2014/main" id="{B4395EC4-0A71-4623-9CD7-086CCE784406}"/>
+                <a16:creationId xmlns:a16="http://schemas.microsoft.com/office/drawing/2014/main" id="{05A20258-6C2F-49F1-B224-F07C5784E087}"/>
               </a:ext>
             </a:extLst>
           </p:cNvPr>
@@ -16894,7 +17785,7 @@
           <p:cNvPr id="6" name="">
             <a:extLst xmlns:a="http://schemas.openxmlformats.org/drawingml/2006/main">
               <a:ext uri="{FF2B5EF4-FFF2-40B4-BE49-F238E27FC236}">
-                <a16:creationId xmlns:a16="http://schemas.microsoft.com/office/drawing/2014/main" id="{BACDDF43-FF51-4689-99D8-311D7FE0976F}"/>
+                <a16:creationId xmlns:a16="http://schemas.microsoft.com/office/drawing/2014/main" id="{3E36C901-7EA6-4A56-B077-B68CF63B3754}"/>
               </a:ext>
             </a:extLst>
           </p:cNvPr>
@@ -17051,7 +17942,7 @@
           <p:cNvPr id="7" name="">
             <a:extLst xmlns:a="http://schemas.openxmlformats.org/drawingml/2006/main">
               <a:ext uri="{FF2B5EF4-FFF2-40B4-BE49-F238E27FC236}">
-                <a16:creationId xmlns:a16="http://schemas.microsoft.com/office/drawing/2014/main" id="{F0F3E601-1133-4B63-A288-3323B98D115A}"/>
+                <a16:creationId xmlns:a16="http://schemas.microsoft.com/office/drawing/2014/main" id="{CDD54E38-A7C4-4280-8345-FF801C900CB7}"/>
               </a:ext>
             </a:extLst>
           </p:cNvPr>
@@ -17208,7 +18099,7 @@
           <p:cNvPr id="8" name="">
             <a:extLst xmlns:a="http://schemas.openxmlformats.org/drawingml/2006/main">
               <a:ext uri="{FF2B5EF4-FFF2-40B4-BE49-F238E27FC236}">
-                <a16:creationId xmlns:a16="http://schemas.microsoft.com/office/drawing/2014/main" id="{18C42C6C-D247-44E4-8D03-877C8A7CE742}"/>
+                <a16:creationId xmlns:a16="http://schemas.microsoft.com/office/drawing/2014/main" id="{13628012-76D2-4120-ABC8-04C211B7AC43}"/>
               </a:ext>
             </a:extLst>
           </p:cNvPr>
@@ -17241,7 +18132,7 @@
           <p:cNvPr id="9" name="">
             <a:extLst xmlns:a="http://schemas.openxmlformats.org/drawingml/2006/main">
               <a:ext uri="{FF2B5EF4-FFF2-40B4-BE49-F238E27FC236}">
-                <a16:creationId xmlns:a16="http://schemas.microsoft.com/office/drawing/2014/main" id="{02770072-8A54-4C63-9D45-58CDB5A82129}"/>
+                <a16:creationId xmlns:a16="http://schemas.microsoft.com/office/drawing/2014/main" id="{25F09F52-7520-4E76-A25B-F3F5A355BC7D}"/>
               </a:ext>
             </a:extLst>
           </p:cNvPr>
@@ -17274,7 +18165,7 @@
           <p:cNvPr id="10" name="">
             <a:extLst xmlns:a="http://schemas.openxmlformats.org/drawingml/2006/main">
               <a:ext uri="{FF2B5EF4-FFF2-40B4-BE49-F238E27FC236}">
-                <a16:creationId xmlns:a16="http://schemas.microsoft.com/office/drawing/2014/main" id="{44C9CE04-C580-4D18-9182-1E833534E13A}"/>
+                <a16:creationId xmlns:a16="http://schemas.microsoft.com/office/drawing/2014/main" id="{61DF5CE2-3E27-450E-8FDA-A9EB3605F0C3}"/>
               </a:ext>
             </a:extLst>
           </p:cNvPr>
@@ -17431,7 +18322,7 @@
           <p:cNvPr id="11" name="">
             <a:extLst xmlns:a="http://schemas.openxmlformats.org/drawingml/2006/main">
               <a:ext uri="{FF2B5EF4-FFF2-40B4-BE49-F238E27FC236}">
-                <a16:creationId xmlns:a16="http://schemas.microsoft.com/office/drawing/2014/main" id="{6026E4E9-F107-46F7-A839-663D8FC97D03}"/>
+                <a16:creationId xmlns:a16="http://schemas.microsoft.com/office/drawing/2014/main" id="{30292532-8C39-4A8D-B0A8-007C8C269D4E}"/>
               </a:ext>
             </a:extLst>
           </p:cNvPr>
@@ -17657,7 +18548,164 @@
           <p:cNvPr id="12" name="">
             <a:extLst xmlns:a="http://schemas.openxmlformats.org/drawingml/2006/main">
               <a:ext uri="{FF2B5EF4-FFF2-40B4-BE49-F238E27FC236}">
-                <a16:creationId xmlns:a16="http://schemas.microsoft.com/office/drawing/2014/main" id="{752D4472-6B14-419B-AF08-7D750D757EAD}"/>
+                <a16:creationId xmlns:a16="http://schemas.microsoft.com/office/drawing/2014/main" id="{2C4B263D-AC65-4527-B828-6C549EB85819}"/>
+              </a:ext>
+            </a:extLst>
+          </p:cNvPr>
+          <p:cNvSpPr>
+            <a:spLocks xmlns:a="http://schemas.openxmlformats.org/drawingml/2006/main" noGrp="1"/>
+          </p:cNvSpPr>
+          <p:nvPr/>
+        </p:nvSpPr>
+        <p:spPr>
+          <a:xfrm xmlns:a="http://schemas.openxmlformats.org/drawingml/2006/main">
+            <a:off x="790575" y="4572000"/>
+            <a:ext cx="4772025" cy="352425"/>
+          </a:xfrm>
+          <a:prstGeom xmlns:a="http://schemas.openxmlformats.org/drawingml/2006/main" prst="rect">
+            <a:avLst/>
+          </a:prstGeom>
+          <a:noFill xmlns:a="http://schemas.openxmlformats.org/drawingml/2006/main"/>
+          <a:ln xmlns:a="http://schemas.openxmlformats.org/drawingml/2006/main" w="0">
+            <a:noFill/>
+            <a:prstDash val="solid"/>
+          </a:ln>
+        </p:spPr>
+        <p:txBody>
+          <a:bodyPr xmlns:a="http://schemas.openxmlformats.org/drawingml/2006/main" anchor="ctr"/>
+          <a:lstStyle xmlns:a="http://schemas.openxmlformats.org/drawingml/2006/main">
+            <a:defPPr algn="l">
+              <a:defRPr sz="1425" b="1">
+                <a:solidFill>
+                  <a:srgbClr val="F5B96C"/>
+                </a:solidFill>
+                <a:latin typeface="Avenir Next"/>
+                <a:ea typeface="Avenir Next"/>
+                <a:cs typeface="Avenir Next"/>
+              </a:defRPr>
+            </a:defPPr>
+            <a:lvl1pPr algn="l">
+              <a:defRPr sz="1425" b="1">
+                <a:solidFill>
+                  <a:srgbClr val="F5B96C"/>
+                </a:solidFill>
+                <a:latin typeface="Avenir Next"/>
+                <a:ea typeface="Avenir Next"/>
+                <a:cs typeface="Avenir Next"/>
+              </a:defRPr>
+            </a:lvl1pPr>
+            <a:lvl2pPr algn="l">
+              <a:defRPr sz="1425" b="1">
+                <a:solidFill>
+                  <a:srgbClr val="F5B96C"/>
+                </a:solidFill>
+                <a:latin typeface="Avenir Next"/>
+                <a:ea typeface="Avenir Next"/>
+                <a:cs typeface="Avenir Next"/>
+              </a:defRPr>
+            </a:lvl2pPr>
+            <a:lvl3pPr algn="l">
+              <a:defRPr sz="1425" b="1">
+                <a:solidFill>
+                  <a:srgbClr val="F5B96C"/>
+                </a:solidFill>
+                <a:latin typeface="Avenir Next"/>
+                <a:ea typeface="Avenir Next"/>
+                <a:cs typeface="Avenir Next"/>
+              </a:defRPr>
+            </a:lvl3pPr>
+            <a:lvl4pPr algn="l">
+              <a:defRPr sz="1425" b="1">
+                <a:solidFill>
+                  <a:srgbClr val="F5B96C"/>
+                </a:solidFill>
+                <a:latin typeface="Avenir Next"/>
+                <a:ea typeface="Avenir Next"/>
+                <a:cs typeface="Avenir Next"/>
+              </a:defRPr>
+            </a:lvl4pPr>
+            <a:lvl5pPr algn="l">
+              <a:defRPr sz="1425" b="1">
+                <a:solidFill>
+                  <a:srgbClr val="F5B96C"/>
+                </a:solidFill>
+                <a:latin typeface="Avenir Next"/>
+                <a:ea typeface="Avenir Next"/>
+                <a:cs typeface="Avenir Next"/>
+              </a:defRPr>
+            </a:lvl5pPr>
+            <a:lvl6pPr algn="l">
+              <a:defRPr sz="1425" b="1">
+                <a:solidFill>
+                  <a:srgbClr val="F5B96C"/>
+                </a:solidFill>
+                <a:latin typeface="Avenir Next"/>
+                <a:ea typeface="Avenir Next"/>
+                <a:cs typeface="Avenir Next"/>
+              </a:defRPr>
+            </a:lvl6pPr>
+            <a:lvl7pPr algn="l">
+              <a:defRPr sz="1425" b="1">
+                <a:solidFill>
+                  <a:srgbClr val="F5B96C"/>
+                </a:solidFill>
+                <a:latin typeface="Avenir Next"/>
+                <a:ea typeface="Avenir Next"/>
+                <a:cs typeface="Avenir Next"/>
+              </a:defRPr>
+            </a:lvl7pPr>
+            <a:lvl8pPr algn="l">
+              <a:defRPr sz="1425" b="1">
+                <a:solidFill>
+                  <a:srgbClr val="F5B96C"/>
+                </a:solidFill>
+                <a:latin typeface="Avenir Next"/>
+                <a:ea typeface="Avenir Next"/>
+                <a:cs typeface="Avenir Next"/>
+              </a:defRPr>
+            </a:lvl8pPr>
+            <a:lvl9pPr algn="l">
+              <a:defRPr sz="1425" b="1">
+                <a:solidFill>
+                  <a:srgbClr val="F5B96C"/>
+                </a:solidFill>
+                <a:latin typeface="Avenir Next"/>
+                <a:ea typeface="Avenir Next"/>
+                <a:cs typeface="Avenir Next"/>
+              </a:defRPr>
+            </a:lvl9pPr>
+          </a:lstStyle>
+          <a:p xmlns:a="http://schemas.openxmlformats.org/drawingml/2006/main">
+            <a:pPr algn="l">
+              <a:defRPr sz="1425" b="1">
+                <a:solidFill>
+                  <a:srgbClr val="F5B96C"/>
+                </a:solidFill>
+                <a:latin typeface="Avenir Next"/>
+                <a:ea typeface="Avenir Next"/>
+                <a:cs typeface="Avenir Next"/>
+              </a:defRPr>
+            </a:pPr>
+            <a:r>
+              <a:rPr sz="1425" b="1">
+                <a:solidFill>
+                  <a:srgbClr val="F5B96C"/>
+                </a:solidFill>
+                <a:latin typeface="Avenir Next"/>
+                <a:ea typeface="Avenir Next"/>
+                <a:cs typeface="Avenir Next"/>
+              </a:rPr>
+              <a:t>Dos usuarios · varias pantallas</a:t>
+            </a:r>
+          </a:p>
+        </p:txBody>
+      </p:sp>
+      <p:sp>
+        <p:nvSpPr>
+          <p:cNvPr id="13" name="">
+            <a:extLst xmlns:a="http://schemas.openxmlformats.org/drawingml/2006/main">
+              <a:ext uri="{FF2B5EF4-FFF2-40B4-BE49-F238E27FC236}">
+                <a16:creationId xmlns:a16="http://schemas.microsoft.com/office/drawing/2014/main" id="{1B85C575-AF99-46E4-A72E-51BDBB35025C}"/>
               </a:ext>
             </a:extLst>
           </p:cNvPr>
@@ -17687,10 +18735,10 @@
       </p:sp>
       <p:sp>
         <p:nvSpPr>
-          <p:cNvPr id="13" name="">
+          <p:cNvPr id="14" name="">
             <a:extLst xmlns:a="http://schemas.openxmlformats.org/drawingml/2006/main">
               <a:ext uri="{FF2B5EF4-FFF2-40B4-BE49-F238E27FC236}">
-                <a16:creationId xmlns:a16="http://schemas.microsoft.com/office/drawing/2014/main" id="{469A0AC9-E294-4A2D-836C-838DB83FF783}"/>
+                <a16:creationId xmlns:a16="http://schemas.microsoft.com/office/drawing/2014/main" id="{5D52605F-B23A-49CD-B927-E17CBEFF51F9}"/>
               </a:ext>
             </a:extLst>
           </p:cNvPr>
@@ -17720,10 +18768,10 @@
       </p:sp>
       <p:sp>
         <p:nvSpPr>
-          <p:cNvPr id="14" name="">
+          <p:cNvPr id="15" name="">
             <a:extLst xmlns:a="http://schemas.openxmlformats.org/drawingml/2006/main">
               <a:ext uri="{FF2B5EF4-FFF2-40B4-BE49-F238E27FC236}">
-                <a16:creationId xmlns:a16="http://schemas.microsoft.com/office/drawing/2014/main" id="{2A7E689B-4F09-4EDD-8B3F-B36F284479F9}"/>
+                <a16:creationId xmlns:a16="http://schemas.microsoft.com/office/drawing/2014/main" id="{08024D36-3625-424F-8EBD-E3C405075B76}"/>
               </a:ext>
             </a:extLst>
           </p:cNvPr>
@@ -17877,10 +18925,10 @@
       </p:sp>
       <p:sp>
         <p:nvSpPr>
-          <p:cNvPr id="15" name="">
+          <p:cNvPr id="16" name="">
             <a:extLst xmlns:a="http://schemas.openxmlformats.org/drawingml/2006/main">
               <a:ext uri="{FF2B5EF4-FFF2-40B4-BE49-F238E27FC236}">
-                <a16:creationId xmlns:a16="http://schemas.microsoft.com/office/drawing/2014/main" id="{797983DE-03A3-4CF8-899C-871DF41CCD28}"/>
+                <a16:creationId xmlns:a16="http://schemas.microsoft.com/office/drawing/2014/main" id="{604F8A95-DB22-4143-BAF0-FEA6B79C61B2}"/>
               </a:ext>
             </a:extLst>
           </p:cNvPr>
@@ -18108,10 +19156,10 @@
       </p:sp>
       <p:sp>
         <p:nvSpPr>
-          <p:cNvPr id="16" name="">
+          <p:cNvPr id="17" name="">
             <a:extLst xmlns:a="http://schemas.openxmlformats.org/drawingml/2006/main">
               <a:ext uri="{FF2B5EF4-FFF2-40B4-BE49-F238E27FC236}">
-                <a16:creationId xmlns:a16="http://schemas.microsoft.com/office/drawing/2014/main" id="{2FE15401-AC87-43EB-B7C0-DA20CC733A88}"/>
+                <a16:creationId xmlns:a16="http://schemas.microsoft.com/office/drawing/2014/main" id="{07C86D2B-20F0-4059-B5A8-EE09213D60C6}"/>
               </a:ext>
             </a:extLst>
           </p:cNvPr>
@@ -18122,7 +19170,164 @@
         </p:nvSpPr>
         <p:spPr>
           <a:xfrm xmlns:a="http://schemas.openxmlformats.org/drawingml/2006/main">
-            <a:off x="6581775" y="4848225"/>
+            <a:off x="6581775" y="4495800"/>
+            <a:ext cx="4772025" cy="295275"/>
+          </a:xfrm>
+          <a:prstGeom xmlns:a="http://schemas.openxmlformats.org/drawingml/2006/main" prst="rect">
+            <a:avLst/>
+          </a:prstGeom>
+          <a:noFill xmlns:a="http://schemas.openxmlformats.org/drawingml/2006/main"/>
+          <a:ln xmlns:a="http://schemas.openxmlformats.org/drawingml/2006/main" w="0">
+            <a:noFill/>
+            <a:prstDash val="solid"/>
+          </a:ln>
+        </p:spPr>
+        <p:txBody>
+          <a:bodyPr xmlns:a="http://schemas.openxmlformats.org/drawingml/2006/main" anchor="ctr"/>
+          <a:lstStyle xmlns:a="http://schemas.openxmlformats.org/drawingml/2006/main">
+            <a:defPPr algn="l">
+              <a:defRPr sz="1350" b="1">
+                <a:solidFill>
+                  <a:srgbClr val="0A4C4E"/>
+                </a:solidFill>
+                <a:latin typeface="Avenir Next"/>
+                <a:ea typeface="Avenir Next"/>
+                <a:cs typeface="Avenir Next"/>
+              </a:defRPr>
+            </a:defPPr>
+            <a:lvl1pPr algn="l">
+              <a:defRPr sz="1350" b="1">
+                <a:solidFill>
+                  <a:srgbClr val="0A4C4E"/>
+                </a:solidFill>
+                <a:latin typeface="Avenir Next"/>
+                <a:ea typeface="Avenir Next"/>
+                <a:cs typeface="Avenir Next"/>
+              </a:defRPr>
+            </a:lvl1pPr>
+            <a:lvl2pPr algn="l">
+              <a:defRPr sz="1350" b="1">
+                <a:solidFill>
+                  <a:srgbClr val="0A4C4E"/>
+                </a:solidFill>
+                <a:latin typeface="Avenir Next"/>
+                <a:ea typeface="Avenir Next"/>
+                <a:cs typeface="Avenir Next"/>
+              </a:defRPr>
+            </a:lvl2pPr>
+            <a:lvl3pPr algn="l">
+              <a:defRPr sz="1350" b="1">
+                <a:solidFill>
+                  <a:srgbClr val="0A4C4E"/>
+                </a:solidFill>
+                <a:latin typeface="Avenir Next"/>
+                <a:ea typeface="Avenir Next"/>
+                <a:cs typeface="Avenir Next"/>
+              </a:defRPr>
+            </a:lvl3pPr>
+            <a:lvl4pPr algn="l">
+              <a:defRPr sz="1350" b="1">
+                <a:solidFill>
+                  <a:srgbClr val="0A4C4E"/>
+                </a:solidFill>
+                <a:latin typeface="Avenir Next"/>
+                <a:ea typeface="Avenir Next"/>
+                <a:cs typeface="Avenir Next"/>
+              </a:defRPr>
+            </a:lvl4pPr>
+            <a:lvl5pPr algn="l">
+              <a:defRPr sz="1350" b="1">
+                <a:solidFill>
+                  <a:srgbClr val="0A4C4E"/>
+                </a:solidFill>
+                <a:latin typeface="Avenir Next"/>
+                <a:ea typeface="Avenir Next"/>
+                <a:cs typeface="Avenir Next"/>
+              </a:defRPr>
+            </a:lvl5pPr>
+            <a:lvl6pPr algn="l">
+              <a:defRPr sz="1350" b="1">
+                <a:solidFill>
+                  <a:srgbClr val="0A4C4E"/>
+                </a:solidFill>
+                <a:latin typeface="Avenir Next"/>
+                <a:ea typeface="Avenir Next"/>
+                <a:cs typeface="Avenir Next"/>
+              </a:defRPr>
+            </a:lvl6pPr>
+            <a:lvl7pPr algn="l">
+              <a:defRPr sz="1350" b="1">
+                <a:solidFill>
+                  <a:srgbClr val="0A4C4E"/>
+                </a:solidFill>
+                <a:latin typeface="Avenir Next"/>
+                <a:ea typeface="Avenir Next"/>
+                <a:cs typeface="Avenir Next"/>
+              </a:defRPr>
+            </a:lvl7pPr>
+            <a:lvl8pPr algn="l">
+              <a:defRPr sz="1350" b="1">
+                <a:solidFill>
+                  <a:srgbClr val="0A4C4E"/>
+                </a:solidFill>
+                <a:latin typeface="Avenir Next"/>
+                <a:ea typeface="Avenir Next"/>
+                <a:cs typeface="Avenir Next"/>
+              </a:defRPr>
+            </a:lvl8pPr>
+            <a:lvl9pPr algn="l">
+              <a:defRPr sz="1350" b="1">
+                <a:solidFill>
+                  <a:srgbClr val="0A4C4E"/>
+                </a:solidFill>
+                <a:latin typeface="Avenir Next"/>
+                <a:ea typeface="Avenir Next"/>
+                <a:cs typeface="Avenir Next"/>
+              </a:defRPr>
+            </a:lvl9pPr>
+          </a:lstStyle>
+          <a:p xmlns:a="http://schemas.openxmlformats.org/drawingml/2006/main">
+            <a:pPr algn="l">
+              <a:defRPr sz="1350" b="1">
+                <a:solidFill>
+                  <a:srgbClr val="0A4C4E"/>
+                </a:solidFill>
+                <a:latin typeface="Avenir Next"/>
+                <a:ea typeface="Avenir Next"/>
+                <a:cs typeface="Avenir Next"/>
+              </a:defRPr>
+            </a:pPr>
+            <a:r>
+              <a:rPr sz="1350" b="1">
+                <a:solidFill>
+                  <a:srgbClr val="0A4C4E"/>
+                </a:solidFill>
+                <a:latin typeface="Avenir Next"/>
+                <a:ea typeface="Avenir Next"/>
+                <a:cs typeface="Avenir Next"/>
+              </a:rPr>
+              <a:t>Aceptar = clic + confirmación + espera</a:t>
+            </a:r>
+          </a:p>
+        </p:txBody>
+      </p:sp>
+      <p:sp>
+        <p:nvSpPr>
+          <p:cNvPr id="18" name="">
+            <a:extLst xmlns:a="http://schemas.openxmlformats.org/drawingml/2006/main">
+              <a:ext uri="{FF2B5EF4-FFF2-40B4-BE49-F238E27FC236}">
+                <a16:creationId xmlns:a16="http://schemas.microsoft.com/office/drawing/2014/main" id="{146A587F-2A20-4507-BFD8-E996D88BB8AD}"/>
+              </a:ext>
+            </a:extLst>
+          </p:cNvPr>
+          <p:cNvSpPr>
+            <a:spLocks xmlns:a="http://schemas.openxmlformats.org/drawingml/2006/main" noGrp="1"/>
+          </p:cNvSpPr>
+          <p:nvPr/>
+        </p:nvSpPr>
+        <p:spPr>
+          <a:xfrm xmlns:a="http://schemas.openxmlformats.org/drawingml/2006/main">
+            <a:off x="6581775" y="4895850"/>
             <a:ext cx="4772025" cy="247650"/>
           </a:xfrm>
           <a:prstGeom xmlns:a="http://schemas.openxmlformats.org/drawingml/2006/main" prst="rect">
@@ -18265,10 +19470,10 @@
       </p:sp>
       <p:sp>
         <p:nvSpPr>
-          <p:cNvPr id="17" name="">
+          <p:cNvPr id="19" name="">
             <a:extLst xmlns:a="http://schemas.openxmlformats.org/drawingml/2006/main">
               <a:ext uri="{FF2B5EF4-FFF2-40B4-BE49-F238E27FC236}">
-                <a16:creationId xmlns:a16="http://schemas.microsoft.com/office/drawing/2014/main" id="{F4B722AB-6B03-47B4-BFA5-A42819FD5000}"/>
+                <a16:creationId xmlns:a16="http://schemas.microsoft.com/office/drawing/2014/main" id="{3AD02546-3D65-4273-8342-D5504B6703A8}"/>
               </a:ext>
             </a:extLst>
           </p:cNvPr>
@@ -18423,7 +19628,7 @@
     </p:spTree>
     <p:extLst>
       <p:ext uri="{BB962C8B-B14F-4D97-AF65-F5344CB8AC3E}">
-        <p14:creationId xmlns:p14="http://schemas.microsoft.com/office/powerpoint/2010/main" val="384629891"/>
+        <p14:creationId xmlns:p14="http://schemas.microsoft.com/office/powerpoint/2010/main" val="1278158393"/>
       </p:ext>
     </p:extLst>
   </p:cSld>
@@ -18451,10 +19656,10 @@
       </p:grpSpPr>
       <p:sp>
         <p:nvSpPr>
-          <p:cNvPr id="16" name="">
+          <p:cNvPr id="17" name="">
             <a:extLst xmlns:a="http://schemas.openxmlformats.org/drawingml/2006/main">
               <a:ext uri="{FF2B5EF4-FFF2-40B4-BE49-F238E27FC236}">
-                <a16:creationId xmlns:a16="http://schemas.microsoft.com/office/drawing/2014/main" id="{CDFCA038-5561-4017-8813-17EC7DC2B954}"/>
+                <a16:creationId xmlns:a16="http://schemas.microsoft.com/office/drawing/2014/main" id="{3538A39F-B63A-4F38-87A1-2674F863DEA5}"/>
               </a:ext>
             </a:extLst>
           </p:cNvPr>
@@ -18485,7 +19690,7 @@
           <p:cNvPr id="2" name="">
             <a:extLst xmlns:a="http://schemas.openxmlformats.org/drawingml/2006/main">
               <a:ext uri="{FF2B5EF4-FFF2-40B4-BE49-F238E27FC236}">
-                <a16:creationId xmlns:a16="http://schemas.microsoft.com/office/drawing/2014/main" id="{802A275E-F71B-4F92-B8C6-BE9C6C69E492}"/>
+                <a16:creationId xmlns:a16="http://schemas.microsoft.com/office/drawing/2014/main" id="{9A7601A1-C6BF-4B3B-BD52-E36B7204F8A4}"/>
               </a:ext>
             </a:extLst>
           </p:cNvPr>
@@ -18642,7 +19847,7 @@
           <p:cNvPr id="3" name="">
             <a:extLst xmlns:a="http://schemas.openxmlformats.org/drawingml/2006/main">
               <a:ext uri="{FF2B5EF4-FFF2-40B4-BE49-F238E27FC236}">
-                <a16:creationId xmlns:a16="http://schemas.microsoft.com/office/drawing/2014/main" id="{8E313DF9-E0E4-479F-9366-D2574AF903AA}"/>
+                <a16:creationId xmlns:a16="http://schemas.microsoft.com/office/drawing/2014/main" id="{395457B6-0B60-4121-B4F0-59782169D481}"/>
               </a:ext>
             </a:extLst>
           </p:cNvPr>
@@ -18799,7 +20004,7 @@
           <p:cNvPr id="4" name="">
             <a:extLst xmlns:a="http://schemas.openxmlformats.org/drawingml/2006/main">
               <a:ext uri="{FF2B5EF4-FFF2-40B4-BE49-F238E27FC236}">
-                <a16:creationId xmlns:a16="http://schemas.microsoft.com/office/drawing/2014/main" id="{75C1D0A8-EC01-4F2D-A740-D3741C920E65}"/>
+                <a16:creationId xmlns:a16="http://schemas.microsoft.com/office/drawing/2014/main" id="{20C8FA66-EA54-400E-BBBA-F57E1576D701}"/>
               </a:ext>
             </a:extLst>
           </p:cNvPr>
@@ -18956,7 +20161,7 @@
           <p:cNvPr id="5" name="">
             <a:extLst xmlns:a="http://schemas.openxmlformats.org/drawingml/2006/main">
               <a:ext uri="{FF2B5EF4-FFF2-40B4-BE49-F238E27FC236}">
-                <a16:creationId xmlns:a16="http://schemas.microsoft.com/office/drawing/2014/main" id="{5A8D1D6A-146F-4F50-83B9-4D42272FBDAB}"/>
+                <a16:creationId xmlns:a16="http://schemas.microsoft.com/office/drawing/2014/main" id="{A18E1FA2-C8C0-4BEF-8206-D31AC0275A67}"/>
               </a:ext>
             </a:extLst>
           </p:cNvPr>
@@ -18987,7 +20192,7 @@
           <p:cNvPr id="6" name="">
             <a:extLst xmlns:a="http://schemas.openxmlformats.org/drawingml/2006/main">
               <a:ext uri="{FF2B5EF4-FFF2-40B4-BE49-F238E27FC236}">
-                <a16:creationId xmlns:a16="http://schemas.microsoft.com/office/drawing/2014/main" id="{5262FEB4-7C9B-46FD-A178-ABB15A328787}"/>
+                <a16:creationId xmlns:a16="http://schemas.microsoft.com/office/drawing/2014/main" id="{C3E23B53-3B9D-44A3-9FBF-FF5F5159DE9B}"/>
               </a:ext>
             </a:extLst>
           </p:cNvPr>
@@ -19144,7 +20349,7 @@
           <p:cNvPr id="7" name="">
             <a:extLst xmlns:a="http://schemas.openxmlformats.org/drawingml/2006/main">
               <a:ext uri="{FF2B5EF4-FFF2-40B4-BE49-F238E27FC236}">
-                <a16:creationId xmlns:a16="http://schemas.microsoft.com/office/drawing/2014/main" id="{7A7281A6-62E6-4DF8-B076-61E810D3DB76}"/>
+                <a16:creationId xmlns:a16="http://schemas.microsoft.com/office/drawing/2014/main" id="{A40C927E-B36C-42C5-9216-A4C4621027FB}"/>
               </a:ext>
             </a:extLst>
           </p:cNvPr>
@@ -19301,7 +20506,7 @@
           <p:cNvPr id="8" name="">
             <a:extLst xmlns:a="http://schemas.openxmlformats.org/drawingml/2006/main">
               <a:ext uri="{FF2B5EF4-FFF2-40B4-BE49-F238E27FC236}">
-                <a16:creationId xmlns:a16="http://schemas.microsoft.com/office/drawing/2014/main" id="{7002CC67-3D93-4D8F-9B4F-0D0EA5A020B0}"/>
+                <a16:creationId xmlns:a16="http://schemas.microsoft.com/office/drawing/2014/main" id="{9318FF28-FE2C-4CCC-82F8-64A4ECA83353}"/>
               </a:ext>
             </a:extLst>
           </p:cNvPr>
@@ -19334,7 +20539,7 @@
           <p:cNvPr id="9" name="">
             <a:extLst xmlns:a="http://schemas.openxmlformats.org/drawingml/2006/main">
               <a:ext uri="{FF2B5EF4-FFF2-40B4-BE49-F238E27FC236}">
-                <a16:creationId xmlns:a16="http://schemas.microsoft.com/office/drawing/2014/main" id="{3A171BE3-E124-4C1D-A3DE-2CF2AFCA893E}"/>
+                <a16:creationId xmlns:a16="http://schemas.microsoft.com/office/drawing/2014/main" id="{FED8633A-D8FD-4DD5-A0B3-5BE3538FD22E}"/>
               </a:ext>
             </a:extLst>
           </p:cNvPr>
@@ -19491,7 +20696,7 @@
           <p:cNvPr id="10" name="">
             <a:extLst xmlns:a="http://schemas.openxmlformats.org/drawingml/2006/main">
               <a:ext uri="{FF2B5EF4-FFF2-40B4-BE49-F238E27FC236}">
-                <a16:creationId xmlns:a16="http://schemas.microsoft.com/office/drawing/2014/main" id="{BEC365DD-DD6F-4508-9E2D-87DE6DEA88F7}"/>
+                <a16:creationId xmlns:a16="http://schemas.microsoft.com/office/drawing/2014/main" id="{0FABE5A6-B161-4831-9101-0E24CAA0B267}"/>
               </a:ext>
             </a:extLst>
           </p:cNvPr>
@@ -19524,7 +20729,7 @@
           <p:cNvPr id="11" name="">
             <a:extLst xmlns:a="http://schemas.openxmlformats.org/drawingml/2006/main">
               <a:ext uri="{FF2B5EF4-FFF2-40B4-BE49-F238E27FC236}">
-                <a16:creationId xmlns:a16="http://schemas.microsoft.com/office/drawing/2014/main" id="{6C9E14C6-FE8B-4D93-9AD0-5CD1C7964A72}"/>
+                <a16:creationId xmlns:a16="http://schemas.microsoft.com/office/drawing/2014/main" id="{05023BE8-3A23-4CA8-8CD2-D3BB2F2BE114}"/>
               </a:ext>
             </a:extLst>
           </p:cNvPr>
@@ -19534,7 +20739,7 @@
           <p:nvPr/>
         </p:nvPicPr>
         <p:blipFill>
-          <a:blip xmlns:r="http://schemas.openxmlformats.org/officeDocument/2006/relationships" xmlns:a="http://schemas.openxmlformats.org/drawingml/2006/main" r:embed="R9688b299f1984ee2"/>
+          <a:blip xmlns:r="http://schemas.openxmlformats.org/officeDocument/2006/relationships" xmlns:a="http://schemas.openxmlformats.org/drawingml/2006/main" r:embed="R3b0efbf838fc494f"/>
           <a:srcRect xmlns:a="http://schemas.openxmlformats.org/drawingml/2006/main" l="0" t="581" r="0" b="581"/>
           <a:stretch xmlns:a="http://schemas.openxmlformats.org/drawingml/2006/main">
             <a:fillRect l="0" t="0" r="0" b="0"/>
@@ -19557,7 +20762,7 @@
           <p:cNvPr id="12" name="">
             <a:extLst xmlns:a="http://schemas.openxmlformats.org/drawingml/2006/main">
               <a:ext uri="{FF2B5EF4-FFF2-40B4-BE49-F238E27FC236}">
-                <a16:creationId xmlns:a16="http://schemas.microsoft.com/office/drawing/2014/main" id="{E922B619-DC6B-464B-ADEB-B34DF5C4E347}"/>
+                <a16:creationId xmlns:a16="http://schemas.microsoft.com/office/drawing/2014/main" id="{CE4D71BB-312F-4492-A2A4-1E588082470B}"/>
               </a:ext>
             </a:extLst>
           </p:cNvPr>
@@ -19590,7 +20795,7 @@
           <p:cNvPr id="13" name="">
             <a:extLst xmlns:a="http://schemas.openxmlformats.org/drawingml/2006/main">
               <a:ext uri="{FF2B5EF4-FFF2-40B4-BE49-F238E27FC236}">
-                <a16:creationId xmlns:a16="http://schemas.microsoft.com/office/drawing/2014/main" id="{573B3F20-818B-4E17-9106-0DB00BFE5F94}"/>
+                <a16:creationId xmlns:a16="http://schemas.microsoft.com/office/drawing/2014/main" id="{1A161618-3AD7-4E59-BAF2-0D57C2874FF0}"/>
               </a:ext>
             </a:extLst>
           </p:cNvPr>
@@ -19747,7 +20952,7 @@
           <p:cNvPr id="14" name="">
             <a:extLst xmlns:a="http://schemas.openxmlformats.org/drawingml/2006/main">
               <a:ext uri="{FF2B5EF4-FFF2-40B4-BE49-F238E27FC236}">
-                <a16:creationId xmlns:a16="http://schemas.microsoft.com/office/drawing/2014/main" id="{A07F2F8D-7223-4440-95F2-9DBC29A0C9E4}"/>
+                <a16:creationId xmlns:a16="http://schemas.microsoft.com/office/drawing/2014/main" id="{29973E7B-34DA-4795-9BB7-B8D7383322C8}"/>
               </a:ext>
             </a:extLst>
           </p:cNvPr>
@@ -19780,7 +20985,7 @@
           <p:cNvPr id="15" name="">
             <a:extLst xmlns:a="http://schemas.openxmlformats.org/drawingml/2006/main">
               <a:ext uri="{FF2B5EF4-FFF2-40B4-BE49-F238E27FC236}">
-                <a16:creationId xmlns:a16="http://schemas.microsoft.com/office/drawing/2014/main" id="{2C73BB68-5F7D-4435-A355-18F630010358}"/>
+                <a16:creationId xmlns:a16="http://schemas.microsoft.com/office/drawing/2014/main" id="{C0C5237A-0721-4508-ADE1-03489570D810}"/>
               </a:ext>
             </a:extLst>
           </p:cNvPr>
@@ -19790,7 +20995,7 @@
           <p:nvPr/>
         </p:nvPicPr>
         <p:blipFill>
-          <a:blip xmlns:r="http://schemas.openxmlformats.org/officeDocument/2006/relationships" xmlns:a="http://schemas.openxmlformats.org/drawingml/2006/main" r:embed="R3c4532d52b21434e"/>
+          <a:blip xmlns:r="http://schemas.openxmlformats.org/officeDocument/2006/relationships" xmlns:a="http://schemas.openxmlformats.org/drawingml/2006/main" r:embed="Reb3c69486f254b1d"/>
           <a:srcRect xmlns:a="http://schemas.openxmlformats.org/drawingml/2006/main" l="0" t="884" r="0" b="884"/>
           <a:stretch xmlns:a="http://schemas.openxmlformats.org/drawingml/2006/main">
             <a:fillRect l="0" t="0" r="0" b="0"/>
@@ -19808,10 +21013,167 @@
           </a:prstGeom>
         </p:spPr>
       </p:pic>
+      <p:sp>
+        <p:nvSpPr>
+          <p:cNvPr id="16" name="">
+            <a:extLst xmlns:a="http://schemas.openxmlformats.org/drawingml/2006/main">
+              <a:ext uri="{FF2B5EF4-FFF2-40B4-BE49-F238E27FC236}">
+                <a16:creationId xmlns:a16="http://schemas.microsoft.com/office/drawing/2014/main" id="{2765A447-8697-4BA1-AC5F-D5E57EDD55FD}"/>
+              </a:ext>
+            </a:extLst>
+          </p:cNvPr>
+          <p:cNvSpPr>
+            <a:spLocks xmlns:a="http://schemas.openxmlformats.org/drawingml/2006/main" noGrp="1"/>
+          </p:cNvSpPr>
+          <p:nvPr/>
+        </p:nvSpPr>
+        <p:spPr>
+          <a:xfrm xmlns:a="http://schemas.openxmlformats.org/drawingml/2006/main">
+            <a:off x="561975" y="5848350"/>
+            <a:ext cx="11058525" cy="333375"/>
+          </a:xfrm>
+          <a:prstGeom xmlns:a="http://schemas.openxmlformats.org/drawingml/2006/main" prst="rect">
+            <a:avLst/>
+          </a:prstGeom>
+          <a:noFill xmlns:a="http://schemas.openxmlformats.org/drawingml/2006/main"/>
+          <a:ln xmlns:a="http://schemas.openxmlformats.org/drawingml/2006/main" w="0">
+            <a:noFill/>
+            <a:prstDash val="solid"/>
+          </a:ln>
+        </p:spPr>
+        <p:txBody>
+          <a:bodyPr xmlns:a="http://schemas.openxmlformats.org/drawingml/2006/main" anchor="ctr"/>
+          <a:lstStyle xmlns:a="http://schemas.openxmlformats.org/drawingml/2006/main">
+            <a:defPPr algn="l">
+              <a:defRPr sz="1500" b="1">
+                <a:solidFill>
+                  <a:srgbClr val="11766E"/>
+                </a:solidFill>
+                <a:latin typeface="Avenir Next"/>
+                <a:ea typeface="Avenir Next"/>
+                <a:cs typeface="Avenir Next"/>
+              </a:defRPr>
+            </a:defPPr>
+            <a:lvl1pPr algn="l">
+              <a:defRPr sz="1500" b="1">
+                <a:solidFill>
+                  <a:srgbClr val="11766E"/>
+                </a:solidFill>
+                <a:latin typeface="Avenir Next"/>
+                <a:ea typeface="Avenir Next"/>
+                <a:cs typeface="Avenir Next"/>
+              </a:defRPr>
+            </a:lvl1pPr>
+            <a:lvl2pPr algn="l">
+              <a:defRPr sz="1500" b="1">
+                <a:solidFill>
+                  <a:srgbClr val="11766E"/>
+                </a:solidFill>
+                <a:latin typeface="Avenir Next"/>
+                <a:ea typeface="Avenir Next"/>
+                <a:cs typeface="Avenir Next"/>
+              </a:defRPr>
+            </a:lvl2pPr>
+            <a:lvl3pPr algn="l">
+              <a:defRPr sz="1500" b="1">
+                <a:solidFill>
+                  <a:srgbClr val="11766E"/>
+                </a:solidFill>
+                <a:latin typeface="Avenir Next"/>
+                <a:ea typeface="Avenir Next"/>
+                <a:cs typeface="Avenir Next"/>
+              </a:defRPr>
+            </a:lvl3pPr>
+            <a:lvl4pPr algn="l">
+              <a:defRPr sz="1500" b="1">
+                <a:solidFill>
+                  <a:srgbClr val="11766E"/>
+                </a:solidFill>
+                <a:latin typeface="Avenir Next"/>
+                <a:ea typeface="Avenir Next"/>
+                <a:cs typeface="Avenir Next"/>
+              </a:defRPr>
+            </a:lvl4pPr>
+            <a:lvl5pPr algn="l">
+              <a:defRPr sz="1500" b="1">
+                <a:solidFill>
+                  <a:srgbClr val="11766E"/>
+                </a:solidFill>
+                <a:latin typeface="Avenir Next"/>
+                <a:ea typeface="Avenir Next"/>
+                <a:cs typeface="Avenir Next"/>
+              </a:defRPr>
+            </a:lvl5pPr>
+            <a:lvl6pPr algn="l">
+              <a:defRPr sz="1500" b="1">
+                <a:solidFill>
+                  <a:srgbClr val="11766E"/>
+                </a:solidFill>
+                <a:latin typeface="Avenir Next"/>
+                <a:ea typeface="Avenir Next"/>
+                <a:cs typeface="Avenir Next"/>
+              </a:defRPr>
+            </a:lvl6pPr>
+            <a:lvl7pPr algn="l">
+              <a:defRPr sz="1500" b="1">
+                <a:solidFill>
+                  <a:srgbClr val="11766E"/>
+                </a:solidFill>
+                <a:latin typeface="Avenir Next"/>
+                <a:ea typeface="Avenir Next"/>
+                <a:cs typeface="Avenir Next"/>
+              </a:defRPr>
+            </a:lvl7pPr>
+            <a:lvl8pPr algn="l">
+              <a:defRPr sz="1500" b="1">
+                <a:solidFill>
+                  <a:srgbClr val="11766E"/>
+                </a:solidFill>
+                <a:latin typeface="Avenir Next"/>
+                <a:ea typeface="Avenir Next"/>
+                <a:cs typeface="Avenir Next"/>
+              </a:defRPr>
+            </a:lvl8pPr>
+            <a:lvl9pPr algn="l">
+              <a:defRPr sz="1500" b="1">
+                <a:solidFill>
+                  <a:srgbClr val="11766E"/>
+                </a:solidFill>
+                <a:latin typeface="Avenir Next"/>
+                <a:ea typeface="Avenir Next"/>
+                <a:cs typeface="Avenir Next"/>
+              </a:defRPr>
+            </a:lvl9pPr>
+          </a:lstStyle>
+          <a:p xmlns:a="http://schemas.openxmlformats.org/drawingml/2006/main">
+            <a:pPr algn="l">
+              <a:defRPr sz="1500" b="1">
+                <a:solidFill>
+                  <a:srgbClr val="11766E"/>
+                </a:solidFill>
+                <a:latin typeface="Avenir Next"/>
+                <a:ea typeface="Avenir Next"/>
+                <a:cs typeface="Avenir Next"/>
+              </a:defRPr>
+            </a:pPr>
+            <a:r>
+              <a:rPr sz="1500" b="1">
+                <a:solidFill>
+                  <a:srgbClr val="11766E"/>
+                </a:solidFill>
+                <a:latin typeface="Avenir Next"/>
+                <a:ea typeface="Avenir Next"/>
+                <a:cs typeface="Avenir Next"/>
+              </a:rPr>
+              <a:t>Solicitamos S/ 25 y verificamos el alias, el mensaje de envío y el estado Pendiente.</a:t>
+            </a:r>
+          </a:p>
+        </p:txBody>
+      </p:sp>
     </p:spTree>
     <p:extLst>
       <p:ext uri="{BB962C8B-B14F-4D97-AF65-F5344CB8AC3E}">
-        <p14:creationId xmlns:p14="http://schemas.microsoft.com/office/powerpoint/2010/main" val="635569642"/>
+        <p14:creationId xmlns:p14="http://schemas.microsoft.com/office/powerpoint/2010/main" val="518029431"/>
       </p:ext>
     </p:extLst>
   </p:cSld>
@@ -19839,10 +21201,10 @@
       </p:grpSpPr>
       <p:sp>
         <p:nvSpPr>
-          <p:cNvPr id="18" name="">
+          <p:cNvPr id="20" name="">
             <a:extLst xmlns:a="http://schemas.openxmlformats.org/drawingml/2006/main">
               <a:ext uri="{FF2B5EF4-FFF2-40B4-BE49-F238E27FC236}">
-                <a16:creationId xmlns:a16="http://schemas.microsoft.com/office/drawing/2014/main" id="{D3EFDAD8-D604-4ED7-9D1C-16A1D3DC1ACF}"/>
+                <a16:creationId xmlns:a16="http://schemas.microsoft.com/office/drawing/2014/main" id="{8D4BB41D-0917-41BE-A624-8451431FA544}"/>
               </a:ext>
             </a:extLst>
           </p:cNvPr>
@@ -19873,7 +21235,7 @@
           <p:cNvPr id="2" name="">
             <a:extLst xmlns:a="http://schemas.openxmlformats.org/drawingml/2006/main">
               <a:ext uri="{FF2B5EF4-FFF2-40B4-BE49-F238E27FC236}">
-                <a16:creationId xmlns:a16="http://schemas.microsoft.com/office/drawing/2014/main" id="{0AB68627-CBAE-43C9-BC8E-1D1774741229}"/>
+                <a16:creationId xmlns:a16="http://schemas.microsoft.com/office/drawing/2014/main" id="{134B79E1-2C67-4837-8EDD-391566E560B9}"/>
               </a:ext>
             </a:extLst>
           </p:cNvPr>
@@ -20030,7 +21392,7 @@
           <p:cNvPr id="3" name="">
             <a:extLst xmlns:a="http://schemas.openxmlformats.org/drawingml/2006/main">
               <a:ext uri="{FF2B5EF4-FFF2-40B4-BE49-F238E27FC236}">
-                <a16:creationId xmlns:a16="http://schemas.microsoft.com/office/drawing/2014/main" id="{129AC497-C42E-4E7F-9825-AA55FF215C95}"/>
+                <a16:creationId xmlns:a16="http://schemas.microsoft.com/office/drawing/2014/main" id="{62B1B77A-C06A-401B-8886-D47B48FA22AB}"/>
               </a:ext>
             </a:extLst>
           </p:cNvPr>
@@ -20187,7 +21549,7 @@
           <p:cNvPr id="4" name="">
             <a:extLst xmlns:a="http://schemas.openxmlformats.org/drawingml/2006/main">
               <a:ext uri="{FF2B5EF4-FFF2-40B4-BE49-F238E27FC236}">
-                <a16:creationId xmlns:a16="http://schemas.microsoft.com/office/drawing/2014/main" id="{D7408DAF-9B7B-46D4-97A4-7478536FD739}"/>
+                <a16:creationId xmlns:a16="http://schemas.microsoft.com/office/drawing/2014/main" id="{96A6EDB6-1C94-47E4-B338-167438A9F321}"/>
               </a:ext>
             </a:extLst>
           </p:cNvPr>
@@ -20334,7 +21696,7 @@
                 <a:ea typeface="Avenir Next"/>
                 <a:cs typeface="Avenir Next"/>
               </a:rPr>
-              <a:t>El resultado se comprueba en estado, operación y saldos.</a:t>
+              <a:t>Aceptada + código de operación + saldos de ambas cuentas.</a:t>
             </a:r>
           </a:p>
         </p:txBody>
@@ -20344,7 +21706,7 @@
           <p:cNvPr id="5" name="">
             <a:extLst xmlns:a="http://schemas.openxmlformats.org/drawingml/2006/main">
               <a:ext uri="{FF2B5EF4-FFF2-40B4-BE49-F238E27FC236}">
-                <a16:creationId xmlns:a16="http://schemas.microsoft.com/office/drawing/2014/main" id="{213620ED-7B1C-45F4-B88A-AD63CED89240}"/>
+                <a16:creationId xmlns:a16="http://schemas.microsoft.com/office/drawing/2014/main" id="{D2F8EA61-E771-4F35-BC24-DE9F31F48A85}"/>
               </a:ext>
             </a:extLst>
           </p:cNvPr>
@@ -20375,7 +21737,7 @@
           <p:cNvPr id="6" name="">
             <a:extLst xmlns:a="http://schemas.openxmlformats.org/drawingml/2006/main">
               <a:ext uri="{FF2B5EF4-FFF2-40B4-BE49-F238E27FC236}">
-                <a16:creationId xmlns:a16="http://schemas.microsoft.com/office/drawing/2014/main" id="{619730F5-35B1-434B-8E16-DE143AD8BA6A}"/>
+                <a16:creationId xmlns:a16="http://schemas.microsoft.com/office/drawing/2014/main" id="{0FC35D3C-2CBA-45AB-A01E-7C4FFF361302}"/>
               </a:ext>
             </a:extLst>
           </p:cNvPr>
@@ -20532,7 +21894,7 @@
           <p:cNvPr id="7" name="">
             <a:extLst xmlns:a="http://schemas.openxmlformats.org/drawingml/2006/main">
               <a:ext uri="{FF2B5EF4-FFF2-40B4-BE49-F238E27FC236}">
-                <a16:creationId xmlns:a16="http://schemas.microsoft.com/office/drawing/2014/main" id="{65DB1732-D5D4-4E26-8FF8-A02692007574}"/>
+                <a16:creationId xmlns:a16="http://schemas.microsoft.com/office/drawing/2014/main" id="{0DDA7F8D-145A-41E6-A91E-7891F143E1E0}"/>
               </a:ext>
             </a:extLst>
           </p:cNvPr>
@@ -20689,7 +22051,7 @@
           <p:cNvPr id="8" name="">
             <a:extLst xmlns:a="http://schemas.openxmlformats.org/drawingml/2006/main">
               <a:ext uri="{FF2B5EF4-FFF2-40B4-BE49-F238E27FC236}">
-                <a16:creationId xmlns:a16="http://schemas.microsoft.com/office/drawing/2014/main" id="{3353EB6E-4EE9-48BF-AF74-F783F45404BC}"/>
+                <a16:creationId xmlns:a16="http://schemas.microsoft.com/office/drawing/2014/main" id="{2A39DFB2-CB4E-4A83-938F-69A0DACD21BB}"/>
               </a:ext>
             </a:extLst>
           </p:cNvPr>
@@ -20722,7 +22084,7 @@
           <p:cNvPr id="9" name="">
             <a:extLst xmlns:a="http://schemas.openxmlformats.org/drawingml/2006/main">
               <a:ext uri="{FF2B5EF4-FFF2-40B4-BE49-F238E27FC236}">
-                <a16:creationId xmlns:a16="http://schemas.microsoft.com/office/drawing/2014/main" id="{C33617FC-75DA-4EA5-B16E-5D89F77B0ECA}"/>
+                <a16:creationId xmlns:a16="http://schemas.microsoft.com/office/drawing/2014/main" id="{E859B9DE-E3C2-43A5-8536-204F7121EBDC}"/>
               </a:ext>
             </a:extLst>
           </p:cNvPr>
@@ -20732,7 +22094,7 @@
           <p:nvPr/>
         </p:nvPicPr>
         <p:blipFill>
-          <a:blip xmlns:r="http://schemas.openxmlformats.org/officeDocument/2006/relationships" xmlns:a="http://schemas.openxmlformats.org/drawingml/2006/main" r:embed="Rf5ad5267d3714ad6"/>
+          <a:blip xmlns:r="http://schemas.openxmlformats.org/officeDocument/2006/relationships" xmlns:a="http://schemas.openxmlformats.org/drawingml/2006/main" r:embed="Ra7a3365566a0497b"/>
           <a:srcRect xmlns:a="http://schemas.openxmlformats.org/drawingml/2006/main" l="0" t="1104" r="0" b="1104"/>
           <a:stretch xmlns:a="http://schemas.openxmlformats.org/drawingml/2006/main">
             <a:fillRect l="0" t="0" r="0" b="0"/>
@@ -20755,7 +22117,7 @@
           <p:cNvPr id="10" name="">
             <a:extLst xmlns:a="http://schemas.openxmlformats.org/drawingml/2006/main">
               <a:ext uri="{FF2B5EF4-FFF2-40B4-BE49-F238E27FC236}">
-                <a16:creationId xmlns:a16="http://schemas.microsoft.com/office/drawing/2014/main" id="{02A770B0-A726-4714-819C-A1D7D3E80130}"/>
+                <a16:creationId xmlns:a16="http://schemas.microsoft.com/office/drawing/2014/main" id="{7993F498-25C6-4E13-8E14-436F909F09CE}"/>
               </a:ext>
             </a:extLst>
           </p:cNvPr>
@@ -20788,7 +22150,7 @@
           <p:cNvPr id="11" name="">
             <a:extLst xmlns:a="http://schemas.openxmlformats.org/drawingml/2006/main">
               <a:ext uri="{FF2B5EF4-FFF2-40B4-BE49-F238E27FC236}">
-                <a16:creationId xmlns:a16="http://schemas.microsoft.com/office/drawing/2014/main" id="{05E4632C-E8E6-4EE6-8A86-7397406E955B}"/>
+                <a16:creationId xmlns:a16="http://schemas.microsoft.com/office/drawing/2014/main" id="{688E6E8A-12DB-4639-B752-FAE3C136AD16}"/>
               </a:ext>
             </a:extLst>
           </p:cNvPr>
@@ -20798,7 +22160,7 @@
           <p:nvPr/>
         </p:nvPicPr>
         <p:blipFill>
-          <a:blip xmlns:r="http://schemas.openxmlformats.org/officeDocument/2006/relationships" xmlns:a="http://schemas.openxmlformats.org/drawingml/2006/main" r:embed="R736a5946ad254ae2"/>
+          <a:blip xmlns:r="http://schemas.openxmlformats.org/officeDocument/2006/relationships" xmlns:a="http://schemas.openxmlformats.org/drawingml/2006/main" r:embed="Reec53ba8f06445d6"/>
           <a:srcRect xmlns:a="http://schemas.openxmlformats.org/drawingml/2006/main" l="94" t="0" r="94" b="0"/>
           <a:stretch xmlns:a="http://schemas.openxmlformats.org/drawingml/2006/main">
             <a:fillRect l="0" t="0" r="0" b="0"/>
@@ -20821,7 +22183,7 @@
           <p:cNvPr id="12" name="">
             <a:extLst xmlns:a="http://schemas.openxmlformats.org/drawingml/2006/main">
               <a:ext uri="{FF2B5EF4-FFF2-40B4-BE49-F238E27FC236}">
-                <a16:creationId xmlns:a16="http://schemas.microsoft.com/office/drawing/2014/main" id="{01468021-BF74-422D-90FE-D38B068EA2FC}"/>
+                <a16:creationId xmlns:a16="http://schemas.microsoft.com/office/drawing/2014/main" id="{D51AFDF7-A9A4-452A-92C2-BC587ADF955B}"/>
               </a:ext>
             </a:extLst>
           </p:cNvPr>
@@ -20854,7 +22216,7 @@
           <p:cNvPr id="13" name="">
             <a:extLst xmlns:a="http://schemas.openxmlformats.org/drawingml/2006/main">
               <a:ext uri="{FF2B5EF4-FFF2-40B4-BE49-F238E27FC236}">
-                <a16:creationId xmlns:a16="http://schemas.microsoft.com/office/drawing/2014/main" id="{59B392B9-CED8-4581-8A40-6545EC87EF99}"/>
+                <a16:creationId xmlns:a16="http://schemas.microsoft.com/office/drawing/2014/main" id="{669C57A0-374D-43FD-9F60-17240F15662C}"/>
               </a:ext>
             </a:extLst>
           </p:cNvPr>
@@ -20865,8 +22227,8 @@
         </p:nvSpPr>
         <p:spPr>
           <a:xfrm xmlns:a="http://schemas.openxmlformats.org/drawingml/2006/main">
-            <a:off x="8629650" y="3771900"/>
-            <a:ext cx="2800350" cy="581025"/>
+            <a:off x="8629650" y="3724275"/>
+            <a:ext cx="2800350" cy="542925"/>
           </a:xfrm>
           <a:prstGeom xmlns:a="http://schemas.openxmlformats.org/drawingml/2006/main" prst="rect">
             <a:avLst/>
@@ -21011,7 +22373,7 @@
           <p:cNvPr id="14" name="">
             <a:extLst xmlns:a="http://schemas.openxmlformats.org/drawingml/2006/main">
               <a:ext uri="{FF2B5EF4-FFF2-40B4-BE49-F238E27FC236}">
-                <a16:creationId xmlns:a16="http://schemas.microsoft.com/office/drawing/2014/main" id="{A4F8038F-04C7-4BC1-9D04-A7DDD6244DE8}"/>
+                <a16:creationId xmlns:a16="http://schemas.microsoft.com/office/drawing/2014/main" id="{3CCFB888-7C8C-4F5D-873D-3787DDDC323B}"/>
               </a:ext>
             </a:extLst>
           </p:cNvPr>
@@ -21022,8 +22384,8 @@
         </p:nvSpPr>
         <p:spPr>
           <a:xfrm xmlns:a="http://schemas.openxmlformats.org/drawingml/2006/main">
-            <a:off x="8629650" y="4381500"/>
-            <a:ext cx="2800350" cy="381000"/>
+            <a:off x="8629650" y="4276725"/>
+            <a:ext cx="2800350" cy="342900"/>
           </a:xfrm>
           <a:prstGeom xmlns:a="http://schemas.openxmlformats.org/drawingml/2006/main" prst="rect">
             <a:avLst/>
@@ -21038,7 +22400,7 @@
           <a:bodyPr xmlns:a="http://schemas.openxmlformats.org/drawingml/2006/main" anchor="ctr"/>
           <a:lstStyle xmlns:a="http://schemas.openxmlformats.org/drawingml/2006/main">
             <a:defPPr algn="l">
-              <a:defRPr sz="1575" b="0">
+              <a:defRPr sz="1500" b="0">
                 <a:solidFill>
                   <a:srgbClr val="FFFFFF"/>
                 </a:solidFill>
@@ -21048,7 +22410,7 @@
               </a:defRPr>
             </a:defPPr>
             <a:lvl1pPr algn="l">
-              <a:defRPr sz="1575" b="0">
+              <a:defRPr sz="1500" b="0">
                 <a:solidFill>
                   <a:srgbClr val="FFFFFF"/>
                 </a:solidFill>
@@ -21058,7 +22420,7 @@
               </a:defRPr>
             </a:lvl1pPr>
             <a:lvl2pPr algn="l">
-              <a:defRPr sz="1575" b="0">
+              <a:defRPr sz="1500" b="0">
                 <a:solidFill>
                   <a:srgbClr val="FFFFFF"/>
                 </a:solidFill>
@@ -21068,7 +22430,7 @@
               </a:defRPr>
             </a:lvl2pPr>
             <a:lvl3pPr algn="l">
-              <a:defRPr sz="1575" b="0">
+              <a:defRPr sz="1500" b="0">
                 <a:solidFill>
                   <a:srgbClr val="FFFFFF"/>
                 </a:solidFill>
@@ -21078,7 +22440,7 @@
               </a:defRPr>
             </a:lvl3pPr>
             <a:lvl4pPr algn="l">
-              <a:defRPr sz="1575" b="0">
+              <a:defRPr sz="1500" b="0">
                 <a:solidFill>
                   <a:srgbClr val="FFFFFF"/>
                 </a:solidFill>
@@ -21088,7 +22450,7 @@
               </a:defRPr>
             </a:lvl4pPr>
             <a:lvl5pPr algn="l">
-              <a:defRPr sz="1575" b="0">
+              <a:defRPr sz="1500" b="0">
                 <a:solidFill>
                   <a:srgbClr val="FFFFFF"/>
                 </a:solidFill>
@@ -21098,7 +22460,7 @@
               </a:defRPr>
             </a:lvl5pPr>
             <a:lvl6pPr algn="l">
-              <a:defRPr sz="1575" b="0">
+              <a:defRPr sz="1500" b="0">
                 <a:solidFill>
                   <a:srgbClr val="FFFFFF"/>
                 </a:solidFill>
@@ -21108,7 +22470,7 @@
               </a:defRPr>
             </a:lvl6pPr>
             <a:lvl7pPr algn="l">
-              <a:defRPr sz="1575" b="0">
+              <a:defRPr sz="1500" b="0">
                 <a:solidFill>
                   <a:srgbClr val="FFFFFF"/>
                 </a:solidFill>
@@ -21118,7 +22480,7 @@
               </a:defRPr>
             </a:lvl7pPr>
             <a:lvl8pPr algn="l">
-              <a:defRPr sz="1575" b="0">
+              <a:defRPr sz="1500" b="0">
                 <a:solidFill>
                   <a:srgbClr val="FFFFFF"/>
                 </a:solidFill>
@@ -21128,7 +22490,7 @@
               </a:defRPr>
             </a:lvl8pPr>
             <a:lvl9pPr algn="l">
-              <a:defRPr sz="1575" b="0">
+              <a:defRPr sz="1500" b="0">
                 <a:solidFill>
                   <a:srgbClr val="FFFFFF"/>
                 </a:solidFill>
@@ -21140,7 +22502,7 @@
           </a:lstStyle>
           <a:p xmlns:a="http://schemas.openxmlformats.org/drawingml/2006/main">
             <a:pPr algn="l">
-              <a:defRPr sz="1575" b="0">
+              <a:defRPr sz="1500" b="0">
                 <a:solidFill>
                   <a:srgbClr val="FFFFFF"/>
                 </a:solidFill>
@@ -21150,7 +22512,7 @@
               </a:defRPr>
             </a:pPr>
             <a:r>
-              <a:rPr sz="1575" b="0">
+              <a:rPr sz="1500" b="0">
                 <a:solidFill>
                   <a:srgbClr val="FFFFFF"/>
                 </a:solidFill>
@@ -21168,7 +22530,164 @@
           <p:cNvPr id="15" name="">
             <a:extLst xmlns:a="http://schemas.openxmlformats.org/drawingml/2006/main">
               <a:ext uri="{FF2B5EF4-FFF2-40B4-BE49-F238E27FC236}">
-                <a16:creationId xmlns:a16="http://schemas.microsoft.com/office/drawing/2014/main" id="{5F34D7E9-4CC9-4FCB-9DCD-48E8558D8FA3}"/>
+                <a16:creationId xmlns:a16="http://schemas.microsoft.com/office/drawing/2014/main" id="{8653B6B3-D3A0-477F-9667-7A7E1A4FFF78}"/>
+              </a:ext>
+            </a:extLst>
+          </p:cNvPr>
+          <p:cNvSpPr>
+            <a:spLocks xmlns:a="http://schemas.openxmlformats.org/drawingml/2006/main" noGrp="1"/>
+          </p:cNvSpPr>
+          <p:nvPr/>
+        </p:nvSpPr>
+        <p:spPr>
+          <a:xfrm xmlns:a="http://schemas.openxmlformats.org/drawingml/2006/main">
+            <a:off x="8629650" y="4638675"/>
+            <a:ext cx="2800350" cy="247650"/>
+          </a:xfrm>
+          <a:prstGeom xmlns:a="http://schemas.openxmlformats.org/drawingml/2006/main" prst="rect">
+            <a:avLst/>
+          </a:prstGeom>
+          <a:noFill xmlns:a="http://schemas.openxmlformats.org/drawingml/2006/main"/>
+          <a:ln xmlns:a="http://schemas.openxmlformats.org/drawingml/2006/main" w="0">
+            <a:noFill/>
+            <a:prstDash val="solid"/>
+          </a:ln>
+        </p:spPr>
+        <p:txBody>
+          <a:bodyPr xmlns:a="http://schemas.openxmlformats.org/drawingml/2006/main" anchor="ctr"/>
+          <a:lstStyle xmlns:a="http://schemas.openxmlformats.org/drawingml/2006/main">
+            <a:defPPr algn="l">
+              <a:defRPr sz="1275" b="0">
+                <a:solidFill>
+                  <a:srgbClr val="FFFFFF"/>
+                </a:solidFill>
+                <a:latin typeface="Avenir Next"/>
+                <a:ea typeface="Avenir Next"/>
+                <a:cs typeface="Avenir Next"/>
+              </a:defRPr>
+            </a:defPPr>
+            <a:lvl1pPr algn="l">
+              <a:defRPr sz="1275" b="0">
+                <a:solidFill>
+                  <a:srgbClr val="FFFFFF"/>
+                </a:solidFill>
+                <a:latin typeface="Avenir Next"/>
+                <a:ea typeface="Avenir Next"/>
+                <a:cs typeface="Avenir Next"/>
+              </a:defRPr>
+            </a:lvl1pPr>
+            <a:lvl2pPr algn="l">
+              <a:defRPr sz="1275" b="0">
+                <a:solidFill>
+                  <a:srgbClr val="FFFFFF"/>
+                </a:solidFill>
+                <a:latin typeface="Avenir Next"/>
+                <a:ea typeface="Avenir Next"/>
+                <a:cs typeface="Avenir Next"/>
+              </a:defRPr>
+            </a:lvl2pPr>
+            <a:lvl3pPr algn="l">
+              <a:defRPr sz="1275" b="0">
+                <a:solidFill>
+                  <a:srgbClr val="FFFFFF"/>
+                </a:solidFill>
+                <a:latin typeface="Avenir Next"/>
+                <a:ea typeface="Avenir Next"/>
+                <a:cs typeface="Avenir Next"/>
+              </a:defRPr>
+            </a:lvl3pPr>
+            <a:lvl4pPr algn="l">
+              <a:defRPr sz="1275" b="0">
+                <a:solidFill>
+                  <a:srgbClr val="FFFFFF"/>
+                </a:solidFill>
+                <a:latin typeface="Avenir Next"/>
+                <a:ea typeface="Avenir Next"/>
+                <a:cs typeface="Avenir Next"/>
+              </a:defRPr>
+            </a:lvl4pPr>
+            <a:lvl5pPr algn="l">
+              <a:defRPr sz="1275" b="0">
+                <a:solidFill>
+                  <a:srgbClr val="FFFFFF"/>
+                </a:solidFill>
+                <a:latin typeface="Avenir Next"/>
+                <a:ea typeface="Avenir Next"/>
+                <a:cs typeface="Avenir Next"/>
+              </a:defRPr>
+            </a:lvl5pPr>
+            <a:lvl6pPr algn="l">
+              <a:defRPr sz="1275" b="0">
+                <a:solidFill>
+                  <a:srgbClr val="FFFFFF"/>
+                </a:solidFill>
+                <a:latin typeface="Avenir Next"/>
+                <a:ea typeface="Avenir Next"/>
+                <a:cs typeface="Avenir Next"/>
+              </a:defRPr>
+            </a:lvl6pPr>
+            <a:lvl7pPr algn="l">
+              <a:defRPr sz="1275" b="0">
+                <a:solidFill>
+                  <a:srgbClr val="FFFFFF"/>
+                </a:solidFill>
+                <a:latin typeface="Avenir Next"/>
+                <a:ea typeface="Avenir Next"/>
+                <a:cs typeface="Avenir Next"/>
+              </a:defRPr>
+            </a:lvl7pPr>
+            <a:lvl8pPr algn="l">
+              <a:defRPr sz="1275" b="0">
+                <a:solidFill>
+                  <a:srgbClr val="FFFFFF"/>
+                </a:solidFill>
+                <a:latin typeface="Avenir Next"/>
+                <a:ea typeface="Avenir Next"/>
+                <a:cs typeface="Avenir Next"/>
+              </a:defRPr>
+            </a:lvl8pPr>
+            <a:lvl9pPr algn="l">
+              <a:defRPr sz="1275" b="0">
+                <a:solidFill>
+                  <a:srgbClr val="FFFFFF"/>
+                </a:solidFill>
+                <a:latin typeface="Avenir Next"/>
+                <a:ea typeface="Avenir Next"/>
+                <a:cs typeface="Avenir Next"/>
+              </a:defRPr>
+            </a:lvl9pPr>
+          </a:lstStyle>
+          <a:p xmlns:a="http://schemas.openxmlformats.org/drawingml/2006/main">
+            <a:pPr algn="l">
+              <a:defRPr sz="1275" b="0">
+                <a:solidFill>
+                  <a:srgbClr val="FFFFFF"/>
+                </a:solidFill>
+                <a:latin typeface="Avenir Next"/>
+                <a:ea typeface="Avenir Next"/>
+                <a:cs typeface="Avenir Next"/>
+              </a:defRPr>
+            </a:pPr>
+            <a:r>
+              <a:rPr sz="1275" b="0">
+                <a:solidFill>
+                  <a:srgbClr val="FFFFFF"/>
+                </a:solidFill>
+                <a:latin typeface="Avenir Next"/>
+                <a:ea typeface="Avenir Next"/>
+                <a:cs typeface="Avenir Next"/>
+              </a:rPr>
+              <a:t>Comisión: S/ 0.00</a:t>
+            </a:r>
+          </a:p>
+        </p:txBody>
+      </p:sp>
+      <p:sp>
+        <p:nvSpPr>
+          <p:cNvPr id="16" name="">
+            <a:extLst xmlns:a="http://schemas.openxmlformats.org/drawingml/2006/main">
+              <a:ext uri="{FF2B5EF4-FFF2-40B4-BE49-F238E27FC236}">
+                <a16:creationId xmlns:a16="http://schemas.microsoft.com/office/drawing/2014/main" id="{2D4CED12-C8FC-4396-8FEE-D6A4BB2FF4AA}"/>
               </a:ext>
             </a:extLst>
           </p:cNvPr>
@@ -21198,10 +22717,10 @@
       </p:sp>
       <p:sp>
         <p:nvSpPr>
-          <p:cNvPr id="16" name="">
+          <p:cNvPr id="17" name="">
             <a:extLst xmlns:a="http://schemas.openxmlformats.org/drawingml/2006/main">
               <a:ext uri="{FF2B5EF4-FFF2-40B4-BE49-F238E27FC236}">
-                <a16:creationId xmlns:a16="http://schemas.microsoft.com/office/drawing/2014/main" id="{8BF8BFC3-B1F7-4423-9DE5-49EC26988967}"/>
+                <a16:creationId xmlns:a16="http://schemas.microsoft.com/office/drawing/2014/main" id="{4908E462-6CE8-43EE-B8A0-1B4F0BB10C54}"/>
               </a:ext>
             </a:extLst>
           </p:cNvPr>
@@ -21355,10 +22874,10 @@
       </p:sp>
       <p:sp>
         <p:nvSpPr>
-          <p:cNvPr id="17" name="">
+          <p:cNvPr id="18" name="">
             <a:extLst xmlns:a="http://schemas.openxmlformats.org/drawingml/2006/main">
               <a:ext uri="{FF2B5EF4-FFF2-40B4-BE49-F238E27FC236}">
-                <a16:creationId xmlns:a16="http://schemas.microsoft.com/office/drawing/2014/main" id="{E61E83AC-D5CF-4D3A-AC6D-777BF89FE9AA}"/>
+                <a16:creationId xmlns:a16="http://schemas.microsoft.com/office/drawing/2014/main" id="{0D520BA9-85A0-469A-983D-FE1F12265CE9}"/>
               </a:ext>
             </a:extLst>
           </p:cNvPr>
@@ -21510,10 +23029,167 @@
           </a:p>
         </p:txBody>
       </p:sp>
+      <p:sp>
+        <p:nvSpPr>
+          <p:cNvPr id="19" name="">
+            <a:extLst xmlns:a="http://schemas.openxmlformats.org/drawingml/2006/main">
+              <a:ext uri="{FF2B5EF4-FFF2-40B4-BE49-F238E27FC236}">
+                <a16:creationId xmlns:a16="http://schemas.microsoft.com/office/drawing/2014/main" id="{4F506EF7-B5AB-4AD4-994F-61FAA6C1AF5C}"/>
+              </a:ext>
+            </a:extLst>
+          </p:cNvPr>
+          <p:cNvSpPr>
+            <a:spLocks xmlns:a="http://schemas.openxmlformats.org/drawingml/2006/main" noGrp="1"/>
+          </p:cNvSpPr>
+          <p:nvPr/>
+        </p:nvSpPr>
+        <p:spPr>
+          <a:xfrm xmlns:a="http://schemas.openxmlformats.org/drawingml/2006/main">
+            <a:off x="561975" y="5962650"/>
+            <a:ext cx="11058525" cy="257175"/>
+          </a:xfrm>
+          <a:prstGeom xmlns:a="http://schemas.openxmlformats.org/drawingml/2006/main" prst="rect">
+            <a:avLst/>
+          </a:prstGeom>
+          <a:noFill xmlns:a="http://schemas.openxmlformats.org/drawingml/2006/main"/>
+          <a:ln xmlns:a="http://schemas.openxmlformats.org/drawingml/2006/main" w="0">
+            <a:noFill/>
+            <a:prstDash val="solid"/>
+          </a:ln>
+        </p:spPr>
+        <p:txBody>
+          <a:bodyPr xmlns:a="http://schemas.openxmlformats.org/drawingml/2006/main" anchor="ctr"/>
+          <a:lstStyle xmlns:a="http://schemas.openxmlformats.org/drawingml/2006/main">
+            <a:defPPr algn="l">
+              <a:defRPr sz="1275" b="1">
+                <a:solidFill>
+                  <a:srgbClr val="11766E"/>
+                </a:solidFill>
+                <a:latin typeface="Avenir Next"/>
+                <a:ea typeface="Avenir Next"/>
+                <a:cs typeface="Avenir Next"/>
+              </a:defRPr>
+            </a:defPPr>
+            <a:lvl1pPr algn="l">
+              <a:defRPr sz="1275" b="1">
+                <a:solidFill>
+                  <a:srgbClr val="11766E"/>
+                </a:solidFill>
+                <a:latin typeface="Avenir Next"/>
+                <a:ea typeface="Avenir Next"/>
+                <a:cs typeface="Avenir Next"/>
+              </a:defRPr>
+            </a:lvl1pPr>
+            <a:lvl2pPr algn="l">
+              <a:defRPr sz="1275" b="1">
+                <a:solidFill>
+                  <a:srgbClr val="11766E"/>
+                </a:solidFill>
+                <a:latin typeface="Avenir Next"/>
+                <a:ea typeface="Avenir Next"/>
+                <a:cs typeface="Avenir Next"/>
+              </a:defRPr>
+            </a:lvl2pPr>
+            <a:lvl3pPr algn="l">
+              <a:defRPr sz="1275" b="1">
+                <a:solidFill>
+                  <a:srgbClr val="11766E"/>
+                </a:solidFill>
+                <a:latin typeface="Avenir Next"/>
+                <a:ea typeface="Avenir Next"/>
+                <a:cs typeface="Avenir Next"/>
+              </a:defRPr>
+            </a:lvl3pPr>
+            <a:lvl4pPr algn="l">
+              <a:defRPr sz="1275" b="1">
+                <a:solidFill>
+                  <a:srgbClr val="11766E"/>
+                </a:solidFill>
+                <a:latin typeface="Avenir Next"/>
+                <a:ea typeface="Avenir Next"/>
+                <a:cs typeface="Avenir Next"/>
+              </a:defRPr>
+            </a:lvl4pPr>
+            <a:lvl5pPr algn="l">
+              <a:defRPr sz="1275" b="1">
+                <a:solidFill>
+                  <a:srgbClr val="11766E"/>
+                </a:solidFill>
+                <a:latin typeface="Avenir Next"/>
+                <a:ea typeface="Avenir Next"/>
+                <a:cs typeface="Avenir Next"/>
+              </a:defRPr>
+            </a:lvl5pPr>
+            <a:lvl6pPr algn="l">
+              <a:defRPr sz="1275" b="1">
+                <a:solidFill>
+                  <a:srgbClr val="11766E"/>
+                </a:solidFill>
+                <a:latin typeface="Avenir Next"/>
+                <a:ea typeface="Avenir Next"/>
+                <a:cs typeface="Avenir Next"/>
+              </a:defRPr>
+            </a:lvl6pPr>
+            <a:lvl7pPr algn="l">
+              <a:defRPr sz="1275" b="1">
+                <a:solidFill>
+                  <a:srgbClr val="11766E"/>
+                </a:solidFill>
+                <a:latin typeface="Avenir Next"/>
+                <a:ea typeface="Avenir Next"/>
+                <a:cs typeface="Avenir Next"/>
+              </a:defRPr>
+            </a:lvl7pPr>
+            <a:lvl8pPr algn="l">
+              <a:defRPr sz="1275" b="1">
+                <a:solidFill>
+                  <a:srgbClr val="11766E"/>
+                </a:solidFill>
+                <a:latin typeface="Avenir Next"/>
+                <a:ea typeface="Avenir Next"/>
+                <a:cs typeface="Avenir Next"/>
+              </a:defRPr>
+            </a:lvl8pPr>
+            <a:lvl9pPr algn="l">
+              <a:defRPr sz="1275" b="1">
+                <a:solidFill>
+                  <a:srgbClr val="11766E"/>
+                </a:solidFill>
+                <a:latin typeface="Avenir Next"/>
+                <a:ea typeface="Avenir Next"/>
+                <a:cs typeface="Avenir Next"/>
+              </a:defRPr>
+            </a:lvl9pPr>
+          </a:lstStyle>
+          <a:p xmlns:a="http://schemas.openxmlformats.org/drawingml/2006/main">
+            <a:pPr algn="l">
+              <a:defRPr sz="1275" b="1">
+                <a:solidFill>
+                  <a:srgbClr val="11766E"/>
+                </a:solidFill>
+                <a:latin typeface="Avenir Next"/>
+                <a:ea typeface="Avenir Next"/>
+                <a:cs typeface="Avenir Next"/>
+              </a:defRPr>
+            </a:pPr>
+            <a:r>
+              <a:rPr sz="1275" b="1">
+                <a:solidFill>
+                  <a:srgbClr val="11766E"/>
+                </a:solidFill>
+                <a:latin typeface="Avenir Next"/>
+                <a:ea typeface="Avenir Next"/>
+                <a:cs typeface="Avenir Next"/>
+              </a:rPr>
+              <a:t>Bruno ve el código de operación; ambos usuarios ven el estado Aceptada.</a:t>
+            </a:r>
+          </a:p>
+        </p:txBody>
+      </p:sp>
     </p:spTree>
     <p:extLst>
       <p:ext uri="{BB962C8B-B14F-4D97-AF65-F5344CB8AC3E}">
-        <p14:creationId xmlns:p14="http://schemas.microsoft.com/office/powerpoint/2010/main" val="151551091"/>
+        <p14:creationId xmlns:p14="http://schemas.microsoft.com/office/powerpoint/2010/main" val="799281658"/>
       </p:ext>
     </p:extLst>
   </p:cSld>
@@ -21544,7 +23220,7 @@
           <p:cNvPr id="15" name="">
             <a:extLst xmlns:a="http://schemas.openxmlformats.org/drawingml/2006/main">
               <a:ext uri="{FF2B5EF4-FFF2-40B4-BE49-F238E27FC236}">
-                <a16:creationId xmlns:a16="http://schemas.microsoft.com/office/drawing/2014/main" id="{66449AEA-370B-4FB8-9A04-A54D46AD2168}"/>
+                <a16:creationId xmlns:a16="http://schemas.microsoft.com/office/drawing/2014/main" id="{18A4B9FA-8ACD-4A3C-9572-87662750F0AF}"/>
               </a:ext>
             </a:extLst>
           </p:cNvPr>
@@ -21575,7 +23251,7 @@
           <p:cNvPr id="2" name="">
             <a:extLst xmlns:a="http://schemas.openxmlformats.org/drawingml/2006/main">
               <a:ext uri="{FF2B5EF4-FFF2-40B4-BE49-F238E27FC236}">
-                <a16:creationId xmlns:a16="http://schemas.microsoft.com/office/drawing/2014/main" id="{EDB172E7-EAB4-4FE4-A9F4-11FA30A0DD6F}"/>
+                <a16:creationId xmlns:a16="http://schemas.microsoft.com/office/drawing/2014/main" id="{87FBA7B3-61E2-4139-A34E-4777685ABC48}"/>
               </a:ext>
             </a:extLst>
           </p:cNvPr>
@@ -21732,7 +23408,7 @@
           <p:cNvPr id="3" name="">
             <a:extLst xmlns:a="http://schemas.openxmlformats.org/drawingml/2006/main">
               <a:ext uri="{FF2B5EF4-FFF2-40B4-BE49-F238E27FC236}">
-                <a16:creationId xmlns:a16="http://schemas.microsoft.com/office/drawing/2014/main" id="{E5E50FAC-BFF2-4ADD-BB82-6928EBE41020}"/>
+                <a16:creationId xmlns:a16="http://schemas.microsoft.com/office/drawing/2014/main" id="{EF8F3530-F2A5-4942-9F54-8A9ACC8A4850}"/>
               </a:ext>
             </a:extLst>
           </p:cNvPr>
@@ -21889,7 +23565,7 @@
           <p:cNvPr id="4" name="">
             <a:extLst xmlns:a="http://schemas.openxmlformats.org/drawingml/2006/main">
               <a:ext uri="{FF2B5EF4-FFF2-40B4-BE49-F238E27FC236}">
-                <a16:creationId xmlns:a16="http://schemas.microsoft.com/office/drawing/2014/main" id="{CF0CDBB8-F932-4CAC-B69C-64C23284B15A}"/>
+                <a16:creationId xmlns:a16="http://schemas.microsoft.com/office/drawing/2014/main" id="{83A2ABCB-0323-453A-BE7B-58911890072E}"/>
               </a:ext>
             </a:extLst>
           </p:cNvPr>
@@ -22046,7 +23722,7 @@
           <p:cNvPr id="5" name="">
             <a:extLst xmlns:a="http://schemas.openxmlformats.org/drawingml/2006/main">
               <a:ext uri="{FF2B5EF4-FFF2-40B4-BE49-F238E27FC236}">
-                <a16:creationId xmlns:a16="http://schemas.microsoft.com/office/drawing/2014/main" id="{7E23E2C2-B11B-49BE-AE21-D3193FB78F1A}"/>
+                <a16:creationId xmlns:a16="http://schemas.microsoft.com/office/drawing/2014/main" id="{029F232E-4785-4380-857C-77A7CFB39786}"/>
               </a:ext>
             </a:extLst>
           </p:cNvPr>
@@ -22077,7 +23753,7 @@
           <p:cNvPr id="6" name="">
             <a:extLst xmlns:a="http://schemas.openxmlformats.org/drawingml/2006/main">
               <a:ext uri="{FF2B5EF4-FFF2-40B4-BE49-F238E27FC236}">
-                <a16:creationId xmlns:a16="http://schemas.microsoft.com/office/drawing/2014/main" id="{AC302A6E-295C-4BD0-BC88-EBDA29CBEA5F}"/>
+                <a16:creationId xmlns:a16="http://schemas.microsoft.com/office/drawing/2014/main" id="{199C677A-87B8-4177-9F50-672021A3BECA}"/>
               </a:ext>
             </a:extLst>
           </p:cNvPr>
@@ -22234,7 +23910,7 @@
           <p:cNvPr id="7" name="">
             <a:extLst xmlns:a="http://schemas.openxmlformats.org/drawingml/2006/main">
               <a:ext uri="{FF2B5EF4-FFF2-40B4-BE49-F238E27FC236}">
-                <a16:creationId xmlns:a16="http://schemas.microsoft.com/office/drawing/2014/main" id="{082E4491-6B93-41D7-86C7-314FF609D3FB}"/>
+                <a16:creationId xmlns:a16="http://schemas.microsoft.com/office/drawing/2014/main" id="{80AF4463-217B-4713-A88F-E158B3C4FC8B}"/>
               </a:ext>
             </a:extLst>
           </p:cNvPr>
@@ -22391,7 +24067,7 @@
           <p:cNvPr id="8" name="">
             <a:extLst xmlns:a="http://schemas.openxmlformats.org/drawingml/2006/main">
               <a:ext uri="{FF2B5EF4-FFF2-40B4-BE49-F238E27FC236}">
-                <a16:creationId xmlns:a16="http://schemas.microsoft.com/office/drawing/2014/main" id="{B8B6CF64-4183-413F-A911-C6FE6D40EA79}"/>
+                <a16:creationId xmlns:a16="http://schemas.microsoft.com/office/drawing/2014/main" id="{E26D0799-D951-4C67-9C08-540C805F148C}"/>
               </a:ext>
             </a:extLst>
           </p:cNvPr>
@@ -22424,7 +24100,7 @@
           <p:cNvPr id="9" name="">
             <a:extLst xmlns:a="http://schemas.openxmlformats.org/drawingml/2006/main">
               <a:ext uri="{FF2B5EF4-FFF2-40B4-BE49-F238E27FC236}">
-                <a16:creationId xmlns:a16="http://schemas.microsoft.com/office/drawing/2014/main" id="{2FB8F2D0-B29A-4BC3-80B5-14205B0DAA0F}"/>
+                <a16:creationId xmlns:a16="http://schemas.microsoft.com/office/drawing/2014/main" id="{C766F8D4-A073-4A2A-8256-332354120328}"/>
               </a:ext>
             </a:extLst>
           </p:cNvPr>
@@ -22434,7 +24110,7 @@
           <p:nvPr/>
         </p:nvPicPr>
         <p:blipFill>
-          <a:blip xmlns:r="http://schemas.openxmlformats.org/officeDocument/2006/relationships" xmlns:a="http://schemas.openxmlformats.org/drawingml/2006/main" r:embed="R90b9793debc346e8"/>
+          <a:blip xmlns:r="http://schemas.openxmlformats.org/officeDocument/2006/relationships" xmlns:a="http://schemas.openxmlformats.org/drawingml/2006/main" r:embed="R4dabb8f45aa34d4d"/>
           <a:srcRect xmlns:a="http://schemas.openxmlformats.org/drawingml/2006/main" l="0" t="417" r="0" b="417"/>
           <a:stretch xmlns:a="http://schemas.openxmlformats.org/drawingml/2006/main">
             <a:fillRect l="0" t="0" r="0" b="0"/>
@@ -22457,7 +24133,7 @@
           <p:cNvPr id="10" name="">
             <a:extLst xmlns:a="http://schemas.openxmlformats.org/drawingml/2006/main">
               <a:ext uri="{FF2B5EF4-FFF2-40B4-BE49-F238E27FC236}">
-                <a16:creationId xmlns:a16="http://schemas.microsoft.com/office/drawing/2014/main" id="{0E6B7241-1558-4D0F-8AEB-C99CAFAAB5E9}"/>
+                <a16:creationId xmlns:a16="http://schemas.microsoft.com/office/drawing/2014/main" id="{BAF7EA5F-7CEB-41B8-98C6-7F23623835AD}"/>
               </a:ext>
             </a:extLst>
           </p:cNvPr>
@@ -22490,7 +24166,7 @@
           <p:cNvPr id="11" name="">
             <a:extLst xmlns:a="http://schemas.openxmlformats.org/drawingml/2006/main">
               <a:ext uri="{FF2B5EF4-FFF2-40B4-BE49-F238E27FC236}">
-                <a16:creationId xmlns:a16="http://schemas.microsoft.com/office/drawing/2014/main" id="{3EA911F2-6D9C-4300-8AFA-68B6A440B564}"/>
+                <a16:creationId xmlns:a16="http://schemas.microsoft.com/office/drawing/2014/main" id="{1FDCD984-ED74-436C-8EFB-7774951C368A}"/>
               </a:ext>
             </a:extLst>
           </p:cNvPr>
@@ -22647,7 +24323,7 @@
           <p:cNvPr id="12" name="">
             <a:extLst xmlns:a="http://schemas.openxmlformats.org/drawingml/2006/main">
               <a:ext uri="{FF2B5EF4-FFF2-40B4-BE49-F238E27FC236}">
-                <a16:creationId xmlns:a16="http://schemas.microsoft.com/office/drawing/2014/main" id="{EC919BA5-0AA7-45B3-85B3-4D1EBE5BD4EB}"/>
+                <a16:creationId xmlns:a16="http://schemas.microsoft.com/office/drawing/2014/main" id="{644F0D73-1008-43ED-88E0-0394ED4AF416}"/>
               </a:ext>
             </a:extLst>
           </p:cNvPr>
@@ -22804,7 +24480,7 @@
           <p:cNvPr id="13" name="">
             <a:extLst xmlns:a="http://schemas.openxmlformats.org/drawingml/2006/main">
               <a:ext uri="{FF2B5EF4-FFF2-40B4-BE49-F238E27FC236}">
-                <a16:creationId xmlns:a16="http://schemas.microsoft.com/office/drawing/2014/main" id="{084410EE-2E34-4CF6-A9B1-AACD1B3A6789}"/>
+                <a16:creationId xmlns:a16="http://schemas.microsoft.com/office/drawing/2014/main" id="{0EC5E0FE-5D1B-4653-8212-9CDEFA94DD47}"/>
               </a:ext>
             </a:extLst>
           </p:cNvPr>
@@ -22815,8 +24491,8 @@
         </p:nvSpPr>
         <p:spPr>
           <a:xfrm xmlns:a="http://schemas.openxmlformats.org/drawingml/2006/main">
-            <a:off x="8258175" y="3448050"/>
-            <a:ext cx="3086100" cy="1676400"/>
+            <a:off x="8258175" y="3333750"/>
+            <a:ext cx="3086100" cy="1866900"/>
           </a:xfrm>
           <a:prstGeom xmlns:a="http://schemas.openxmlformats.org/drawingml/2006/main" prst="rect">
             <a:avLst/>
@@ -22831,7 +24507,7 @@
           <a:bodyPr xmlns:a="http://schemas.openxmlformats.org/drawingml/2006/main" anchor="ctr"/>
           <a:lstStyle xmlns:a="http://schemas.openxmlformats.org/drawingml/2006/main">
             <a:defPPr algn="l">
-              <a:defRPr sz="1800" b="0">
+              <a:defRPr sz="1575" b="0">
                 <a:solidFill>
                   <a:srgbClr val="FFFFFF"/>
                 </a:solidFill>
@@ -22841,7 +24517,7 @@
               </a:defRPr>
             </a:defPPr>
             <a:lvl1pPr algn="l">
-              <a:defRPr sz="1800" b="0">
+              <a:defRPr sz="1575" b="0">
                 <a:solidFill>
                   <a:srgbClr val="FFFFFF"/>
                 </a:solidFill>
@@ -22851,7 +24527,7 @@
               </a:defRPr>
             </a:lvl1pPr>
             <a:lvl2pPr algn="l">
-              <a:defRPr sz="1800" b="0">
+              <a:defRPr sz="1575" b="0">
                 <a:solidFill>
                   <a:srgbClr val="FFFFFF"/>
                 </a:solidFill>
@@ -22861,7 +24537,7 @@
               </a:defRPr>
             </a:lvl2pPr>
             <a:lvl3pPr algn="l">
-              <a:defRPr sz="1800" b="0">
+              <a:defRPr sz="1575" b="0">
                 <a:solidFill>
                   <a:srgbClr val="FFFFFF"/>
                 </a:solidFill>
@@ -22871,7 +24547,7 @@
               </a:defRPr>
             </a:lvl3pPr>
             <a:lvl4pPr algn="l">
-              <a:defRPr sz="1800" b="0">
+              <a:defRPr sz="1575" b="0">
                 <a:solidFill>
                   <a:srgbClr val="FFFFFF"/>
                 </a:solidFill>
@@ -22881,7 +24557,7 @@
               </a:defRPr>
             </a:lvl4pPr>
             <a:lvl5pPr algn="l">
-              <a:defRPr sz="1800" b="0">
+              <a:defRPr sz="1575" b="0">
                 <a:solidFill>
                   <a:srgbClr val="FFFFFF"/>
                 </a:solidFill>
@@ -22891,7 +24567,7 @@
               </a:defRPr>
             </a:lvl5pPr>
             <a:lvl6pPr algn="l">
-              <a:defRPr sz="1800" b="0">
+              <a:defRPr sz="1575" b="0">
                 <a:solidFill>
                   <a:srgbClr val="FFFFFF"/>
                 </a:solidFill>
@@ -22901,7 +24577,7 @@
               </a:defRPr>
             </a:lvl6pPr>
             <a:lvl7pPr algn="l">
-              <a:defRPr sz="1800" b="0">
+              <a:defRPr sz="1575" b="0">
                 <a:solidFill>
                   <a:srgbClr val="FFFFFF"/>
                 </a:solidFill>
@@ -22911,7 +24587,7 @@
               </a:defRPr>
             </a:lvl7pPr>
             <a:lvl8pPr algn="l">
-              <a:defRPr sz="1800" b="0">
+              <a:defRPr sz="1575" b="0">
                 <a:solidFill>
                   <a:srgbClr val="FFFFFF"/>
                 </a:solidFill>
@@ -22921,7 +24597,7 @@
               </a:defRPr>
             </a:lvl8pPr>
             <a:lvl9pPr algn="l">
-              <a:defRPr sz="1800" b="0">
+              <a:defRPr sz="1575" b="0">
                 <a:solidFill>
                   <a:srgbClr val="FFFFFF"/>
                 </a:solidFill>
@@ -22933,7 +24609,7 @@
           </a:lstStyle>
           <a:p xmlns:a="http://schemas.openxmlformats.org/drawingml/2006/main">
             <a:pPr algn="l">
-              <a:defRPr sz="1800" b="0">
+              <a:defRPr sz="1575" b="0">
                 <a:solidFill>
                   <a:srgbClr val="FFFFFF"/>
                 </a:solidFill>
@@ -22943,7 +24619,7 @@
               </a:defRPr>
             </a:pPr>
             <a:r>
-              <a:rPr sz="1800" b="0">
+              <a:rPr sz="1575" b="0">
                 <a:solidFill>
                   <a:srgbClr val="FFFFFF"/>
                 </a:solidFill>
@@ -22956,7 +24632,7 @@
           </a:p>
           <a:p xmlns:a="http://schemas.openxmlformats.org/drawingml/2006/main">
             <a:pPr algn="l">
-              <a:defRPr sz="1800" b="0">
+              <a:defRPr sz="1575" b="0">
                 <a:solidFill>
                   <a:srgbClr val="FFFFFF"/>
                 </a:solidFill>
@@ -22966,7 +24642,7 @@
               </a:defRPr>
             </a:pPr>
             <a:r>
-              <a:rPr sz="1800" b="0">
+              <a:rPr sz="1575" b="0">
                 <a:solidFill>
                   <a:srgbClr val="FFFFFF"/>
                 </a:solidFill>
@@ -22974,12 +24650,12 @@
                 <a:ea typeface="Avenir Next"/>
                 <a:cs typeface="Avenir Next"/>
               </a:rPr>
-              <a:t>Ejecutar Robot</a:t>
+              <a:t>Ejecutar Robot en Chromium</a:t>
             </a:r>
           </a:p>
           <a:p xmlns:a="http://schemas.openxmlformats.org/drawingml/2006/main">
             <a:pPr algn="l">
-              <a:defRPr sz="1800" b="0">
+              <a:defRPr sz="1575" b="0">
                 <a:solidFill>
                   <a:srgbClr val="FFFFFF"/>
                 </a:solidFill>
@@ -22989,7 +24665,7 @@
               </a:defRPr>
             </a:pPr>
             <a:r>
-              <a:rPr sz="1800" b="0">
+              <a:rPr sz="1575" b="0">
                 <a:solidFill>
                   <a:srgbClr val="FFFFFF"/>
                 </a:solidFill>
@@ -23002,7 +24678,7 @@
           </a:p>
           <a:p xmlns:a="http://schemas.openxmlformats.org/drawingml/2006/main">
             <a:pPr algn="l">
-              <a:defRPr sz="1800" b="0">
+              <a:defRPr sz="1575" b="0">
                 <a:solidFill>
                   <a:srgbClr val="FFFFFF"/>
                 </a:solidFill>
@@ -23012,7 +24688,7 @@
               </a:defRPr>
             </a:pPr>
             <a:r>
-              <a:rPr sz="1800" b="0">
+              <a:rPr sz="1575" b="0">
                 <a:solidFill>
                   <a:srgbClr val="FFFFFF"/>
                 </a:solidFill>
@@ -23020,7 +24696,30 @@
                 <a:ea typeface="Avenir Next"/>
                 <a:cs typeface="Avenir Next"/>
               </a:rPr>
-              <a:t>Expandir log.html</a:t>
+              <a:t>En log.html: estado,</a:t>
+            </a:r>
+          </a:p>
+          <a:p xmlns:a="http://schemas.openxmlformats.org/drawingml/2006/main">
+            <a:pPr algn="l">
+              <a:defRPr sz="1575" b="0">
+                <a:solidFill>
+                  <a:srgbClr val="FFFFFF"/>
+                </a:solidFill>
+                <a:latin typeface="Avenir Next"/>
+                <a:ea typeface="Avenir Next"/>
+                <a:cs typeface="Avenir Next"/>
+              </a:defRPr>
+            </a:pPr>
+            <a:r>
+              <a:rPr sz="1575" b="0">
+                <a:solidFill>
+                  <a:srgbClr val="FFFFFF"/>
+                </a:solidFill>
+                <a:latin typeface="Avenir Next"/>
+                <a:ea typeface="Avenir Next"/>
+                <a:cs typeface="Avenir Next"/>
+              </a:rPr>
+              <a:t>operación y saldos</a:t>
             </a:r>
           </a:p>
         </p:txBody>
@@ -23030,7 +24729,7 @@
           <p:cNvPr id="14" name="">
             <a:extLst xmlns:a="http://schemas.openxmlformats.org/drawingml/2006/main">
               <a:ext uri="{FF2B5EF4-FFF2-40B4-BE49-F238E27FC236}">
-                <a16:creationId xmlns:a16="http://schemas.microsoft.com/office/drawing/2014/main" id="{D6DEDB5E-75F1-486A-BF96-F2308EC96C88}"/>
+                <a16:creationId xmlns:a16="http://schemas.microsoft.com/office/drawing/2014/main" id="{5BBBECF1-771D-42F1-8402-5B47DC57FCE4}"/>
               </a:ext>
             </a:extLst>
           </p:cNvPr>
@@ -23176,7 +24875,7 @@
                 <a:latin typeface="Avenir Next"/>
                 <a:ea typeface="Avenir Next"/>
                 <a:cs typeface="Avenir Next"/>
-                <a:hlinkClick xmlns:r="http://schemas.openxmlformats.org/officeDocument/2006/relationships" r:id="R7cd36be46e304e3d"/>
+                <a:hlinkClick xmlns:r="http://schemas.openxmlformats.org/officeDocument/2006/relationships" r:id="R58e3f9a717694f5d"/>
               </a:rPr>
               <a:t>Abrir README de ejecución</a:t>
             </a:r>
@@ -23186,7 +24885,7 @@
     </p:spTree>
     <p:extLst>
       <p:ext uri="{BB962C8B-B14F-4D97-AF65-F5344CB8AC3E}">
-        <p14:creationId xmlns:p14="http://schemas.microsoft.com/office/powerpoint/2010/main" val="1629542298"/>
+        <p14:creationId xmlns:p14="http://schemas.microsoft.com/office/powerpoint/2010/main" val="603186725"/>
       </p:ext>
     </p:extLst>
   </p:cSld>
@@ -23214,10 +24913,10 @@
       </p:grpSpPr>
       <p:sp>
         <p:nvSpPr>
-          <p:cNvPr id="19" name="">
+          <p:cNvPr id="20" name="">
             <a:extLst xmlns:a="http://schemas.openxmlformats.org/drawingml/2006/main">
               <a:ext uri="{FF2B5EF4-FFF2-40B4-BE49-F238E27FC236}">
-                <a16:creationId xmlns:a16="http://schemas.microsoft.com/office/drawing/2014/main" id="{8120710B-7029-4994-83F2-FF59B2B3D96E}"/>
+                <a16:creationId xmlns:a16="http://schemas.microsoft.com/office/drawing/2014/main" id="{4F3CD418-7139-4541-BE1C-0F61E2918959}"/>
               </a:ext>
             </a:extLst>
           </p:cNvPr>
@@ -23248,7 +24947,7 @@
           <p:cNvPr id="2" name="">
             <a:extLst xmlns:a="http://schemas.openxmlformats.org/drawingml/2006/main">
               <a:ext uri="{FF2B5EF4-FFF2-40B4-BE49-F238E27FC236}">
-                <a16:creationId xmlns:a16="http://schemas.microsoft.com/office/drawing/2014/main" id="{923888A0-F100-434D-A618-CF885558781C}"/>
+                <a16:creationId xmlns:a16="http://schemas.microsoft.com/office/drawing/2014/main" id="{ABCFD53D-A8A2-4315-AF45-4CCBBF900CD7}"/>
               </a:ext>
             </a:extLst>
           </p:cNvPr>
@@ -23405,7 +25104,7 @@
           <p:cNvPr id="3" name="">
             <a:extLst xmlns:a="http://schemas.openxmlformats.org/drawingml/2006/main">
               <a:ext uri="{FF2B5EF4-FFF2-40B4-BE49-F238E27FC236}">
-                <a16:creationId xmlns:a16="http://schemas.microsoft.com/office/drawing/2014/main" id="{F7F1D703-C935-4E2E-BF73-E02406692919}"/>
+                <a16:creationId xmlns:a16="http://schemas.microsoft.com/office/drawing/2014/main" id="{98783BEE-9C62-42E1-812E-AA1B9A6BE09D}"/>
               </a:ext>
             </a:extLst>
           </p:cNvPr>
@@ -23562,7 +25261,7 @@
           <p:cNvPr id="4" name="">
             <a:extLst xmlns:a="http://schemas.openxmlformats.org/drawingml/2006/main">
               <a:ext uri="{FF2B5EF4-FFF2-40B4-BE49-F238E27FC236}">
-                <a16:creationId xmlns:a16="http://schemas.microsoft.com/office/drawing/2014/main" id="{7D1B584F-29DA-4A92-96DE-D7E31085C151}"/>
+                <a16:creationId xmlns:a16="http://schemas.microsoft.com/office/drawing/2014/main" id="{3F56EE03-9842-4128-83B0-D862DECAFCAC}"/>
               </a:ext>
             </a:extLst>
           </p:cNvPr>
@@ -23709,7 +25408,7 @@
                 <a:ea typeface="Avenir Next"/>
                 <a:cs typeface="Avenir Next"/>
               </a:rPr>
-              <a:t>Codex contrasta la ejecución de Robot con los criterios de aceptación.</a:t>
+              <a:t>Entradas: output.xml, caso .robot y criterios de aceptación de Qolqe.</a:t>
             </a:r>
           </a:p>
         </p:txBody>
@@ -23719,7 +25418,7 @@
           <p:cNvPr id="5" name="">
             <a:extLst xmlns:a="http://schemas.openxmlformats.org/drawingml/2006/main">
               <a:ext uri="{FF2B5EF4-FFF2-40B4-BE49-F238E27FC236}">
-                <a16:creationId xmlns:a16="http://schemas.microsoft.com/office/drawing/2014/main" id="{FA2DC893-697F-4AE6-B542-881954C7FA77}"/>
+                <a16:creationId xmlns:a16="http://schemas.microsoft.com/office/drawing/2014/main" id="{58256567-0923-4D73-A82B-BAC0CFDBBDFC}"/>
               </a:ext>
             </a:extLst>
           </p:cNvPr>
@@ -23750,7 +25449,7 @@
           <p:cNvPr id="6" name="">
             <a:extLst xmlns:a="http://schemas.openxmlformats.org/drawingml/2006/main">
               <a:ext uri="{FF2B5EF4-FFF2-40B4-BE49-F238E27FC236}">
-                <a16:creationId xmlns:a16="http://schemas.microsoft.com/office/drawing/2014/main" id="{675A4E74-024C-40CD-A1CA-828A36234EDF}"/>
+                <a16:creationId xmlns:a16="http://schemas.microsoft.com/office/drawing/2014/main" id="{0183D3D0-5464-4856-A4E6-74DFC4DFD926}"/>
               </a:ext>
             </a:extLst>
           </p:cNvPr>
@@ -23907,7 +25606,7 @@
           <p:cNvPr id="7" name="">
             <a:extLst xmlns:a="http://schemas.openxmlformats.org/drawingml/2006/main">
               <a:ext uri="{FF2B5EF4-FFF2-40B4-BE49-F238E27FC236}">
-                <a16:creationId xmlns:a16="http://schemas.microsoft.com/office/drawing/2014/main" id="{F905A7D7-23BC-433B-8394-BD5D130BEC01}"/>
+                <a16:creationId xmlns:a16="http://schemas.microsoft.com/office/drawing/2014/main" id="{CFE5D599-BE1E-4641-B2C4-38BFE56C455B}"/>
               </a:ext>
             </a:extLst>
           </p:cNvPr>
@@ -24064,7 +25763,7 @@
           <p:cNvPr id="8" name="">
             <a:extLst xmlns:a="http://schemas.openxmlformats.org/drawingml/2006/main">
               <a:ext uri="{FF2B5EF4-FFF2-40B4-BE49-F238E27FC236}">
-                <a16:creationId xmlns:a16="http://schemas.microsoft.com/office/drawing/2014/main" id="{F383F324-1AAE-4745-857D-B45A3478EBC3}"/>
+                <a16:creationId xmlns:a16="http://schemas.microsoft.com/office/drawing/2014/main" id="{E1E26631-1470-4992-8174-597E705461CB}"/>
               </a:ext>
             </a:extLst>
           </p:cNvPr>
@@ -24097,7 +25796,7 @@
           <p:cNvPr id="9" name="">
             <a:extLst xmlns:a="http://schemas.openxmlformats.org/drawingml/2006/main">
               <a:ext uri="{FF2B5EF4-FFF2-40B4-BE49-F238E27FC236}">
-                <a16:creationId xmlns:a16="http://schemas.microsoft.com/office/drawing/2014/main" id="{E8BD1A57-9257-4FED-B8C7-5937EB8364FA}"/>
+                <a16:creationId xmlns:a16="http://schemas.microsoft.com/office/drawing/2014/main" id="{4FEF2830-C1CD-411B-98E6-9C2BE4DA34C2}"/>
               </a:ext>
             </a:extLst>
           </p:cNvPr>
@@ -24130,7 +25829,7 @@
           <p:cNvPr id="10" name="">
             <a:extLst xmlns:a="http://schemas.openxmlformats.org/drawingml/2006/main">
               <a:ext uri="{FF2B5EF4-FFF2-40B4-BE49-F238E27FC236}">
-                <a16:creationId xmlns:a16="http://schemas.microsoft.com/office/drawing/2014/main" id="{6D61C56E-090A-46E4-97C0-C2300F2177BD}"/>
+                <a16:creationId xmlns:a16="http://schemas.microsoft.com/office/drawing/2014/main" id="{B0567BB4-668E-42C6-A179-419C9D6BCB6B}"/>
               </a:ext>
             </a:extLst>
           </p:cNvPr>
@@ -24287,7 +25986,7 @@
           <p:cNvPr id="11" name="">
             <a:extLst xmlns:a="http://schemas.openxmlformats.org/drawingml/2006/main">
               <a:ext uri="{FF2B5EF4-FFF2-40B4-BE49-F238E27FC236}">
-                <a16:creationId xmlns:a16="http://schemas.microsoft.com/office/drawing/2014/main" id="{CE610B44-828A-4C69-90AE-7B2842C44798}"/>
+                <a16:creationId xmlns:a16="http://schemas.microsoft.com/office/drawing/2014/main" id="{7A68D65C-2772-4D07-BC65-F9D18679CAAF}"/>
               </a:ext>
             </a:extLst>
           </p:cNvPr>
@@ -24467,7 +26166,7 @@
           <p:cNvPr id="12" name="">
             <a:extLst xmlns:a="http://schemas.openxmlformats.org/drawingml/2006/main">
               <a:ext uri="{FF2B5EF4-FFF2-40B4-BE49-F238E27FC236}">
-                <a16:creationId xmlns:a16="http://schemas.microsoft.com/office/drawing/2014/main" id="{88071D09-59CB-44B3-B895-2FC45063ECF7}"/>
+                <a16:creationId xmlns:a16="http://schemas.microsoft.com/office/drawing/2014/main" id="{E8063513-6D90-451D-9A44-D21BA19394FB}"/>
               </a:ext>
             </a:extLst>
           </p:cNvPr>
@@ -24500,7 +26199,7 @@
           <p:cNvPr id="13" name="">
             <a:extLst xmlns:a="http://schemas.openxmlformats.org/drawingml/2006/main">
               <a:ext uri="{FF2B5EF4-FFF2-40B4-BE49-F238E27FC236}">
-                <a16:creationId xmlns:a16="http://schemas.microsoft.com/office/drawing/2014/main" id="{4BB3F7E8-3FF0-4CF8-A0D8-A776E18C36EF}"/>
+                <a16:creationId xmlns:a16="http://schemas.microsoft.com/office/drawing/2014/main" id="{D7BEA03D-F4AB-4C9D-AB8D-93469104083B}"/>
               </a:ext>
             </a:extLst>
           </p:cNvPr>
@@ -24657,7 +26356,7 @@
           <p:cNvPr id="14" name="">
             <a:extLst xmlns:a="http://schemas.openxmlformats.org/drawingml/2006/main">
               <a:ext uri="{FF2B5EF4-FFF2-40B4-BE49-F238E27FC236}">
-                <a16:creationId xmlns:a16="http://schemas.microsoft.com/office/drawing/2014/main" id="{150419C7-1E8F-46B0-8738-524134BBD6D5}"/>
+                <a16:creationId xmlns:a16="http://schemas.microsoft.com/office/drawing/2014/main" id="{E1A63C7E-D810-43BC-ABD5-E4187A4A91DE}"/>
               </a:ext>
             </a:extLst>
           </p:cNvPr>
@@ -24837,7 +26536,7 @@
           <p:cNvPr id="15" name="">
             <a:extLst xmlns:a="http://schemas.openxmlformats.org/drawingml/2006/main">
               <a:ext uri="{FF2B5EF4-FFF2-40B4-BE49-F238E27FC236}">
-                <a16:creationId xmlns:a16="http://schemas.microsoft.com/office/drawing/2014/main" id="{B9FA757A-859B-4C3A-9CEE-07EEFF47ABFF}"/>
+                <a16:creationId xmlns:a16="http://schemas.microsoft.com/office/drawing/2014/main" id="{0C30E10A-03F3-4D77-9CE8-C24299C5F6AB}"/>
               </a:ext>
             </a:extLst>
           </p:cNvPr>
@@ -24870,7 +26569,7 @@
           <p:cNvPr id="16" name="">
             <a:extLst xmlns:a="http://schemas.openxmlformats.org/drawingml/2006/main">
               <a:ext uri="{FF2B5EF4-FFF2-40B4-BE49-F238E27FC236}">
-                <a16:creationId xmlns:a16="http://schemas.microsoft.com/office/drawing/2014/main" id="{D562F405-1A9A-4D4C-AAEB-80C80D558C71}"/>
+                <a16:creationId xmlns:a16="http://schemas.microsoft.com/office/drawing/2014/main" id="{FB3221B0-D5C8-4B1B-A9DE-DC3666504C54}"/>
               </a:ext>
             </a:extLst>
           </p:cNvPr>
@@ -25027,7 +26726,7 @@
           <p:cNvPr id="17" name="">
             <a:extLst xmlns:a="http://schemas.openxmlformats.org/drawingml/2006/main">
               <a:ext uri="{FF2B5EF4-FFF2-40B4-BE49-F238E27FC236}">
-                <a16:creationId xmlns:a16="http://schemas.microsoft.com/office/drawing/2014/main" id="{A5C05754-2FB4-4B70-B40A-A3DE018A1AA7}"/>
+                <a16:creationId xmlns:a16="http://schemas.microsoft.com/office/drawing/2014/main" id="{BB3B678C-5066-4D3E-8B52-07912120EC0A}"/>
               </a:ext>
             </a:extLst>
           </p:cNvPr>
@@ -25207,7 +26906,7 @@
           <p:cNvPr id="18" name="">
             <a:extLst xmlns:a="http://schemas.openxmlformats.org/drawingml/2006/main">
               <a:ext uri="{FF2B5EF4-FFF2-40B4-BE49-F238E27FC236}">
-                <a16:creationId xmlns:a16="http://schemas.microsoft.com/office/drawing/2014/main" id="{79AE9826-282A-4C4D-8FE1-4204E6A64459}"/>
+                <a16:creationId xmlns:a16="http://schemas.microsoft.com/office/drawing/2014/main" id="{CD681A26-4F64-4241-A81A-95EB86A3BF5C}"/>
               </a:ext>
             </a:extLst>
           </p:cNvPr>
@@ -25353,9 +27052,166 @@
                 <a:latin typeface="Avenir Next"/>
                 <a:ea typeface="Avenir Next"/>
                 <a:cs typeface="Avenir Next"/>
-                <a:hlinkClick xmlns:r="http://schemas.openxmlformats.org/officeDocument/2006/relationships" r:id="R9c2f3d13c6a34446"/>
+                <a:hlinkClick xmlns:r="http://schemas.openxmlformats.org/officeDocument/2006/relationships" r:id="Rec1dcab006c64f8f"/>
               </a:rPr>
               <a:t>Abrir guía de la demo IA</a:t>
+            </a:r>
+          </a:p>
+        </p:txBody>
+      </p:sp>
+      <p:sp>
+        <p:nvSpPr>
+          <p:cNvPr id="19" name="">
+            <a:extLst xmlns:a="http://schemas.openxmlformats.org/drawingml/2006/main">
+              <a:ext uri="{FF2B5EF4-FFF2-40B4-BE49-F238E27FC236}">
+                <a16:creationId xmlns:a16="http://schemas.microsoft.com/office/drawing/2014/main" id="{ED5BDABE-63C5-4695-AD30-33BAE826A9B9}"/>
+              </a:ext>
+            </a:extLst>
+          </p:cNvPr>
+          <p:cNvSpPr>
+            <a:spLocks xmlns:a="http://schemas.openxmlformats.org/drawingml/2006/main" noGrp="1"/>
+          </p:cNvSpPr>
+          <p:nvPr/>
+        </p:nvSpPr>
+        <p:spPr>
+          <a:xfrm xmlns:a="http://schemas.openxmlformats.org/drawingml/2006/main">
+            <a:off x="6381750" y="5495925"/>
+            <a:ext cx="5238750" cy="409575"/>
+          </a:xfrm>
+          <a:prstGeom xmlns:a="http://schemas.openxmlformats.org/drawingml/2006/main" prst="rect">
+            <a:avLst/>
+          </a:prstGeom>
+          <a:noFill xmlns:a="http://schemas.openxmlformats.org/drawingml/2006/main"/>
+          <a:ln xmlns:a="http://schemas.openxmlformats.org/drawingml/2006/main" w="0">
+            <a:noFill/>
+            <a:prstDash val="solid"/>
+          </a:ln>
+        </p:spPr>
+        <p:txBody>
+          <a:bodyPr xmlns:a="http://schemas.openxmlformats.org/drawingml/2006/main" anchor="ctr"/>
+          <a:lstStyle xmlns:a="http://schemas.openxmlformats.org/drawingml/2006/main">
+            <a:defPPr algn="l">
+              <a:defRPr sz="1425" b="1">
+                <a:solidFill>
+                  <a:srgbClr val="11766E"/>
+                </a:solidFill>
+                <a:latin typeface="Avenir Next"/>
+                <a:ea typeface="Avenir Next"/>
+                <a:cs typeface="Avenir Next"/>
+              </a:defRPr>
+            </a:defPPr>
+            <a:lvl1pPr algn="l">
+              <a:defRPr sz="1425" b="1">
+                <a:solidFill>
+                  <a:srgbClr val="11766E"/>
+                </a:solidFill>
+                <a:latin typeface="Avenir Next"/>
+                <a:ea typeface="Avenir Next"/>
+                <a:cs typeface="Avenir Next"/>
+              </a:defRPr>
+            </a:lvl1pPr>
+            <a:lvl2pPr algn="l">
+              <a:defRPr sz="1425" b="1">
+                <a:solidFill>
+                  <a:srgbClr val="11766E"/>
+                </a:solidFill>
+                <a:latin typeface="Avenir Next"/>
+                <a:ea typeface="Avenir Next"/>
+                <a:cs typeface="Avenir Next"/>
+              </a:defRPr>
+            </a:lvl2pPr>
+            <a:lvl3pPr algn="l">
+              <a:defRPr sz="1425" b="1">
+                <a:solidFill>
+                  <a:srgbClr val="11766E"/>
+                </a:solidFill>
+                <a:latin typeface="Avenir Next"/>
+                <a:ea typeface="Avenir Next"/>
+                <a:cs typeface="Avenir Next"/>
+              </a:defRPr>
+            </a:lvl3pPr>
+            <a:lvl4pPr algn="l">
+              <a:defRPr sz="1425" b="1">
+                <a:solidFill>
+                  <a:srgbClr val="11766E"/>
+                </a:solidFill>
+                <a:latin typeface="Avenir Next"/>
+                <a:ea typeface="Avenir Next"/>
+                <a:cs typeface="Avenir Next"/>
+              </a:defRPr>
+            </a:lvl4pPr>
+            <a:lvl5pPr algn="l">
+              <a:defRPr sz="1425" b="1">
+                <a:solidFill>
+                  <a:srgbClr val="11766E"/>
+                </a:solidFill>
+                <a:latin typeface="Avenir Next"/>
+                <a:ea typeface="Avenir Next"/>
+                <a:cs typeface="Avenir Next"/>
+              </a:defRPr>
+            </a:lvl5pPr>
+            <a:lvl6pPr algn="l">
+              <a:defRPr sz="1425" b="1">
+                <a:solidFill>
+                  <a:srgbClr val="11766E"/>
+                </a:solidFill>
+                <a:latin typeface="Avenir Next"/>
+                <a:ea typeface="Avenir Next"/>
+                <a:cs typeface="Avenir Next"/>
+              </a:defRPr>
+            </a:lvl6pPr>
+            <a:lvl7pPr algn="l">
+              <a:defRPr sz="1425" b="1">
+                <a:solidFill>
+                  <a:srgbClr val="11766E"/>
+                </a:solidFill>
+                <a:latin typeface="Avenir Next"/>
+                <a:ea typeface="Avenir Next"/>
+                <a:cs typeface="Avenir Next"/>
+              </a:defRPr>
+            </a:lvl7pPr>
+            <a:lvl8pPr algn="l">
+              <a:defRPr sz="1425" b="1">
+                <a:solidFill>
+                  <a:srgbClr val="11766E"/>
+                </a:solidFill>
+                <a:latin typeface="Avenir Next"/>
+                <a:ea typeface="Avenir Next"/>
+                <a:cs typeface="Avenir Next"/>
+              </a:defRPr>
+            </a:lvl8pPr>
+            <a:lvl9pPr algn="l">
+              <a:defRPr sz="1425" b="1">
+                <a:solidFill>
+                  <a:srgbClr val="11766E"/>
+                </a:solidFill>
+                <a:latin typeface="Avenir Next"/>
+                <a:ea typeface="Avenir Next"/>
+                <a:cs typeface="Avenir Next"/>
+              </a:defRPr>
+            </a:lvl9pPr>
+          </a:lstStyle>
+          <a:p xmlns:a="http://schemas.openxmlformats.org/drawingml/2006/main">
+            <a:pPr algn="l">
+              <a:defRPr sz="1425" b="1">
+                <a:solidFill>
+                  <a:srgbClr val="11766E"/>
+                </a:solidFill>
+                <a:latin typeface="Avenir Next"/>
+                <a:ea typeface="Avenir Next"/>
+                <a:cs typeface="Avenir Next"/>
+              </a:defRPr>
+            </a:pPr>
+            <a:r>
+              <a:rPr sz="1425" b="1">
+                <a:solidFill>
+                  <a:srgbClr val="11766E"/>
+                </a:solidFill>
+                <a:latin typeface="Avenir Next"/>
+                <a:ea typeface="Avenir Next"/>
+                <a:cs typeface="Avenir Next"/>
+              </a:rPr>
+              <a:t>La IA propone; solo cuenta si se ejecuta la prueba.</a:t>
             </a:r>
           </a:p>
         </p:txBody>
@@ -25363,7 +27219,7 @@
     </p:spTree>
     <p:extLst>
       <p:ext uri="{BB962C8B-B14F-4D97-AF65-F5344CB8AC3E}">
-        <p14:creationId xmlns:p14="http://schemas.microsoft.com/office/powerpoint/2010/main" val="1664538901"/>
+        <p14:creationId xmlns:p14="http://schemas.microsoft.com/office/powerpoint/2010/main" val="1833157569"/>
       </p:ext>
     </p:extLst>
   </p:cSld>

</xml_diff>

<commit_message>
Document exact live demo and add optional browser pacing
</commit_message>
<xml_diff>
--- a/docs/Presentacion_Robot_Framework_G4_visual.pptx
+++ b/docs/Presentacion_Robot_Framework_G4_visual.pptx
@@ -2,22 +2,22 @@
 <file path=ppt/presentation.xml><?xml version="1.0" encoding="utf-8"?>
 <p:presentation xmlns:p="http://schemas.openxmlformats.org/presentationml/2006/main">
   <p:sldMasterIdLst>
-    <p:sldMasterId xmlns:r="http://schemas.openxmlformats.org/officeDocument/2006/relationships" id="2147483648" r:id="R4466f21476964483"/>
+    <p:sldMasterId xmlns:r="http://schemas.openxmlformats.org/officeDocument/2006/relationships" id="2147483648" r:id="Rb7d87696eb60459d"/>
   </p:sldMasterIdLst>
   <p:notesMasterIdLst>
-    <p:notesMasterId xmlns:r="http://schemas.openxmlformats.org/officeDocument/2006/relationships" r:id="R8ddd3a5d857c4668"/>
+    <p:notesMasterId xmlns:r="http://schemas.openxmlformats.org/officeDocument/2006/relationships" r:id="R03ae263e117c48a9"/>
   </p:notesMasterIdLst>
   <p:sldIdLst>
-    <p:sldId xmlns:r="http://schemas.openxmlformats.org/officeDocument/2006/relationships" id="256" r:id="R7443b7981e154fb9"/>
-    <p:sldId xmlns:r="http://schemas.openxmlformats.org/officeDocument/2006/relationships" id="257" r:id="Rfd14674a671e47f6"/>
-    <p:sldId xmlns:r="http://schemas.openxmlformats.org/officeDocument/2006/relationships" id="258" r:id="R71e11bfdec694053"/>
-    <p:sldId xmlns:r="http://schemas.openxmlformats.org/officeDocument/2006/relationships" id="259" r:id="R782c8ef467fc49d0"/>
-    <p:sldId xmlns:r="http://schemas.openxmlformats.org/officeDocument/2006/relationships" id="260" r:id="R588a943505524f1e"/>
-    <p:sldId xmlns:r="http://schemas.openxmlformats.org/officeDocument/2006/relationships" id="261" r:id="R8f1c0e6fe96a4228"/>
-    <p:sldId xmlns:r="http://schemas.openxmlformats.org/officeDocument/2006/relationships" id="262" r:id="R616efd341dc44ba0"/>
-    <p:sldId xmlns:r="http://schemas.openxmlformats.org/officeDocument/2006/relationships" id="263" r:id="R6aa6a7f57288474f"/>
-    <p:sldId xmlns:r="http://schemas.openxmlformats.org/officeDocument/2006/relationships" id="264" r:id="Rc31e49eb5d884363"/>
-    <p:sldId xmlns:r="http://schemas.openxmlformats.org/officeDocument/2006/relationships" id="265" r:id="R793c3a4f35894720"/>
+    <p:sldId xmlns:r="http://schemas.openxmlformats.org/officeDocument/2006/relationships" id="256" r:id="R447c7d065cf64a2a"/>
+    <p:sldId xmlns:r="http://schemas.openxmlformats.org/officeDocument/2006/relationships" id="257" r:id="Rf2cab15647f04579"/>
+    <p:sldId xmlns:r="http://schemas.openxmlformats.org/officeDocument/2006/relationships" id="258" r:id="R8d871e7597d24d2b"/>
+    <p:sldId xmlns:r="http://schemas.openxmlformats.org/officeDocument/2006/relationships" id="259" r:id="Re70833fed4e34d9d"/>
+    <p:sldId xmlns:r="http://schemas.openxmlformats.org/officeDocument/2006/relationships" id="260" r:id="R8d9c4cd9bdda438e"/>
+    <p:sldId xmlns:r="http://schemas.openxmlformats.org/officeDocument/2006/relationships" id="261" r:id="R69fcc3f54f934946"/>
+    <p:sldId xmlns:r="http://schemas.openxmlformats.org/officeDocument/2006/relationships" id="262" r:id="R5886eb9de0204e2c"/>
+    <p:sldId xmlns:r="http://schemas.openxmlformats.org/officeDocument/2006/relationships" id="263" r:id="Rcc832a0bd5574977"/>
+    <p:sldId xmlns:r="http://schemas.openxmlformats.org/officeDocument/2006/relationships" id="264" r:id="R788d180fb3b7470a"/>
+    <p:sldId xmlns:r="http://schemas.openxmlformats.org/officeDocument/2006/relationships" id="265" r:id="R76121aff705f45b1"/>
   </p:sldIdLst>
   <p:sldSz cx="12192000" cy="6858000"/>
   <p:notesSz cx="6858000" cy="9144000"/>
@@ -1176,7 +1176,7 @@
           </a:p>
           <a:p xmlns:a="http://schemas.openxmlformats.org/drawingml/2006/main">
             <a:r>
-              <a:t>Pasemos a la ejecución. Voy a lanzar Robot con el navegador visible. El caso prepara los datos de una instancia local de pruebas, entra primero como Diego y después como Bruno, y hace las comprobaciones que acabamos de revisar.</a:t>
+              <a:t>Pasemos a la ejecución. Voy a lanzar Robot con el navegador visible y un poco más lento para que podamos seguirlo. El caso prepara los datos de una instancia local de pruebas, entra primero como Diego y después como Bruno, y hace las comprobaciones que acabamos de revisar.</a:t>
             </a:r>
           </a:p>
           <a:p xmlns:a="http://schemas.openxmlformats.org/drawingml/2006/main">
@@ -1186,7 +1186,7 @@
           </a:p>
           <a:p xmlns:a="http://schemas.openxmlformats.org/drawingml/2006/main">
             <a:r>
-              <a:t>[ACCIÓN EN VIVO, NO LEER] No leer: con Qolqe ya iniciado, ejecutar en otra terminal: python -m robot --variable HEADLESS:False --outputdir reportes tests/e2e/g4_solicitud_happy_path.robot. Luego abrir reportes/report.html y expandir un paso en reportes/log.html.</a:t>
+              <a:t>[ACCIÓN EN VIVO, NO LEER] No leer: con Qolqe ya iniciado, ejecutar el comando del paso 2 de la guía: HEADLESS:False y SLOWMO:0.5s. Esperar el PASS; abrir reportes/report.html y luego reportes/log.html.</a:t>
             </a:r>
           </a:p>
           <a:p xmlns:a="http://schemas.openxmlformats.org/drawingml/2006/main">
@@ -1211,7 +1211,7 @@
           </a:p>
           <a:p xmlns:a="http://schemas.openxmlformats.org/drawingml/2006/main">
             <a:r>
-              <a:t>5:55-7:30 (95 s). PREPARACIÓN: Qolqe debe estar iniciado con el comando de la sección 7 del README. EN VIVO: ejecutar python -m robot --variable HEADLESS:False --outputdir reportes tests/e2e/g4_solicitud_happy_path.robot. Dejar que la audiencia vea Chromium; abrir reportes/report.html, señalar 1 test/1 passed; abrir log.html y expandir Enviar solicitud a contacto o Aceptar solicitud recibida para mostrar validaciones. Si la ventana tarda, usar la captura real como respaldo, aclarando que es una ejecución previa. La ejecución verificada el 24 de octubre de 2026 aprobó 1 de 1 prueba. Fuente: reportes locales y captura real 08-robot-report.png.</a:t>
+              <a:t>5:55-7:30 (95 s). PREPARACIÓN: Qolqe debe estar iniciado con el comando de la sección 7 del README. EN VIVO: ejecutar python -m robot --variable HEADLESS:False --variable SLOWMO:0.5s --outputdir reportes tests/e2e/g4_solicitud_happy_path.robot. Dejar que la audiencia vea Chromium; abrir reportes/report.html, señalar 1 test/1 passed; abrir log.html y expandir Enviar solicitud a contacto o Aceptar solicitud recibida para mostrar validaciones. Si la ventana tarda, usar la captura real como respaldo, aclarando que es una ejecución previa. La ejecución visible verificada el 24 de octubre de 2026 aprobó 1 de 1 prueba en unos 18 segundos. Fuente: reportes locales y captura real 08-robot-report.png.</a:t>
             </a:r>
           </a:p>
         </p:txBody>
@@ -1321,7 +1321,7 @@
           </a:p>
           <a:p xmlns:a="http://schemas.openxmlformats.org/drawingml/2006/main">
             <a:r>
-              <a:t>7:30-9:10 (100 s). EN VIVO: abrir Codex con este repositorio y pegar el prompt completo de docs/demo-robot-ia.md. Adjuntar o referir reportes/output.xml, tests/e2e/g4_solicitud_happy_path.robot y docs/requisitos.md. Pedir tres cosas: qué validó Robot, qué requisito no validó, y un keyword mínimo propuesto. La respuesta útil debe detectar los SMS simulados de HU-G4-06 CA2 y HU-G4-08 CA3. La IA es asistencia externa aplicada al resultado de Robot; no atribuir IA integrada al motor. Mostrar la propuesta y aclarar que se debe comprobar con requisitos y ejecutar antes de incorporarla. Fuente: docs/demo-robot-ia.md y docs/requisitos.md.</a:t>
+              <a:t>7:30-9:10 (100 s). EN VIVO: abrir Codex con este repositorio y pegar el prompt completo de docs/demo-robot-ia.md. Adjuntar o referir reportes/output.xml, tests/e2e/g4_solicitud_happy_path.robot y docs/requisitos.md. Prompt exacto: Revisa el resultado real de reportes/output.xml y la prueba tests/e2e/g4_solicitud_happy_path.robot contra HU-G4-06 y HU-G4-08 de docs/requisitos.md. Dime qué validación importante falta en este único happy path. Propón un cambio mínimo a Robot Framework, con el criterio de aceptación exacto que cubre. No modifiques el código de qolqe/ ni afirmes que la prueba cubre escenarios negativos. Distingue claramente lo que el reporte ya comprobó de lo que solo estás proponiendo. La respuesta útil debe detectar los SMS simulados de HU-G4-06 CA2 y HU-G4-08 CA3. La IA es asistencia externa aplicada al resultado de Robot; no atribuir IA integrada al motor. Mostrar la propuesta y aclarar que se debe comprobar con requisitos y ejecutar antes de incorporarla. Fuente: docs/demo-robot-ia.md y docs/requisitos.md.</a:t>
             </a:r>
           </a:p>
         </p:txBody>
@@ -1368,7 +1368,7 @@
           <p:cNvPr id="3" name="Title">
             <a:extLst xmlns:a="http://schemas.openxmlformats.org/drawingml/2006/main">
               <a:ext uri="{FF2B5EF4-FFF2-40B4-BE49-F238E27FC236}">
-                <a16:creationId xmlns:a16="http://schemas.microsoft.com/office/drawing/2014/main" id="{361D7898-4D4C-4FF4-B381-1FD797C2A816}"/>
+                <a16:creationId xmlns:a16="http://schemas.microsoft.com/office/drawing/2014/main" id="{18D9AC6B-6C6A-455E-9080-D2D2D99556B3}"/>
               </a:ext>
             </a:extLst>
           </p:cNvPr>
@@ -1597,7 +1597,7 @@
           <p:cNvPr id="2" name="Subtitle">
             <a:extLst xmlns:a="http://schemas.openxmlformats.org/drawingml/2006/main">
               <a:ext uri="{FF2B5EF4-FFF2-40B4-BE49-F238E27FC236}">
-                <a16:creationId xmlns:a16="http://schemas.microsoft.com/office/drawing/2014/main" id="{7D1072C6-E049-4BB4-9BA4-789EDC4F50FC}"/>
+                <a16:creationId xmlns:a16="http://schemas.microsoft.com/office/drawing/2014/main" id="{F4E4196A-7237-4501-B516-408D70628542}"/>
               </a:ext>
             </a:extLst>
           </p:cNvPr>
@@ -1843,7 +1843,7 @@
           <p:cNvPr id="2" name="Section title">
             <a:extLst xmlns:a="http://schemas.openxmlformats.org/drawingml/2006/main">
               <a:ext uri="{FF2B5EF4-FFF2-40B4-BE49-F238E27FC236}">
-                <a16:creationId xmlns:a16="http://schemas.microsoft.com/office/drawing/2014/main" id="{FD873AB6-C80A-475B-9476-A20E9FF0E4DE}"/>
+                <a16:creationId xmlns:a16="http://schemas.microsoft.com/office/drawing/2014/main" id="{4153FB1D-7C7C-4B18-BA85-FE105B45BEAF}"/>
               </a:ext>
             </a:extLst>
           </p:cNvPr>
@@ -2089,7 +2089,7 @@
           <p:cNvPr id="3" name="Title">
             <a:extLst xmlns:a="http://schemas.openxmlformats.org/drawingml/2006/main">
               <a:ext uri="{FF2B5EF4-FFF2-40B4-BE49-F238E27FC236}">
-                <a16:creationId xmlns:a16="http://schemas.microsoft.com/office/drawing/2014/main" id="{45080D34-7ABB-4F1A-B058-6344D98EB512}"/>
+                <a16:creationId xmlns:a16="http://schemas.microsoft.com/office/drawing/2014/main" id="{3E62F02C-196F-4DA3-B7DE-E7B0A20BFF9D}"/>
               </a:ext>
             </a:extLst>
           </p:cNvPr>
@@ -2318,7 +2318,7 @@
           <p:cNvPr id="2" name="Body">
             <a:extLst xmlns:a="http://schemas.openxmlformats.org/drawingml/2006/main">
               <a:ext uri="{FF2B5EF4-FFF2-40B4-BE49-F238E27FC236}">
-                <a16:creationId xmlns:a16="http://schemas.microsoft.com/office/drawing/2014/main" id="{51FECD3F-EE88-46B7-9472-D3555496FA8B}"/>
+                <a16:creationId xmlns:a16="http://schemas.microsoft.com/office/drawing/2014/main" id="{198B960F-117C-42E7-8454-067F1FD85513}"/>
               </a:ext>
             </a:extLst>
           </p:cNvPr>
@@ -2564,7 +2564,7 @@
           <p:cNvPr id="4" name="Title">
             <a:extLst xmlns:a="http://schemas.openxmlformats.org/drawingml/2006/main">
               <a:ext uri="{FF2B5EF4-FFF2-40B4-BE49-F238E27FC236}">
-                <a16:creationId xmlns:a16="http://schemas.microsoft.com/office/drawing/2014/main" id="{1B6358FC-5EDD-482F-A27C-FE9B52D92036}"/>
+                <a16:creationId xmlns:a16="http://schemas.microsoft.com/office/drawing/2014/main" id="{ABCAA681-4E75-427F-A14B-247E37A15DCA}"/>
               </a:ext>
             </a:extLst>
           </p:cNvPr>
@@ -2793,7 +2793,7 @@
           <p:cNvPr id="2" name="Left column">
             <a:extLst xmlns:a="http://schemas.openxmlformats.org/drawingml/2006/main">
               <a:ext uri="{FF2B5EF4-FFF2-40B4-BE49-F238E27FC236}">
-                <a16:creationId xmlns:a16="http://schemas.microsoft.com/office/drawing/2014/main" id="{0D7DCEB9-D316-42FA-8A53-36EC1480D4C2}"/>
+                <a16:creationId xmlns:a16="http://schemas.microsoft.com/office/drawing/2014/main" id="{53D44F27-BBBD-4A19-8E6E-90851B451D59}"/>
               </a:ext>
             </a:extLst>
           </p:cNvPr>
@@ -3022,7 +3022,7 @@
           <p:cNvPr id="3" name="Right column">
             <a:extLst xmlns:a="http://schemas.openxmlformats.org/drawingml/2006/main">
               <a:ext uri="{FF2B5EF4-FFF2-40B4-BE49-F238E27FC236}">
-                <a16:creationId xmlns:a16="http://schemas.microsoft.com/office/drawing/2014/main" id="{2F0B760B-573A-4DEA-A0AA-3AA9079B3BED}"/>
+                <a16:creationId xmlns:a16="http://schemas.microsoft.com/office/drawing/2014/main" id="{7C67C356-47F7-42FF-820C-5F7C9EB813D8}"/>
               </a:ext>
             </a:extLst>
           </p:cNvPr>
@@ -3268,7 +3268,7 @@
           <p:cNvPr id="3" name="Title">
             <a:extLst xmlns:a="http://schemas.openxmlformats.org/drawingml/2006/main">
               <a:ext uri="{FF2B5EF4-FFF2-40B4-BE49-F238E27FC236}">
-                <a16:creationId xmlns:a16="http://schemas.microsoft.com/office/drawing/2014/main" id="{7F02192F-A2F8-43FF-8DCA-58BFECEA5C80}"/>
+                <a16:creationId xmlns:a16="http://schemas.microsoft.com/office/drawing/2014/main" id="{EDDC61B7-184C-4767-82F5-2DCD660BA640}"/>
               </a:ext>
             </a:extLst>
           </p:cNvPr>
@@ -3497,7 +3497,7 @@
           <p:cNvPr id="2" name="Left column">
             <a:extLst xmlns:a="http://schemas.openxmlformats.org/drawingml/2006/main">
               <a:ext uri="{FF2B5EF4-FFF2-40B4-BE49-F238E27FC236}">
-                <a16:creationId xmlns:a16="http://schemas.microsoft.com/office/drawing/2014/main" id="{1ECE5D41-0BBA-4E27-9409-603012C455AF}"/>
+                <a16:creationId xmlns:a16="http://schemas.microsoft.com/office/drawing/2014/main" id="{68A11454-885B-4247-9AEA-E62CDEF995DD}"/>
               </a:ext>
             </a:extLst>
           </p:cNvPr>
@@ -3764,12 +3764,12 @@
   </p:cSld>
   <p:clrMap bg1="lt1" tx1="dk1" bg2="lt2" tx2="dk2" accent1="accent1" accent2="accent2" accent3="accent3" accent4="accent4" accent5="accent5" accent6="accent6" hlink="hlink" folHlink="folHlink"/>
   <p:sldLayoutIdLst>
-    <p:sldLayoutId xmlns:r="http://schemas.openxmlformats.org/officeDocument/2006/relationships" id="2147483649" r:id="R32f179d829fe4123"/>
-    <p:sldLayoutId xmlns:r="http://schemas.openxmlformats.org/officeDocument/2006/relationships" id="2147483650" r:id="Rdf713b9150e04859"/>
-    <p:sldLayoutId xmlns:r="http://schemas.openxmlformats.org/officeDocument/2006/relationships" id="2147483651" r:id="Rede5c8891ec6433e"/>
-    <p:sldLayoutId xmlns:r="http://schemas.openxmlformats.org/officeDocument/2006/relationships" id="2147483652" r:id="R67dbd31b2ba84a97"/>
-    <p:sldLayoutId xmlns:r="http://schemas.openxmlformats.org/officeDocument/2006/relationships" id="2147483653" r:id="R102e41e1af954845"/>
-    <p:sldLayoutId xmlns:r="http://schemas.openxmlformats.org/officeDocument/2006/relationships" id="2147483654" r:id="R31d7b5d9aa0a45c7"/>
+    <p:sldLayoutId xmlns:r="http://schemas.openxmlformats.org/officeDocument/2006/relationships" id="2147483649" r:id="R38ccfb38f34445ac"/>
+    <p:sldLayoutId xmlns:r="http://schemas.openxmlformats.org/officeDocument/2006/relationships" id="2147483650" r:id="Re40fd10fc3e5411a"/>
+    <p:sldLayoutId xmlns:r="http://schemas.openxmlformats.org/officeDocument/2006/relationships" id="2147483651" r:id="Rcb5c95d9aeaf4182"/>
+    <p:sldLayoutId xmlns:r="http://schemas.openxmlformats.org/officeDocument/2006/relationships" id="2147483652" r:id="R9417874804804304"/>
+    <p:sldLayoutId xmlns:r="http://schemas.openxmlformats.org/officeDocument/2006/relationships" id="2147483653" r:id="Raf649e6c69984610"/>
+    <p:sldLayoutId xmlns:r="http://schemas.openxmlformats.org/officeDocument/2006/relationships" id="2147483654" r:id="Rd19ccf2cb45c43ee"/>
   </p:sldLayoutIdLst>
   <p:txStyles>
     <p:titleStyle>
@@ -4320,7 +4320,7 @@
           <p:cNvPr id="13" name="">
             <a:extLst xmlns:a="http://schemas.openxmlformats.org/drawingml/2006/main">
               <a:ext uri="{FF2B5EF4-FFF2-40B4-BE49-F238E27FC236}">
-                <a16:creationId xmlns:a16="http://schemas.microsoft.com/office/drawing/2014/main" id="{BCC613AC-2E4B-4D25-B898-52C9D86B7DA6}"/>
+                <a16:creationId xmlns:a16="http://schemas.microsoft.com/office/drawing/2014/main" id="{2716A204-7172-47FB-9A84-5D00BE20100C}"/>
               </a:ext>
             </a:extLst>
           </p:cNvPr>
@@ -4351,7 +4351,7 @@
           <p:cNvPr id="2" name="">
             <a:extLst xmlns:a="http://schemas.openxmlformats.org/drawingml/2006/main">
               <a:ext uri="{FF2B5EF4-FFF2-40B4-BE49-F238E27FC236}">
-                <a16:creationId xmlns:a16="http://schemas.microsoft.com/office/drawing/2014/main" id="{57A510FC-4444-4845-B4C6-D8AEDEB40494}"/>
+                <a16:creationId xmlns:a16="http://schemas.microsoft.com/office/drawing/2014/main" id="{FE6BCE27-0D5A-4071-BBF4-BABBADE91890}"/>
               </a:ext>
             </a:extLst>
           </p:cNvPr>
@@ -4382,7 +4382,7 @@
           <p:cNvPr id="3" name="">
             <a:extLst xmlns:a="http://schemas.openxmlformats.org/drawingml/2006/main">
               <a:ext uri="{FF2B5EF4-FFF2-40B4-BE49-F238E27FC236}">
-                <a16:creationId xmlns:a16="http://schemas.microsoft.com/office/drawing/2014/main" id="{9C259622-3764-4F24-A007-AF926D386B6E}"/>
+                <a16:creationId xmlns:a16="http://schemas.microsoft.com/office/drawing/2014/main" id="{2FA501F8-C876-48E8-87AA-FC250C9A0C19}"/>
               </a:ext>
             </a:extLst>
           </p:cNvPr>
@@ -4562,7 +4562,7 @@
           <p:cNvPr id="4" name="">
             <a:extLst xmlns:a="http://schemas.openxmlformats.org/drawingml/2006/main">
               <a:ext uri="{FF2B5EF4-FFF2-40B4-BE49-F238E27FC236}">
-                <a16:creationId xmlns:a16="http://schemas.microsoft.com/office/drawing/2014/main" id="{648D470C-5C00-40B9-833A-613E30D65A73}"/>
+                <a16:creationId xmlns:a16="http://schemas.microsoft.com/office/drawing/2014/main" id="{FF406018-004F-4287-99D8-42A3E4D8AD83}"/>
               </a:ext>
             </a:extLst>
           </p:cNvPr>
@@ -4719,7 +4719,7 @@
           <p:cNvPr id="5" name="">
             <a:extLst xmlns:a="http://schemas.openxmlformats.org/drawingml/2006/main">
               <a:ext uri="{FF2B5EF4-FFF2-40B4-BE49-F238E27FC236}">
-                <a16:creationId xmlns:a16="http://schemas.microsoft.com/office/drawing/2014/main" id="{354FFA4B-F6D3-4AE2-AF7D-6082CDD3A3C2}"/>
+                <a16:creationId xmlns:a16="http://schemas.microsoft.com/office/drawing/2014/main" id="{7014CC81-9C30-41E9-B8A5-6F705B4AEBE8}"/>
               </a:ext>
             </a:extLst>
           </p:cNvPr>
@@ -4899,7 +4899,7 @@
           <p:cNvPr id="6" name="">
             <a:extLst xmlns:a="http://schemas.openxmlformats.org/drawingml/2006/main">
               <a:ext uri="{FF2B5EF4-FFF2-40B4-BE49-F238E27FC236}">
-                <a16:creationId xmlns:a16="http://schemas.microsoft.com/office/drawing/2014/main" id="{271B8233-1CB3-4ADD-94A8-BC81401E2ACD}"/>
+                <a16:creationId xmlns:a16="http://schemas.microsoft.com/office/drawing/2014/main" id="{9EF1ADF7-9BFA-45A1-A7CF-BF90F7DA9DB8}"/>
               </a:ext>
             </a:extLst>
           </p:cNvPr>
@@ -4932,7 +4932,7 @@
           <p:cNvPr id="7" name="">
             <a:extLst xmlns:a="http://schemas.openxmlformats.org/drawingml/2006/main">
               <a:ext uri="{FF2B5EF4-FFF2-40B4-BE49-F238E27FC236}">
-                <a16:creationId xmlns:a16="http://schemas.microsoft.com/office/drawing/2014/main" id="{A0599D76-0706-4AE1-A31F-D331710CF8D7}"/>
+                <a16:creationId xmlns:a16="http://schemas.microsoft.com/office/drawing/2014/main" id="{8A825FD8-88AA-4457-BBDD-39B5942E0EC6}"/>
               </a:ext>
             </a:extLst>
           </p:cNvPr>
@@ -5089,7 +5089,7 @@
           <p:cNvPr id="8" name="">
             <a:extLst xmlns:a="http://schemas.openxmlformats.org/drawingml/2006/main">
               <a:ext uri="{FF2B5EF4-FFF2-40B4-BE49-F238E27FC236}">
-                <a16:creationId xmlns:a16="http://schemas.microsoft.com/office/drawing/2014/main" id="{462DAAE2-436A-495D-995B-5E3E7E2E6574}"/>
+                <a16:creationId xmlns:a16="http://schemas.microsoft.com/office/drawing/2014/main" id="{F36DF35E-8AFD-410E-B571-D373C92F9D41}"/>
               </a:ext>
             </a:extLst>
           </p:cNvPr>
@@ -5246,7 +5246,7 @@
           <p:cNvPr id="9" name="">
             <a:extLst xmlns:a="http://schemas.openxmlformats.org/drawingml/2006/main">
               <a:ext uri="{FF2B5EF4-FFF2-40B4-BE49-F238E27FC236}">
-                <a16:creationId xmlns:a16="http://schemas.microsoft.com/office/drawing/2014/main" id="{E4CD5E8B-0825-417C-A4BA-154C35EC7C63}"/>
+                <a16:creationId xmlns:a16="http://schemas.microsoft.com/office/drawing/2014/main" id="{C6664D07-F8F0-4B5A-BDA2-04784F31C7C5}"/>
               </a:ext>
             </a:extLst>
           </p:cNvPr>
@@ -5279,7 +5279,7 @@
           <p:cNvPr id="10" name="">
             <a:extLst xmlns:a="http://schemas.openxmlformats.org/drawingml/2006/main">
               <a:ext uri="{FF2B5EF4-FFF2-40B4-BE49-F238E27FC236}">
-                <a16:creationId xmlns:a16="http://schemas.microsoft.com/office/drawing/2014/main" id="{3F9C0E4D-1CF0-4BD5-870C-E95CF91365E2}"/>
+                <a16:creationId xmlns:a16="http://schemas.microsoft.com/office/drawing/2014/main" id="{F7A9BAB6-1B8B-48DC-8F10-3F41F171CA86}"/>
               </a:ext>
             </a:extLst>
           </p:cNvPr>
@@ -5289,7 +5289,7 @@
           <p:nvPr/>
         </p:nvPicPr>
         <p:blipFill>
-          <a:blip xmlns:r="http://schemas.openxmlformats.org/officeDocument/2006/relationships" xmlns:a="http://schemas.openxmlformats.org/drawingml/2006/main" r:embed="R1e97c9911dcb4758"/>
+          <a:blip xmlns:r="http://schemas.openxmlformats.org/officeDocument/2006/relationships" xmlns:a="http://schemas.openxmlformats.org/drawingml/2006/main" r:embed="R94b724784c8e453d"/>
           <a:stretch xmlns:a="http://schemas.openxmlformats.org/drawingml/2006/main"/>
         </p:blipFill>
         <p:spPr>
@@ -5309,7 +5309,7 @@
           <p:cNvPr id="11" name="">
             <a:extLst xmlns:a="http://schemas.openxmlformats.org/drawingml/2006/main">
               <a:ext uri="{FF2B5EF4-FFF2-40B4-BE49-F238E27FC236}">
-                <a16:creationId xmlns:a16="http://schemas.microsoft.com/office/drawing/2014/main" id="{A12ACC0E-6D72-4531-A279-60FD7649F5FF}"/>
+                <a16:creationId xmlns:a16="http://schemas.microsoft.com/office/drawing/2014/main" id="{CED1C4A4-A2A5-45A8-89EE-8D61F7377E28}"/>
               </a:ext>
             </a:extLst>
           </p:cNvPr>
@@ -5466,7 +5466,7 @@
           <p:cNvPr id="12" name="">
             <a:extLst xmlns:a="http://schemas.openxmlformats.org/drawingml/2006/main">
               <a:ext uri="{FF2B5EF4-FFF2-40B4-BE49-F238E27FC236}">
-                <a16:creationId xmlns:a16="http://schemas.microsoft.com/office/drawing/2014/main" id="{66EBD298-2FD3-401E-8C73-65FE365D8E76}"/>
+                <a16:creationId xmlns:a16="http://schemas.microsoft.com/office/drawing/2014/main" id="{E242C328-8308-4492-8B33-01B7A5F0C9C2}"/>
               </a:ext>
             </a:extLst>
           </p:cNvPr>
@@ -5621,7 +5621,7 @@
     </p:spTree>
     <p:extLst>
       <p:ext uri="{BB962C8B-B14F-4D97-AF65-F5344CB8AC3E}">
-        <p14:creationId xmlns:p14="http://schemas.microsoft.com/office/powerpoint/2010/main" val="195414263"/>
+        <p14:creationId xmlns:p14="http://schemas.microsoft.com/office/powerpoint/2010/main" val="1044931806"/>
       </p:ext>
     </p:extLst>
   </p:cSld>
@@ -5652,7 +5652,7 @@
           <p:cNvPr id="22" name="">
             <a:extLst xmlns:a="http://schemas.openxmlformats.org/drawingml/2006/main">
               <a:ext uri="{FF2B5EF4-FFF2-40B4-BE49-F238E27FC236}">
-                <a16:creationId xmlns:a16="http://schemas.microsoft.com/office/drawing/2014/main" id="{E2B38562-5FB0-4FED-9B8E-8017E6861F0C}"/>
+                <a16:creationId xmlns:a16="http://schemas.microsoft.com/office/drawing/2014/main" id="{736B53DE-7A89-4CDD-9013-481AA54475A0}"/>
               </a:ext>
             </a:extLst>
           </p:cNvPr>
@@ -5683,7 +5683,7 @@
           <p:cNvPr id="2" name="">
             <a:extLst xmlns:a="http://schemas.openxmlformats.org/drawingml/2006/main">
               <a:ext uri="{FF2B5EF4-FFF2-40B4-BE49-F238E27FC236}">
-                <a16:creationId xmlns:a16="http://schemas.microsoft.com/office/drawing/2014/main" id="{DFB72549-DC95-416E-AA34-6CCCE2471243}"/>
+                <a16:creationId xmlns:a16="http://schemas.microsoft.com/office/drawing/2014/main" id="{CAED147E-F702-4F74-B168-32A6F4CC07D3}"/>
               </a:ext>
             </a:extLst>
           </p:cNvPr>
@@ -5840,7 +5840,7 @@
           <p:cNvPr id="3" name="">
             <a:extLst xmlns:a="http://schemas.openxmlformats.org/drawingml/2006/main">
               <a:ext uri="{FF2B5EF4-FFF2-40B4-BE49-F238E27FC236}">
-                <a16:creationId xmlns:a16="http://schemas.microsoft.com/office/drawing/2014/main" id="{12D9CFC0-1D0F-4AE3-9952-99C35F0A7721}"/>
+                <a16:creationId xmlns:a16="http://schemas.microsoft.com/office/drawing/2014/main" id="{20A09B43-3A1B-4F35-8957-62DDF2898D14}"/>
               </a:ext>
             </a:extLst>
           </p:cNvPr>
@@ -5997,7 +5997,7 @@
           <p:cNvPr id="4" name="">
             <a:extLst xmlns:a="http://schemas.openxmlformats.org/drawingml/2006/main">
               <a:ext uri="{FF2B5EF4-FFF2-40B4-BE49-F238E27FC236}">
-                <a16:creationId xmlns:a16="http://schemas.microsoft.com/office/drawing/2014/main" id="{51A23FFC-0926-4DA5-8227-5552D590B0FC}"/>
+                <a16:creationId xmlns:a16="http://schemas.microsoft.com/office/drawing/2014/main" id="{A9D60C7E-774F-416F-9616-DDBCD801C273}"/>
               </a:ext>
             </a:extLst>
           </p:cNvPr>
@@ -6154,7 +6154,7 @@
           <p:cNvPr id="5" name="">
             <a:extLst xmlns:a="http://schemas.openxmlformats.org/drawingml/2006/main">
               <a:ext uri="{FF2B5EF4-FFF2-40B4-BE49-F238E27FC236}">
-                <a16:creationId xmlns:a16="http://schemas.microsoft.com/office/drawing/2014/main" id="{265EF831-778A-4FF5-8615-64744626D924}"/>
+                <a16:creationId xmlns:a16="http://schemas.microsoft.com/office/drawing/2014/main" id="{DEEDF3FD-43AA-4F4B-A339-072034207519}"/>
               </a:ext>
             </a:extLst>
           </p:cNvPr>
@@ -6185,7 +6185,7 @@
           <p:cNvPr id="6" name="">
             <a:extLst xmlns:a="http://schemas.openxmlformats.org/drawingml/2006/main">
               <a:ext uri="{FF2B5EF4-FFF2-40B4-BE49-F238E27FC236}">
-                <a16:creationId xmlns:a16="http://schemas.microsoft.com/office/drawing/2014/main" id="{423708ED-02A7-424F-8543-99FDA2EAFC75}"/>
+                <a16:creationId xmlns:a16="http://schemas.microsoft.com/office/drawing/2014/main" id="{2EA50208-7974-4E0B-8C39-19639E92445E}"/>
               </a:ext>
             </a:extLst>
           </p:cNvPr>
@@ -6342,7 +6342,7 @@
           <p:cNvPr id="7" name="">
             <a:extLst xmlns:a="http://schemas.openxmlformats.org/drawingml/2006/main">
               <a:ext uri="{FF2B5EF4-FFF2-40B4-BE49-F238E27FC236}">
-                <a16:creationId xmlns:a16="http://schemas.microsoft.com/office/drawing/2014/main" id="{C8AA5724-052C-48C9-B653-EB8C817A0EED}"/>
+                <a16:creationId xmlns:a16="http://schemas.microsoft.com/office/drawing/2014/main" id="{FAF1730B-1306-4B88-BFE2-57CEA4C06C9F}"/>
               </a:ext>
             </a:extLst>
           </p:cNvPr>
@@ -6499,7 +6499,7 @@
           <p:cNvPr id="8" name="">
             <a:extLst xmlns:a="http://schemas.openxmlformats.org/drawingml/2006/main">
               <a:ext uri="{FF2B5EF4-FFF2-40B4-BE49-F238E27FC236}">
-                <a16:creationId xmlns:a16="http://schemas.microsoft.com/office/drawing/2014/main" id="{0B0A5BB5-E207-4D90-BCB5-02005D2F6F4E}"/>
+                <a16:creationId xmlns:a16="http://schemas.microsoft.com/office/drawing/2014/main" id="{DEDF4976-6DA4-421A-9351-6AD79BC677A6}"/>
               </a:ext>
             </a:extLst>
           </p:cNvPr>
@@ -6532,7 +6532,7 @@
           <p:cNvPr id="9" name="">
             <a:extLst xmlns:a="http://schemas.openxmlformats.org/drawingml/2006/main">
               <a:ext uri="{FF2B5EF4-FFF2-40B4-BE49-F238E27FC236}">
-                <a16:creationId xmlns:a16="http://schemas.microsoft.com/office/drawing/2014/main" id="{B6EA264B-DDE9-41C9-928D-29074A77EA6B}"/>
+                <a16:creationId xmlns:a16="http://schemas.microsoft.com/office/drawing/2014/main" id="{585977CC-343A-481A-9467-441D5458D43B}"/>
               </a:ext>
             </a:extLst>
           </p:cNvPr>
@@ -6689,7 +6689,7 @@
           <p:cNvPr id="10" name="">
             <a:extLst xmlns:a="http://schemas.openxmlformats.org/drawingml/2006/main">
               <a:ext uri="{FF2B5EF4-FFF2-40B4-BE49-F238E27FC236}">
-                <a16:creationId xmlns:a16="http://schemas.microsoft.com/office/drawing/2014/main" id="{502B09CB-768F-47FE-9D94-E7165ED32F17}"/>
+                <a16:creationId xmlns:a16="http://schemas.microsoft.com/office/drawing/2014/main" id="{5E18193F-861B-4610-AB4D-F537584A67E2}"/>
               </a:ext>
             </a:extLst>
           </p:cNvPr>
@@ -6869,7 +6869,7 @@
           <p:cNvPr id="11" name="">
             <a:extLst xmlns:a="http://schemas.openxmlformats.org/drawingml/2006/main">
               <a:ext uri="{FF2B5EF4-FFF2-40B4-BE49-F238E27FC236}">
-                <a16:creationId xmlns:a16="http://schemas.microsoft.com/office/drawing/2014/main" id="{55D882BA-7A12-4D4F-A2A6-8D5D9F843C0E}"/>
+                <a16:creationId xmlns:a16="http://schemas.microsoft.com/office/drawing/2014/main" id="{E5D9B93A-BD63-40AA-B4F7-29831C46D179}"/>
               </a:ext>
             </a:extLst>
           </p:cNvPr>
@@ -6902,7 +6902,7 @@
           <p:cNvPr id="12" name="">
             <a:extLst xmlns:a="http://schemas.openxmlformats.org/drawingml/2006/main">
               <a:ext uri="{FF2B5EF4-FFF2-40B4-BE49-F238E27FC236}">
-                <a16:creationId xmlns:a16="http://schemas.microsoft.com/office/drawing/2014/main" id="{E2A682EE-E9F1-479B-839F-2AD773E63407}"/>
+                <a16:creationId xmlns:a16="http://schemas.microsoft.com/office/drawing/2014/main" id="{36FAAC85-0DB4-4E15-93B9-2A7C8B20ECF8}"/>
               </a:ext>
             </a:extLst>
           </p:cNvPr>
@@ -7059,7 +7059,7 @@
           <p:cNvPr id="13" name="">
             <a:extLst xmlns:a="http://schemas.openxmlformats.org/drawingml/2006/main">
               <a:ext uri="{FF2B5EF4-FFF2-40B4-BE49-F238E27FC236}">
-                <a16:creationId xmlns:a16="http://schemas.microsoft.com/office/drawing/2014/main" id="{8E07B4E4-338A-44EE-9057-13F60783CB25}"/>
+                <a16:creationId xmlns:a16="http://schemas.microsoft.com/office/drawing/2014/main" id="{112FC3F7-6565-4FF6-8B6B-562F1328925D}"/>
               </a:ext>
             </a:extLst>
           </p:cNvPr>
@@ -7239,7 +7239,7 @@
           <p:cNvPr id="14" name="">
             <a:extLst xmlns:a="http://schemas.openxmlformats.org/drawingml/2006/main">
               <a:ext uri="{FF2B5EF4-FFF2-40B4-BE49-F238E27FC236}">
-                <a16:creationId xmlns:a16="http://schemas.microsoft.com/office/drawing/2014/main" id="{32CE00A5-1CF9-4669-8778-0BE12F49C2A0}"/>
+                <a16:creationId xmlns:a16="http://schemas.microsoft.com/office/drawing/2014/main" id="{F8687B22-AC24-42C8-81B6-ED78002BE506}"/>
               </a:ext>
             </a:extLst>
           </p:cNvPr>
@@ -7272,7 +7272,7 @@
           <p:cNvPr id="15" name="">
             <a:extLst xmlns:a="http://schemas.openxmlformats.org/drawingml/2006/main">
               <a:ext uri="{FF2B5EF4-FFF2-40B4-BE49-F238E27FC236}">
-                <a16:creationId xmlns:a16="http://schemas.microsoft.com/office/drawing/2014/main" id="{1A5F9DCC-70E6-4892-8374-F2DE92E1724F}"/>
+                <a16:creationId xmlns:a16="http://schemas.microsoft.com/office/drawing/2014/main" id="{3B3FF535-99F8-46A3-AC48-C0A5E37BBC83}"/>
               </a:ext>
             </a:extLst>
           </p:cNvPr>
@@ -7429,7 +7429,7 @@
           <p:cNvPr id="16" name="">
             <a:extLst xmlns:a="http://schemas.openxmlformats.org/drawingml/2006/main">
               <a:ext uri="{FF2B5EF4-FFF2-40B4-BE49-F238E27FC236}">
-                <a16:creationId xmlns:a16="http://schemas.microsoft.com/office/drawing/2014/main" id="{7B46CCA9-0398-42D4-813A-3647F378AB3F}"/>
+                <a16:creationId xmlns:a16="http://schemas.microsoft.com/office/drawing/2014/main" id="{D110F4BD-09DE-4FA4-98EF-539CB8B62AB7}"/>
               </a:ext>
             </a:extLst>
           </p:cNvPr>
@@ -7609,7 +7609,7 @@
           <p:cNvPr id="17" name="">
             <a:extLst xmlns:a="http://schemas.openxmlformats.org/drawingml/2006/main">
               <a:ext uri="{FF2B5EF4-FFF2-40B4-BE49-F238E27FC236}">
-                <a16:creationId xmlns:a16="http://schemas.microsoft.com/office/drawing/2014/main" id="{72243941-52BB-44BE-8B30-ACAB4C78DAD8}"/>
+                <a16:creationId xmlns:a16="http://schemas.microsoft.com/office/drawing/2014/main" id="{EF0B8F14-D8C5-4AD2-9C6C-A8909BDFB4DB}"/>
               </a:ext>
             </a:extLst>
           </p:cNvPr>
@@ -7766,7 +7766,7 @@
           <p:cNvPr id="18" name="">
             <a:extLst xmlns:a="http://schemas.openxmlformats.org/drawingml/2006/main">
               <a:ext uri="{FF2B5EF4-FFF2-40B4-BE49-F238E27FC236}">
-                <a16:creationId xmlns:a16="http://schemas.microsoft.com/office/drawing/2014/main" id="{D62911CE-9CE7-45B2-B02E-41F7FF83E254}"/>
+                <a16:creationId xmlns:a16="http://schemas.microsoft.com/office/drawing/2014/main" id="{325AA86F-72F4-4B9C-8F32-C69F07725AAC}"/>
               </a:ext>
             </a:extLst>
           </p:cNvPr>
@@ -7799,7 +7799,7 @@
           <p:cNvPr id="19" name="">
             <a:extLst xmlns:a="http://schemas.openxmlformats.org/drawingml/2006/main">
               <a:ext uri="{FF2B5EF4-FFF2-40B4-BE49-F238E27FC236}">
-                <a16:creationId xmlns:a16="http://schemas.microsoft.com/office/drawing/2014/main" id="{0219DDBF-A64A-4ABC-A54D-8542731C37F9}"/>
+                <a16:creationId xmlns:a16="http://schemas.microsoft.com/office/drawing/2014/main" id="{4F67EBF0-4D61-4C97-A17E-50C55F75A796}"/>
               </a:ext>
             </a:extLst>
           </p:cNvPr>
@@ -7956,7 +7956,7 @@
           <p:cNvPr id="20" name="">
             <a:extLst xmlns:a="http://schemas.openxmlformats.org/drawingml/2006/main">
               <a:ext uri="{FF2B5EF4-FFF2-40B4-BE49-F238E27FC236}">
-                <a16:creationId xmlns:a16="http://schemas.microsoft.com/office/drawing/2014/main" id="{6EFD2ECC-E71E-46A2-A7D2-61FF427EDE74}"/>
+                <a16:creationId xmlns:a16="http://schemas.microsoft.com/office/drawing/2014/main" id="{6C4C9526-2FA6-48F1-B511-3DFA62B79067}"/>
               </a:ext>
             </a:extLst>
           </p:cNvPr>
@@ -8113,7 +8113,7 @@
           <p:cNvPr id="21" name="">
             <a:extLst xmlns:a="http://schemas.openxmlformats.org/drawingml/2006/main">
               <a:ext uri="{FF2B5EF4-FFF2-40B4-BE49-F238E27FC236}">
-                <a16:creationId xmlns:a16="http://schemas.microsoft.com/office/drawing/2014/main" id="{05A36839-9290-47C1-908E-40F00393C8E9}"/>
+                <a16:creationId xmlns:a16="http://schemas.microsoft.com/office/drawing/2014/main" id="{B4AA0280-6FA2-45C5-9E4C-BB7212BDEDE1}"/>
               </a:ext>
             </a:extLst>
           </p:cNvPr>
@@ -8259,7 +8259,7 @@
                 <a:latin typeface="Avenir Next"/>
                 <a:ea typeface="Avenir Next"/>
                 <a:cs typeface="Avenir Next"/>
-                <a:hlinkClick xmlns:r="http://schemas.openxmlformats.org/officeDocument/2006/relationships" r:id="R039a068bff7b41ee"/>
+                <a:hlinkClick xmlns:r="http://schemas.openxmlformats.org/officeDocument/2006/relationships" r:id="R78f5c63dbfcf4cc6"/>
               </a:rPr>
               <a:t>Repositorio y código</a:t>
             </a:r>
@@ -8269,7 +8269,7 @@
     </p:spTree>
     <p:extLst>
       <p:ext uri="{BB962C8B-B14F-4D97-AF65-F5344CB8AC3E}">
-        <p14:creationId xmlns:p14="http://schemas.microsoft.com/office/powerpoint/2010/main" val="975580904"/>
+        <p14:creationId xmlns:p14="http://schemas.microsoft.com/office/powerpoint/2010/main" val="1855676016"/>
       </p:ext>
     </p:extLst>
   </p:cSld>
@@ -8300,7 +8300,7 @@
           <p:cNvPr id="18" name="">
             <a:extLst xmlns:a="http://schemas.openxmlformats.org/drawingml/2006/main">
               <a:ext uri="{FF2B5EF4-FFF2-40B4-BE49-F238E27FC236}">
-                <a16:creationId xmlns:a16="http://schemas.microsoft.com/office/drawing/2014/main" id="{76072913-89E8-4940-95A5-1E69176B4C06}"/>
+                <a16:creationId xmlns:a16="http://schemas.microsoft.com/office/drawing/2014/main" id="{5E0F760E-B0FE-4D0A-B3D6-FEF535944243}"/>
               </a:ext>
             </a:extLst>
           </p:cNvPr>
@@ -8331,7 +8331,7 @@
           <p:cNvPr id="2" name="">
             <a:extLst xmlns:a="http://schemas.openxmlformats.org/drawingml/2006/main">
               <a:ext uri="{FF2B5EF4-FFF2-40B4-BE49-F238E27FC236}">
-                <a16:creationId xmlns:a16="http://schemas.microsoft.com/office/drawing/2014/main" id="{AC817C9D-178A-47B3-8053-C9C9C755D103}"/>
+                <a16:creationId xmlns:a16="http://schemas.microsoft.com/office/drawing/2014/main" id="{70FD61F4-4D28-4B3A-8986-AAC4106F0EE6}"/>
               </a:ext>
             </a:extLst>
           </p:cNvPr>
@@ -8488,7 +8488,7 @@
           <p:cNvPr id="3" name="">
             <a:extLst xmlns:a="http://schemas.openxmlformats.org/drawingml/2006/main">
               <a:ext uri="{FF2B5EF4-FFF2-40B4-BE49-F238E27FC236}">
-                <a16:creationId xmlns:a16="http://schemas.microsoft.com/office/drawing/2014/main" id="{DD79612F-D2EA-45E0-AE8D-CEE3336BE449}"/>
+                <a16:creationId xmlns:a16="http://schemas.microsoft.com/office/drawing/2014/main" id="{0E1DBDE9-C9C4-4A5C-8AB5-ACEA3B1CF121}"/>
               </a:ext>
             </a:extLst>
           </p:cNvPr>
@@ -8645,7 +8645,7 @@
           <p:cNvPr id="4" name="">
             <a:extLst xmlns:a="http://schemas.openxmlformats.org/drawingml/2006/main">
               <a:ext uri="{FF2B5EF4-FFF2-40B4-BE49-F238E27FC236}">
-                <a16:creationId xmlns:a16="http://schemas.microsoft.com/office/drawing/2014/main" id="{F85F1216-3E4F-4721-ABB9-BCCD50799A1E}"/>
+                <a16:creationId xmlns:a16="http://schemas.microsoft.com/office/drawing/2014/main" id="{A6A3D3D6-A82B-449A-BB07-300A124CCA6B}"/>
               </a:ext>
             </a:extLst>
           </p:cNvPr>
@@ -8802,7 +8802,7 @@
           <p:cNvPr id="5" name="">
             <a:extLst xmlns:a="http://schemas.openxmlformats.org/drawingml/2006/main">
               <a:ext uri="{FF2B5EF4-FFF2-40B4-BE49-F238E27FC236}">
-                <a16:creationId xmlns:a16="http://schemas.microsoft.com/office/drawing/2014/main" id="{69CF3472-48F6-4F67-B039-062FBA5AE0EB}"/>
+                <a16:creationId xmlns:a16="http://schemas.microsoft.com/office/drawing/2014/main" id="{54051C07-90D2-42CC-A9AD-1F6315F99DA5}"/>
               </a:ext>
             </a:extLst>
           </p:cNvPr>
@@ -8833,7 +8833,7 @@
           <p:cNvPr id="6" name="">
             <a:extLst xmlns:a="http://schemas.openxmlformats.org/drawingml/2006/main">
               <a:ext uri="{FF2B5EF4-FFF2-40B4-BE49-F238E27FC236}">
-                <a16:creationId xmlns:a16="http://schemas.microsoft.com/office/drawing/2014/main" id="{5F231816-3B96-4B5B-9AD7-4F5CFA0E5DE3}"/>
+                <a16:creationId xmlns:a16="http://schemas.microsoft.com/office/drawing/2014/main" id="{D89AEE2E-2294-4916-9670-2A79E887C926}"/>
               </a:ext>
             </a:extLst>
           </p:cNvPr>
@@ -8990,7 +8990,7 @@
           <p:cNvPr id="7" name="">
             <a:extLst xmlns:a="http://schemas.openxmlformats.org/drawingml/2006/main">
               <a:ext uri="{FF2B5EF4-FFF2-40B4-BE49-F238E27FC236}">
-                <a16:creationId xmlns:a16="http://schemas.microsoft.com/office/drawing/2014/main" id="{E92CB9D5-05C6-49CB-BDA9-0D4AB84E7531}"/>
+                <a16:creationId xmlns:a16="http://schemas.microsoft.com/office/drawing/2014/main" id="{3DE64AAD-0D5D-4465-9F4F-D8DF20F4D8BA}"/>
               </a:ext>
             </a:extLst>
           </p:cNvPr>
@@ -9147,7 +9147,7 @@
           <p:cNvPr id="8" name="">
             <a:extLst xmlns:a="http://schemas.openxmlformats.org/drawingml/2006/main">
               <a:ext uri="{FF2B5EF4-FFF2-40B4-BE49-F238E27FC236}">
-                <a16:creationId xmlns:a16="http://schemas.microsoft.com/office/drawing/2014/main" id="{7368E9FD-D563-4F64-AF90-84C10CCDD5A7}"/>
+                <a16:creationId xmlns:a16="http://schemas.microsoft.com/office/drawing/2014/main" id="{624F2295-7AED-4A15-A244-9897C58BB025}"/>
               </a:ext>
             </a:extLst>
           </p:cNvPr>
@@ -9180,7 +9180,7 @@
           <p:cNvPr id="9" name="">
             <a:extLst xmlns:a="http://schemas.openxmlformats.org/drawingml/2006/main">
               <a:ext uri="{FF2B5EF4-FFF2-40B4-BE49-F238E27FC236}">
-                <a16:creationId xmlns:a16="http://schemas.microsoft.com/office/drawing/2014/main" id="{B137009A-9BB3-4002-AA13-7E2B99E3D883}"/>
+                <a16:creationId xmlns:a16="http://schemas.microsoft.com/office/drawing/2014/main" id="{6E2857C6-27C8-491E-8F7C-C1B3F0144C95}"/>
               </a:ext>
             </a:extLst>
           </p:cNvPr>
@@ -9337,7 +9337,7 @@
           <p:cNvPr id="10" name="">
             <a:extLst xmlns:a="http://schemas.openxmlformats.org/drawingml/2006/main">
               <a:ext uri="{FF2B5EF4-FFF2-40B4-BE49-F238E27FC236}">
-                <a16:creationId xmlns:a16="http://schemas.microsoft.com/office/drawing/2014/main" id="{C8109CEF-F352-4A6C-835A-BEFCFF72D616}"/>
+                <a16:creationId xmlns:a16="http://schemas.microsoft.com/office/drawing/2014/main" id="{06CFA4D9-6C5F-4854-BFEC-FA59B406B18E}"/>
               </a:ext>
             </a:extLst>
           </p:cNvPr>
@@ -9517,7 +9517,7 @@
           <p:cNvPr id="11" name="">
             <a:extLst xmlns:a="http://schemas.openxmlformats.org/drawingml/2006/main">
               <a:ext uri="{FF2B5EF4-FFF2-40B4-BE49-F238E27FC236}">
-                <a16:creationId xmlns:a16="http://schemas.microsoft.com/office/drawing/2014/main" id="{E3C29E2B-5E86-45E5-A7F4-12B3771CFA6B}"/>
+                <a16:creationId xmlns:a16="http://schemas.microsoft.com/office/drawing/2014/main" id="{027AF405-68A3-4182-97DA-D7B02A9840CF}"/>
               </a:ext>
             </a:extLst>
           </p:cNvPr>
@@ -9550,7 +9550,7 @@
           <p:cNvPr id="12" name="">
             <a:extLst xmlns:a="http://schemas.openxmlformats.org/drawingml/2006/main">
               <a:ext uri="{FF2B5EF4-FFF2-40B4-BE49-F238E27FC236}">
-                <a16:creationId xmlns:a16="http://schemas.microsoft.com/office/drawing/2014/main" id="{614A73AA-4201-4AA6-BA84-390F600959FE}"/>
+                <a16:creationId xmlns:a16="http://schemas.microsoft.com/office/drawing/2014/main" id="{0521F062-CB1B-4EEE-8D03-77F5A196DE46}"/>
               </a:ext>
             </a:extLst>
           </p:cNvPr>
@@ -9707,7 +9707,7 @@
           <p:cNvPr id="13" name="">
             <a:extLst xmlns:a="http://schemas.openxmlformats.org/drawingml/2006/main">
               <a:ext uri="{FF2B5EF4-FFF2-40B4-BE49-F238E27FC236}">
-                <a16:creationId xmlns:a16="http://schemas.microsoft.com/office/drawing/2014/main" id="{627A011F-08FC-4409-B047-6975F055F364}"/>
+                <a16:creationId xmlns:a16="http://schemas.microsoft.com/office/drawing/2014/main" id="{17072260-68FD-4D9A-81A5-56E284F527F3}"/>
               </a:ext>
             </a:extLst>
           </p:cNvPr>
@@ -9887,7 +9887,7 @@
           <p:cNvPr id="14" name="">
             <a:extLst xmlns:a="http://schemas.openxmlformats.org/drawingml/2006/main">
               <a:ext uri="{FF2B5EF4-FFF2-40B4-BE49-F238E27FC236}">
-                <a16:creationId xmlns:a16="http://schemas.microsoft.com/office/drawing/2014/main" id="{0F25C73C-AD3D-4139-8E44-EE6E955A97C4}"/>
+                <a16:creationId xmlns:a16="http://schemas.microsoft.com/office/drawing/2014/main" id="{C99C4C69-366F-4AC6-A5C7-AC7AD41CFA7A}"/>
               </a:ext>
             </a:extLst>
           </p:cNvPr>
@@ -9920,7 +9920,7 @@
           <p:cNvPr id="15" name="">
             <a:extLst xmlns:a="http://schemas.openxmlformats.org/drawingml/2006/main">
               <a:ext uri="{FF2B5EF4-FFF2-40B4-BE49-F238E27FC236}">
-                <a16:creationId xmlns:a16="http://schemas.microsoft.com/office/drawing/2014/main" id="{388602A3-EA8A-4549-92DE-21256CE32DE1}"/>
+                <a16:creationId xmlns:a16="http://schemas.microsoft.com/office/drawing/2014/main" id="{94065704-4EEA-4A18-91E4-7D292BEA96B6}"/>
               </a:ext>
             </a:extLst>
           </p:cNvPr>
@@ -9930,7 +9930,7 @@
           <p:nvPr/>
         </p:nvPicPr>
         <p:blipFill>
-          <a:blip xmlns:r="http://schemas.openxmlformats.org/officeDocument/2006/relationships" xmlns:a="http://schemas.openxmlformats.org/drawingml/2006/main" r:embed="Ra3e49aff25d34f0a"/>
+          <a:blip xmlns:r="http://schemas.openxmlformats.org/officeDocument/2006/relationships" xmlns:a="http://schemas.openxmlformats.org/drawingml/2006/main" r:embed="Rf33ff51dc8964a4d"/>
           <a:stretch xmlns:a="http://schemas.openxmlformats.org/drawingml/2006/main"/>
         </p:blipFill>
         <p:spPr>
@@ -9950,7 +9950,7 @@
           <p:cNvPr id="16" name="">
             <a:extLst xmlns:a="http://schemas.openxmlformats.org/drawingml/2006/main">
               <a:ext uri="{FF2B5EF4-FFF2-40B4-BE49-F238E27FC236}">
-                <a16:creationId xmlns:a16="http://schemas.microsoft.com/office/drawing/2014/main" id="{B5E232D7-66E7-4F32-B437-72C329AB4697}"/>
+                <a16:creationId xmlns:a16="http://schemas.microsoft.com/office/drawing/2014/main" id="{A0E7D824-86C7-4993-8F89-5A8A68312497}"/>
               </a:ext>
             </a:extLst>
           </p:cNvPr>
@@ -10107,7 +10107,7 @@
           <p:cNvPr id="17" name="">
             <a:extLst xmlns:a="http://schemas.openxmlformats.org/drawingml/2006/main">
               <a:ext uri="{FF2B5EF4-FFF2-40B4-BE49-F238E27FC236}">
-                <a16:creationId xmlns:a16="http://schemas.microsoft.com/office/drawing/2014/main" id="{E9E57225-4FCE-48F0-8415-F8D589D59650}"/>
+                <a16:creationId xmlns:a16="http://schemas.microsoft.com/office/drawing/2014/main" id="{5FDF9AC9-4AC5-43DB-89C1-7AF4F111B29E}"/>
               </a:ext>
             </a:extLst>
           </p:cNvPr>
@@ -10262,7 +10262,7 @@
     </p:spTree>
     <p:extLst>
       <p:ext uri="{BB962C8B-B14F-4D97-AF65-F5344CB8AC3E}">
-        <p14:creationId xmlns:p14="http://schemas.microsoft.com/office/powerpoint/2010/main" val="1540248039"/>
+        <p14:creationId xmlns:p14="http://schemas.microsoft.com/office/powerpoint/2010/main" val="1279488911"/>
       </p:ext>
     </p:extLst>
   </p:cSld>
@@ -10293,7 +10293,7 @@
           <p:cNvPr id="25" name="">
             <a:extLst xmlns:a="http://schemas.openxmlformats.org/drawingml/2006/main">
               <a:ext uri="{FF2B5EF4-FFF2-40B4-BE49-F238E27FC236}">
-                <a16:creationId xmlns:a16="http://schemas.microsoft.com/office/drawing/2014/main" id="{ADD37B3B-D093-480C-8F00-ED6BB4DA97FE}"/>
+                <a16:creationId xmlns:a16="http://schemas.microsoft.com/office/drawing/2014/main" id="{44E33972-1AFC-44DC-B157-71DB4F82E6C4}"/>
               </a:ext>
             </a:extLst>
           </p:cNvPr>
@@ -10324,7 +10324,7 @@
           <p:cNvPr id="2" name="">
             <a:extLst xmlns:a="http://schemas.openxmlformats.org/drawingml/2006/main">
               <a:ext uri="{FF2B5EF4-FFF2-40B4-BE49-F238E27FC236}">
-                <a16:creationId xmlns:a16="http://schemas.microsoft.com/office/drawing/2014/main" id="{12F0F5AE-5361-4886-B48C-679BEC63B9EE}"/>
+                <a16:creationId xmlns:a16="http://schemas.microsoft.com/office/drawing/2014/main" id="{9F790F82-CFF3-4318-93A3-ECF1EE304109}"/>
               </a:ext>
             </a:extLst>
           </p:cNvPr>
@@ -10481,7 +10481,7 @@
           <p:cNvPr id="3" name="">
             <a:extLst xmlns:a="http://schemas.openxmlformats.org/drawingml/2006/main">
               <a:ext uri="{FF2B5EF4-FFF2-40B4-BE49-F238E27FC236}">
-                <a16:creationId xmlns:a16="http://schemas.microsoft.com/office/drawing/2014/main" id="{F5A734EC-393D-4510-8EAB-E79669751F0A}"/>
+                <a16:creationId xmlns:a16="http://schemas.microsoft.com/office/drawing/2014/main" id="{D03374D2-D0AA-4792-A0DB-536A9417286B}"/>
               </a:ext>
             </a:extLst>
           </p:cNvPr>
@@ -10638,7 +10638,7 @@
           <p:cNvPr id="4" name="">
             <a:extLst xmlns:a="http://schemas.openxmlformats.org/drawingml/2006/main">
               <a:ext uri="{FF2B5EF4-FFF2-40B4-BE49-F238E27FC236}">
-                <a16:creationId xmlns:a16="http://schemas.microsoft.com/office/drawing/2014/main" id="{5665E02E-6199-4267-A4D3-875F5AD61036}"/>
+                <a16:creationId xmlns:a16="http://schemas.microsoft.com/office/drawing/2014/main" id="{D5BC5609-65E9-41AE-8883-5AF3F47717A7}"/>
               </a:ext>
             </a:extLst>
           </p:cNvPr>
@@ -10795,7 +10795,7 @@
           <p:cNvPr id="5" name="">
             <a:extLst xmlns:a="http://schemas.openxmlformats.org/drawingml/2006/main">
               <a:ext uri="{FF2B5EF4-FFF2-40B4-BE49-F238E27FC236}">
-                <a16:creationId xmlns:a16="http://schemas.microsoft.com/office/drawing/2014/main" id="{FE68EE16-8266-4C8C-926D-CA137843BD5B}"/>
+                <a16:creationId xmlns:a16="http://schemas.microsoft.com/office/drawing/2014/main" id="{0DBDD9F2-2ABC-436C-A34D-A34937000C1B}"/>
               </a:ext>
             </a:extLst>
           </p:cNvPr>
@@ -10826,7 +10826,7 @@
           <p:cNvPr id="6" name="">
             <a:extLst xmlns:a="http://schemas.openxmlformats.org/drawingml/2006/main">
               <a:ext uri="{FF2B5EF4-FFF2-40B4-BE49-F238E27FC236}">
-                <a16:creationId xmlns:a16="http://schemas.microsoft.com/office/drawing/2014/main" id="{7871C315-A730-4492-82B2-228C1C58F841}"/>
+                <a16:creationId xmlns:a16="http://schemas.microsoft.com/office/drawing/2014/main" id="{45A7A780-9D12-4460-8196-5E3510CD58D5}"/>
               </a:ext>
             </a:extLst>
           </p:cNvPr>
@@ -10983,7 +10983,7 @@
           <p:cNvPr id="7" name="">
             <a:extLst xmlns:a="http://schemas.openxmlformats.org/drawingml/2006/main">
               <a:ext uri="{FF2B5EF4-FFF2-40B4-BE49-F238E27FC236}">
-                <a16:creationId xmlns:a16="http://schemas.microsoft.com/office/drawing/2014/main" id="{82430060-61FF-45D4-896F-D22DA9EB5FB2}"/>
+                <a16:creationId xmlns:a16="http://schemas.microsoft.com/office/drawing/2014/main" id="{79921C31-B0B2-4209-AA21-8BA56C02DC5E}"/>
               </a:ext>
             </a:extLst>
           </p:cNvPr>
@@ -11140,7 +11140,7 @@
           <p:cNvPr id="8" name="">
             <a:extLst xmlns:a="http://schemas.openxmlformats.org/drawingml/2006/main">
               <a:ext uri="{FF2B5EF4-FFF2-40B4-BE49-F238E27FC236}">
-                <a16:creationId xmlns:a16="http://schemas.microsoft.com/office/drawing/2014/main" id="{10CE322C-7F88-4097-BC2C-92883E9B9AD0}"/>
+                <a16:creationId xmlns:a16="http://schemas.microsoft.com/office/drawing/2014/main" id="{E4AF06F2-0FCC-424E-8DD9-8DEC39D610CA}"/>
               </a:ext>
             </a:extLst>
           </p:cNvPr>
@@ -11171,7 +11171,7 @@
           <p:cNvPr id="9" name="">
             <a:extLst xmlns:a="http://schemas.openxmlformats.org/drawingml/2006/main">
               <a:ext uri="{FF2B5EF4-FFF2-40B4-BE49-F238E27FC236}">
-                <a16:creationId xmlns:a16="http://schemas.microsoft.com/office/drawing/2014/main" id="{A71E52F4-9F93-426A-8142-4389EA1B6FF4}"/>
+                <a16:creationId xmlns:a16="http://schemas.microsoft.com/office/drawing/2014/main" id="{2B2D9875-04FA-4372-8831-D65B4DC62902}"/>
               </a:ext>
             </a:extLst>
           </p:cNvPr>
@@ -11204,7 +11204,7 @@
           <p:cNvPr id="10" name="">
             <a:extLst xmlns:a="http://schemas.openxmlformats.org/drawingml/2006/main">
               <a:ext uri="{FF2B5EF4-FFF2-40B4-BE49-F238E27FC236}">
-                <a16:creationId xmlns:a16="http://schemas.microsoft.com/office/drawing/2014/main" id="{1EACA5B4-F9FF-41DF-995B-9511851A8B95}"/>
+                <a16:creationId xmlns:a16="http://schemas.microsoft.com/office/drawing/2014/main" id="{C0EFF074-7A1B-4A94-A265-5866E461CB62}"/>
               </a:ext>
             </a:extLst>
           </p:cNvPr>
@@ -11237,7 +11237,7 @@
           <p:cNvPr id="11" name="">
             <a:extLst xmlns:a="http://schemas.openxmlformats.org/drawingml/2006/main">
               <a:ext uri="{FF2B5EF4-FFF2-40B4-BE49-F238E27FC236}">
-                <a16:creationId xmlns:a16="http://schemas.microsoft.com/office/drawing/2014/main" id="{2A9F25C2-7030-4582-8638-CFA5327622EE}"/>
+                <a16:creationId xmlns:a16="http://schemas.microsoft.com/office/drawing/2014/main" id="{4CB20FB3-A1BA-4879-BACB-5E021EE3D822}"/>
               </a:ext>
             </a:extLst>
           </p:cNvPr>
@@ -11394,7 +11394,7 @@
           <p:cNvPr id="12" name="">
             <a:extLst xmlns:a="http://schemas.openxmlformats.org/drawingml/2006/main">
               <a:ext uri="{FF2B5EF4-FFF2-40B4-BE49-F238E27FC236}">
-                <a16:creationId xmlns:a16="http://schemas.microsoft.com/office/drawing/2014/main" id="{72333E1C-C80B-4FBC-8F52-7AD560D8428C}"/>
+                <a16:creationId xmlns:a16="http://schemas.microsoft.com/office/drawing/2014/main" id="{8A872844-3D3A-4F5C-BD9B-F4403FB417BF}"/>
               </a:ext>
             </a:extLst>
           </p:cNvPr>
@@ -11551,7 +11551,7 @@
           <p:cNvPr id="13" name="">
             <a:extLst xmlns:a="http://schemas.openxmlformats.org/drawingml/2006/main">
               <a:ext uri="{FF2B5EF4-FFF2-40B4-BE49-F238E27FC236}">
-                <a16:creationId xmlns:a16="http://schemas.microsoft.com/office/drawing/2014/main" id="{43CD61AA-6EC1-42DF-877D-BF4D0EBE9865}"/>
+                <a16:creationId xmlns:a16="http://schemas.microsoft.com/office/drawing/2014/main" id="{46FA601E-0A0B-49D6-BA7C-596575B56FD1}"/>
               </a:ext>
             </a:extLst>
           </p:cNvPr>
@@ -11731,7 +11731,7 @@
           <p:cNvPr id="14" name="">
             <a:extLst xmlns:a="http://schemas.openxmlformats.org/drawingml/2006/main">
               <a:ext uri="{FF2B5EF4-FFF2-40B4-BE49-F238E27FC236}">
-                <a16:creationId xmlns:a16="http://schemas.microsoft.com/office/drawing/2014/main" id="{1E299ADB-97F3-4F84-9728-716FB44B8588}"/>
+                <a16:creationId xmlns:a16="http://schemas.microsoft.com/office/drawing/2014/main" id="{4F461F70-16C2-428D-BB4F-729BE52DB1B8}"/>
               </a:ext>
             </a:extLst>
           </p:cNvPr>
@@ -11764,7 +11764,7 @@
           <p:cNvPr id="15" name="">
             <a:extLst xmlns:a="http://schemas.openxmlformats.org/drawingml/2006/main">
               <a:ext uri="{FF2B5EF4-FFF2-40B4-BE49-F238E27FC236}">
-                <a16:creationId xmlns:a16="http://schemas.microsoft.com/office/drawing/2014/main" id="{00052CF7-502F-4EC8-BCEA-B81D34967C9C}"/>
+                <a16:creationId xmlns:a16="http://schemas.microsoft.com/office/drawing/2014/main" id="{F839D1F7-A704-437C-9012-F0F926213A3E}"/>
               </a:ext>
             </a:extLst>
           </p:cNvPr>
@@ -11797,7 +11797,7 @@
           <p:cNvPr id="16" name="">
             <a:extLst xmlns:a="http://schemas.openxmlformats.org/drawingml/2006/main">
               <a:ext uri="{FF2B5EF4-FFF2-40B4-BE49-F238E27FC236}">
-                <a16:creationId xmlns:a16="http://schemas.microsoft.com/office/drawing/2014/main" id="{1C714DFD-E071-4FF0-B2FC-BB220089821A}"/>
+                <a16:creationId xmlns:a16="http://schemas.microsoft.com/office/drawing/2014/main" id="{0765FEBB-232E-4D61-8924-2B447D3A4990}"/>
               </a:ext>
             </a:extLst>
           </p:cNvPr>
@@ -11954,7 +11954,7 @@
           <p:cNvPr id="17" name="">
             <a:extLst xmlns:a="http://schemas.openxmlformats.org/drawingml/2006/main">
               <a:ext uri="{FF2B5EF4-FFF2-40B4-BE49-F238E27FC236}">
-                <a16:creationId xmlns:a16="http://schemas.microsoft.com/office/drawing/2014/main" id="{E7372A63-A00A-4869-827C-753F440B7075}"/>
+                <a16:creationId xmlns:a16="http://schemas.microsoft.com/office/drawing/2014/main" id="{2B111439-DA57-4031-A4DA-0334C370481F}"/>
               </a:ext>
             </a:extLst>
           </p:cNvPr>
@@ -12111,7 +12111,7 @@
           <p:cNvPr id="18" name="">
             <a:extLst xmlns:a="http://schemas.openxmlformats.org/drawingml/2006/main">
               <a:ext uri="{FF2B5EF4-FFF2-40B4-BE49-F238E27FC236}">
-                <a16:creationId xmlns:a16="http://schemas.microsoft.com/office/drawing/2014/main" id="{3A0A8EA4-F290-4A97-8A3A-621648E99037}"/>
+                <a16:creationId xmlns:a16="http://schemas.microsoft.com/office/drawing/2014/main" id="{65D0C3D1-8EEC-475D-9C7C-F66E84427B38}"/>
               </a:ext>
             </a:extLst>
           </p:cNvPr>
@@ -12291,7 +12291,7 @@
           <p:cNvPr id="19" name="">
             <a:extLst xmlns:a="http://schemas.openxmlformats.org/drawingml/2006/main">
               <a:ext uri="{FF2B5EF4-FFF2-40B4-BE49-F238E27FC236}">
-                <a16:creationId xmlns:a16="http://schemas.microsoft.com/office/drawing/2014/main" id="{5FAAA6F5-26A0-43FB-AAE9-6B7DE4F61A4F}"/>
+                <a16:creationId xmlns:a16="http://schemas.microsoft.com/office/drawing/2014/main" id="{1E66ABAB-B21E-4133-B48C-28CAE3BFDAE8}"/>
               </a:ext>
             </a:extLst>
           </p:cNvPr>
@@ -12324,7 +12324,7 @@
           <p:cNvPr id="20" name="">
             <a:extLst xmlns:a="http://schemas.openxmlformats.org/drawingml/2006/main">
               <a:ext uri="{FF2B5EF4-FFF2-40B4-BE49-F238E27FC236}">
-                <a16:creationId xmlns:a16="http://schemas.microsoft.com/office/drawing/2014/main" id="{CD6F9481-8F8C-4E98-B129-60E0FD302CA2}"/>
+                <a16:creationId xmlns:a16="http://schemas.microsoft.com/office/drawing/2014/main" id="{A3222A0F-5A7F-467E-88D1-9C1E1E71F6D8}"/>
               </a:ext>
             </a:extLst>
           </p:cNvPr>
@@ -12357,7 +12357,7 @@
           <p:cNvPr id="21" name="">
             <a:extLst xmlns:a="http://schemas.openxmlformats.org/drawingml/2006/main">
               <a:ext uri="{FF2B5EF4-FFF2-40B4-BE49-F238E27FC236}">
-                <a16:creationId xmlns:a16="http://schemas.microsoft.com/office/drawing/2014/main" id="{9001AF3C-A7F8-4F83-8D95-EED342BBDA74}"/>
+                <a16:creationId xmlns:a16="http://schemas.microsoft.com/office/drawing/2014/main" id="{192D400D-3AF6-4609-84DE-8ED766A1A22D}"/>
               </a:ext>
             </a:extLst>
           </p:cNvPr>
@@ -12514,7 +12514,7 @@
           <p:cNvPr id="22" name="">
             <a:extLst xmlns:a="http://schemas.openxmlformats.org/drawingml/2006/main">
               <a:ext uri="{FF2B5EF4-FFF2-40B4-BE49-F238E27FC236}">
-                <a16:creationId xmlns:a16="http://schemas.microsoft.com/office/drawing/2014/main" id="{12615FCD-D5E6-4F79-BBF6-26538E63250B}"/>
+                <a16:creationId xmlns:a16="http://schemas.microsoft.com/office/drawing/2014/main" id="{7A042C38-CBC7-43BE-BCB8-C40576D20EE4}"/>
               </a:ext>
             </a:extLst>
           </p:cNvPr>
@@ -12671,7 +12671,7 @@
           <p:cNvPr id="23" name="">
             <a:extLst xmlns:a="http://schemas.openxmlformats.org/drawingml/2006/main">
               <a:ext uri="{FF2B5EF4-FFF2-40B4-BE49-F238E27FC236}">
-                <a16:creationId xmlns:a16="http://schemas.microsoft.com/office/drawing/2014/main" id="{78E758A1-7FED-4C3D-B619-07BC6FBD0784}"/>
+                <a16:creationId xmlns:a16="http://schemas.microsoft.com/office/drawing/2014/main" id="{5EAF4422-30BF-46F9-B280-22F61A393AD7}"/>
               </a:ext>
             </a:extLst>
           </p:cNvPr>
@@ -12851,7 +12851,7 @@
           <p:cNvPr id="24" name="">
             <a:extLst xmlns:a="http://schemas.openxmlformats.org/drawingml/2006/main">
               <a:ext uri="{FF2B5EF4-FFF2-40B4-BE49-F238E27FC236}">
-                <a16:creationId xmlns:a16="http://schemas.microsoft.com/office/drawing/2014/main" id="{5EF78D8F-442E-4B80-884A-F36CDD1D3613}"/>
+                <a16:creationId xmlns:a16="http://schemas.microsoft.com/office/drawing/2014/main" id="{9E3ED7E4-1385-4F40-8678-3C299F7BFBFA}"/>
               </a:ext>
             </a:extLst>
           </p:cNvPr>
@@ -13006,7 +13006,7 @@
     </p:spTree>
     <p:extLst>
       <p:ext uri="{BB962C8B-B14F-4D97-AF65-F5344CB8AC3E}">
-        <p14:creationId xmlns:p14="http://schemas.microsoft.com/office/powerpoint/2010/main" val="1040367580"/>
+        <p14:creationId xmlns:p14="http://schemas.microsoft.com/office/powerpoint/2010/main" val="1033300638"/>
       </p:ext>
     </p:extLst>
   </p:cSld>
@@ -13037,7 +13037,7 @@
           <p:cNvPr id="35" name="">
             <a:extLst xmlns:a="http://schemas.openxmlformats.org/drawingml/2006/main">
               <a:ext uri="{FF2B5EF4-FFF2-40B4-BE49-F238E27FC236}">
-                <a16:creationId xmlns:a16="http://schemas.microsoft.com/office/drawing/2014/main" id="{8E2E7907-42D3-4B56-8625-9A97B1197CBD}"/>
+                <a16:creationId xmlns:a16="http://schemas.microsoft.com/office/drawing/2014/main" id="{E0236D65-70D7-49EB-868D-9FA6EC48A10C}"/>
               </a:ext>
             </a:extLst>
           </p:cNvPr>
@@ -13068,7 +13068,7 @@
           <p:cNvPr id="2" name="">
             <a:extLst xmlns:a="http://schemas.openxmlformats.org/drawingml/2006/main">
               <a:ext uri="{FF2B5EF4-FFF2-40B4-BE49-F238E27FC236}">
-                <a16:creationId xmlns:a16="http://schemas.microsoft.com/office/drawing/2014/main" id="{03BE8C03-2805-437C-B940-AA2E9FE8351A}"/>
+                <a16:creationId xmlns:a16="http://schemas.microsoft.com/office/drawing/2014/main" id="{949C7535-299C-42AE-9E4E-8036A339BF07}"/>
               </a:ext>
             </a:extLst>
           </p:cNvPr>
@@ -13225,7 +13225,7 @@
           <p:cNvPr id="3" name="">
             <a:extLst xmlns:a="http://schemas.openxmlformats.org/drawingml/2006/main">
               <a:ext uri="{FF2B5EF4-FFF2-40B4-BE49-F238E27FC236}">
-                <a16:creationId xmlns:a16="http://schemas.microsoft.com/office/drawing/2014/main" id="{A0499CBC-482F-4258-98CA-11E6339F6FDF}"/>
+                <a16:creationId xmlns:a16="http://schemas.microsoft.com/office/drawing/2014/main" id="{DD101721-82B9-491B-974C-DD3A8530D695}"/>
               </a:ext>
             </a:extLst>
           </p:cNvPr>
@@ -13382,7 +13382,7 @@
           <p:cNvPr id="4" name="">
             <a:extLst xmlns:a="http://schemas.openxmlformats.org/drawingml/2006/main">
               <a:ext uri="{FF2B5EF4-FFF2-40B4-BE49-F238E27FC236}">
-                <a16:creationId xmlns:a16="http://schemas.microsoft.com/office/drawing/2014/main" id="{24A7612D-DD2C-4FC6-9172-967FAB5D9B29}"/>
+                <a16:creationId xmlns:a16="http://schemas.microsoft.com/office/drawing/2014/main" id="{C0F9CA33-2F03-47EF-BB47-2588C437BC99}"/>
               </a:ext>
             </a:extLst>
           </p:cNvPr>
@@ -13539,7 +13539,7 @@
           <p:cNvPr id="5" name="">
             <a:extLst xmlns:a="http://schemas.openxmlformats.org/drawingml/2006/main">
               <a:ext uri="{FF2B5EF4-FFF2-40B4-BE49-F238E27FC236}">
-                <a16:creationId xmlns:a16="http://schemas.microsoft.com/office/drawing/2014/main" id="{750F4074-D055-4DA2-9E66-B002E4A0C6F1}"/>
+                <a16:creationId xmlns:a16="http://schemas.microsoft.com/office/drawing/2014/main" id="{62936362-4BDC-4DCE-9364-FD1DD7553347}"/>
               </a:ext>
             </a:extLst>
           </p:cNvPr>
@@ -13570,7 +13570,7 @@
           <p:cNvPr id="6" name="">
             <a:extLst xmlns:a="http://schemas.openxmlformats.org/drawingml/2006/main">
               <a:ext uri="{FF2B5EF4-FFF2-40B4-BE49-F238E27FC236}">
-                <a16:creationId xmlns:a16="http://schemas.microsoft.com/office/drawing/2014/main" id="{4F26F557-110E-4179-8505-9329DABAA0DF}"/>
+                <a16:creationId xmlns:a16="http://schemas.microsoft.com/office/drawing/2014/main" id="{F81EF791-EE5C-4547-A2B0-FFE2356AEE8E}"/>
               </a:ext>
             </a:extLst>
           </p:cNvPr>
@@ -13727,7 +13727,7 @@
           <p:cNvPr id="7" name="">
             <a:extLst xmlns:a="http://schemas.openxmlformats.org/drawingml/2006/main">
               <a:ext uri="{FF2B5EF4-FFF2-40B4-BE49-F238E27FC236}">
-                <a16:creationId xmlns:a16="http://schemas.microsoft.com/office/drawing/2014/main" id="{21E94B63-E20C-45E4-9431-FDA5AF10986B}"/>
+                <a16:creationId xmlns:a16="http://schemas.microsoft.com/office/drawing/2014/main" id="{F9C25A32-EEE0-42FC-BD06-22F980D1813E}"/>
               </a:ext>
             </a:extLst>
           </p:cNvPr>
@@ -13884,7 +13884,7 @@
           <p:cNvPr id="8" name="">
             <a:extLst xmlns:a="http://schemas.openxmlformats.org/drawingml/2006/main">
               <a:ext uri="{FF2B5EF4-FFF2-40B4-BE49-F238E27FC236}">
-                <a16:creationId xmlns:a16="http://schemas.microsoft.com/office/drawing/2014/main" id="{83AC038D-2CB8-4EB8-A4B6-000E1BD71D64}"/>
+                <a16:creationId xmlns:a16="http://schemas.microsoft.com/office/drawing/2014/main" id="{C6D8014D-7E70-4DA5-A426-01B47E514D7C}"/>
               </a:ext>
             </a:extLst>
           </p:cNvPr>
@@ -14041,7 +14041,7 @@
           <p:cNvPr id="9" name="">
             <a:extLst xmlns:a="http://schemas.openxmlformats.org/drawingml/2006/main">
               <a:ext uri="{FF2B5EF4-FFF2-40B4-BE49-F238E27FC236}">
-                <a16:creationId xmlns:a16="http://schemas.microsoft.com/office/drawing/2014/main" id="{D880DED6-0503-4969-A01A-6BA037940613}"/>
+                <a16:creationId xmlns:a16="http://schemas.microsoft.com/office/drawing/2014/main" id="{ECCDC931-A54A-41A0-856F-BC896CB40872}"/>
               </a:ext>
             </a:extLst>
           </p:cNvPr>
@@ -14074,7 +14074,7 @@
           <p:cNvPr id="10" name="">
             <a:extLst xmlns:a="http://schemas.openxmlformats.org/drawingml/2006/main">
               <a:ext uri="{FF2B5EF4-FFF2-40B4-BE49-F238E27FC236}">
-                <a16:creationId xmlns:a16="http://schemas.microsoft.com/office/drawing/2014/main" id="{4F78F561-72EF-44EC-8C89-14CDF6531761}"/>
+                <a16:creationId xmlns:a16="http://schemas.microsoft.com/office/drawing/2014/main" id="{AE7F0857-7B6D-4CCA-9568-B71CA694197B}"/>
               </a:ext>
             </a:extLst>
           </p:cNvPr>
@@ -14254,7 +14254,7 @@
           <p:cNvPr id="11" name="">
             <a:extLst xmlns:a="http://schemas.openxmlformats.org/drawingml/2006/main">
               <a:ext uri="{FF2B5EF4-FFF2-40B4-BE49-F238E27FC236}">
-                <a16:creationId xmlns:a16="http://schemas.microsoft.com/office/drawing/2014/main" id="{FDAF46B6-3411-4337-8541-EB3DEC691F4E}"/>
+                <a16:creationId xmlns:a16="http://schemas.microsoft.com/office/drawing/2014/main" id="{44A1B51C-39B8-4194-B0CF-CAE5EBB9ED63}"/>
               </a:ext>
             </a:extLst>
           </p:cNvPr>
@@ -14411,7 +14411,7 @@
           <p:cNvPr id="12" name="">
             <a:extLst xmlns:a="http://schemas.openxmlformats.org/drawingml/2006/main">
               <a:ext uri="{FF2B5EF4-FFF2-40B4-BE49-F238E27FC236}">
-                <a16:creationId xmlns:a16="http://schemas.microsoft.com/office/drawing/2014/main" id="{B12F242E-225E-4760-891D-F576E898F1A6}"/>
+                <a16:creationId xmlns:a16="http://schemas.microsoft.com/office/drawing/2014/main" id="{04546DA1-2FB5-4042-9B22-B61BFD750C77}"/>
               </a:ext>
             </a:extLst>
           </p:cNvPr>
@@ -14444,7 +14444,7 @@
           <p:cNvPr id="13" name="">
             <a:extLst xmlns:a="http://schemas.openxmlformats.org/drawingml/2006/main">
               <a:ext uri="{FF2B5EF4-FFF2-40B4-BE49-F238E27FC236}">
-                <a16:creationId xmlns:a16="http://schemas.microsoft.com/office/drawing/2014/main" id="{E56C922C-8EF2-441F-A028-784996F13E30}"/>
+                <a16:creationId xmlns:a16="http://schemas.microsoft.com/office/drawing/2014/main" id="{044B7F39-BA00-4C7F-BB27-A77A9FE74DA1}"/>
               </a:ext>
             </a:extLst>
           </p:cNvPr>
@@ -14624,7 +14624,7 @@
           <p:cNvPr id="14" name="">
             <a:extLst xmlns:a="http://schemas.openxmlformats.org/drawingml/2006/main">
               <a:ext uri="{FF2B5EF4-FFF2-40B4-BE49-F238E27FC236}">
-                <a16:creationId xmlns:a16="http://schemas.microsoft.com/office/drawing/2014/main" id="{69FF3AFA-96F5-454A-8959-D1D342C43B86}"/>
+                <a16:creationId xmlns:a16="http://schemas.microsoft.com/office/drawing/2014/main" id="{CD55D845-FA85-43C1-9FC9-F9A8D701CC8D}"/>
               </a:ext>
             </a:extLst>
           </p:cNvPr>
@@ -14781,7 +14781,7 @@
           <p:cNvPr id="15" name="">
             <a:extLst xmlns:a="http://schemas.openxmlformats.org/drawingml/2006/main">
               <a:ext uri="{FF2B5EF4-FFF2-40B4-BE49-F238E27FC236}">
-                <a16:creationId xmlns:a16="http://schemas.microsoft.com/office/drawing/2014/main" id="{76D23866-F8EE-47AE-A7CE-722A164729AB}"/>
+                <a16:creationId xmlns:a16="http://schemas.microsoft.com/office/drawing/2014/main" id="{D23A0D50-CFD4-43F8-A1A3-098A0DD57B89}"/>
               </a:ext>
             </a:extLst>
           </p:cNvPr>
@@ -14814,7 +14814,7 @@
           <p:cNvPr id="16" name="">
             <a:extLst xmlns:a="http://schemas.openxmlformats.org/drawingml/2006/main">
               <a:ext uri="{FF2B5EF4-FFF2-40B4-BE49-F238E27FC236}">
-                <a16:creationId xmlns:a16="http://schemas.microsoft.com/office/drawing/2014/main" id="{04691FB2-41FD-4DB0-8AC5-A9C51C560CE9}"/>
+                <a16:creationId xmlns:a16="http://schemas.microsoft.com/office/drawing/2014/main" id="{11ADD995-B468-4EF0-9655-14D4968A52EA}"/>
               </a:ext>
             </a:extLst>
           </p:cNvPr>
@@ -14994,7 +14994,7 @@
           <p:cNvPr id="17" name="">
             <a:extLst xmlns:a="http://schemas.openxmlformats.org/drawingml/2006/main">
               <a:ext uri="{FF2B5EF4-FFF2-40B4-BE49-F238E27FC236}">
-                <a16:creationId xmlns:a16="http://schemas.microsoft.com/office/drawing/2014/main" id="{ED03D2D7-E226-4C1C-BAD6-7E7E64512344}"/>
+                <a16:creationId xmlns:a16="http://schemas.microsoft.com/office/drawing/2014/main" id="{AAEB1D83-44FB-46C5-94BB-4448B9D281BA}"/>
               </a:ext>
             </a:extLst>
           </p:cNvPr>
@@ -15151,7 +15151,7 @@
           <p:cNvPr id="18" name="">
             <a:extLst xmlns:a="http://schemas.openxmlformats.org/drawingml/2006/main">
               <a:ext uri="{FF2B5EF4-FFF2-40B4-BE49-F238E27FC236}">
-                <a16:creationId xmlns:a16="http://schemas.microsoft.com/office/drawing/2014/main" id="{7A9FE8B1-00C8-4201-B66A-921851D3745F}"/>
+                <a16:creationId xmlns:a16="http://schemas.microsoft.com/office/drawing/2014/main" id="{A5E30A52-9EC2-4F96-8AFC-70C5FE8B9638}"/>
               </a:ext>
             </a:extLst>
           </p:cNvPr>
@@ -15184,7 +15184,7 @@
           <p:cNvPr id="19" name="">
             <a:extLst xmlns:a="http://schemas.openxmlformats.org/drawingml/2006/main">
               <a:ext uri="{FF2B5EF4-FFF2-40B4-BE49-F238E27FC236}">
-                <a16:creationId xmlns:a16="http://schemas.microsoft.com/office/drawing/2014/main" id="{5AB4AFD2-1580-41EB-873A-D43E9AC4638C}"/>
+                <a16:creationId xmlns:a16="http://schemas.microsoft.com/office/drawing/2014/main" id="{61E3C950-38FD-4DB8-AB34-95EE137E5BAC}"/>
               </a:ext>
             </a:extLst>
           </p:cNvPr>
@@ -15364,7 +15364,7 @@
           <p:cNvPr id="20" name="">
             <a:extLst xmlns:a="http://schemas.openxmlformats.org/drawingml/2006/main">
               <a:ext uri="{FF2B5EF4-FFF2-40B4-BE49-F238E27FC236}">
-                <a16:creationId xmlns:a16="http://schemas.microsoft.com/office/drawing/2014/main" id="{B7D2AAD0-1452-4744-A68C-FA213439FA82}"/>
+                <a16:creationId xmlns:a16="http://schemas.microsoft.com/office/drawing/2014/main" id="{EBE08861-E698-4DA9-BE1F-E135EF3E5CAD}"/>
               </a:ext>
             </a:extLst>
           </p:cNvPr>
@@ -15521,7 +15521,7 @@
           <p:cNvPr id="21" name="">
             <a:extLst xmlns:a="http://schemas.openxmlformats.org/drawingml/2006/main">
               <a:ext uri="{FF2B5EF4-FFF2-40B4-BE49-F238E27FC236}">
-                <a16:creationId xmlns:a16="http://schemas.microsoft.com/office/drawing/2014/main" id="{D50D4B3F-564B-4B2B-A9CE-F54FB34907AD}"/>
+                <a16:creationId xmlns:a16="http://schemas.microsoft.com/office/drawing/2014/main" id="{3015F5BF-9187-4A2A-A6CD-D95EF1E56B55}"/>
               </a:ext>
             </a:extLst>
           </p:cNvPr>
@@ -15554,7 +15554,7 @@
           <p:cNvPr id="22" name="">
             <a:extLst xmlns:a="http://schemas.openxmlformats.org/drawingml/2006/main">
               <a:ext uri="{FF2B5EF4-FFF2-40B4-BE49-F238E27FC236}">
-                <a16:creationId xmlns:a16="http://schemas.microsoft.com/office/drawing/2014/main" id="{9F79FD16-FFD0-4BDB-B8B5-05FEABB99234}"/>
+                <a16:creationId xmlns:a16="http://schemas.microsoft.com/office/drawing/2014/main" id="{AED23430-5A14-428E-8A55-9C77B9F9C005}"/>
               </a:ext>
             </a:extLst>
           </p:cNvPr>
@@ -15711,7 +15711,7 @@
           <p:cNvPr id="23" name="">
             <a:extLst xmlns:a="http://schemas.openxmlformats.org/drawingml/2006/main">
               <a:ext uri="{FF2B5EF4-FFF2-40B4-BE49-F238E27FC236}">
-                <a16:creationId xmlns:a16="http://schemas.microsoft.com/office/drawing/2014/main" id="{8E33E5AF-7503-47D0-BE7E-DDACE9E84099}"/>
+                <a16:creationId xmlns:a16="http://schemas.microsoft.com/office/drawing/2014/main" id="{8B5FD9E1-3A79-4EB7-AFDA-387A2EF44BA5}"/>
               </a:ext>
             </a:extLst>
           </p:cNvPr>
@@ -15868,7 +15868,7 @@
           <p:cNvPr id="24" name="">
             <a:extLst xmlns:a="http://schemas.openxmlformats.org/drawingml/2006/main">
               <a:ext uri="{FF2B5EF4-FFF2-40B4-BE49-F238E27FC236}">
-                <a16:creationId xmlns:a16="http://schemas.microsoft.com/office/drawing/2014/main" id="{886002BD-3337-4D64-9F3D-59AF234B7F31}"/>
+                <a16:creationId xmlns:a16="http://schemas.microsoft.com/office/drawing/2014/main" id="{E4801A35-D080-44EA-A291-7F1D5C2A4C22}"/>
               </a:ext>
             </a:extLst>
           </p:cNvPr>
@@ -15901,7 +15901,7 @@
           <p:cNvPr id="25" name="">
             <a:extLst xmlns:a="http://schemas.openxmlformats.org/drawingml/2006/main">
               <a:ext uri="{FF2B5EF4-FFF2-40B4-BE49-F238E27FC236}">
-                <a16:creationId xmlns:a16="http://schemas.microsoft.com/office/drawing/2014/main" id="{749063E3-1B2D-4E7E-8618-5A1AB837287C}"/>
+                <a16:creationId xmlns:a16="http://schemas.microsoft.com/office/drawing/2014/main" id="{714D0224-B86F-4D9E-B46E-2D338C69D3FF}"/>
               </a:ext>
             </a:extLst>
           </p:cNvPr>
@@ -16058,7 +16058,7 @@
           <p:cNvPr id="26" name="">
             <a:extLst xmlns:a="http://schemas.openxmlformats.org/drawingml/2006/main">
               <a:ext uri="{FF2B5EF4-FFF2-40B4-BE49-F238E27FC236}">
-                <a16:creationId xmlns:a16="http://schemas.microsoft.com/office/drawing/2014/main" id="{6E2D1F23-8F46-44DD-AA12-917F7A0F7973}"/>
+                <a16:creationId xmlns:a16="http://schemas.microsoft.com/office/drawing/2014/main" id="{0EEB670E-19D4-4FA7-AB97-93E1C876A752}"/>
               </a:ext>
             </a:extLst>
           </p:cNvPr>
@@ -16215,7 +16215,7 @@
           <p:cNvPr id="27" name="">
             <a:extLst xmlns:a="http://schemas.openxmlformats.org/drawingml/2006/main">
               <a:ext uri="{FF2B5EF4-FFF2-40B4-BE49-F238E27FC236}">
-                <a16:creationId xmlns:a16="http://schemas.microsoft.com/office/drawing/2014/main" id="{F9D93AC7-B8A2-4B43-8499-EB26B124DBD0}"/>
+                <a16:creationId xmlns:a16="http://schemas.microsoft.com/office/drawing/2014/main" id="{DD1CCA97-B5B9-4EC6-9F3D-9AA91506C982}"/>
               </a:ext>
             </a:extLst>
           </p:cNvPr>
@@ -16248,7 +16248,7 @@
           <p:cNvPr id="28" name="">
             <a:extLst xmlns:a="http://schemas.openxmlformats.org/drawingml/2006/main">
               <a:ext uri="{FF2B5EF4-FFF2-40B4-BE49-F238E27FC236}">
-                <a16:creationId xmlns:a16="http://schemas.microsoft.com/office/drawing/2014/main" id="{54EE15DF-EF63-4549-B9C1-030FA4550B32}"/>
+                <a16:creationId xmlns:a16="http://schemas.microsoft.com/office/drawing/2014/main" id="{4832300E-2B4C-4D63-850A-14D2230FA3DE}"/>
               </a:ext>
             </a:extLst>
           </p:cNvPr>
@@ -16405,7 +16405,7 @@
           <p:cNvPr id="29" name="">
             <a:extLst xmlns:a="http://schemas.openxmlformats.org/drawingml/2006/main">
               <a:ext uri="{FF2B5EF4-FFF2-40B4-BE49-F238E27FC236}">
-                <a16:creationId xmlns:a16="http://schemas.microsoft.com/office/drawing/2014/main" id="{ED40DD0F-56F0-4F86-BFE2-09731680D7AE}"/>
+                <a16:creationId xmlns:a16="http://schemas.microsoft.com/office/drawing/2014/main" id="{B8999E4F-31E0-4A4D-B6B0-C78680966771}"/>
               </a:ext>
             </a:extLst>
           </p:cNvPr>
@@ -16562,7 +16562,7 @@
           <p:cNvPr id="30" name="">
             <a:extLst xmlns:a="http://schemas.openxmlformats.org/drawingml/2006/main">
               <a:ext uri="{FF2B5EF4-FFF2-40B4-BE49-F238E27FC236}">
-                <a16:creationId xmlns:a16="http://schemas.microsoft.com/office/drawing/2014/main" id="{88B8F0C0-92D4-4452-B441-C34B2B6DFD91}"/>
+                <a16:creationId xmlns:a16="http://schemas.microsoft.com/office/drawing/2014/main" id="{256AD27F-698D-4C07-BD19-05D217FBEDEF}"/>
               </a:ext>
             </a:extLst>
           </p:cNvPr>
@@ -16719,7 +16719,7 @@
           <p:cNvPr id="31" name="">
             <a:extLst xmlns:a="http://schemas.openxmlformats.org/drawingml/2006/main">
               <a:ext uri="{FF2B5EF4-FFF2-40B4-BE49-F238E27FC236}">
-                <a16:creationId xmlns:a16="http://schemas.microsoft.com/office/drawing/2014/main" id="{8F2A09A5-ED63-4BBD-A892-4CD6287DE93F}"/>
+                <a16:creationId xmlns:a16="http://schemas.microsoft.com/office/drawing/2014/main" id="{0B2D4AF6-DDD6-45A1-A584-6A7BA337CC69}"/>
               </a:ext>
             </a:extLst>
           </p:cNvPr>
@@ -16876,7 +16876,7 @@
           <p:cNvPr id="32" name="">
             <a:extLst xmlns:a="http://schemas.openxmlformats.org/drawingml/2006/main">
               <a:ext uri="{FF2B5EF4-FFF2-40B4-BE49-F238E27FC236}">
-                <a16:creationId xmlns:a16="http://schemas.microsoft.com/office/drawing/2014/main" id="{5E140609-6E12-47B1-AF2B-2CA1F19EFA4F}"/>
+                <a16:creationId xmlns:a16="http://schemas.microsoft.com/office/drawing/2014/main" id="{575D6EDB-8BB4-4D7B-87FF-2125A45EF84D}"/>
               </a:ext>
             </a:extLst>
           </p:cNvPr>
@@ -16909,7 +16909,7 @@
           <p:cNvPr id="33" name="">
             <a:extLst xmlns:a="http://schemas.openxmlformats.org/drawingml/2006/main">
               <a:ext uri="{FF2B5EF4-FFF2-40B4-BE49-F238E27FC236}">
-                <a16:creationId xmlns:a16="http://schemas.microsoft.com/office/drawing/2014/main" id="{0FD66315-C21A-405D-A5B3-6D94829C26A0}"/>
+                <a16:creationId xmlns:a16="http://schemas.microsoft.com/office/drawing/2014/main" id="{90DD04DD-02D5-4B1D-8333-E81B48DC4212}"/>
               </a:ext>
             </a:extLst>
           </p:cNvPr>
@@ -17066,7 +17066,7 @@
           <p:cNvPr id="34" name="">
             <a:extLst xmlns:a="http://schemas.openxmlformats.org/drawingml/2006/main">
               <a:ext uri="{FF2B5EF4-FFF2-40B4-BE49-F238E27FC236}">
-                <a16:creationId xmlns:a16="http://schemas.microsoft.com/office/drawing/2014/main" id="{993C75CC-7FD7-479C-A6CC-10CE019E9A5B}"/>
+                <a16:creationId xmlns:a16="http://schemas.microsoft.com/office/drawing/2014/main" id="{49173B32-FB0E-4156-AEC3-68D79F69850E}"/>
               </a:ext>
             </a:extLst>
           </p:cNvPr>
@@ -17221,7 +17221,7 @@
     </p:spTree>
     <p:extLst>
       <p:ext uri="{BB962C8B-B14F-4D97-AF65-F5344CB8AC3E}">
-        <p14:creationId xmlns:p14="http://schemas.microsoft.com/office/powerpoint/2010/main" val="1859350037"/>
+        <p14:creationId xmlns:p14="http://schemas.microsoft.com/office/powerpoint/2010/main" val="1678883626"/>
       </p:ext>
     </p:extLst>
   </p:cSld>
@@ -17252,7 +17252,7 @@
           <p:cNvPr id="20" name="">
             <a:extLst xmlns:a="http://schemas.openxmlformats.org/drawingml/2006/main">
               <a:ext uri="{FF2B5EF4-FFF2-40B4-BE49-F238E27FC236}">
-                <a16:creationId xmlns:a16="http://schemas.microsoft.com/office/drawing/2014/main" id="{80B48DC0-56B5-4944-ACDB-48B8594E10EF}"/>
+                <a16:creationId xmlns:a16="http://schemas.microsoft.com/office/drawing/2014/main" id="{9AC4EC1A-E32A-4EF4-BD96-B409002BDC03}"/>
               </a:ext>
             </a:extLst>
           </p:cNvPr>
@@ -17283,7 +17283,7 @@
           <p:cNvPr id="2" name="">
             <a:extLst xmlns:a="http://schemas.openxmlformats.org/drawingml/2006/main">
               <a:ext uri="{FF2B5EF4-FFF2-40B4-BE49-F238E27FC236}">
-                <a16:creationId xmlns:a16="http://schemas.microsoft.com/office/drawing/2014/main" id="{7975F511-F180-46FB-960C-6E714B8438EC}"/>
+                <a16:creationId xmlns:a16="http://schemas.microsoft.com/office/drawing/2014/main" id="{34174752-9BD6-4059-9BCE-013DBD8E17D2}"/>
               </a:ext>
             </a:extLst>
           </p:cNvPr>
@@ -17440,7 +17440,7 @@
           <p:cNvPr id="3" name="">
             <a:extLst xmlns:a="http://schemas.openxmlformats.org/drawingml/2006/main">
               <a:ext uri="{FF2B5EF4-FFF2-40B4-BE49-F238E27FC236}">
-                <a16:creationId xmlns:a16="http://schemas.microsoft.com/office/drawing/2014/main" id="{D2A8B5DA-C256-4821-967E-6221779E7A96}"/>
+                <a16:creationId xmlns:a16="http://schemas.microsoft.com/office/drawing/2014/main" id="{8F5633F8-CD09-4024-AC09-157EBE24BF02}"/>
               </a:ext>
             </a:extLst>
           </p:cNvPr>
@@ -17597,7 +17597,7 @@
           <p:cNvPr id="4" name="">
             <a:extLst xmlns:a="http://schemas.openxmlformats.org/drawingml/2006/main">
               <a:ext uri="{FF2B5EF4-FFF2-40B4-BE49-F238E27FC236}">
-                <a16:creationId xmlns:a16="http://schemas.microsoft.com/office/drawing/2014/main" id="{F4405FBF-A354-4CC2-8705-D76119873EF0}"/>
+                <a16:creationId xmlns:a16="http://schemas.microsoft.com/office/drawing/2014/main" id="{DDBC2669-ED77-4E9E-8E01-44D758CACAA0}"/>
               </a:ext>
             </a:extLst>
           </p:cNvPr>
@@ -17754,7 +17754,7 @@
           <p:cNvPr id="5" name="">
             <a:extLst xmlns:a="http://schemas.openxmlformats.org/drawingml/2006/main">
               <a:ext uri="{FF2B5EF4-FFF2-40B4-BE49-F238E27FC236}">
-                <a16:creationId xmlns:a16="http://schemas.microsoft.com/office/drawing/2014/main" id="{05A20258-6C2F-49F1-B224-F07C5784E087}"/>
+                <a16:creationId xmlns:a16="http://schemas.microsoft.com/office/drawing/2014/main" id="{4A12B259-3F7B-40EC-8E95-C275B7B15B56}"/>
               </a:ext>
             </a:extLst>
           </p:cNvPr>
@@ -17785,7 +17785,7 @@
           <p:cNvPr id="6" name="">
             <a:extLst xmlns:a="http://schemas.openxmlformats.org/drawingml/2006/main">
               <a:ext uri="{FF2B5EF4-FFF2-40B4-BE49-F238E27FC236}">
-                <a16:creationId xmlns:a16="http://schemas.microsoft.com/office/drawing/2014/main" id="{3E36C901-7EA6-4A56-B077-B68CF63B3754}"/>
+                <a16:creationId xmlns:a16="http://schemas.microsoft.com/office/drawing/2014/main" id="{A137B7FB-BFEA-4563-9EBA-AAA3D3C91505}"/>
               </a:ext>
             </a:extLst>
           </p:cNvPr>
@@ -17942,7 +17942,7 @@
           <p:cNvPr id="7" name="">
             <a:extLst xmlns:a="http://schemas.openxmlformats.org/drawingml/2006/main">
               <a:ext uri="{FF2B5EF4-FFF2-40B4-BE49-F238E27FC236}">
-                <a16:creationId xmlns:a16="http://schemas.microsoft.com/office/drawing/2014/main" id="{CDD54E38-A7C4-4280-8345-FF801C900CB7}"/>
+                <a16:creationId xmlns:a16="http://schemas.microsoft.com/office/drawing/2014/main" id="{E291B4D2-E266-449A-A563-BEB9EC409D33}"/>
               </a:ext>
             </a:extLst>
           </p:cNvPr>
@@ -18099,7 +18099,7 @@
           <p:cNvPr id="8" name="">
             <a:extLst xmlns:a="http://schemas.openxmlformats.org/drawingml/2006/main">
               <a:ext uri="{FF2B5EF4-FFF2-40B4-BE49-F238E27FC236}">
-                <a16:creationId xmlns:a16="http://schemas.microsoft.com/office/drawing/2014/main" id="{13628012-76D2-4120-ABC8-04C211B7AC43}"/>
+                <a16:creationId xmlns:a16="http://schemas.microsoft.com/office/drawing/2014/main" id="{CD76CC9D-11B9-408E-A325-542E333AD989}"/>
               </a:ext>
             </a:extLst>
           </p:cNvPr>
@@ -18132,7 +18132,7 @@
           <p:cNvPr id="9" name="">
             <a:extLst xmlns:a="http://schemas.openxmlformats.org/drawingml/2006/main">
               <a:ext uri="{FF2B5EF4-FFF2-40B4-BE49-F238E27FC236}">
-                <a16:creationId xmlns:a16="http://schemas.microsoft.com/office/drawing/2014/main" id="{25F09F52-7520-4E76-A25B-F3F5A355BC7D}"/>
+                <a16:creationId xmlns:a16="http://schemas.microsoft.com/office/drawing/2014/main" id="{F48BD84B-A0A1-4513-9DEF-C4AB103CDE53}"/>
               </a:ext>
             </a:extLst>
           </p:cNvPr>
@@ -18165,7 +18165,7 @@
           <p:cNvPr id="10" name="">
             <a:extLst xmlns:a="http://schemas.openxmlformats.org/drawingml/2006/main">
               <a:ext uri="{FF2B5EF4-FFF2-40B4-BE49-F238E27FC236}">
-                <a16:creationId xmlns:a16="http://schemas.microsoft.com/office/drawing/2014/main" id="{61DF5CE2-3E27-450E-8FDA-A9EB3605F0C3}"/>
+                <a16:creationId xmlns:a16="http://schemas.microsoft.com/office/drawing/2014/main" id="{F5AC5D4D-3844-450A-902A-CB7DB8BBD761}"/>
               </a:ext>
             </a:extLst>
           </p:cNvPr>
@@ -18322,7 +18322,7 @@
           <p:cNvPr id="11" name="">
             <a:extLst xmlns:a="http://schemas.openxmlformats.org/drawingml/2006/main">
               <a:ext uri="{FF2B5EF4-FFF2-40B4-BE49-F238E27FC236}">
-                <a16:creationId xmlns:a16="http://schemas.microsoft.com/office/drawing/2014/main" id="{30292532-8C39-4A8D-B0A8-007C8C269D4E}"/>
+                <a16:creationId xmlns:a16="http://schemas.microsoft.com/office/drawing/2014/main" id="{02651EB6-448F-439D-B7C0-DA5E556602B4}"/>
               </a:ext>
             </a:extLst>
           </p:cNvPr>
@@ -18548,7 +18548,7 @@
           <p:cNvPr id="12" name="">
             <a:extLst xmlns:a="http://schemas.openxmlformats.org/drawingml/2006/main">
               <a:ext uri="{FF2B5EF4-FFF2-40B4-BE49-F238E27FC236}">
-                <a16:creationId xmlns:a16="http://schemas.microsoft.com/office/drawing/2014/main" id="{2C4B263D-AC65-4527-B828-6C549EB85819}"/>
+                <a16:creationId xmlns:a16="http://schemas.microsoft.com/office/drawing/2014/main" id="{20C48518-17C6-4D19-BCBD-72998FD2A644}"/>
               </a:ext>
             </a:extLst>
           </p:cNvPr>
@@ -18705,7 +18705,7 @@
           <p:cNvPr id="13" name="">
             <a:extLst xmlns:a="http://schemas.openxmlformats.org/drawingml/2006/main">
               <a:ext uri="{FF2B5EF4-FFF2-40B4-BE49-F238E27FC236}">
-                <a16:creationId xmlns:a16="http://schemas.microsoft.com/office/drawing/2014/main" id="{1B85C575-AF99-46E4-A72E-51BDBB35025C}"/>
+                <a16:creationId xmlns:a16="http://schemas.microsoft.com/office/drawing/2014/main" id="{6BB0896C-5C0C-4A62-9A05-1B599BC02CEA}"/>
               </a:ext>
             </a:extLst>
           </p:cNvPr>
@@ -18738,7 +18738,7 @@
           <p:cNvPr id="14" name="">
             <a:extLst xmlns:a="http://schemas.openxmlformats.org/drawingml/2006/main">
               <a:ext uri="{FF2B5EF4-FFF2-40B4-BE49-F238E27FC236}">
-                <a16:creationId xmlns:a16="http://schemas.microsoft.com/office/drawing/2014/main" id="{5D52605F-B23A-49CD-B927-E17CBEFF51F9}"/>
+                <a16:creationId xmlns:a16="http://schemas.microsoft.com/office/drawing/2014/main" id="{AE81D7C0-2C4D-49B9-A591-9E0CA48FCA69}"/>
               </a:ext>
             </a:extLst>
           </p:cNvPr>
@@ -18771,7 +18771,7 @@
           <p:cNvPr id="15" name="">
             <a:extLst xmlns:a="http://schemas.openxmlformats.org/drawingml/2006/main">
               <a:ext uri="{FF2B5EF4-FFF2-40B4-BE49-F238E27FC236}">
-                <a16:creationId xmlns:a16="http://schemas.microsoft.com/office/drawing/2014/main" id="{08024D36-3625-424F-8EBD-E3C405075B76}"/>
+                <a16:creationId xmlns:a16="http://schemas.microsoft.com/office/drawing/2014/main" id="{DCA7315E-641E-46DA-B958-40F753816C50}"/>
               </a:ext>
             </a:extLst>
           </p:cNvPr>
@@ -18928,7 +18928,7 @@
           <p:cNvPr id="16" name="">
             <a:extLst xmlns:a="http://schemas.openxmlformats.org/drawingml/2006/main">
               <a:ext uri="{FF2B5EF4-FFF2-40B4-BE49-F238E27FC236}">
-                <a16:creationId xmlns:a16="http://schemas.microsoft.com/office/drawing/2014/main" id="{604F8A95-DB22-4143-BAF0-FEA6B79C61B2}"/>
+                <a16:creationId xmlns:a16="http://schemas.microsoft.com/office/drawing/2014/main" id="{3C0E0646-C498-478B-85F7-7115F794C77D}"/>
               </a:ext>
             </a:extLst>
           </p:cNvPr>
@@ -19159,7 +19159,7 @@
           <p:cNvPr id="17" name="">
             <a:extLst xmlns:a="http://schemas.openxmlformats.org/drawingml/2006/main">
               <a:ext uri="{FF2B5EF4-FFF2-40B4-BE49-F238E27FC236}">
-                <a16:creationId xmlns:a16="http://schemas.microsoft.com/office/drawing/2014/main" id="{07C86D2B-20F0-4059-B5A8-EE09213D60C6}"/>
+                <a16:creationId xmlns:a16="http://schemas.microsoft.com/office/drawing/2014/main" id="{351711D7-DB2C-4E7F-A455-547EE5A4FC3F}"/>
               </a:ext>
             </a:extLst>
           </p:cNvPr>
@@ -19316,7 +19316,7 @@
           <p:cNvPr id="18" name="">
             <a:extLst xmlns:a="http://schemas.openxmlformats.org/drawingml/2006/main">
               <a:ext uri="{FF2B5EF4-FFF2-40B4-BE49-F238E27FC236}">
-                <a16:creationId xmlns:a16="http://schemas.microsoft.com/office/drawing/2014/main" id="{146A587F-2A20-4507-BFD8-E996D88BB8AD}"/>
+                <a16:creationId xmlns:a16="http://schemas.microsoft.com/office/drawing/2014/main" id="{BD930BE0-E19B-4F20-9C00-FDC8F07D7CC0}"/>
               </a:ext>
             </a:extLst>
           </p:cNvPr>
@@ -19473,7 +19473,7 @@
           <p:cNvPr id="19" name="">
             <a:extLst xmlns:a="http://schemas.openxmlformats.org/drawingml/2006/main">
               <a:ext uri="{FF2B5EF4-FFF2-40B4-BE49-F238E27FC236}">
-                <a16:creationId xmlns:a16="http://schemas.microsoft.com/office/drawing/2014/main" id="{3AD02546-3D65-4273-8342-D5504B6703A8}"/>
+                <a16:creationId xmlns:a16="http://schemas.microsoft.com/office/drawing/2014/main" id="{9873EE2B-D33B-414F-A136-D5DDDE462DE0}"/>
               </a:ext>
             </a:extLst>
           </p:cNvPr>
@@ -19628,7 +19628,7 @@
     </p:spTree>
     <p:extLst>
       <p:ext uri="{BB962C8B-B14F-4D97-AF65-F5344CB8AC3E}">
-        <p14:creationId xmlns:p14="http://schemas.microsoft.com/office/powerpoint/2010/main" val="1278158393"/>
+        <p14:creationId xmlns:p14="http://schemas.microsoft.com/office/powerpoint/2010/main" val="517459854"/>
       </p:ext>
     </p:extLst>
   </p:cSld>
@@ -19659,7 +19659,7 @@
           <p:cNvPr id="17" name="">
             <a:extLst xmlns:a="http://schemas.openxmlformats.org/drawingml/2006/main">
               <a:ext uri="{FF2B5EF4-FFF2-40B4-BE49-F238E27FC236}">
-                <a16:creationId xmlns:a16="http://schemas.microsoft.com/office/drawing/2014/main" id="{3538A39F-B63A-4F38-87A1-2674F863DEA5}"/>
+                <a16:creationId xmlns:a16="http://schemas.microsoft.com/office/drawing/2014/main" id="{EB0826AF-0E86-4F41-8436-4954ADED5C4D}"/>
               </a:ext>
             </a:extLst>
           </p:cNvPr>
@@ -19690,7 +19690,7 @@
           <p:cNvPr id="2" name="">
             <a:extLst xmlns:a="http://schemas.openxmlformats.org/drawingml/2006/main">
               <a:ext uri="{FF2B5EF4-FFF2-40B4-BE49-F238E27FC236}">
-                <a16:creationId xmlns:a16="http://schemas.microsoft.com/office/drawing/2014/main" id="{9A7601A1-C6BF-4B3B-BD52-E36B7204F8A4}"/>
+                <a16:creationId xmlns:a16="http://schemas.microsoft.com/office/drawing/2014/main" id="{0EF7500D-08A8-4DAC-A8D6-2E5452391942}"/>
               </a:ext>
             </a:extLst>
           </p:cNvPr>
@@ -19847,7 +19847,7 @@
           <p:cNvPr id="3" name="">
             <a:extLst xmlns:a="http://schemas.openxmlformats.org/drawingml/2006/main">
               <a:ext uri="{FF2B5EF4-FFF2-40B4-BE49-F238E27FC236}">
-                <a16:creationId xmlns:a16="http://schemas.microsoft.com/office/drawing/2014/main" id="{395457B6-0B60-4121-B4F0-59782169D481}"/>
+                <a16:creationId xmlns:a16="http://schemas.microsoft.com/office/drawing/2014/main" id="{93E02090-8514-4339-AC6A-58DA083699BE}"/>
               </a:ext>
             </a:extLst>
           </p:cNvPr>
@@ -20004,7 +20004,7 @@
           <p:cNvPr id="4" name="">
             <a:extLst xmlns:a="http://schemas.openxmlformats.org/drawingml/2006/main">
               <a:ext uri="{FF2B5EF4-FFF2-40B4-BE49-F238E27FC236}">
-                <a16:creationId xmlns:a16="http://schemas.microsoft.com/office/drawing/2014/main" id="{20C8FA66-EA54-400E-BBBA-F57E1576D701}"/>
+                <a16:creationId xmlns:a16="http://schemas.microsoft.com/office/drawing/2014/main" id="{6C689CCB-4681-4D64-818D-590E97A055CD}"/>
               </a:ext>
             </a:extLst>
           </p:cNvPr>
@@ -20161,7 +20161,7 @@
           <p:cNvPr id="5" name="">
             <a:extLst xmlns:a="http://schemas.openxmlformats.org/drawingml/2006/main">
               <a:ext uri="{FF2B5EF4-FFF2-40B4-BE49-F238E27FC236}">
-                <a16:creationId xmlns:a16="http://schemas.microsoft.com/office/drawing/2014/main" id="{A18E1FA2-C8C0-4BEF-8206-D31AC0275A67}"/>
+                <a16:creationId xmlns:a16="http://schemas.microsoft.com/office/drawing/2014/main" id="{649A92B1-DA98-4B1F-98F4-A9C4561E7408}"/>
               </a:ext>
             </a:extLst>
           </p:cNvPr>
@@ -20192,7 +20192,7 @@
           <p:cNvPr id="6" name="">
             <a:extLst xmlns:a="http://schemas.openxmlformats.org/drawingml/2006/main">
               <a:ext uri="{FF2B5EF4-FFF2-40B4-BE49-F238E27FC236}">
-                <a16:creationId xmlns:a16="http://schemas.microsoft.com/office/drawing/2014/main" id="{C3E23B53-3B9D-44A3-9FBF-FF5F5159DE9B}"/>
+                <a16:creationId xmlns:a16="http://schemas.microsoft.com/office/drawing/2014/main" id="{D2DBC8AC-C436-4E23-AD29-3573DDF9CC50}"/>
               </a:ext>
             </a:extLst>
           </p:cNvPr>
@@ -20349,7 +20349,7 @@
           <p:cNvPr id="7" name="">
             <a:extLst xmlns:a="http://schemas.openxmlformats.org/drawingml/2006/main">
               <a:ext uri="{FF2B5EF4-FFF2-40B4-BE49-F238E27FC236}">
-                <a16:creationId xmlns:a16="http://schemas.microsoft.com/office/drawing/2014/main" id="{A40C927E-B36C-42C5-9216-A4C4621027FB}"/>
+                <a16:creationId xmlns:a16="http://schemas.microsoft.com/office/drawing/2014/main" id="{00565820-3C35-4D55-BBE5-D401C1EA547F}"/>
               </a:ext>
             </a:extLst>
           </p:cNvPr>
@@ -20506,7 +20506,7 @@
           <p:cNvPr id="8" name="">
             <a:extLst xmlns:a="http://schemas.openxmlformats.org/drawingml/2006/main">
               <a:ext uri="{FF2B5EF4-FFF2-40B4-BE49-F238E27FC236}">
-                <a16:creationId xmlns:a16="http://schemas.microsoft.com/office/drawing/2014/main" id="{9318FF28-FE2C-4CCC-82F8-64A4ECA83353}"/>
+                <a16:creationId xmlns:a16="http://schemas.microsoft.com/office/drawing/2014/main" id="{7EFEE34F-D7E9-476A-BDCA-B8995F27D837}"/>
               </a:ext>
             </a:extLst>
           </p:cNvPr>
@@ -20539,7 +20539,7 @@
           <p:cNvPr id="9" name="">
             <a:extLst xmlns:a="http://schemas.openxmlformats.org/drawingml/2006/main">
               <a:ext uri="{FF2B5EF4-FFF2-40B4-BE49-F238E27FC236}">
-                <a16:creationId xmlns:a16="http://schemas.microsoft.com/office/drawing/2014/main" id="{FED8633A-D8FD-4DD5-A0B3-5BE3538FD22E}"/>
+                <a16:creationId xmlns:a16="http://schemas.microsoft.com/office/drawing/2014/main" id="{8431A237-2990-4970-A124-F02C466A9D8F}"/>
               </a:ext>
             </a:extLst>
           </p:cNvPr>
@@ -20696,7 +20696,7 @@
           <p:cNvPr id="10" name="">
             <a:extLst xmlns:a="http://schemas.openxmlformats.org/drawingml/2006/main">
               <a:ext uri="{FF2B5EF4-FFF2-40B4-BE49-F238E27FC236}">
-                <a16:creationId xmlns:a16="http://schemas.microsoft.com/office/drawing/2014/main" id="{0FABE5A6-B161-4831-9101-0E24CAA0B267}"/>
+                <a16:creationId xmlns:a16="http://schemas.microsoft.com/office/drawing/2014/main" id="{93044E8F-F75C-48EB-B2AF-D9F75769DFB2}"/>
               </a:ext>
             </a:extLst>
           </p:cNvPr>
@@ -20729,7 +20729,7 @@
           <p:cNvPr id="11" name="">
             <a:extLst xmlns:a="http://schemas.openxmlformats.org/drawingml/2006/main">
               <a:ext uri="{FF2B5EF4-FFF2-40B4-BE49-F238E27FC236}">
-                <a16:creationId xmlns:a16="http://schemas.microsoft.com/office/drawing/2014/main" id="{05023BE8-3A23-4CA8-8CD2-D3BB2F2BE114}"/>
+                <a16:creationId xmlns:a16="http://schemas.microsoft.com/office/drawing/2014/main" id="{1FA61759-49E5-4BD1-A2CA-A7518CA8167B}"/>
               </a:ext>
             </a:extLst>
           </p:cNvPr>
@@ -20739,7 +20739,7 @@
           <p:nvPr/>
         </p:nvPicPr>
         <p:blipFill>
-          <a:blip xmlns:r="http://schemas.openxmlformats.org/officeDocument/2006/relationships" xmlns:a="http://schemas.openxmlformats.org/drawingml/2006/main" r:embed="R3b0efbf838fc494f"/>
+          <a:blip xmlns:r="http://schemas.openxmlformats.org/officeDocument/2006/relationships" xmlns:a="http://schemas.openxmlformats.org/drawingml/2006/main" r:embed="R96b35a9d085e4b07"/>
           <a:srcRect xmlns:a="http://schemas.openxmlformats.org/drawingml/2006/main" l="0" t="581" r="0" b="581"/>
           <a:stretch xmlns:a="http://schemas.openxmlformats.org/drawingml/2006/main">
             <a:fillRect l="0" t="0" r="0" b="0"/>
@@ -20762,7 +20762,7 @@
           <p:cNvPr id="12" name="">
             <a:extLst xmlns:a="http://schemas.openxmlformats.org/drawingml/2006/main">
               <a:ext uri="{FF2B5EF4-FFF2-40B4-BE49-F238E27FC236}">
-                <a16:creationId xmlns:a16="http://schemas.microsoft.com/office/drawing/2014/main" id="{CE4D71BB-312F-4492-A2A4-1E588082470B}"/>
+                <a16:creationId xmlns:a16="http://schemas.microsoft.com/office/drawing/2014/main" id="{1B33AF20-1E07-459E-A846-F4F753F7FE9D}"/>
               </a:ext>
             </a:extLst>
           </p:cNvPr>
@@ -20795,7 +20795,7 @@
           <p:cNvPr id="13" name="">
             <a:extLst xmlns:a="http://schemas.openxmlformats.org/drawingml/2006/main">
               <a:ext uri="{FF2B5EF4-FFF2-40B4-BE49-F238E27FC236}">
-                <a16:creationId xmlns:a16="http://schemas.microsoft.com/office/drawing/2014/main" id="{1A161618-3AD7-4E59-BAF2-0D57C2874FF0}"/>
+                <a16:creationId xmlns:a16="http://schemas.microsoft.com/office/drawing/2014/main" id="{0F3B60C0-1256-4DC3-9366-F60F2C51BE69}"/>
               </a:ext>
             </a:extLst>
           </p:cNvPr>
@@ -20952,7 +20952,7 @@
           <p:cNvPr id="14" name="">
             <a:extLst xmlns:a="http://schemas.openxmlformats.org/drawingml/2006/main">
               <a:ext uri="{FF2B5EF4-FFF2-40B4-BE49-F238E27FC236}">
-                <a16:creationId xmlns:a16="http://schemas.microsoft.com/office/drawing/2014/main" id="{29973E7B-34DA-4795-9BB7-B8D7383322C8}"/>
+                <a16:creationId xmlns:a16="http://schemas.microsoft.com/office/drawing/2014/main" id="{9099A655-D619-42B7-81EE-C67A39D3718E}"/>
               </a:ext>
             </a:extLst>
           </p:cNvPr>
@@ -20985,7 +20985,7 @@
           <p:cNvPr id="15" name="">
             <a:extLst xmlns:a="http://schemas.openxmlformats.org/drawingml/2006/main">
               <a:ext uri="{FF2B5EF4-FFF2-40B4-BE49-F238E27FC236}">
-                <a16:creationId xmlns:a16="http://schemas.microsoft.com/office/drawing/2014/main" id="{C0C5237A-0721-4508-ADE1-03489570D810}"/>
+                <a16:creationId xmlns:a16="http://schemas.microsoft.com/office/drawing/2014/main" id="{EEA31F75-7ECD-4817-91AE-16FC2A7884DD}"/>
               </a:ext>
             </a:extLst>
           </p:cNvPr>
@@ -20995,7 +20995,7 @@
           <p:nvPr/>
         </p:nvPicPr>
         <p:blipFill>
-          <a:blip xmlns:r="http://schemas.openxmlformats.org/officeDocument/2006/relationships" xmlns:a="http://schemas.openxmlformats.org/drawingml/2006/main" r:embed="Reb3c69486f254b1d"/>
+          <a:blip xmlns:r="http://schemas.openxmlformats.org/officeDocument/2006/relationships" xmlns:a="http://schemas.openxmlformats.org/drawingml/2006/main" r:embed="Rfd08bb88e26f4fc6"/>
           <a:srcRect xmlns:a="http://schemas.openxmlformats.org/drawingml/2006/main" l="0" t="884" r="0" b="884"/>
           <a:stretch xmlns:a="http://schemas.openxmlformats.org/drawingml/2006/main">
             <a:fillRect l="0" t="0" r="0" b="0"/>
@@ -21018,7 +21018,7 @@
           <p:cNvPr id="16" name="">
             <a:extLst xmlns:a="http://schemas.openxmlformats.org/drawingml/2006/main">
               <a:ext uri="{FF2B5EF4-FFF2-40B4-BE49-F238E27FC236}">
-                <a16:creationId xmlns:a16="http://schemas.microsoft.com/office/drawing/2014/main" id="{2765A447-8697-4BA1-AC5F-D5E57EDD55FD}"/>
+                <a16:creationId xmlns:a16="http://schemas.microsoft.com/office/drawing/2014/main" id="{6766C0DA-4A5F-4919-924F-9640106FEECD}"/>
               </a:ext>
             </a:extLst>
           </p:cNvPr>
@@ -21173,7 +21173,7 @@
     </p:spTree>
     <p:extLst>
       <p:ext uri="{BB962C8B-B14F-4D97-AF65-F5344CB8AC3E}">
-        <p14:creationId xmlns:p14="http://schemas.microsoft.com/office/powerpoint/2010/main" val="518029431"/>
+        <p14:creationId xmlns:p14="http://schemas.microsoft.com/office/powerpoint/2010/main" val="1159514239"/>
       </p:ext>
     </p:extLst>
   </p:cSld>
@@ -21204,7 +21204,7 @@
           <p:cNvPr id="20" name="">
             <a:extLst xmlns:a="http://schemas.openxmlformats.org/drawingml/2006/main">
               <a:ext uri="{FF2B5EF4-FFF2-40B4-BE49-F238E27FC236}">
-                <a16:creationId xmlns:a16="http://schemas.microsoft.com/office/drawing/2014/main" id="{8D4BB41D-0917-41BE-A624-8451431FA544}"/>
+                <a16:creationId xmlns:a16="http://schemas.microsoft.com/office/drawing/2014/main" id="{D20D2E40-C2BF-4F22-AB42-EDAD3CB85F04}"/>
               </a:ext>
             </a:extLst>
           </p:cNvPr>
@@ -21235,7 +21235,7 @@
           <p:cNvPr id="2" name="">
             <a:extLst xmlns:a="http://schemas.openxmlformats.org/drawingml/2006/main">
               <a:ext uri="{FF2B5EF4-FFF2-40B4-BE49-F238E27FC236}">
-                <a16:creationId xmlns:a16="http://schemas.microsoft.com/office/drawing/2014/main" id="{134B79E1-2C67-4837-8EDD-391566E560B9}"/>
+                <a16:creationId xmlns:a16="http://schemas.microsoft.com/office/drawing/2014/main" id="{734ED9C1-7EDF-42AD-815E-C49D8E51B35C}"/>
               </a:ext>
             </a:extLst>
           </p:cNvPr>
@@ -21392,7 +21392,7 @@
           <p:cNvPr id="3" name="">
             <a:extLst xmlns:a="http://schemas.openxmlformats.org/drawingml/2006/main">
               <a:ext uri="{FF2B5EF4-FFF2-40B4-BE49-F238E27FC236}">
-                <a16:creationId xmlns:a16="http://schemas.microsoft.com/office/drawing/2014/main" id="{62B1B77A-C06A-401B-8886-D47B48FA22AB}"/>
+                <a16:creationId xmlns:a16="http://schemas.microsoft.com/office/drawing/2014/main" id="{0E9218CE-77F8-4681-AF41-F85B2F251C90}"/>
               </a:ext>
             </a:extLst>
           </p:cNvPr>
@@ -21549,7 +21549,7 @@
           <p:cNvPr id="4" name="">
             <a:extLst xmlns:a="http://schemas.openxmlformats.org/drawingml/2006/main">
               <a:ext uri="{FF2B5EF4-FFF2-40B4-BE49-F238E27FC236}">
-                <a16:creationId xmlns:a16="http://schemas.microsoft.com/office/drawing/2014/main" id="{96A6EDB6-1C94-47E4-B338-167438A9F321}"/>
+                <a16:creationId xmlns:a16="http://schemas.microsoft.com/office/drawing/2014/main" id="{06270A76-D2D4-4BA9-9518-1D8BEA1B351E}"/>
               </a:ext>
             </a:extLst>
           </p:cNvPr>
@@ -21706,7 +21706,7 @@
           <p:cNvPr id="5" name="">
             <a:extLst xmlns:a="http://schemas.openxmlformats.org/drawingml/2006/main">
               <a:ext uri="{FF2B5EF4-FFF2-40B4-BE49-F238E27FC236}">
-                <a16:creationId xmlns:a16="http://schemas.microsoft.com/office/drawing/2014/main" id="{D2F8EA61-E771-4F35-BC24-DE9F31F48A85}"/>
+                <a16:creationId xmlns:a16="http://schemas.microsoft.com/office/drawing/2014/main" id="{0A0689C4-917A-4E25-BD49-4DAD65EEC49E}"/>
               </a:ext>
             </a:extLst>
           </p:cNvPr>
@@ -21737,7 +21737,7 @@
           <p:cNvPr id="6" name="">
             <a:extLst xmlns:a="http://schemas.openxmlformats.org/drawingml/2006/main">
               <a:ext uri="{FF2B5EF4-FFF2-40B4-BE49-F238E27FC236}">
-                <a16:creationId xmlns:a16="http://schemas.microsoft.com/office/drawing/2014/main" id="{0FC35D3C-2CBA-45AB-A01E-7C4FFF361302}"/>
+                <a16:creationId xmlns:a16="http://schemas.microsoft.com/office/drawing/2014/main" id="{A1AE0F46-4A87-4B1B-BDE4-11FB92D57D30}"/>
               </a:ext>
             </a:extLst>
           </p:cNvPr>
@@ -21894,7 +21894,7 @@
           <p:cNvPr id="7" name="">
             <a:extLst xmlns:a="http://schemas.openxmlformats.org/drawingml/2006/main">
               <a:ext uri="{FF2B5EF4-FFF2-40B4-BE49-F238E27FC236}">
-                <a16:creationId xmlns:a16="http://schemas.microsoft.com/office/drawing/2014/main" id="{0DDA7F8D-145A-41E6-A91E-7891F143E1E0}"/>
+                <a16:creationId xmlns:a16="http://schemas.microsoft.com/office/drawing/2014/main" id="{4D2F6413-A6A8-4253-9660-4163B5555E1C}"/>
               </a:ext>
             </a:extLst>
           </p:cNvPr>
@@ -22051,7 +22051,7 @@
           <p:cNvPr id="8" name="">
             <a:extLst xmlns:a="http://schemas.openxmlformats.org/drawingml/2006/main">
               <a:ext uri="{FF2B5EF4-FFF2-40B4-BE49-F238E27FC236}">
-                <a16:creationId xmlns:a16="http://schemas.microsoft.com/office/drawing/2014/main" id="{2A39DFB2-CB4E-4A83-938F-69A0DACD21BB}"/>
+                <a16:creationId xmlns:a16="http://schemas.microsoft.com/office/drawing/2014/main" id="{F8C632FB-9C84-462D-A36C-B8A8668BCF39}"/>
               </a:ext>
             </a:extLst>
           </p:cNvPr>
@@ -22084,7 +22084,7 @@
           <p:cNvPr id="9" name="">
             <a:extLst xmlns:a="http://schemas.openxmlformats.org/drawingml/2006/main">
               <a:ext uri="{FF2B5EF4-FFF2-40B4-BE49-F238E27FC236}">
-                <a16:creationId xmlns:a16="http://schemas.microsoft.com/office/drawing/2014/main" id="{E859B9DE-E3C2-43A5-8536-204F7121EBDC}"/>
+                <a16:creationId xmlns:a16="http://schemas.microsoft.com/office/drawing/2014/main" id="{0E7C8B94-DF43-4ED6-8A77-C032CB67BE24}"/>
               </a:ext>
             </a:extLst>
           </p:cNvPr>
@@ -22094,7 +22094,7 @@
           <p:nvPr/>
         </p:nvPicPr>
         <p:blipFill>
-          <a:blip xmlns:r="http://schemas.openxmlformats.org/officeDocument/2006/relationships" xmlns:a="http://schemas.openxmlformats.org/drawingml/2006/main" r:embed="Ra7a3365566a0497b"/>
+          <a:blip xmlns:r="http://schemas.openxmlformats.org/officeDocument/2006/relationships" xmlns:a="http://schemas.openxmlformats.org/drawingml/2006/main" r:embed="Rf05db8e722d64739"/>
           <a:srcRect xmlns:a="http://schemas.openxmlformats.org/drawingml/2006/main" l="0" t="1104" r="0" b="1104"/>
           <a:stretch xmlns:a="http://schemas.openxmlformats.org/drawingml/2006/main">
             <a:fillRect l="0" t="0" r="0" b="0"/>
@@ -22117,7 +22117,7 @@
           <p:cNvPr id="10" name="">
             <a:extLst xmlns:a="http://schemas.openxmlformats.org/drawingml/2006/main">
               <a:ext uri="{FF2B5EF4-FFF2-40B4-BE49-F238E27FC236}">
-                <a16:creationId xmlns:a16="http://schemas.microsoft.com/office/drawing/2014/main" id="{7993F498-25C6-4E13-8E14-436F909F09CE}"/>
+                <a16:creationId xmlns:a16="http://schemas.microsoft.com/office/drawing/2014/main" id="{CD448750-D098-42E7-9953-EF692FD610BC}"/>
               </a:ext>
             </a:extLst>
           </p:cNvPr>
@@ -22150,7 +22150,7 @@
           <p:cNvPr id="11" name="">
             <a:extLst xmlns:a="http://schemas.openxmlformats.org/drawingml/2006/main">
               <a:ext uri="{FF2B5EF4-FFF2-40B4-BE49-F238E27FC236}">
-                <a16:creationId xmlns:a16="http://schemas.microsoft.com/office/drawing/2014/main" id="{688E6E8A-12DB-4639-B752-FAE3C136AD16}"/>
+                <a16:creationId xmlns:a16="http://schemas.microsoft.com/office/drawing/2014/main" id="{B1A8F7E2-0AD8-4D0A-93F2-640C7DCDCA16}"/>
               </a:ext>
             </a:extLst>
           </p:cNvPr>
@@ -22160,7 +22160,7 @@
           <p:nvPr/>
         </p:nvPicPr>
         <p:blipFill>
-          <a:blip xmlns:r="http://schemas.openxmlformats.org/officeDocument/2006/relationships" xmlns:a="http://schemas.openxmlformats.org/drawingml/2006/main" r:embed="Reec53ba8f06445d6"/>
+          <a:blip xmlns:r="http://schemas.openxmlformats.org/officeDocument/2006/relationships" xmlns:a="http://schemas.openxmlformats.org/drawingml/2006/main" r:embed="R89be65cb585c4b17"/>
           <a:srcRect xmlns:a="http://schemas.openxmlformats.org/drawingml/2006/main" l="94" t="0" r="94" b="0"/>
           <a:stretch xmlns:a="http://schemas.openxmlformats.org/drawingml/2006/main">
             <a:fillRect l="0" t="0" r="0" b="0"/>
@@ -22183,7 +22183,7 @@
           <p:cNvPr id="12" name="">
             <a:extLst xmlns:a="http://schemas.openxmlformats.org/drawingml/2006/main">
               <a:ext uri="{FF2B5EF4-FFF2-40B4-BE49-F238E27FC236}">
-                <a16:creationId xmlns:a16="http://schemas.microsoft.com/office/drawing/2014/main" id="{D51AFDF7-A9A4-452A-92C2-BC587ADF955B}"/>
+                <a16:creationId xmlns:a16="http://schemas.microsoft.com/office/drawing/2014/main" id="{60BA662F-2C94-4815-B027-20419F7AFE5B}"/>
               </a:ext>
             </a:extLst>
           </p:cNvPr>
@@ -22216,7 +22216,7 @@
           <p:cNvPr id="13" name="">
             <a:extLst xmlns:a="http://schemas.openxmlformats.org/drawingml/2006/main">
               <a:ext uri="{FF2B5EF4-FFF2-40B4-BE49-F238E27FC236}">
-                <a16:creationId xmlns:a16="http://schemas.microsoft.com/office/drawing/2014/main" id="{669C57A0-374D-43FD-9F60-17240F15662C}"/>
+                <a16:creationId xmlns:a16="http://schemas.microsoft.com/office/drawing/2014/main" id="{90C128BF-1242-441F-9FF9-02B2542C7DDE}"/>
               </a:ext>
             </a:extLst>
           </p:cNvPr>
@@ -22373,7 +22373,7 @@
           <p:cNvPr id="14" name="">
             <a:extLst xmlns:a="http://schemas.openxmlformats.org/drawingml/2006/main">
               <a:ext uri="{FF2B5EF4-FFF2-40B4-BE49-F238E27FC236}">
-                <a16:creationId xmlns:a16="http://schemas.microsoft.com/office/drawing/2014/main" id="{3CCFB888-7C8C-4F5D-873D-3787DDDC323B}"/>
+                <a16:creationId xmlns:a16="http://schemas.microsoft.com/office/drawing/2014/main" id="{93B3983E-6125-42E4-BD91-09ED6E234E3B}"/>
               </a:ext>
             </a:extLst>
           </p:cNvPr>
@@ -22530,7 +22530,7 @@
           <p:cNvPr id="15" name="">
             <a:extLst xmlns:a="http://schemas.openxmlformats.org/drawingml/2006/main">
               <a:ext uri="{FF2B5EF4-FFF2-40B4-BE49-F238E27FC236}">
-                <a16:creationId xmlns:a16="http://schemas.microsoft.com/office/drawing/2014/main" id="{8653B6B3-D3A0-477F-9667-7A7E1A4FFF78}"/>
+                <a16:creationId xmlns:a16="http://schemas.microsoft.com/office/drawing/2014/main" id="{FEED4E07-5C8E-4101-A4B0-EB29F4B1867D}"/>
               </a:ext>
             </a:extLst>
           </p:cNvPr>
@@ -22687,7 +22687,7 @@
           <p:cNvPr id="16" name="">
             <a:extLst xmlns:a="http://schemas.openxmlformats.org/drawingml/2006/main">
               <a:ext uri="{FF2B5EF4-FFF2-40B4-BE49-F238E27FC236}">
-                <a16:creationId xmlns:a16="http://schemas.microsoft.com/office/drawing/2014/main" id="{2D4CED12-C8FC-4396-8FEE-D6A4BB2FF4AA}"/>
+                <a16:creationId xmlns:a16="http://schemas.microsoft.com/office/drawing/2014/main" id="{696C1277-C3D3-442F-9334-F6C0C582AA5A}"/>
               </a:ext>
             </a:extLst>
           </p:cNvPr>
@@ -22720,7 +22720,7 @@
           <p:cNvPr id="17" name="">
             <a:extLst xmlns:a="http://schemas.openxmlformats.org/drawingml/2006/main">
               <a:ext uri="{FF2B5EF4-FFF2-40B4-BE49-F238E27FC236}">
-                <a16:creationId xmlns:a16="http://schemas.microsoft.com/office/drawing/2014/main" id="{4908E462-6CE8-43EE-B8A0-1B4F0BB10C54}"/>
+                <a16:creationId xmlns:a16="http://schemas.microsoft.com/office/drawing/2014/main" id="{77002EF2-7422-463E-8B03-E1E38158D825}"/>
               </a:ext>
             </a:extLst>
           </p:cNvPr>
@@ -22877,7 +22877,7 @@
           <p:cNvPr id="18" name="">
             <a:extLst xmlns:a="http://schemas.openxmlformats.org/drawingml/2006/main">
               <a:ext uri="{FF2B5EF4-FFF2-40B4-BE49-F238E27FC236}">
-                <a16:creationId xmlns:a16="http://schemas.microsoft.com/office/drawing/2014/main" id="{0D520BA9-85A0-469A-983D-FE1F12265CE9}"/>
+                <a16:creationId xmlns:a16="http://schemas.microsoft.com/office/drawing/2014/main" id="{815981D6-FFFC-47B6-AE0F-B4923927CB2D}"/>
               </a:ext>
             </a:extLst>
           </p:cNvPr>
@@ -23034,7 +23034,7 @@
           <p:cNvPr id="19" name="">
             <a:extLst xmlns:a="http://schemas.openxmlformats.org/drawingml/2006/main">
               <a:ext uri="{FF2B5EF4-FFF2-40B4-BE49-F238E27FC236}">
-                <a16:creationId xmlns:a16="http://schemas.microsoft.com/office/drawing/2014/main" id="{4F506EF7-B5AB-4AD4-994F-61FAA6C1AF5C}"/>
+                <a16:creationId xmlns:a16="http://schemas.microsoft.com/office/drawing/2014/main" id="{6700EE30-AFD8-49F6-85B5-44899091C3A7}"/>
               </a:ext>
             </a:extLst>
           </p:cNvPr>
@@ -23189,7 +23189,7 @@
     </p:spTree>
     <p:extLst>
       <p:ext uri="{BB962C8B-B14F-4D97-AF65-F5344CB8AC3E}">
-        <p14:creationId xmlns:p14="http://schemas.microsoft.com/office/powerpoint/2010/main" val="799281658"/>
+        <p14:creationId xmlns:p14="http://schemas.microsoft.com/office/powerpoint/2010/main" val="1229660452"/>
       </p:ext>
     </p:extLst>
   </p:cSld>
@@ -23217,10 +23217,10 @@
       </p:grpSpPr>
       <p:sp>
         <p:nvSpPr>
-          <p:cNvPr id="15" name="">
+          <p:cNvPr id="16" name="">
             <a:extLst xmlns:a="http://schemas.openxmlformats.org/drawingml/2006/main">
               <a:ext uri="{FF2B5EF4-FFF2-40B4-BE49-F238E27FC236}">
-                <a16:creationId xmlns:a16="http://schemas.microsoft.com/office/drawing/2014/main" id="{18A4B9FA-8ACD-4A3C-9572-87662750F0AF}"/>
+                <a16:creationId xmlns:a16="http://schemas.microsoft.com/office/drawing/2014/main" id="{12E10B7C-BE0B-4F68-B6F7-7F915FDDD753}"/>
               </a:ext>
             </a:extLst>
           </p:cNvPr>
@@ -23251,7 +23251,7 @@
           <p:cNvPr id="2" name="">
             <a:extLst xmlns:a="http://schemas.openxmlformats.org/drawingml/2006/main">
               <a:ext uri="{FF2B5EF4-FFF2-40B4-BE49-F238E27FC236}">
-                <a16:creationId xmlns:a16="http://schemas.microsoft.com/office/drawing/2014/main" id="{87FBA7B3-61E2-4139-A34E-4777685ABC48}"/>
+                <a16:creationId xmlns:a16="http://schemas.microsoft.com/office/drawing/2014/main" id="{A290BBA0-289C-46FC-8F11-658624E7FE1D}"/>
               </a:ext>
             </a:extLst>
           </p:cNvPr>
@@ -23408,7 +23408,7 @@
           <p:cNvPr id="3" name="">
             <a:extLst xmlns:a="http://schemas.openxmlformats.org/drawingml/2006/main">
               <a:ext uri="{FF2B5EF4-FFF2-40B4-BE49-F238E27FC236}">
-                <a16:creationId xmlns:a16="http://schemas.microsoft.com/office/drawing/2014/main" id="{EF8F3530-F2A5-4942-9F54-8A9ACC8A4850}"/>
+                <a16:creationId xmlns:a16="http://schemas.microsoft.com/office/drawing/2014/main" id="{D5B37D72-8DE3-4EB6-9292-D69B707EBEAF}"/>
               </a:ext>
             </a:extLst>
           </p:cNvPr>
@@ -23565,7 +23565,7 @@
           <p:cNvPr id="4" name="">
             <a:extLst xmlns:a="http://schemas.openxmlformats.org/drawingml/2006/main">
               <a:ext uri="{FF2B5EF4-FFF2-40B4-BE49-F238E27FC236}">
-                <a16:creationId xmlns:a16="http://schemas.microsoft.com/office/drawing/2014/main" id="{83A2ABCB-0323-453A-BE7B-58911890072E}"/>
+                <a16:creationId xmlns:a16="http://schemas.microsoft.com/office/drawing/2014/main" id="{B69BC5ED-19F2-4C9A-923A-80F32CB94276}"/>
               </a:ext>
             </a:extLst>
           </p:cNvPr>
@@ -23722,7 +23722,7 @@
           <p:cNvPr id="5" name="">
             <a:extLst xmlns:a="http://schemas.openxmlformats.org/drawingml/2006/main">
               <a:ext uri="{FF2B5EF4-FFF2-40B4-BE49-F238E27FC236}">
-                <a16:creationId xmlns:a16="http://schemas.microsoft.com/office/drawing/2014/main" id="{029F232E-4785-4380-857C-77A7CFB39786}"/>
+                <a16:creationId xmlns:a16="http://schemas.microsoft.com/office/drawing/2014/main" id="{1F9CF930-9B17-4D61-AEB0-47CF6B9138ED}"/>
               </a:ext>
             </a:extLst>
           </p:cNvPr>
@@ -23753,7 +23753,7 @@
           <p:cNvPr id="6" name="">
             <a:extLst xmlns:a="http://schemas.openxmlformats.org/drawingml/2006/main">
               <a:ext uri="{FF2B5EF4-FFF2-40B4-BE49-F238E27FC236}">
-                <a16:creationId xmlns:a16="http://schemas.microsoft.com/office/drawing/2014/main" id="{199C677A-87B8-4177-9F50-672021A3BECA}"/>
+                <a16:creationId xmlns:a16="http://schemas.microsoft.com/office/drawing/2014/main" id="{6D1CA73B-367D-4FCB-B5F3-678F26471452}"/>
               </a:ext>
             </a:extLst>
           </p:cNvPr>
@@ -23910,7 +23910,7 @@
           <p:cNvPr id="7" name="">
             <a:extLst xmlns:a="http://schemas.openxmlformats.org/drawingml/2006/main">
               <a:ext uri="{FF2B5EF4-FFF2-40B4-BE49-F238E27FC236}">
-                <a16:creationId xmlns:a16="http://schemas.microsoft.com/office/drawing/2014/main" id="{80AF4463-217B-4713-A88F-E158B3C4FC8B}"/>
+                <a16:creationId xmlns:a16="http://schemas.microsoft.com/office/drawing/2014/main" id="{C802BAD3-5628-4380-AB2C-FE1C1401E136}"/>
               </a:ext>
             </a:extLst>
           </p:cNvPr>
@@ -24067,7 +24067,7 @@
           <p:cNvPr id="8" name="">
             <a:extLst xmlns:a="http://schemas.openxmlformats.org/drawingml/2006/main">
               <a:ext uri="{FF2B5EF4-FFF2-40B4-BE49-F238E27FC236}">
-                <a16:creationId xmlns:a16="http://schemas.microsoft.com/office/drawing/2014/main" id="{E26D0799-D951-4C67-9C08-540C805F148C}"/>
+                <a16:creationId xmlns:a16="http://schemas.microsoft.com/office/drawing/2014/main" id="{92C6D1B2-C556-4DF9-BD99-E76D24D59470}"/>
               </a:ext>
             </a:extLst>
           </p:cNvPr>
@@ -24100,7 +24100,7 @@
           <p:cNvPr id="9" name="">
             <a:extLst xmlns:a="http://schemas.openxmlformats.org/drawingml/2006/main">
               <a:ext uri="{FF2B5EF4-FFF2-40B4-BE49-F238E27FC236}">
-                <a16:creationId xmlns:a16="http://schemas.microsoft.com/office/drawing/2014/main" id="{C766F8D4-A073-4A2A-8256-332354120328}"/>
+                <a16:creationId xmlns:a16="http://schemas.microsoft.com/office/drawing/2014/main" id="{FBD097ED-FE2F-4DF1-B375-F2234E5A60AF}"/>
               </a:ext>
             </a:extLst>
           </p:cNvPr>
@@ -24110,7 +24110,7 @@
           <p:nvPr/>
         </p:nvPicPr>
         <p:blipFill>
-          <a:blip xmlns:r="http://schemas.openxmlformats.org/officeDocument/2006/relationships" xmlns:a="http://schemas.openxmlformats.org/drawingml/2006/main" r:embed="R4dabb8f45aa34d4d"/>
+          <a:blip xmlns:r="http://schemas.openxmlformats.org/officeDocument/2006/relationships" xmlns:a="http://schemas.openxmlformats.org/drawingml/2006/main" r:embed="R7c7fb9814ee1423f"/>
           <a:srcRect xmlns:a="http://schemas.openxmlformats.org/drawingml/2006/main" l="0" t="417" r="0" b="417"/>
           <a:stretch xmlns:a="http://schemas.openxmlformats.org/drawingml/2006/main">
             <a:fillRect l="0" t="0" r="0" b="0"/>
@@ -24133,7 +24133,7 @@
           <p:cNvPr id="10" name="">
             <a:extLst xmlns:a="http://schemas.openxmlformats.org/drawingml/2006/main">
               <a:ext uri="{FF2B5EF4-FFF2-40B4-BE49-F238E27FC236}">
-                <a16:creationId xmlns:a16="http://schemas.microsoft.com/office/drawing/2014/main" id="{BAF7EA5F-7CEB-41B8-98C6-7F23623835AD}"/>
+                <a16:creationId xmlns:a16="http://schemas.microsoft.com/office/drawing/2014/main" id="{3BB1DD4B-67DA-4011-9428-7FB2B1DD1333}"/>
               </a:ext>
             </a:extLst>
           </p:cNvPr>
@@ -24166,7 +24166,7 @@
           <p:cNvPr id="11" name="">
             <a:extLst xmlns:a="http://schemas.openxmlformats.org/drawingml/2006/main">
               <a:ext uri="{FF2B5EF4-FFF2-40B4-BE49-F238E27FC236}">
-                <a16:creationId xmlns:a16="http://schemas.microsoft.com/office/drawing/2014/main" id="{1FDCD984-ED74-436C-8EFB-7774951C368A}"/>
+                <a16:creationId xmlns:a16="http://schemas.microsoft.com/office/drawing/2014/main" id="{1B2C494F-D2C3-47DA-8869-390D41D9C1CF}"/>
               </a:ext>
             </a:extLst>
           </p:cNvPr>
@@ -24323,7 +24323,7 @@
           <p:cNvPr id="12" name="">
             <a:extLst xmlns:a="http://schemas.openxmlformats.org/drawingml/2006/main">
               <a:ext uri="{FF2B5EF4-FFF2-40B4-BE49-F238E27FC236}">
-                <a16:creationId xmlns:a16="http://schemas.microsoft.com/office/drawing/2014/main" id="{644F0D73-1008-43ED-88E0-0394ED4AF416}"/>
+                <a16:creationId xmlns:a16="http://schemas.microsoft.com/office/drawing/2014/main" id="{8F359EDC-3937-4EE0-9E34-D8793856570C}"/>
               </a:ext>
             </a:extLst>
           </p:cNvPr>
@@ -24480,7 +24480,7 @@
           <p:cNvPr id="13" name="">
             <a:extLst xmlns:a="http://schemas.openxmlformats.org/drawingml/2006/main">
               <a:ext uri="{FF2B5EF4-FFF2-40B4-BE49-F238E27FC236}">
-                <a16:creationId xmlns:a16="http://schemas.microsoft.com/office/drawing/2014/main" id="{0EC5E0FE-5D1B-4653-8212-9CDEFA94DD47}"/>
+                <a16:creationId xmlns:a16="http://schemas.microsoft.com/office/drawing/2014/main" id="{2E778943-5F93-41EF-9AC3-202FACC357B9}"/>
               </a:ext>
             </a:extLst>
           </p:cNvPr>
@@ -24729,7 +24729,164 @@
           <p:cNvPr id="14" name="">
             <a:extLst xmlns:a="http://schemas.openxmlformats.org/drawingml/2006/main">
               <a:ext uri="{FF2B5EF4-FFF2-40B4-BE49-F238E27FC236}">
-                <a16:creationId xmlns:a16="http://schemas.microsoft.com/office/drawing/2014/main" id="{5BBBECF1-771D-42F1-8402-5B47DC57FCE4}"/>
+                <a16:creationId xmlns:a16="http://schemas.microsoft.com/office/drawing/2014/main" id="{8FCF51FE-9C4E-4579-AAB9-857F27AA26F4}"/>
+              </a:ext>
+            </a:extLst>
+          </p:cNvPr>
+          <p:cNvSpPr>
+            <a:spLocks xmlns:a="http://schemas.openxmlformats.org/drawingml/2006/main" noGrp="1"/>
+          </p:cNvSpPr>
+          <p:nvPr/>
+        </p:nvSpPr>
+        <p:spPr>
+          <a:xfrm xmlns:a="http://schemas.openxmlformats.org/drawingml/2006/main">
+            <a:off x="8258175" y="5029200"/>
+            <a:ext cx="3086100" cy="276225"/>
+          </a:xfrm>
+          <a:prstGeom xmlns:a="http://schemas.openxmlformats.org/drawingml/2006/main" prst="rect">
+            <a:avLst/>
+          </a:prstGeom>
+          <a:noFill xmlns:a="http://schemas.openxmlformats.org/drawingml/2006/main"/>
+          <a:ln xmlns:a="http://schemas.openxmlformats.org/drawingml/2006/main" w="0">
+            <a:noFill/>
+            <a:prstDash val="solid"/>
+          </a:ln>
+        </p:spPr>
+        <p:txBody>
+          <a:bodyPr xmlns:a="http://schemas.openxmlformats.org/drawingml/2006/main" anchor="ctr"/>
+          <a:lstStyle xmlns:a="http://schemas.openxmlformats.org/drawingml/2006/main">
+            <a:defPPr algn="l">
+              <a:defRPr sz="1275" b="1">
+                <a:solidFill>
+                  <a:srgbClr val="F5B96C"/>
+                </a:solidFill>
+                <a:latin typeface="Avenir Next"/>
+                <a:ea typeface="Avenir Next"/>
+                <a:cs typeface="Avenir Next"/>
+              </a:defRPr>
+            </a:defPPr>
+            <a:lvl1pPr algn="l">
+              <a:defRPr sz="1275" b="1">
+                <a:solidFill>
+                  <a:srgbClr val="F5B96C"/>
+                </a:solidFill>
+                <a:latin typeface="Avenir Next"/>
+                <a:ea typeface="Avenir Next"/>
+                <a:cs typeface="Avenir Next"/>
+              </a:defRPr>
+            </a:lvl1pPr>
+            <a:lvl2pPr algn="l">
+              <a:defRPr sz="1275" b="1">
+                <a:solidFill>
+                  <a:srgbClr val="F5B96C"/>
+                </a:solidFill>
+                <a:latin typeface="Avenir Next"/>
+                <a:ea typeface="Avenir Next"/>
+                <a:cs typeface="Avenir Next"/>
+              </a:defRPr>
+            </a:lvl2pPr>
+            <a:lvl3pPr algn="l">
+              <a:defRPr sz="1275" b="1">
+                <a:solidFill>
+                  <a:srgbClr val="F5B96C"/>
+                </a:solidFill>
+                <a:latin typeface="Avenir Next"/>
+                <a:ea typeface="Avenir Next"/>
+                <a:cs typeface="Avenir Next"/>
+              </a:defRPr>
+            </a:lvl3pPr>
+            <a:lvl4pPr algn="l">
+              <a:defRPr sz="1275" b="1">
+                <a:solidFill>
+                  <a:srgbClr val="F5B96C"/>
+                </a:solidFill>
+                <a:latin typeface="Avenir Next"/>
+                <a:ea typeface="Avenir Next"/>
+                <a:cs typeface="Avenir Next"/>
+              </a:defRPr>
+            </a:lvl4pPr>
+            <a:lvl5pPr algn="l">
+              <a:defRPr sz="1275" b="1">
+                <a:solidFill>
+                  <a:srgbClr val="F5B96C"/>
+                </a:solidFill>
+                <a:latin typeface="Avenir Next"/>
+                <a:ea typeface="Avenir Next"/>
+                <a:cs typeface="Avenir Next"/>
+              </a:defRPr>
+            </a:lvl5pPr>
+            <a:lvl6pPr algn="l">
+              <a:defRPr sz="1275" b="1">
+                <a:solidFill>
+                  <a:srgbClr val="F5B96C"/>
+                </a:solidFill>
+                <a:latin typeface="Avenir Next"/>
+                <a:ea typeface="Avenir Next"/>
+                <a:cs typeface="Avenir Next"/>
+              </a:defRPr>
+            </a:lvl6pPr>
+            <a:lvl7pPr algn="l">
+              <a:defRPr sz="1275" b="1">
+                <a:solidFill>
+                  <a:srgbClr val="F5B96C"/>
+                </a:solidFill>
+                <a:latin typeface="Avenir Next"/>
+                <a:ea typeface="Avenir Next"/>
+                <a:cs typeface="Avenir Next"/>
+              </a:defRPr>
+            </a:lvl7pPr>
+            <a:lvl8pPr algn="l">
+              <a:defRPr sz="1275" b="1">
+                <a:solidFill>
+                  <a:srgbClr val="F5B96C"/>
+                </a:solidFill>
+                <a:latin typeface="Avenir Next"/>
+                <a:ea typeface="Avenir Next"/>
+                <a:cs typeface="Avenir Next"/>
+              </a:defRPr>
+            </a:lvl8pPr>
+            <a:lvl9pPr algn="l">
+              <a:defRPr sz="1275" b="1">
+                <a:solidFill>
+                  <a:srgbClr val="F5B96C"/>
+                </a:solidFill>
+                <a:latin typeface="Avenir Next"/>
+                <a:ea typeface="Avenir Next"/>
+                <a:cs typeface="Avenir Next"/>
+              </a:defRPr>
+            </a:lvl9pPr>
+          </a:lstStyle>
+          <a:p xmlns:a="http://schemas.openxmlformats.org/drawingml/2006/main">
+            <a:pPr algn="l">
+              <a:defRPr sz="1275" b="1">
+                <a:solidFill>
+                  <a:srgbClr val="F5B96C"/>
+                </a:solidFill>
+                <a:latin typeface="Avenir Next"/>
+                <a:ea typeface="Avenir Next"/>
+                <a:cs typeface="Avenir Next"/>
+              </a:defRPr>
+            </a:pPr>
+            <a:r>
+              <a:rPr sz="1275" b="1">
+                <a:solidFill>
+                  <a:srgbClr val="F5B96C"/>
+                </a:solidFill>
+                <a:latin typeface="Avenir Next"/>
+                <a:ea typeface="Avenir Next"/>
+                <a:cs typeface="Avenir Next"/>
+              </a:rPr>
+              <a:t>SLOWMO:0.5s</a:t>
+            </a:r>
+          </a:p>
+        </p:txBody>
+      </p:sp>
+      <p:sp>
+        <p:nvSpPr>
+          <p:cNvPr id="15" name="">
+            <a:extLst xmlns:a="http://schemas.openxmlformats.org/drawingml/2006/main">
+              <a:ext uri="{FF2B5EF4-FFF2-40B4-BE49-F238E27FC236}">
+                <a16:creationId xmlns:a16="http://schemas.microsoft.com/office/drawing/2014/main" id="{C372E7EF-9724-4263-BFF5-1978213F6CB6}"/>
               </a:ext>
             </a:extLst>
           </p:cNvPr>
@@ -24875,7 +25032,7 @@
                 <a:latin typeface="Avenir Next"/>
                 <a:ea typeface="Avenir Next"/>
                 <a:cs typeface="Avenir Next"/>
-                <a:hlinkClick xmlns:r="http://schemas.openxmlformats.org/officeDocument/2006/relationships" r:id="R58e3f9a717694f5d"/>
+                <a:hlinkClick xmlns:r="http://schemas.openxmlformats.org/officeDocument/2006/relationships" r:id="R314f6da465c24135"/>
               </a:rPr>
               <a:t>Abrir README de ejecución</a:t>
             </a:r>
@@ -24885,7 +25042,7 @@
     </p:spTree>
     <p:extLst>
       <p:ext uri="{BB962C8B-B14F-4D97-AF65-F5344CB8AC3E}">
-        <p14:creationId xmlns:p14="http://schemas.microsoft.com/office/powerpoint/2010/main" val="603186725"/>
+        <p14:creationId xmlns:p14="http://schemas.microsoft.com/office/powerpoint/2010/main" val="48748829"/>
       </p:ext>
     </p:extLst>
   </p:cSld>
@@ -24916,7 +25073,7 @@
           <p:cNvPr id="20" name="">
             <a:extLst xmlns:a="http://schemas.openxmlformats.org/drawingml/2006/main">
               <a:ext uri="{FF2B5EF4-FFF2-40B4-BE49-F238E27FC236}">
-                <a16:creationId xmlns:a16="http://schemas.microsoft.com/office/drawing/2014/main" id="{4F3CD418-7139-4541-BE1C-0F61E2918959}"/>
+                <a16:creationId xmlns:a16="http://schemas.microsoft.com/office/drawing/2014/main" id="{A7E73675-76D7-4D11-8A6C-BCFDE19D1DDE}"/>
               </a:ext>
             </a:extLst>
           </p:cNvPr>
@@ -24947,7 +25104,7 @@
           <p:cNvPr id="2" name="">
             <a:extLst xmlns:a="http://schemas.openxmlformats.org/drawingml/2006/main">
               <a:ext uri="{FF2B5EF4-FFF2-40B4-BE49-F238E27FC236}">
-                <a16:creationId xmlns:a16="http://schemas.microsoft.com/office/drawing/2014/main" id="{ABCFD53D-A8A2-4315-AF45-4CCBBF900CD7}"/>
+                <a16:creationId xmlns:a16="http://schemas.microsoft.com/office/drawing/2014/main" id="{8FF56307-DF3D-47EE-8F28-1AD2F6B1D48E}"/>
               </a:ext>
             </a:extLst>
           </p:cNvPr>
@@ -25104,7 +25261,7 @@
           <p:cNvPr id="3" name="">
             <a:extLst xmlns:a="http://schemas.openxmlformats.org/drawingml/2006/main">
               <a:ext uri="{FF2B5EF4-FFF2-40B4-BE49-F238E27FC236}">
-                <a16:creationId xmlns:a16="http://schemas.microsoft.com/office/drawing/2014/main" id="{98783BEE-9C62-42E1-812E-AA1B9A6BE09D}"/>
+                <a16:creationId xmlns:a16="http://schemas.microsoft.com/office/drawing/2014/main" id="{A62628D6-5030-48BB-B091-41BD8B552764}"/>
               </a:ext>
             </a:extLst>
           </p:cNvPr>
@@ -25261,7 +25418,7 @@
           <p:cNvPr id="4" name="">
             <a:extLst xmlns:a="http://schemas.openxmlformats.org/drawingml/2006/main">
               <a:ext uri="{FF2B5EF4-FFF2-40B4-BE49-F238E27FC236}">
-                <a16:creationId xmlns:a16="http://schemas.microsoft.com/office/drawing/2014/main" id="{3F56EE03-9842-4128-83B0-D862DECAFCAC}"/>
+                <a16:creationId xmlns:a16="http://schemas.microsoft.com/office/drawing/2014/main" id="{5DEABD44-6C12-43C7-8FE1-AD2093BD0B73}"/>
               </a:ext>
             </a:extLst>
           </p:cNvPr>
@@ -25418,7 +25575,7 @@
           <p:cNvPr id="5" name="">
             <a:extLst xmlns:a="http://schemas.openxmlformats.org/drawingml/2006/main">
               <a:ext uri="{FF2B5EF4-FFF2-40B4-BE49-F238E27FC236}">
-                <a16:creationId xmlns:a16="http://schemas.microsoft.com/office/drawing/2014/main" id="{58256567-0923-4D73-A82B-BAC0CFDBBDFC}"/>
+                <a16:creationId xmlns:a16="http://schemas.microsoft.com/office/drawing/2014/main" id="{ED086399-6B75-45A1-B61C-32E094229962}"/>
               </a:ext>
             </a:extLst>
           </p:cNvPr>
@@ -25449,7 +25606,7 @@
           <p:cNvPr id="6" name="">
             <a:extLst xmlns:a="http://schemas.openxmlformats.org/drawingml/2006/main">
               <a:ext uri="{FF2B5EF4-FFF2-40B4-BE49-F238E27FC236}">
-                <a16:creationId xmlns:a16="http://schemas.microsoft.com/office/drawing/2014/main" id="{0183D3D0-5464-4856-A4E6-74DFC4DFD926}"/>
+                <a16:creationId xmlns:a16="http://schemas.microsoft.com/office/drawing/2014/main" id="{5B2BB9D7-26D3-4C1D-8514-AE9D71885AAC}"/>
               </a:ext>
             </a:extLst>
           </p:cNvPr>
@@ -25606,7 +25763,7 @@
           <p:cNvPr id="7" name="">
             <a:extLst xmlns:a="http://schemas.openxmlformats.org/drawingml/2006/main">
               <a:ext uri="{FF2B5EF4-FFF2-40B4-BE49-F238E27FC236}">
-                <a16:creationId xmlns:a16="http://schemas.microsoft.com/office/drawing/2014/main" id="{CFE5D599-BE1E-4641-B2C4-38BFE56C455B}"/>
+                <a16:creationId xmlns:a16="http://schemas.microsoft.com/office/drawing/2014/main" id="{7F09DBAB-30C2-4CE6-8053-5FDD45F86171}"/>
               </a:ext>
             </a:extLst>
           </p:cNvPr>
@@ -25763,7 +25920,7 @@
           <p:cNvPr id="8" name="">
             <a:extLst xmlns:a="http://schemas.openxmlformats.org/drawingml/2006/main">
               <a:ext uri="{FF2B5EF4-FFF2-40B4-BE49-F238E27FC236}">
-                <a16:creationId xmlns:a16="http://schemas.microsoft.com/office/drawing/2014/main" id="{E1E26631-1470-4992-8174-597E705461CB}"/>
+                <a16:creationId xmlns:a16="http://schemas.microsoft.com/office/drawing/2014/main" id="{B8196B16-75AA-49E4-8347-815C0192215B}"/>
               </a:ext>
             </a:extLst>
           </p:cNvPr>
@@ -25796,7 +25953,7 @@
           <p:cNvPr id="9" name="">
             <a:extLst xmlns:a="http://schemas.openxmlformats.org/drawingml/2006/main">
               <a:ext uri="{FF2B5EF4-FFF2-40B4-BE49-F238E27FC236}">
-                <a16:creationId xmlns:a16="http://schemas.microsoft.com/office/drawing/2014/main" id="{4FEF2830-C1CD-411B-98E6-9C2BE4DA34C2}"/>
+                <a16:creationId xmlns:a16="http://schemas.microsoft.com/office/drawing/2014/main" id="{5B7B2490-950C-482D-84DC-3F0D226BEDDA}"/>
               </a:ext>
             </a:extLst>
           </p:cNvPr>
@@ -25829,7 +25986,7 @@
           <p:cNvPr id="10" name="">
             <a:extLst xmlns:a="http://schemas.openxmlformats.org/drawingml/2006/main">
               <a:ext uri="{FF2B5EF4-FFF2-40B4-BE49-F238E27FC236}">
-                <a16:creationId xmlns:a16="http://schemas.microsoft.com/office/drawing/2014/main" id="{B0567BB4-668E-42C6-A179-419C9D6BCB6B}"/>
+                <a16:creationId xmlns:a16="http://schemas.microsoft.com/office/drawing/2014/main" id="{6E9FD2BB-2AB4-4CF6-88B7-1F4C67CDD3D7}"/>
               </a:ext>
             </a:extLst>
           </p:cNvPr>
@@ -25986,7 +26143,7 @@
           <p:cNvPr id="11" name="">
             <a:extLst xmlns:a="http://schemas.openxmlformats.org/drawingml/2006/main">
               <a:ext uri="{FF2B5EF4-FFF2-40B4-BE49-F238E27FC236}">
-                <a16:creationId xmlns:a16="http://schemas.microsoft.com/office/drawing/2014/main" id="{7A68D65C-2772-4D07-BC65-F9D18679CAAF}"/>
+                <a16:creationId xmlns:a16="http://schemas.microsoft.com/office/drawing/2014/main" id="{92C0EDCE-9824-4BF6-B00C-FB08ABC9B355}"/>
               </a:ext>
             </a:extLst>
           </p:cNvPr>
@@ -26166,7 +26323,7 @@
           <p:cNvPr id="12" name="">
             <a:extLst xmlns:a="http://schemas.openxmlformats.org/drawingml/2006/main">
               <a:ext uri="{FF2B5EF4-FFF2-40B4-BE49-F238E27FC236}">
-                <a16:creationId xmlns:a16="http://schemas.microsoft.com/office/drawing/2014/main" id="{E8063513-6D90-451D-9A44-D21BA19394FB}"/>
+                <a16:creationId xmlns:a16="http://schemas.microsoft.com/office/drawing/2014/main" id="{765C6EFE-9890-4CF2-88F8-3CEF0416A9ED}"/>
               </a:ext>
             </a:extLst>
           </p:cNvPr>
@@ -26199,7 +26356,7 @@
           <p:cNvPr id="13" name="">
             <a:extLst xmlns:a="http://schemas.openxmlformats.org/drawingml/2006/main">
               <a:ext uri="{FF2B5EF4-FFF2-40B4-BE49-F238E27FC236}">
-                <a16:creationId xmlns:a16="http://schemas.microsoft.com/office/drawing/2014/main" id="{D7BEA03D-F4AB-4C9D-AB8D-93469104083B}"/>
+                <a16:creationId xmlns:a16="http://schemas.microsoft.com/office/drawing/2014/main" id="{8951DFF3-3689-4C37-8168-0081F271B69C}"/>
               </a:ext>
             </a:extLst>
           </p:cNvPr>
@@ -26356,7 +26513,7 @@
           <p:cNvPr id="14" name="">
             <a:extLst xmlns:a="http://schemas.openxmlformats.org/drawingml/2006/main">
               <a:ext uri="{FF2B5EF4-FFF2-40B4-BE49-F238E27FC236}">
-                <a16:creationId xmlns:a16="http://schemas.microsoft.com/office/drawing/2014/main" id="{E1A63C7E-D810-43BC-ABD5-E4187A4A91DE}"/>
+                <a16:creationId xmlns:a16="http://schemas.microsoft.com/office/drawing/2014/main" id="{9F547D83-19EA-407B-B1B2-1B7695382ACB}"/>
               </a:ext>
             </a:extLst>
           </p:cNvPr>
@@ -26536,7 +26693,7 @@
           <p:cNvPr id="15" name="">
             <a:extLst xmlns:a="http://schemas.openxmlformats.org/drawingml/2006/main">
               <a:ext uri="{FF2B5EF4-FFF2-40B4-BE49-F238E27FC236}">
-                <a16:creationId xmlns:a16="http://schemas.microsoft.com/office/drawing/2014/main" id="{0C30E10A-03F3-4D77-9CE8-C24299C5F6AB}"/>
+                <a16:creationId xmlns:a16="http://schemas.microsoft.com/office/drawing/2014/main" id="{EA406644-07C8-4488-A7DD-EBDDEE889BFE}"/>
               </a:ext>
             </a:extLst>
           </p:cNvPr>
@@ -26569,7 +26726,7 @@
           <p:cNvPr id="16" name="">
             <a:extLst xmlns:a="http://schemas.openxmlformats.org/drawingml/2006/main">
               <a:ext uri="{FF2B5EF4-FFF2-40B4-BE49-F238E27FC236}">
-                <a16:creationId xmlns:a16="http://schemas.microsoft.com/office/drawing/2014/main" id="{FB3221B0-D5C8-4B1B-A9DE-DC3666504C54}"/>
+                <a16:creationId xmlns:a16="http://schemas.microsoft.com/office/drawing/2014/main" id="{C2D511C6-23BC-4AAF-905A-D1F46F729A18}"/>
               </a:ext>
             </a:extLst>
           </p:cNvPr>
@@ -26726,7 +26883,7 @@
           <p:cNvPr id="17" name="">
             <a:extLst xmlns:a="http://schemas.openxmlformats.org/drawingml/2006/main">
               <a:ext uri="{FF2B5EF4-FFF2-40B4-BE49-F238E27FC236}">
-                <a16:creationId xmlns:a16="http://schemas.microsoft.com/office/drawing/2014/main" id="{BB3B678C-5066-4D3E-8B52-07912120EC0A}"/>
+                <a16:creationId xmlns:a16="http://schemas.microsoft.com/office/drawing/2014/main" id="{62773A42-91C0-476C-836C-A998CC507595}"/>
               </a:ext>
             </a:extLst>
           </p:cNvPr>
@@ -26906,7 +27063,7 @@
           <p:cNvPr id="18" name="">
             <a:extLst xmlns:a="http://schemas.openxmlformats.org/drawingml/2006/main">
               <a:ext uri="{FF2B5EF4-FFF2-40B4-BE49-F238E27FC236}">
-                <a16:creationId xmlns:a16="http://schemas.microsoft.com/office/drawing/2014/main" id="{CD681A26-4F64-4241-A81A-95EB86A3BF5C}"/>
+                <a16:creationId xmlns:a16="http://schemas.microsoft.com/office/drawing/2014/main" id="{462D9BD1-3A2E-4F26-8655-F8B7C0B1F43D}"/>
               </a:ext>
             </a:extLst>
           </p:cNvPr>
@@ -27052,7 +27209,7 @@
                 <a:latin typeface="Avenir Next"/>
                 <a:ea typeface="Avenir Next"/>
                 <a:cs typeface="Avenir Next"/>
-                <a:hlinkClick xmlns:r="http://schemas.openxmlformats.org/officeDocument/2006/relationships" r:id="Rec1dcab006c64f8f"/>
+                <a:hlinkClick xmlns:r="http://schemas.openxmlformats.org/officeDocument/2006/relationships" r:id="R50545276dd6a4d0d"/>
               </a:rPr>
               <a:t>Abrir guía de la demo IA</a:t>
             </a:r>
@@ -27064,7 +27221,7 @@
           <p:cNvPr id="19" name="">
             <a:extLst xmlns:a="http://schemas.openxmlformats.org/drawingml/2006/main">
               <a:ext uri="{FF2B5EF4-FFF2-40B4-BE49-F238E27FC236}">
-                <a16:creationId xmlns:a16="http://schemas.microsoft.com/office/drawing/2014/main" id="{ED5BDABE-63C5-4695-AD30-33BAE826A9B9}"/>
+                <a16:creationId xmlns:a16="http://schemas.microsoft.com/office/drawing/2014/main" id="{2DD04C0C-77F9-431A-948C-10459382BC8F}"/>
               </a:ext>
             </a:extLst>
           </p:cNvPr>
@@ -27219,7 +27376,7 @@
     </p:spTree>
     <p:extLst>
       <p:ext uri="{BB962C8B-B14F-4D97-AF65-F5344CB8AC3E}">
-        <p14:creationId xmlns:p14="http://schemas.microsoft.com/office/powerpoint/2010/main" val="1833157569"/>
+        <p14:creationId xmlns:p14="http://schemas.microsoft.com/office/powerpoint/2010/main" val="1419059261"/>
       </p:ext>
     </p:extLst>
   </p:cSld>

</xml_diff>